<commit_message>
Model failover, working extraction model, deck updated with real results
Three models reached end-of-life during the build, one mid-run, so the
extractor now fails over to the next configured model on 410/404 instead
of burning the rest of the run.

- LLM_MODEL=meta/llama-3.2-11b-vision-instruct (swept 56, six responded)
- 800-char prompt chunks: a small model returns 1 of 40 fares from a full
  page, 38-39 when the listing is split
- max_retries=0 on the client so the configured timeout means what it says
- departure_time stored (in the spec's JSON schema, missing from its table)
- deck rewritten around results rather than intentions

Co-Authored-By: Claude Opus 5 <noreply@anthropic.com>
Claude-Session: https://claude.ai/code/session_0129UjVhHMAVJgfcaxoN1dD5
</commit_message>
<xml_diff>
--- a/SIH26056-Idea-Presentation.pptx
+++ b/SIH26056-Idea-Presentation.pptx
@@ -8328,7 +8328,7 @@
                 </a:solidFill>
                 <a:latin typeface="Arial"/>
               </a:rPr>
-              <a:t>LLM on an OpenAI-compatible endpoint (NVIDIA NIM)</a:t>
+              <a:t>LLM over an OpenAI-compatible endpoint — model is config, with failover</a:t>
             </a:r>
           </a:p>
         </p:txBody>
@@ -9952,7 +9952,7 @@
                 </a:solidFill>
                 <a:latin typeface="Arial"/>
               </a:rPr>
-              <a:t>VERIFIED ON A LIVE RUN  ·  31 Aug 2026</a:t>
+              <a:t>RUNNING, NOT PROPOSED  ·  1 Sep 2026</a:t>
             </a:r>
           </a:p>
           <a:p>
@@ -9974,7 +9974,7 @@
                 </a:solidFill>
                 <a:latin typeface="Arial"/>
               </a:rPr>
-              <a:t>61 fare rows returned for DEL–BOM in ~16 s  ·  results page trimmed from 13,000 to 3,700 characters before the model sees it  ·  78 validated rows written end-to-end across 2 routes × 2 windows.</a:t>
+              <a:t>109 live fares scraped, parsed and written to Postgres in one 5-minute run — zero failed fetches, zero failed extractions. Results page trimmed from 13,000 to 3,700 characters before the model sees it. The dashboard reads the database directly at real-time-airfare.vercel.app.</a:t>
             </a:r>
           </a:p>
         </p:txBody>
@@ -12067,7 +12067,7 @@
                 </a:solidFill>
                 <a:latin typeface="Arial"/>
               </a:rPr>
-              <a:t>Models get retired without notice</a:t>
+              <a:t>Model availability is unreliable — the pipeline now routes around it</a:t>
             </a:r>
           </a:p>
           <a:p>
@@ -12089,7 +12089,7 @@
                 </a:solidFill>
                 <a:latin typeface="Arial"/>
               </a:rPr>
-              <a:t>Both models named at design time were withdrawn within the month. The client is model-agnostic, a preflight lists live models, and model_used is stored per row.</a:t>
+              <a:t>Three models died during this build: two were already end-of-life at design time, and a third was retired mid-run (410 Gone). Extraction now fails over to the next configured model automatically, and model_used is stored per row so every switch is auditable.</a:t>
             </a:r>
           </a:p>
         </p:txBody>
@@ -13829,7 +13829,7 @@
         <p:spPr>
           <a:xfrm>
             <a:off x="6355080" y="4956048"/>
-            <a:ext cx="5394960" cy="548640"/>
+            <a:ext cx="5394960" cy="685800"/>
           </a:xfrm>
           <a:prstGeom prst="rect">
             <a:avLst/>
@@ -13854,13 +13854,35 @@
               </a:spcAft>
             </a:pPr>
             <a:r>
+              <a:rPr sz="950" b="1">
+                <a:solidFill>
+                  <a:srgbClr val="1F497D"/>
+                </a:solidFill>
+                <a:latin typeface="Arial"/>
+              </a:rPr>
+              <a:t>Live at real-time-airfare.vercel.app, reading the database on every load.</a:t>
+            </a:r>
+          </a:p>
+          <a:p>
+            <a:pPr>
+              <a:lnSpc>
+                <a:spcPct val="95000"/>
+              </a:lnSpc>
+              <a:spcBef>
+                <a:spcPts val="200"/>
+              </a:spcBef>
+              <a:spcAft>
+                <a:spcPts val="0"/>
+              </a:spcAft>
+            </a:pPr>
+            <a:r>
               <a:rPr sz="900" b="0">
                 <a:solidFill>
                   <a:srgbClr val="5A626C"/>
                 </a:solidFill>
                 <a:latin typeface="Arial"/>
               </a:rPr>
-              <a:t>Index, advance-booking curve, fare composition and late-booking premium — built against the live database schema. Figures shown are sample data; the series fills in as the scheduled runs accumulate.</a:t>
+              <a:t>Two audiences, one dataset: the index for MoSPI, and a plain-language “should I book?” view for travellers. Verdicts are withheld until enough history exists rather than guessed.</a:t>
             </a:r>
           </a:p>
         </p:txBody>
@@ -14334,8 +14356,8 @@
         </p:nvSpPr>
         <p:spPr>
           <a:xfrm>
-            <a:off x="411480" y="1444752"/>
-            <a:ext cx="8275320" cy="859536"/>
+            <a:off x="411480" y="1426464"/>
+            <a:ext cx="8275320" cy="793699"/>
           </a:xfrm>
           <a:prstGeom prst="rect">
             <a:avLst/>
@@ -14445,7 +14467,7 @@
         </p:nvSpPr>
         <p:spPr>
           <a:xfrm>
-            <a:off x="411480" y="2404872"/>
+            <a:off x="411480" y="2293315"/>
             <a:ext cx="8275320" cy="274320"/>
           </a:xfrm>
           <a:prstGeom prst="rect">
@@ -14490,7 +14512,7 @@
         </p:nvSpPr>
         <p:spPr>
           <a:xfrm>
-            <a:off x="429768" y="2679191"/>
+            <a:off x="429768" y="2567635"/>
             <a:ext cx="1371600" cy="25603"/>
           </a:xfrm>
           <a:prstGeom prst="rect">
@@ -14534,8 +14556,8 @@
         </p:nvSpPr>
         <p:spPr>
           <a:xfrm>
-            <a:off x="411480" y="2734056"/>
-            <a:ext cx="8275320" cy="658368"/>
+            <a:off x="411480" y="2604211"/>
+            <a:ext cx="8275320" cy="604418"/>
           </a:xfrm>
           <a:prstGeom prst="rect">
             <a:avLst/>
@@ -14623,7 +14645,7 @@
         </p:nvSpPr>
         <p:spPr>
           <a:xfrm>
-            <a:off x="411480" y="3493008"/>
+            <a:off x="411480" y="3281781"/>
             <a:ext cx="8275320" cy="274320"/>
           </a:xfrm>
           <a:prstGeom prst="rect">
@@ -14668,7 +14690,7 @@
         </p:nvSpPr>
         <p:spPr>
           <a:xfrm>
-            <a:off x="429768" y="3767328"/>
+            <a:off x="429768" y="3556101"/>
             <a:ext cx="1371600" cy="25603"/>
           </a:xfrm>
           <a:prstGeom prst="rect">
@@ -14712,8 +14734,8 @@
         </p:nvSpPr>
         <p:spPr>
           <a:xfrm>
-            <a:off x="411480" y="3822192"/>
-            <a:ext cx="8275320" cy="457199"/>
+            <a:off x="411480" y="3592677"/>
+            <a:ext cx="8275320" cy="415137"/>
           </a:xfrm>
           <a:prstGeom prst="rect">
             <a:avLst/>
@@ -14779,7 +14801,7 @@
         </p:nvSpPr>
         <p:spPr>
           <a:xfrm>
-            <a:off x="411480" y="4379976"/>
+            <a:off x="411480" y="4080967"/>
             <a:ext cx="8275320" cy="274320"/>
           </a:xfrm>
           <a:prstGeom prst="rect">
@@ -14824,7 +14846,7 @@
         </p:nvSpPr>
         <p:spPr>
           <a:xfrm>
-            <a:off x="429768" y="4654296"/>
+            <a:off x="429768" y="4355287"/>
             <a:ext cx="1371600" cy="25603"/>
           </a:xfrm>
           <a:prstGeom prst="rect">
@@ -14868,8 +14890,8 @@
         </p:nvSpPr>
         <p:spPr>
           <a:xfrm>
-            <a:off x="411480" y="4709160"/>
-            <a:ext cx="8275320" cy="978408"/>
+            <a:off x="411480" y="4391863"/>
+            <a:ext cx="8275320" cy="1422806"/>
           </a:xfrm>
           <a:prstGeom prst="rect">
             <a:avLst/>
@@ -14944,7 +14966,29 @@
                 </a:solidFill>
                 <a:latin typeface="Arial"/>
               </a:rPr>
-              <a:t>•  Model availability: both models named at design time returned 410 Gone (end-of-life 21 Aug and 7 Aug 2026), which is why model choice is configuration.</a:t>
+              <a:t>•  Model availability: of 56 free-tier chat models, six answered at all, and three reached end-of-life during this build — one mid-run. Catalogue sweeping and failover are now part of the system.</a:t>
+            </a:r>
+          </a:p>
+          <a:p>
+            <a:pPr>
+              <a:lnSpc>
+                <a:spcPct val="95000"/>
+              </a:lnSpc>
+              <a:spcBef>
+                <a:spcPts val="300"/>
+              </a:spcBef>
+              <a:spcAft>
+                <a:spcPts val="0"/>
+              </a:spcAft>
+            </a:pPr>
+            <a:r>
+              <a:rPr sz="1000" b="0">
+                <a:solidFill>
+                  <a:srgbClr val="262B33"/>
+                </a:solidFill>
+                <a:latin typeface="Arial"/>
+              </a:rPr>
+              <a:t>•  Prompt sizing: a small model returned 1 of 40 fares from a full page, but all 38 once split into 800-character chunks — quality is as much how much you ask for as who you ask.</a:t>
             </a:r>
           </a:p>
         </p:txBody>
@@ -15075,7 +15119,7 @@
                 </a:solidFill>
                 <a:latin typeface="Arial"/>
               </a:rPr>
-              <a:t>Verified live</a:t>
+              <a:t>Running end to end</a:t>
             </a:r>
           </a:p>
           <a:p>
@@ -15097,7 +15141,7 @@
                 </a:solidFill>
                 <a:latin typeface="Arial"/>
               </a:rPr>
-              <a:t>61 fare rows for DEL–BOM in ~16 s; 78 validated rows written end-to-end.</a:t>
+              <a:t>Live fares in Supabase Postgres, a public dashboard reading them, and scheduled runs every 4 hours.</a:t>
             </a:r>
           </a:p>
           <a:p>

</xml_diff>

<commit_message>
Schedule from a residential host: CI runners are blocked by the source
GitHub-hosted runners get HTTP 403 from Cleartrip (verified in CI run
33526308194) — even for /robots.txt. OTAs block datacenter ranges, so
scheduled scraping cannot live on GitHub-hosted runners.

- workflow schedules disabled, workflow_dispatch kept for manual and
  self-hosted use, with the reason recorded in the files
- run-scheduled.sh: flock-guarded wrapper with daily logs, 14-day retention
- crontab.example: hot basket 8-hourly, full basket daily
- deck gains the finding as a risk with its mitigation

Co-Authored-By: Claude Opus 5 <noreply@anthropic.com>
Claude-Session: https://claude.ai/code/session_0129UjVhHMAVJgfcaxoN1dD5
</commit_message>
<xml_diff>
--- a/SIH26056-Idea-Presentation.pptx
+++ b/SIH26056-Idea-Presentation.pptx
@@ -8628,7 +8628,7 @@
                 </a:solidFill>
                 <a:latin typeface="Arial"/>
               </a:rPr>
-              <a:t>GitHub Actions — cron, every 4 hours</a:t>
+              <a:t>cron on a residential host; CI kept for manual runs</a:t>
             </a:r>
           </a:p>
         </p:txBody>
@@ -11625,8 +11625,8 @@
         </p:nvSpPr>
         <p:spPr>
           <a:xfrm>
-            <a:off x="5074920" y="1517904"/>
-            <a:ext cx="6675120" cy="786384"/>
+            <a:off x="5074920" y="1444752"/>
+            <a:ext cx="6675120" cy="722376"/>
           </a:xfrm>
           <a:prstGeom prst="roundRect">
             <a:avLst>
@@ -11673,8 +11673,8 @@
         </p:nvSpPr>
         <p:spPr>
           <a:xfrm>
-            <a:off x="5074920" y="1517904"/>
-            <a:ext cx="45720" cy="786384"/>
+            <a:off x="5074920" y="1444752"/>
+            <a:ext cx="45720" cy="722376"/>
           </a:xfrm>
           <a:prstGeom prst="rect">
             <a:avLst/>
@@ -11717,7 +11717,7 @@
         </p:nvSpPr>
         <p:spPr>
           <a:xfrm>
-            <a:off x="5230368" y="1581912"/>
+            <a:off x="5230368" y="1508760"/>
             <a:ext cx="6400800" cy="658368"/>
           </a:xfrm>
           <a:prstGeom prst="rect">
@@ -11784,8 +11784,8 @@
         </p:nvSpPr>
         <p:spPr>
           <a:xfrm>
-            <a:off x="5074920" y="2377439"/>
-            <a:ext cx="6675120" cy="786384"/>
+            <a:off x="5074920" y="2217420"/>
+            <a:ext cx="6675120" cy="722376"/>
           </a:xfrm>
           <a:prstGeom prst="roundRect">
             <a:avLst>
@@ -11832,8 +11832,8 @@
         </p:nvSpPr>
         <p:spPr>
           <a:xfrm>
-            <a:off x="5074920" y="2377439"/>
-            <a:ext cx="45720" cy="786384"/>
+            <a:off x="5074920" y="2217420"/>
+            <a:ext cx="45720" cy="722376"/>
           </a:xfrm>
           <a:prstGeom prst="rect">
             <a:avLst/>
@@ -11876,7 +11876,7 @@
         </p:nvSpPr>
         <p:spPr>
           <a:xfrm>
-            <a:off x="5230368" y="2441447"/>
+            <a:off x="5230368" y="2281428"/>
             <a:ext cx="6400800" cy="658368"/>
           </a:xfrm>
           <a:prstGeom prst="rect">
@@ -11908,7 +11908,7 @@
                 </a:solidFill>
                 <a:latin typeface="Arial"/>
               </a:rPr>
-              <a:t>Some portals disallow their search paths</a:t>
+              <a:t>Portals block cloud IPs, so CI cannot scrape</a:t>
             </a:r>
           </a:p>
           <a:p>
@@ -11930,7 +11930,7 @@
                 </a:solidFill>
                 <a:latin typeface="Arial"/>
               </a:rPr>
-              <a:t>Ixigo's robots.txt forbids /search/result/. The gate detects it and skips the source automatically — we only ever crawl what we are permitted to.</a:t>
+              <a:t>Cleartrip serves a home connection normally but answers GitHub's runners with HTTP 403. Scheduling therefore runs from a residential host under cron with a lock file; the CI workflows are kept for manual and self-hosted runs.</a:t>
             </a:r>
           </a:p>
         </p:txBody>
@@ -11943,8 +11943,8 @@
         </p:nvSpPr>
         <p:spPr>
           <a:xfrm>
-            <a:off x="5074920" y="3236975"/>
-            <a:ext cx="6675120" cy="786384"/>
+            <a:off x="5074920" y="2990088"/>
+            <a:ext cx="6675120" cy="722376"/>
           </a:xfrm>
           <a:prstGeom prst="roundRect">
             <a:avLst>
@@ -11991,8 +11991,8 @@
         </p:nvSpPr>
         <p:spPr>
           <a:xfrm>
-            <a:off x="5074920" y="3236975"/>
-            <a:ext cx="45720" cy="786384"/>
+            <a:off x="5074920" y="2990088"/>
+            <a:ext cx="45720" cy="722376"/>
           </a:xfrm>
           <a:prstGeom prst="rect">
             <a:avLst/>
@@ -12035,7 +12035,7 @@
         </p:nvSpPr>
         <p:spPr>
           <a:xfrm>
-            <a:off x="5230368" y="3300983"/>
+            <a:off x="5230368" y="3054096"/>
             <a:ext cx="6400800" cy="658368"/>
           </a:xfrm>
           <a:prstGeom prst="rect">
@@ -12067,7 +12067,7 @@
                 </a:solidFill>
                 <a:latin typeface="Arial"/>
               </a:rPr>
-              <a:t>Model availability is unreliable — the pipeline now routes around it</a:t>
+              <a:t>Some portals disallow their search paths</a:t>
             </a:r>
           </a:p>
           <a:p>
@@ -12089,7 +12089,7 @@
                 </a:solidFill>
                 <a:latin typeface="Arial"/>
               </a:rPr>
-              <a:t>Three models died during this build: two were already end-of-life at design time, and a third was retired mid-run (410 Gone). Extraction now fails over to the next configured model automatically, and model_used is stored per row so every switch is auditable.</a:t>
+              <a:t>Ixigo's robots.txt forbids /search/result/. The gate detects it and skips the source automatically — we only ever crawl what we are permitted to.</a:t>
             </a:r>
           </a:p>
         </p:txBody>
@@ -12102,8 +12102,8 @@
         </p:nvSpPr>
         <p:spPr>
           <a:xfrm>
-            <a:off x="5074920" y="4096511"/>
-            <a:ext cx="6675120" cy="786384"/>
+            <a:off x="5074920" y="3762756"/>
+            <a:ext cx="6675120" cy="722376"/>
           </a:xfrm>
           <a:prstGeom prst="roundRect">
             <a:avLst>
@@ -12150,8 +12150,8 @@
         </p:nvSpPr>
         <p:spPr>
           <a:xfrm>
-            <a:off x="5074920" y="4096511"/>
-            <a:ext cx="45720" cy="786384"/>
+            <a:off x="5074920" y="3762756"/>
+            <a:ext cx="45720" cy="722376"/>
           </a:xfrm>
           <a:prstGeom prst="rect">
             <a:avLst/>
@@ -12194,7 +12194,7 @@
         </p:nvSpPr>
         <p:spPr>
           <a:xfrm>
-            <a:off x="5230368" y="4160520"/>
+            <a:off x="5230368" y="3826764"/>
             <a:ext cx="6400800" cy="658368"/>
           </a:xfrm>
           <a:prstGeom prst="rect">
@@ -12226,7 +12226,7 @@
                 </a:solidFill>
                 <a:latin typeface="Arial"/>
               </a:rPr>
-              <a:t>Sites redesign their markup</a:t>
+              <a:t>Model availability is unreliable — the pipeline now routes around it</a:t>
             </a:r>
           </a:p>
           <a:p>
@@ -12248,7 +12248,7 @@
                 </a:solidFill>
                 <a:latin typeface="Arial"/>
               </a:rPr>
-              <a:t>Extraction keys off structure (a time next to a price), not class names, so a redesign changes nothing. An explicit selector can still be pinned per source.</a:t>
+              <a:t>Three models died during this build: two were already end-of-life at design time, and a third was retired mid-run (410 Gone). Extraction now fails over to the next configured model automatically, and model_used is stored per row so every switch is auditable.</a:t>
             </a:r>
           </a:p>
         </p:txBody>
@@ -12261,8 +12261,8 @@
         </p:nvSpPr>
         <p:spPr>
           <a:xfrm>
-            <a:off x="5074920" y="4956048"/>
-            <a:ext cx="6675120" cy="786384"/>
+            <a:off x="5074920" y="4535424"/>
+            <a:ext cx="6675120" cy="722376"/>
           </a:xfrm>
           <a:prstGeom prst="roundRect">
             <a:avLst>
@@ -12309,8 +12309,8 @@
         </p:nvSpPr>
         <p:spPr>
           <a:xfrm>
-            <a:off x="5074920" y="4956048"/>
-            <a:ext cx="45720" cy="786384"/>
+            <a:off x="5074920" y="4535424"/>
+            <a:ext cx="45720" cy="722376"/>
           </a:xfrm>
           <a:prstGeom prst="rect">
             <a:avLst/>
@@ -12353,7 +12353,166 @@
         </p:nvSpPr>
         <p:spPr>
           <a:xfrm>
-            <a:off x="5230368" y="5020056"/>
+            <a:off x="5230368" y="4599432"/>
+            <a:ext cx="6400800" cy="658368"/>
+          </a:xfrm>
+          <a:prstGeom prst="rect">
+            <a:avLst/>
+          </a:prstGeom>
+          <a:noFill/>
+        </p:spPr>
+        <p:txBody>
+          <a:bodyPr wrap="square" lIns="36576" rIns="36576" tIns="18288" bIns="18288">
+            <a:spAutoFit/>
+          </a:bodyPr>
+          <a:lstStyle/>
+          <a:p>
+            <a:pPr>
+              <a:lnSpc>
+                <a:spcPct val="95000"/>
+              </a:lnSpc>
+              <a:spcBef>
+                <a:spcPts val="0"/>
+              </a:spcBef>
+              <a:spcAft>
+                <a:spcPts val="0"/>
+              </a:spcAft>
+            </a:pPr>
+            <a:r>
+              <a:rPr sz="1000" b="1">
+                <a:solidFill>
+                  <a:srgbClr val="1F497D"/>
+                </a:solidFill>
+                <a:latin typeface="Arial"/>
+              </a:rPr>
+              <a:t>Sites redesign their markup</a:t>
+            </a:r>
+          </a:p>
+          <a:p>
+            <a:pPr>
+              <a:lnSpc>
+                <a:spcPct val="95000"/>
+              </a:lnSpc>
+              <a:spcBef>
+                <a:spcPts val="200"/>
+              </a:spcBef>
+              <a:spcAft>
+                <a:spcPts val="0"/>
+              </a:spcAft>
+            </a:pPr>
+            <a:r>
+              <a:rPr sz="950" b="0">
+                <a:solidFill>
+                  <a:srgbClr val="262B33"/>
+                </a:solidFill>
+                <a:latin typeface="Arial"/>
+              </a:rPr>
+              <a:t>Extraction keys off structure (a time next to a price), not class names, so a redesign changes nothing. An explicit selector can still be pinned per source.</a:t>
+            </a:r>
+          </a:p>
+        </p:txBody>
+      </p:sp>
+      <p:sp>
+        <p:nvSpPr>
+          <p:cNvPr id="17445" name="Rounded Rectangle 17444"/>
+          <p:cNvSpPr/>
+          <p:nvPr/>
+        </p:nvSpPr>
+        <p:spPr>
+          <a:xfrm>
+            <a:off x="5074920" y="5308092"/>
+            <a:ext cx="6675120" cy="722376"/>
+          </a:xfrm>
+          <a:prstGeom prst="roundRect">
+            <a:avLst>
+              <a:gd name="adj" fmla="val 6000"/>
+            </a:avLst>
+          </a:prstGeom>
+          <a:solidFill>
+            <a:srgbClr val="FFFFFF"/>
+          </a:solidFill>
+          <a:ln w="12700">
+            <a:solidFill>
+              <a:srgbClr val="C7D3E3"/>
+            </a:solidFill>
+          </a:ln>
+          <a:effectLst/>
+        </p:spPr>
+        <p:style>
+          <a:lnRef idx="1">
+            <a:schemeClr val="accent1"/>
+          </a:lnRef>
+          <a:fillRef idx="3">
+            <a:schemeClr val="accent1"/>
+          </a:fillRef>
+          <a:effectRef idx="2">
+            <a:schemeClr val="accent1"/>
+          </a:effectRef>
+          <a:fontRef idx="minor">
+            <a:schemeClr val="lt1"/>
+          </a:fontRef>
+        </p:style>
+        <p:txBody>
+          <a:bodyPr rtlCol="0" anchor="ctr" wrap="square"/>
+          <a:lstStyle/>
+          <a:p>
+            <a:pPr algn="ctr"/>
+          </a:p>
+        </p:txBody>
+      </p:sp>
+      <p:sp>
+        <p:nvSpPr>
+          <p:cNvPr id="17446" name="Rectangle 17445"/>
+          <p:cNvSpPr/>
+          <p:nvPr/>
+        </p:nvSpPr>
+        <p:spPr>
+          <a:xfrm>
+            <a:off x="5074920" y="5308092"/>
+            <a:ext cx="45720" cy="722376"/>
+          </a:xfrm>
+          <a:prstGeom prst="rect">
+            <a:avLst/>
+          </a:prstGeom>
+          <a:solidFill>
+            <a:srgbClr val="4F81BD"/>
+          </a:solidFill>
+          <a:ln>
+            <a:noFill/>
+          </a:ln>
+          <a:effectLst/>
+        </p:spPr>
+        <p:style>
+          <a:lnRef idx="1">
+            <a:schemeClr val="accent1"/>
+          </a:lnRef>
+          <a:fillRef idx="3">
+            <a:schemeClr val="accent1"/>
+          </a:fillRef>
+          <a:effectRef idx="2">
+            <a:schemeClr val="accent1"/>
+          </a:effectRef>
+          <a:fontRef idx="minor">
+            <a:schemeClr val="lt1"/>
+          </a:fontRef>
+        </p:style>
+        <p:txBody>
+          <a:bodyPr rtlCol="0" anchor="ctr"/>
+          <a:lstStyle/>
+          <a:p>
+            <a:pPr algn="ctr"/>
+          </a:p>
+        </p:txBody>
+      </p:sp>
+      <p:sp>
+        <p:nvSpPr>
+          <p:cNvPr id="17447" name="TextBox 17446"/>
+          <p:cNvSpPr txBox="1"/>
+          <p:nvPr/>
+        </p:nvSpPr>
+        <p:spPr>
+          <a:xfrm>
+            <a:off x="5230368" y="5372100"/>
             <a:ext cx="6400800" cy="658368"/>
           </a:xfrm>
           <a:prstGeom prst="rect">

</xml_diff>

<commit_message>
Deck: fresh data, carrier coverage, clearer problem-first arc
- slide 2 opens with the problem, then the solution, then proof
- new chart: one OTA source reaches every major Indian carrier, which is
  the honest answer to having no airline source of our own
- numbers refreshed from the database: 2,342 fares, 14 runs, 2 days
- chart and deck generators moved into tools/ so the deck is reproducible
  from live data rather than hand-maintained

Co-Authored-By: Claude Opus 5 <noreply@anthropic.com>
Claude-Session: https://claude.ai/code/session_0129UjVhHMAVJgfcaxoN1dD5
</commit_message>
<xml_diff>
--- a/SIH26056-Idea-Presentation.pptx
+++ b/SIH26056-Idea-Presentation.pptx
@@ -6207,87 +6207,22 @@
       </p:pic>
       <p:sp>
         <p:nvSpPr>
-          <p:cNvPr id="15362" name="TextBox 15361"/>
-          <p:cNvSpPr txBox="1"/>
-          <p:nvPr/>
-        </p:nvSpPr>
-        <p:spPr>
-          <a:xfrm>
-            <a:off x="411480" y="1133856"/>
-            <a:ext cx="5669280" cy="1371600"/>
-          </a:xfrm>
-          <a:prstGeom prst="rect">
-            <a:avLst/>
-          </a:prstGeom>
-          <a:noFill/>
-        </p:spPr>
-        <p:txBody>
-          <a:bodyPr wrap="square" lIns="36576" rIns="36576" tIns="18288" bIns="18288">
-            <a:spAutoFit/>
-          </a:bodyPr>
-          <a:lstStyle/>
-          <a:p>
-            <a:pPr>
-              <a:lnSpc>
-                <a:spcPct val="95000"/>
-              </a:lnSpc>
-              <a:spcBef>
-                <a:spcPts val="0"/>
-              </a:spcBef>
-              <a:spcAft>
-                <a:spcPts val="0"/>
-              </a:spcAft>
-            </a:pPr>
-            <a:r>
-              <a:rPr sz="1500" b="1">
-                <a:solidFill>
-                  <a:srgbClr val="1F497D"/>
-                </a:solidFill>
-                <a:latin typeface="Arial"/>
-              </a:rPr>
-              <a:t>Proposed Solution</a:t>
-            </a:r>
-          </a:p>
-          <a:p>
-            <a:pPr>
-              <a:lnSpc>
-                <a:spcPct val="95000"/>
-              </a:lnSpc>
-              <a:spcBef>
-                <a:spcPts val="800"/>
-              </a:spcBef>
-              <a:spcAft>
-                <a:spcPts val="0"/>
-              </a:spcAft>
-            </a:pPr>
-            <a:r>
-              <a:rPr sz="1500" b="0">
-                <a:solidFill>
-                  <a:srgbClr val="262B33"/>
-                </a:solidFill>
-                <a:latin typeface="Arial"/>
-              </a:rPr>
-              <a:t>A fixed basket of routes, re-priced every 10 minutes, published as a price index — and as a plain answer for travellers: is today a good day to book?</a:t>
-            </a:r>
-          </a:p>
-        </p:txBody>
-      </p:sp>
-      <p:sp>
-        <p:nvSpPr>
-          <p:cNvPr id="15363" name="Rectangle 15362"/>
+          <p:cNvPr id="15362" name="Rounded Rectangle 15361"/>
           <p:cNvSpPr/>
           <p:nvPr/>
         </p:nvSpPr>
         <p:spPr>
           <a:xfrm>
-            <a:off x="429768" y="1408176"/>
-            <a:ext cx="1371600" cy="27432"/>
-          </a:xfrm>
-          <a:prstGeom prst="rect">
-            <a:avLst/>
+            <a:off x="411480" y="1115568"/>
+            <a:ext cx="5669280" cy="749808"/>
+          </a:xfrm>
+          <a:prstGeom prst="roundRect">
+            <a:avLst>
+              <a:gd name="adj" fmla="val 6000"/>
+            </a:avLst>
           </a:prstGeom>
           <a:solidFill>
-            <a:srgbClr val="4F81BD"/>
+            <a:srgbClr val="DCE6F1"/>
           </a:solidFill>
           <a:ln>
             <a:noFill/>
@@ -6309,68 +6244,131 @@
           </a:fontRef>
         </p:style>
         <p:txBody>
-          <a:bodyPr rtlCol="0" anchor="ctr"/>
+          <a:bodyPr rtlCol="0" anchor="ctr" wrap="square" lIns="36576" rIns="36576" tIns="18288" bIns="18288"/>
           <a:lstStyle/>
           <a:p>
-            <a:pPr algn="ctr"/>
-          </a:p>
-        </p:txBody>
-      </p:sp>
-      <p:sp>
-        <p:nvSpPr>
-          <p:cNvPr id="15364" name="TextBox 15363"/>
-          <p:cNvSpPr txBox="1"/>
-          <p:nvPr/>
-        </p:nvSpPr>
-        <p:spPr>
-          <a:xfrm>
-            <a:off x="411480" y="2670048"/>
-            <a:ext cx="5669280" cy="274320"/>
-          </a:xfrm>
-          <a:prstGeom prst="rect">
-            <a:avLst/>
-          </a:prstGeom>
-          <a:noFill/>
-        </p:spPr>
-        <p:txBody>
-          <a:bodyPr wrap="square" lIns="36576" rIns="36576" tIns="18288" bIns="18288">
-            <a:spAutoFit/>
-          </a:bodyPr>
-          <a:lstStyle/>
+            <a:pPr algn="ctr">
+              <a:lnSpc>
+                <a:spcPct val="95000"/>
+              </a:lnSpc>
+              <a:spcBef>
+                <a:spcPts val="0"/>
+              </a:spcBef>
+              <a:spcAft>
+                <a:spcPts val="0"/>
+              </a:spcAft>
+            </a:pPr>
+            <a:r>
+              <a:rPr sz="1100" b="1">
+                <a:solidFill>
+                  <a:srgbClr val="1F497D"/>
+                </a:solidFill>
+                <a:latin typeface="Arial"/>
+              </a:rPr>
+              <a:t>THE PROBLEM</a:t>
+            </a:r>
+          </a:p>
           <a:p>
             <a:pPr>
               <a:lnSpc>
                 <a:spcPct val="95000"/>
               </a:lnSpc>
               <a:spcBef>
-                <a:spcPts val="0"/>
+                <a:spcPts val="400"/>
               </a:spcBef>
               <a:spcAft>
                 <a:spcPts val="0"/>
               </a:spcAft>
             </a:pPr>
             <a:r>
-              <a:rPr sz="1400" b="1">
-                <a:solidFill>
-                  <a:srgbClr val="1F497D"/>
+              <a:rPr sz="1400" b="0">
+                <a:solidFill>
+                  <a:srgbClr val="262B33"/>
                 </a:solidFill>
                 <a:latin typeface="Arial"/>
               </a:rPr>
-              <a:t>How it addresses the problem</a:t>
-            </a:r>
-          </a:p>
-        </p:txBody>
-      </p:sp>
-      <p:sp>
-        <p:nvSpPr>
-          <p:cNvPr id="15365" name="Rectangle 15364"/>
+              <a:t>CPI prices air travel from occasional manual quotes — but an airfare is not one price. It depends on when you book.</a:t>
+            </a:r>
+          </a:p>
+        </p:txBody>
+      </p:sp>
+      <p:sp>
+        <p:nvSpPr>
+          <p:cNvPr id="15363" name="TextBox 15362"/>
+          <p:cNvSpPr txBox="1"/>
+          <p:nvPr/>
+        </p:nvSpPr>
+        <p:spPr>
+          <a:xfrm>
+            <a:off x="411480" y="2066543"/>
+            <a:ext cx="5669280" cy="1280160"/>
+          </a:xfrm>
+          <a:prstGeom prst="rect">
+            <a:avLst/>
+          </a:prstGeom>
+          <a:noFill/>
+        </p:spPr>
+        <p:txBody>
+          <a:bodyPr wrap="square" lIns="36576" rIns="36576" tIns="18288" bIns="18288">
+            <a:spAutoFit/>
+          </a:bodyPr>
+          <a:lstStyle/>
+          <a:p>
+            <a:pPr>
+              <a:lnSpc>
+                <a:spcPct val="95000"/>
+              </a:lnSpc>
+              <a:spcBef>
+                <a:spcPts val="0"/>
+              </a:spcBef>
+              <a:spcAft>
+                <a:spcPts val="0"/>
+              </a:spcAft>
+            </a:pPr>
+            <a:r>
+              <a:rPr sz="1500" b="1">
+                <a:solidFill>
+                  <a:srgbClr val="1F497D"/>
+                </a:solidFill>
+                <a:latin typeface="Arial"/>
+              </a:rPr>
+              <a:t>Proposed Solution</a:t>
+            </a:r>
+          </a:p>
+          <a:p>
+            <a:pPr>
+              <a:lnSpc>
+                <a:spcPct val="95000"/>
+              </a:lnSpc>
+              <a:spcBef>
+                <a:spcPts val="800"/>
+              </a:spcBef>
+              <a:spcAft>
+                <a:spcPts val="0"/>
+              </a:spcAft>
+            </a:pPr>
+            <a:r>
+              <a:rPr sz="1500" b="0">
+                <a:solidFill>
+                  <a:srgbClr val="262B33"/>
+                </a:solidFill>
+                <a:latin typeface="Arial"/>
+              </a:rPr>
+              <a:t>A fixed basket of routes, re-priced every 10 minutes, published as a price index — and as a plain answer for travellers: is today a good day to book?</a:t>
+            </a:r>
+          </a:p>
+        </p:txBody>
+      </p:sp>
+      <p:sp>
+        <p:nvSpPr>
+          <p:cNvPr id="15364" name="Rectangle 15363"/>
           <p:cNvSpPr/>
           <p:nvPr/>
         </p:nvSpPr>
         <p:spPr>
           <a:xfrm>
-            <a:off x="429768" y="2944368"/>
-            <a:ext cx="1371600" cy="25603"/>
+            <a:off x="429768" y="2340864"/>
+            <a:ext cx="1371600" cy="27432"/>
           </a:xfrm>
           <a:prstGeom prst="rect">
             <a:avLst/>
@@ -6407,14 +6405,14 @@
       </p:sp>
       <p:sp>
         <p:nvSpPr>
-          <p:cNvPr id="15366" name="TextBox 15365"/>
+          <p:cNvPr id="15365" name="TextBox 15364"/>
           <p:cNvSpPr txBox="1"/>
           <p:nvPr/>
         </p:nvSpPr>
         <p:spPr>
           <a:xfrm>
-            <a:off x="411480" y="3063240"/>
-            <a:ext cx="5669280" cy="1051560"/>
+            <a:off x="411480" y="3584448"/>
+            <a:ext cx="5669280" cy="274320"/>
           </a:xfrm>
           <a:prstGeom prst="rect">
             <a:avLst/>
@@ -6439,95 +6437,6 @@
               </a:spcAft>
             </a:pPr>
             <a:r>
-              <a:rPr sz="1400" b="0">
-                <a:solidFill>
-                  <a:srgbClr val="262B33"/>
-                </a:solidFill>
-                <a:latin typeface="Arial"/>
-              </a:rPr>
-              <a:t>•  CPI prices air travel from manual quotes.</a:t>
-            </a:r>
-          </a:p>
-          <a:p>
-            <a:pPr>
-              <a:lnSpc>
-                <a:spcPct val="95000"/>
-              </a:lnSpc>
-              <a:spcBef>
-                <a:spcPts val="900"/>
-              </a:spcBef>
-              <a:spcAft>
-                <a:spcPts val="0"/>
-              </a:spcAft>
-            </a:pPr>
-            <a:r>
-              <a:rPr sz="1400" b="0">
-                <a:solidFill>
-                  <a:srgbClr val="262B33"/>
-                </a:solidFill>
-                <a:latin typeface="Arial"/>
-              </a:rPr>
-              <a:t>•  A fare depends on how early you book.</a:t>
-            </a:r>
-          </a:p>
-          <a:p>
-            <a:pPr>
-              <a:lnSpc>
-                <a:spcPct val="95000"/>
-              </a:lnSpc>
-              <a:spcBef>
-                <a:spcPts val="900"/>
-              </a:spcBef>
-              <a:spcAft>
-                <a:spcPts val="0"/>
-              </a:spcAft>
-            </a:pPr>
-            <a:r>
-              <a:rPr sz="1400" b="0">
-                <a:solidFill>
-                  <a:srgbClr val="262B33"/>
-                </a:solidFill>
-                <a:latin typeface="Arial"/>
-              </a:rPr>
-              <a:t>•  Same basket, same lead times, every day.</a:t>
-            </a:r>
-          </a:p>
-        </p:txBody>
-      </p:sp>
-      <p:sp>
-        <p:nvSpPr>
-          <p:cNvPr id="15367" name="TextBox 15366"/>
-          <p:cNvSpPr txBox="1"/>
-          <p:nvPr/>
-        </p:nvSpPr>
-        <p:spPr>
-          <a:xfrm>
-            <a:off x="411480" y="4315968"/>
-            <a:ext cx="5669280" cy="274320"/>
-          </a:xfrm>
-          <a:prstGeom prst="rect">
-            <a:avLst/>
-          </a:prstGeom>
-          <a:noFill/>
-        </p:spPr>
-        <p:txBody>
-          <a:bodyPr wrap="square" lIns="36576" rIns="36576" tIns="18288" bIns="18288">
-            <a:spAutoFit/>
-          </a:bodyPr>
-          <a:lstStyle/>
-          <a:p>
-            <a:pPr>
-              <a:lnSpc>
-                <a:spcPct val="95000"/>
-              </a:lnSpc>
-              <a:spcBef>
-                <a:spcPts val="0"/>
-              </a:spcBef>
-              <a:spcAft>
-                <a:spcPts val="0"/>
-              </a:spcAft>
-            </a:pPr>
-            <a:r>
               <a:rPr sz="1400" b="1">
                 <a:solidFill>
                   <a:srgbClr val="1F497D"/>
@@ -6541,13 +6450,13 @@
       </p:sp>
       <p:sp>
         <p:nvSpPr>
-          <p:cNvPr id="15368" name="Rectangle 15367"/>
+          <p:cNvPr id="15366" name="Rectangle 15365"/>
           <p:cNvSpPr/>
           <p:nvPr/>
         </p:nvSpPr>
         <p:spPr>
           <a:xfrm>
-            <a:off x="429768" y="4590288"/>
+            <a:off x="429768" y="3858768"/>
             <a:ext cx="1371600" cy="25603"/>
           </a:xfrm>
           <a:prstGeom prst="rect">
@@ -6585,14 +6494,14 @@
       </p:sp>
       <p:sp>
         <p:nvSpPr>
-          <p:cNvPr id="15369" name="TextBox 15368"/>
+          <p:cNvPr id="15367" name="TextBox 15366"/>
           <p:cNvSpPr txBox="1"/>
           <p:nvPr/>
         </p:nvSpPr>
         <p:spPr>
           <a:xfrm>
-            <a:off x="411480" y="4709160"/>
-            <a:ext cx="5669280" cy="1051560"/>
+            <a:off x="411480" y="3977639"/>
+            <a:ext cx="5669280" cy="1737360"/>
           </a:xfrm>
           <a:prstGeom prst="rect">
             <a:avLst/>
@@ -6632,7 +6541,7 @@
                 <a:spcPct val="95000"/>
               </a:lnSpc>
               <a:spcBef>
-                <a:spcPts val="900"/>
+                <a:spcPts val="1000"/>
               </a:spcBef>
               <a:spcAft>
                 <a:spcPts val="0"/>
@@ -6654,7 +6563,7 @@
                 <a:spcPct val="95000"/>
               </a:lnSpc>
               <a:spcBef>
-                <a:spcPts val="900"/>
+                <a:spcPts val="1000"/>
               </a:spcBef>
               <a:spcAft>
                 <a:spcPts val="0"/>
@@ -6667,14 +6576,101 @@
                 </a:solidFill>
                 <a:latin typeface="Arial"/>
               </a:rPr>
-              <a:t>•  Robots-checked before every fetch.</a:t>
+              <a:t>•  Robots-checked before every single fetch.</a:t>
+            </a:r>
+          </a:p>
+          <a:p>
+            <a:pPr>
+              <a:lnSpc>
+                <a:spcPct val="95000"/>
+              </a:lnSpc>
+              <a:spcBef>
+                <a:spcPts val="1000"/>
+              </a:spcBef>
+              <a:spcAft>
+                <a:spcPts val="0"/>
+              </a:spcAft>
+            </a:pPr>
+            <a:r>
+              <a:rPr sz="1400" b="0">
+                <a:solidFill>
+                  <a:srgbClr val="262B33"/>
+                </a:solidFill>
+                <a:latin typeface="Arial"/>
+              </a:rPr>
+              <a:t>•  Never estimates: unpublished fields stay NULL.</a:t>
+            </a:r>
+          </a:p>
+        </p:txBody>
+      </p:sp>
+      <p:sp>
+        <p:nvSpPr>
+          <p:cNvPr id="15368" name="Rounded Rectangle 15367"/>
+          <p:cNvSpPr/>
+          <p:nvPr/>
+        </p:nvSpPr>
+        <p:spPr>
+          <a:xfrm>
+            <a:off x="411480" y="5532120"/>
+            <a:ext cx="5669280" cy="658368"/>
+          </a:xfrm>
+          <a:prstGeom prst="roundRect">
+            <a:avLst>
+              <a:gd name="adj" fmla="val 6000"/>
+            </a:avLst>
+          </a:prstGeom>
+          <a:solidFill>
+            <a:srgbClr val="DCE6F1"/>
+          </a:solidFill>
+          <a:ln>
+            <a:noFill/>
+          </a:ln>
+          <a:effectLst/>
+        </p:spPr>
+        <p:style>
+          <a:lnRef idx="1">
+            <a:schemeClr val="accent1"/>
+          </a:lnRef>
+          <a:fillRef idx="3">
+            <a:schemeClr val="accent1"/>
+          </a:fillRef>
+          <a:effectRef idx="2">
+            <a:schemeClr val="accent1"/>
+          </a:effectRef>
+          <a:fontRef idx="minor">
+            <a:schemeClr val="lt1"/>
+          </a:fontRef>
+        </p:style>
+        <p:txBody>
+          <a:bodyPr rtlCol="0" anchor="ctr" wrap="square" lIns="36576" rIns="36576" tIns="18288" bIns="18288"/>
+          <a:lstStyle/>
+          <a:p>
+            <a:pPr algn="ctr">
+              <a:lnSpc>
+                <a:spcPct val="95000"/>
+              </a:lnSpc>
+              <a:spcBef>
+                <a:spcPts val="0"/>
+              </a:spcBef>
+              <a:spcAft>
+                <a:spcPts val="0"/>
+              </a:spcAft>
+            </a:pPr>
+            <a:r>
+              <a:rPr sz="1300" b="1">
+                <a:solidFill>
+                  <a:srgbClr val="1F497D"/>
+                </a:solidFill>
+                <a:latin typeface="Arial"/>
+              </a:rPr>
+              <a:t>RUNNING NOW  ·  2,342 fares  ·  6 routes × 5 windows  ·  every 10 minutes</a:t>
             </a:r>
           </a:p>
         </p:txBody>
       </p:sp>
       <p:pic>
         <p:nvPicPr>
-          <p:cNvPr id="15370" name="Picture 15369" descr="chart-curve.png"/>
+          <p:cNvPr id="15369" name="Picture 15368" descr="chart-curve.png"/>
           <p:cNvPicPr>
             <a:picLocks noChangeAspect="1"/>
           </p:cNvPicPr>
@@ -6698,14 +6694,14 @@
       </p:pic>
       <p:sp>
         <p:nvSpPr>
-          <p:cNvPr id="15371" name="TextBox 15370"/>
+          <p:cNvPr id="15370" name="TextBox 15369"/>
           <p:cNvSpPr txBox="1"/>
           <p:nvPr/>
         </p:nvSpPr>
         <p:spPr>
           <a:xfrm>
-            <a:off x="6400800" y="5138928"/>
-            <a:ext cx="5394960" cy="822960"/>
+            <a:off x="6400800" y="5102352"/>
+            <a:ext cx="5394960" cy="1051560"/>
           </a:xfrm>
           <a:prstGeom prst="rect">
             <a:avLst/>
@@ -6730,13 +6726,13 @@
               </a:spcAft>
             </a:pPr>
             <a:r>
-              <a:rPr sz="1300" b="1">
+              <a:rPr sz="1350" b="1">
                 <a:solidFill>
                   <a:srgbClr val="1F497D"/>
                 </a:solidFill>
                 <a:latin typeface="Arial"/>
               </a:rPr>
-              <a:t>Real fares, collected 1 Sep 2026.</a:t>
+              <a:t>Real fares from our own scraper.</a:t>
             </a:r>
           </a:p>
           <a:p>
@@ -6758,7 +6754,7 @@
                 </a:solidFill>
                 <a:latin typeface="Arial"/>
               </a:rPr>
-              <a:t>Booking a month ahead saves 40% on BLR–HYD and 2% on DEL–BOM. That spread is the finding — and the reason to measure.</a:t>
+              <a:t>Booking a month ahead saves 40% on BLR–HYD and nothing at all on DEL–BOM. Nobody publishes that spread — which is exactly why it has to be measured rather than assumed.</a:t>
             </a:r>
           </a:p>
         </p:txBody>
@@ -8095,7 +8091,7 @@
                 </a:solidFill>
                 <a:latin typeface="Arial"/>
               </a:rPr>
-              <a:t>1,000+ live fares in Postgres · 6 routes × 5 booking windows · zero failed extractions on the last full run · public dashboard reading the database directly.</a:t>
+              <a:t>2,342 live fares in Postgres · 14 scheduled runs · zero failed extractions · a public dashboard reading the database on every load.</a:t>
             </a:r>
           </a:p>
         </p:txBody>
@@ -8943,7 +8939,7 @@
         <p:spPr>
           <a:xfrm>
             <a:off x="411480" y="1554480"/>
-            <a:ext cx="5486400" cy="2011680"/>
+            <a:ext cx="5486400" cy="1828800"/>
           </a:xfrm>
           <a:prstGeom prst="rect">
             <a:avLst/>
@@ -8974,7 +8970,7 @@
                 </a:solidFill>
                 <a:latin typeface="Arial"/>
               </a:rPr>
-              <a:t>•  A working prototype exists and is collecting now.</a:t>
+              <a:t>•  A working prototype, collecting right now.</a:t>
             </a:r>
           </a:p>
           <a:p>
@@ -8983,7 +8979,7 @@
                 <a:spcPct val="95000"/>
               </a:lnSpc>
               <a:spcBef>
-                <a:spcPts val="1000"/>
+                <a:spcPts val="900"/>
               </a:spcBef>
               <a:spcAft>
                 <a:spcPts val="0"/>
@@ -9005,7 +9001,7 @@
                 <a:spcPct val="95000"/>
               </a:lnSpc>
               <a:spcBef>
-                <a:spcPts val="1000"/>
+                <a:spcPts val="900"/>
               </a:spcBef>
               <a:spcAft>
                 <a:spcPts val="0"/>
@@ -9027,7 +9023,7 @@
                 <a:spcPct val="95000"/>
               </a:lnSpc>
               <a:spcBef>
-                <a:spcPts val="1000"/>
+                <a:spcPts val="900"/>
               </a:spcBef>
               <a:spcAft>
                 <a:spcPts val="0"/>
@@ -9053,8 +9049,8 @@
         </p:nvSpPr>
         <p:spPr>
           <a:xfrm>
-            <a:off x="411480" y="3794760"/>
-            <a:ext cx="5486400" cy="1051560"/>
+            <a:off x="411480" y="3611880"/>
+            <a:ext cx="5486400" cy="868680"/>
           </a:xfrm>
           <a:prstGeom prst="roundRect">
             <a:avLst>
@@ -9121,20 +9117,44 @@
               </a:spcAft>
             </a:pPr>
             <a:r>
-              <a:rPr sz="1350" b="0">
+              <a:rPr sz="1300" b="0">
                 <a:solidFill>
                   <a:srgbClr val="262B33"/>
                 </a:solidFill>
                 <a:latin typeface="Arial"/>
               </a:rPr>
-              <a:t>periodic → every 10 minutes   ·   one quoted price → 5 lead times   ·   field records → URL, timestamp and model stored per fare</a:t>
-            </a:r>
-          </a:p>
-        </p:txBody>
-      </p:sp>
-      <p:sp>
-        <p:nvSpPr>
-          <p:cNvPr id="17414" name="TextBox 17413"/>
+              <a:t>periodic → every 10 minutes  ·  one quoted price → 5 lead times  ·  field notes → URL, timestamp and model stored per fare</a:t>
+            </a:r>
+          </a:p>
+        </p:txBody>
+      </p:sp>
+      <p:pic>
+        <p:nvPicPr>
+          <p:cNvPr id="17414" name="Picture 17413" descr="chart-carriers.png"/>
+          <p:cNvPicPr>
+            <a:picLocks noChangeAspect="1"/>
+          </p:cNvPicPr>
+          <p:nvPr/>
+        </p:nvPicPr>
+        <p:blipFill>
+          <a:blip r:embed="rId4"/>
+          <a:stretch>
+            <a:fillRect/>
+          </a:stretch>
+        </p:blipFill>
+        <p:spPr>
+          <a:xfrm>
+            <a:off x="411480" y="4645152"/>
+            <a:ext cx="5486400" cy="1498488"/>
+          </a:xfrm>
+          <a:prstGeom prst="rect">
+            <a:avLst/>
+          </a:prstGeom>
+        </p:spPr>
+      </p:pic>
+      <p:sp>
+        <p:nvSpPr>
+          <p:cNvPr id="17415" name="TextBox 17414"/>
           <p:cNvSpPr txBox="1"/>
           <p:nvPr/>
         </p:nvSpPr>
@@ -9179,7 +9199,7 @@
       </p:sp>
       <p:sp>
         <p:nvSpPr>
-          <p:cNvPr id="17415" name="Rectangle 17414"/>
+          <p:cNvPr id="17416" name="Rectangle 17415"/>
           <p:cNvSpPr/>
           <p:nvPr/>
         </p:nvSpPr>
@@ -9223,7 +9243,7 @@
       </p:sp>
       <p:sp>
         <p:nvSpPr>
-          <p:cNvPr id="17416" name="Rounded Rectangle 17415"/>
+          <p:cNvPr id="17417" name="Rounded Rectangle 17416"/>
           <p:cNvSpPr/>
           <p:nvPr/>
         </p:nvSpPr>
@@ -9271,7 +9291,7 @@
       </p:sp>
       <p:sp>
         <p:nvSpPr>
-          <p:cNvPr id="17417" name="Rectangle 17416"/>
+          <p:cNvPr id="17418" name="Rectangle 17417"/>
           <p:cNvSpPr/>
           <p:nvPr/>
         </p:nvSpPr>
@@ -9315,7 +9335,7 @@
       </p:sp>
       <p:sp>
         <p:nvSpPr>
-          <p:cNvPr id="17418" name="TextBox 17417"/>
+          <p:cNvPr id="17419" name="TextBox 17418"/>
           <p:cNvSpPr txBox="1"/>
           <p:nvPr/>
         </p:nvSpPr>
@@ -9382,7 +9402,7 @@
       </p:sp>
       <p:sp>
         <p:nvSpPr>
-          <p:cNvPr id="17419" name="Rounded Rectangle 17418"/>
+          <p:cNvPr id="17420" name="Rounded Rectangle 17419"/>
           <p:cNvSpPr/>
           <p:nvPr/>
         </p:nvSpPr>
@@ -9430,7 +9450,7 @@
       </p:sp>
       <p:sp>
         <p:nvSpPr>
-          <p:cNvPr id="17420" name="Rectangle 17419"/>
+          <p:cNvPr id="17421" name="Rectangle 17420"/>
           <p:cNvSpPr/>
           <p:nvPr/>
         </p:nvSpPr>
@@ -9474,7 +9494,7 @@
       </p:sp>
       <p:sp>
         <p:nvSpPr>
-          <p:cNvPr id="17421" name="TextBox 17420"/>
+          <p:cNvPr id="17422" name="TextBox 17421"/>
           <p:cNvSpPr txBox="1"/>
           <p:nvPr/>
         </p:nvSpPr>
@@ -9541,7 +9561,7 @@
       </p:sp>
       <p:sp>
         <p:nvSpPr>
-          <p:cNvPr id="17422" name="Rounded Rectangle 17421"/>
+          <p:cNvPr id="17423" name="Rounded Rectangle 17422"/>
           <p:cNvSpPr/>
           <p:nvPr/>
         </p:nvSpPr>
@@ -9589,7 +9609,7 @@
       </p:sp>
       <p:sp>
         <p:nvSpPr>
-          <p:cNvPr id="17423" name="Rectangle 17422"/>
+          <p:cNvPr id="17424" name="Rectangle 17423"/>
           <p:cNvSpPr/>
           <p:nvPr/>
         </p:nvSpPr>
@@ -9633,7 +9653,7 @@
       </p:sp>
       <p:sp>
         <p:nvSpPr>
-          <p:cNvPr id="17424" name="TextBox 17423"/>
+          <p:cNvPr id="17425" name="TextBox 17424"/>
           <p:cNvSpPr txBox="1"/>
           <p:nvPr/>
         </p:nvSpPr>
@@ -9700,7 +9720,7 @@
       </p:sp>
       <p:sp>
         <p:nvSpPr>
-          <p:cNvPr id="17425" name="Rounded Rectangle 17424"/>
+          <p:cNvPr id="17426" name="Rounded Rectangle 17425"/>
           <p:cNvSpPr/>
           <p:nvPr/>
         </p:nvSpPr>
@@ -9748,7 +9768,7 @@
       </p:sp>
       <p:sp>
         <p:nvSpPr>
-          <p:cNvPr id="17426" name="Rectangle 17425"/>
+          <p:cNvPr id="17427" name="Rectangle 17426"/>
           <p:cNvSpPr/>
           <p:nvPr/>
         </p:nvSpPr>
@@ -9792,7 +9812,7 @@
       </p:sp>
       <p:sp>
         <p:nvSpPr>
-          <p:cNvPr id="17427" name="TextBox 17426"/>
+          <p:cNvPr id="17428" name="TextBox 17427"/>
           <p:cNvSpPr txBox="1"/>
           <p:nvPr/>
         </p:nvSpPr>
@@ -10261,7 +10281,7 @@
         </p:nvSpPr>
         <p:spPr>
           <a:xfrm>
-            <a:off x="411480" y="4343400"/>
+            <a:off x="411480" y="4224528"/>
             <a:ext cx="5760720" cy="274320"/>
           </a:xfrm>
           <a:prstGeom prst="rect">
@@ -10306,7 +10326,7 @@
         </p:nvSpPr>
         <p:spPr>
           <a:xfrm>
-            <a:off x="429768" y="4617720"/>
+            <a:off x="429768" y="4498848"/>
             <a:ext cx="1371600" cy="25603"/>
           </a:xfrm>
           <a:prstGeom prst="rect">
@@ -10350,8 +10370,8 @@
         </p:nvSpPr>
         <p:spPr>
           <a:xfrm>
-            <a:off x="411480" y="4736592"/>
-            <a:ext cx="5760720" cy="1371600"/>
+            <a:off x="411480" y="4617720"/>
+            <a:ext cx="5760720" cy="1097280"/>
           </a:xfrm>
           <a:prstGeom prst="rect">
             <a:avLst/>
@@ -10433,65 +10453,22 @@
       </p:sp>
       <p:sp>
         <p:nvSpPr>
-          <p:cNvPr id="17414" name="TextBox 17413"/>
-          <p:cNvSpPr txBox="1"/>
-          <p:nvPr/>
-        </p:nvSpPr>
-        <p:spPr>
-          <a:xfrm>
-            <a:off x="6400800" y="1133856"/>
-            <a:ext cx="5394960" cy="274320"/>
-          </a:xfrm>
-          <a:prstGeom prst="rect">
-            <a:avLst/>
-          </a:prstGeom>
-          <a:noFill/>
-        </p:spPr>
-        <p:txBody>
-          <a:bodyPr wrap="square" lIns="36576" rIns="36576" tIns="18288" bIns="18288">
-            <a:spAutoFit/>
-          </a:bodyPr>
-          <a:lstStyle/>
-          <a:p>
-            <a:pPr>
-              <a:lnSpc>
-                <a:spcPct val="95000"/>
-              </a:lnSpc>
-              <a:spcBef>
-                <a:spcPts val="0"/>
-              </a:spcBef>
-              <a:spcAft>
-                <a:spcPts val="0"/>
-              </a:spcAft>
-            </a:pPr>
-            <a:r>
-              <a:rPr sz="1500" b="1">
-                <a:solidFill>
-                  <a:srgbClr val="1F497D"/>
-                </a:solidFill>
-                <a:latin typeface="Arial"/>
-              </a:rPr>
-              <a:t>What changes</a:t>
-            </a:r>
-          </a:p>
-        </p:txBody>
-      </p:sp>
-      <p:sp>
-        <p:nvSpPr>
-          <p:cNvPr id="17415" name="Rectangle 17414"/>
+          <p:cNvPr id="17414" name="Rounded Rectangle 17413"/>
           <p:cNvSpPr/>
           <p:nvPr/>
         </p:nvSpPr>
         <p:spPr>
           <a:xfrm>
-            <a:off x="6419088" y="1408176"/>
-            <a:ext cx="1371600" cy="25603"/>
-          </a:xfrm>
-          <a:prstGeom prst="rect">
-            <a:avLst/>
+            <a:off x="411480" y="5577840"/>
+            <a:ext cx="5760720" cy="658368"/>
+          </a:xfrm>
+          <a:prstGeom prst="roundRect">
+            <a:avLst>
+              <a:gd name="adj" fmla="val 6000"/>
+            </a:avLst>
           </a:prstGeom>
           <a:solidFill>
-            <a:srgbClr val="4F81BD"/>
+            <a:srgbClr val="DCE6F1"/>
           </a:solidFill>
           <a:ln>
             <a:noFill/>
@@ -10513,6 +10490,136 @@
           </a:fontRef>
         </p:style>
         <p:txBody>
+          <a:bodyPr rtlCol="0" anchor="ctr" wrap="square" lIns="36576" rIns="36576" tIns="18288" bIns="18288"/>
+          <a:lstStyle/>
+          <a:p>
+            <a:pPr algn="ctr">
+              <a:lnSpc>
+                <a:spcPct val="95000"/>
+              </a:lnSpc>
+              <a:spcBef>
+                <a:spcPts val="0"/>
+              </a:spcBef>
+              <a:spcAft>
+                <a:spcPts val="0"/>
+              </a:spcAft>
+            </a:pPr>
+            <a:r>
+              <a:rPr sz="1100" b="1">
+                <a:solidFill>
+                  <a:srgbClr val="1F497D"/>
+                </a:solidFill>
+                <a:latin typeface="Arial"/>
+              </a:rPr>
+              <a:t>NEXT</a:t>
+            </a:r>
+          </a:p>
+          <a:p>
+            <a:pPr>
+              <a:lnSpc>
+                <a:spcPct val="95000"/>
+              </a:lnSpc>
+              <a:spcBef>
+                <a:spcPts val="300"/>
+              </a:spcBef>
+              <a:spcAft>
+                <a:spcPts val="0"/>
+              </a:spcAft>
+            </a:pPr>
+            <a:r>
+              <a:rPr sz="1300" b="0">
+                <a:solidFill>
+                  <a:srgbClr val="262B33"/>
+                </a:solidFill>
+                <a:latin typeface="Arial"/>
+              </a:rPr>
+              <a:t>More city pairs, a second permitted portal, and rail and bus on the same pipeline.</a:t>
+            </a:r>
+          </a:p>
+        </p:txBody>
+      </p:sp>
+      <p:sp>
+        <p:nvSpPr>
+          <p:cNvPr id="17415" name="TextBox 17414"/>
+          <p:cNvSpPr txBox="1"/>
+          <p:nvPr/>
+        </p:nvSpPr>
+        <p:spPr>
+          <a:xfrm>
+            <a:off x="6400800" y="1133856"/>
+            <a:ext cx="5394960" cy="274320"/>
+          </a:xfrm>
+          <a:prstGeom prst="rect">
+            <a:avLst/>
+          </a:prstGeom>
+          <a:noFill/>
+        </p:spPr>
+        <p:txBody>
+          <a:bodyPr wrap="square" lIns="36576" rIns="36576" tIns="18288" bIns="18288">
+            <a:spAutoFit/>
+          </a:bodyPr>
+          <a:lstStyle/>
+          <a:p>
+            <a:pPr>
+              <a:lnSpc>
+                <a:spcPct val="95000"/>
+              </a:lnSpc>
+              <a:spcBef>
+                <a:spcPts val="0"/>
+              </a:spcBef>
+              <a:spcAft>
+                <a:spcPts val="0"/>
+              </a:spcAft>
+            </a:pPr>
+            <a:r>
+              <a:rPr sz="1500" b="1">
+                <a:solidFill>
+                  <a:srgbClr val="1F497D"/>
+                </a:solidFill>
+                <a:latin typeface="Arial"/>
+              </a:rPr>
+              <a:t>What changes</a:t>
+            </a:r>
+          </a:p>
+        </p:txBody>
+      </p:sp>
+      <p:sp>
+        <p:nvSpPr>
+          <p:cNvPr id="17416" name="Rectangle 17415"/>
+          <p:cNvSpPr/>
+          <p:nvPr/>
+        </p:nvSpPr>
+        <p:spPr>
+          <a:xfrm>
+            <a:off x="6419088" y="1408176"/>
+            <a:ext cx="1371600" cy="25603"/>
+          </a:xfrm>
+          <a:prstGeom prst="rect">
+            <a:avLst/>
+          </a:prstGeom>
+          <a:solidFill>
+            <a:srgbClr val="4F81BD"/>
+          </a:solidFill>
+          <a:ln>
+            <a:noFill/>
+          </a:ln>
+          <a:effectLst/>
+        </p:spPr>
+        <p:style>
+          <a:lnRef idx="1">
+            <a:schemeClr val="accent1"/>
+          </a:lnRef>
+          <a:fillRef idx="3">
+            <a:schemeClr val="accent1"/>
+          </a:fillRef>
+          <a:effectRef idx="2">
+            <a:schemeClr val="accent1"/>
+          </a:effectRef>
+          <a:fontRef idx="minor">
+            <a:schemeClr val="lt1"/>
+          </a:fontRef>
+        </p:style>
+        <p:txBody>
           <a:bodyPr rtlCol="0" anchor="ctr"/>
           <a:lstStyle/>
           <a:p>
@@ -10522,7 +10629,7 @@
       </p:sp>
       <p:sp>
         <p:nvSpPr>
-          <p:cNvPr id="17416" name="TextBox 17415"/>
+          <p:cNvPr id="17417" name="TextBox 17416"/>
           <p:cNvSpPr txBox="1"/>
           <p:nvPr/>
         </p:nvSpPr>
@@ -10611,7 +10718,7 @@
       </p:sp>
       <p:pic>
         <p:nvPicPr>
-          <p:cNvPr id="17417" name="Picture 17416" descr="dash-live.png"/>
+          <p:cNvPr id="17418" name="Picture 17417" descr="dash-live.png"/>
           <p:cNvPicPr>
             <a:picLocks noChangeAspect="1"/>
           </p:cNvPicPr>
@@ -10635,7 +10742,7 @@
       </p:pic>
       <p:sp>
         <p:nvSpPr>
-          <p:cNvPr id="17418" name="TextBox 17417"/>
+          <p:cNvPr id="17419" name="TextBox 17418"/>
           <p:cNvSpPr txBox="1"/>
           <p:nvPr/>
         </p:nvSpPr>

</xml_diff>

<commit_message>
Real countdown, cleaner header, intraday view, two new deck figures
Dashboard
- the header's 'next in 1h 56m' was a hardcoded string; it now computes
  from the last run plus the 10-minute cadence and ticks every second
- removed the model id and the basket blurb from the header
- fares_hourly view added: collection runs every 10 minutes but the daily
  rollup plotted two days as two points, hiding all of it. The index chart
  uses intraday buckets when the view exists and falls back when it does not

Deck
- schematic map of the six city pairs, and one real stored fare with every
  field shown — an outside reader can now see what is collected
- 669 words across six slides, nothing below 13pt

Co-Authored-By: Claude Opus 5 <noreply@anthropic.com>
Claude-Session: https://claude.ai/code/session_0129UjVhHMAVJgfcaxoN1dD5
</commit_message>
<xml_diff>
--- a/SIH26056-Idea-Presentation.pptx
+++ b/SIH26056-Idea-Presentation.pptx
@@ -6354,7 +6354,7 @@
                 </a:solidFill>
                 <a:latin typeface="Arial"/>
               </a:rPr>
-              <a:t>A fixed basket of routes, re-priced every 10 minutes, published as a price index — and as a plain answer for travellers: is today a good day to book?</a:t>
+              <a:t>A fixed basket of routes, re-priced every 10 minutes and published as a price index.</a:t>
             </a:r>
           </a:p>
         </p:txBody>
@@ -6403,16 +6403,64 @@
           </a:p>
         </p:txBody>
       </p:sp>
-      <p:sp>
-        <p:nvSpPr>
-          <p:cNvPr id="15365" name="TextBox 15364"/>
+      <p:pic>
+        <p:nvPicPr>
+          <p:cNvPr id="15365" name="Picture 15364" descr="chart-map.png"/>
+          <p:cNvPicPr>
+            <a:picLocks noChangeAspect="1"/>
+          </p:cNvPicPr>
+          <p:nvPr/>
+        </p:nvPicPr>
+        <p:blipFill>
+          <a:blip r:embed="rId4"/>
+          <a:stretch>
+            <a:fillRect/>
+          </a:stretch>
+        </p:blipFill>
+        <p:spPr>
+          <a:xfrm>
+            <a:off x="411480" y="3063240"/>
+            <a:ext cx="5257800" cy="2930577"/>
+          </a:xfrm>
+          <a:prstGeom prst="rect">
+            <a:avLst/>
+          </a:prstGeom>
+        </p:spPr>
+      </p:pic>
+      <p:pic>
+        <p:nvPicPr>
+          <p:cNvPr id="15366" name="Picture 15365" descr="chart-curve.png"/>
+          <p:cNvPicPr>
+            <a:picLocks noChangeAspect="1"/>
+          </p:cNvPicPr>
+          <p:nvPr/>
+        </p:nvPicPr>
+        <p:blipFill>
+          <a:blip r:embed="rId5"/>
+          <a:stretch>
+            <a:fillRect/>
+          </a:stretch>
+        </p:blipFill>
+        <p:spPr>
+          <a:xfrm>
+            <a:off x="6400800" y="1133856"/>
+            <a:ext cx="5394960" cy="2624057"/>
+          </a:xfrm>
+          <a:prstGeom prst="rect">
+            <a:avLst/>
+          </a:prstGeom>
+        </p:spPr>
+      </p:pic>
+      <p:sp>
+        <p:nvSpPr>
+          <p:cNvPr id="15367" name="TextBox 15366"/>
           <p:cNvSpPr txBox="1"/>
           <p:nvPr/>
         </p:nvSpPr>
         <p:spPr>
           <a:xfrm>
-            <a:off x="411480" y="3584448"/>
-            <a:ext cx="5669280" cy="274320"/>
+            <a:off x="6400800" y="4224528"/>
+            <a:ext cx="5394960" cy="777240"/>
           </a:xfrm>
           <a:prstGeom prst="rect">
             <a:avLst/>
@@ -6437,6 +6485,73 @@
               </a:spcAft>
             </a:pPr>
             <a:r>
+              <a:rPr sz="1350" b="1">
+                <a:solidFill>
+                  <a:srgbClr val="1F497D"/>
+                </a:solidFill>
+                <a:latin typeface="Arial"/>
+              </a:rPr>
+              <a:t>Real fares from our own scraper.</a:t>
+            </a:r>
+          </a:p>
+          <a:p>
+            <a:pPr>
+              <a:lnSpc>
+                <a:spcPct val="95000"/>
+              </a:lnSpc>
+              <a:spcBef>
+                <a:spcPts val="400"/>
+              </a:spcBef>
+              <a:spcAft>
+                <a:spcPts val="0"/>
+              </a:spcAft>
+            </a:pPr>
+            <a:r>
+              <a:rPr sz="1300" b="0">
+                <a:solidFill>
+                  <a:srgbClr val="5A626C"/>
+                </a:solidFill>
+                <a:latin typeface="Arial"/>
+              </a:rPr>
+              <a:t>Booking a month ahead saves 40% on BLR–HYD and nothing on DEL–BOM. Nobody publishes that spread — so it has to be measured.</a:t>
+            </a:r>
+          </a:p>
+        </p:txBody>
+      </p:sp>
+      <p:sp>
+        <p:nvSpPr>
+          <p:cNvPr id="15368" name="TextBox 15367"/>
+          <p:cNvSpPr txBox="1"/>
+          <p:nvPr/>
+        </p:nvSpPr>
+        <p:spPr>
+          <a:xfrm>
+            <a:off x="6400800" y="5102352"/>
+            <a:ext cx="5394960" cy="274320"/>
+          </a:xfrm>
+          <a:prstGeom prst="rect">
+            <a:avLst/>
+          </a:prstGeom>
+          <a:noFill/>
+        </p:spPr>
+        <p:txBody>
+          <a:bodyPr wrap="square" lIns="36576" rIns="36576" tIns="18288" bIns="18288">
+            <a:spAutoFit/>
+          </a:bodyPr>
+          <a:lstStyle/>
+          <a:p>
+            <a:pPr>
+              <a:lnSpc>
+                <a:spcPct val="95000"/>
+              </a:lnSpc>
+              <a:spcBef>
+                <a:spcPts val="0"/>
+              </a:spcBef>
+              <a:spcAft>
+                <a:spcPts val="0"/>
+              </a:spcAft>
+            </a:pPr>
+            <a:r>
               <a:rPr sz="1400" b="1">
                 <a:solidFill>
                   <a:srgbClr val="1F497D"/>
@@ -6450,13 +6565,13 @@
       </p:sp>
       <p:sp>
         <p:nvSpPr>
-          <p:cNvPr id="15366" name="Rectangle 15365"/>
+          <p:cNvPr id="15369" name="Rectangle 15368"/>
           <p:cNvSpPr/>
           <p:nvPr/>
         </p:nvSpPr>
         <p:spPr>
           <a:xfrm>
-            <a:off x="429768" y="3858768"/>
+            <a:off x="6419088" y="5376672"/>
             <a:ext cx="1371600" cy="25603"/>
           </a:xfrm>
           <a:prstGeom prst="rect">
@@ -6494,14 +6609,14 @@
       </p:sp>
       <p:sp>
         <p:nvSpPr>
-          <p:cNvPr id="15367" name="TextBox 15366"/>
+          <p:cNvPr id="15370" name="TextBox 15369"/>
           <p:cNvSpPr txBox="1"/>
           <p:nvPr/>
         </p:nvSpPr>
         <p:spPr>
           <a:xfrm>
-            <a:off x="411480" y="3977639"/>
-            <a:ext cx="5669280" cy="1737360"/>
+            <a:off x="6400800" y="5486400"/>
+            <a:ext cx="5394960" cy="731520"/>
           </a:xfrm>
           <a:prstGeom prst="rect">
             <a:avLst/>
@@ -6526,7 +6641,7 @@
               </a:spcAft>
             </a:pPr>
             <a:r>
-              <a:rPr sz="1400" b="0">
+              <a:rPr sz="1300" b="0">
                 <a:solidFill>
                   <a:srgbClr val="262B33"/>
                 </a:solidFill>
@@ -6541,220 +6656,20 @@
                 <a:spcPct val="95000"/>
               </a:lnSpc>
               <a:spcBef>
-                <a:spcPts val="1000"/>
+                <a:spcPts val="600"/>
               </a:spcBef>
               <a:spcAft>
                 <a:spcPts val="0"/>
               </a:spcAft>
             </a:pPr>
             <a:r>
-              <a:rPr sz="1400" b="0">
+              <a:rPr sz="1300" b="0">
                 <a:solidFill>
                   <a:srgbClr val="262B33"/>
                 </a:solidFill>
                 <a:latin typeface="Arial"/>
               </a:rPr>
-              <a:t>•  The model is config — it fails over when one dies.</a:t>
-            </a:r>
-          </a:p>
-          <a:p>
-            <a:pPr>
-              <a:lnSpc>
-                <a:spcPct val="95000"/>
-              </a:lnSpc>
-              <a:spcBef>
-                <a:spcPts val="1000"/>
-              </a:spcBef>
-              <a:spcAft>
-                <a:spcPts val="0"/>
-              </a:spcAft>
-            </a:pPr>
-            <a:r>
-              <a:rPr sz="1400" b="0">
-                <a:solidFill>
-                  <a:srgbClr val="262B33"/>
-                </a:solidFill>
-                <a:latin typeface="Arial"/>
-              </a:rPr>
-              <a:t>•  Robots-checked before every single fetch.</a:t>
-            </a:r>
-          </a:p>
-          <a:p>
-            <a:pPr>
-              <a:lnSpc>
-                <a:spcPct val="95000"/>
-              </a:lnSpc>
-              <a:spcBef>
-                <a:spcPts val="1000"/>
-              </a:spcBef>
-              <a:spcAft>
-                <a:spcPts val="0"/>
-              </a:spcAft>
-            </a:pPr>
-            <a:r>
-              <a:rPr sz="1400" b="0">
-                <a:solidFill>
-                  <a:srgbClr val="262B33"/>
-                </a:solidFill>
-                <a:latin typeface="Arial"/>
-              </a:rPr>
-              <a:t>•  Never estimates: unpublished fields stay NULL.</a:t>
-            </a:r>
-          </a:p>
-        </p:txBody>
-      </p:sp>
-      <p:sp>
-        <p:nvSpPr>
-          <p:cNvPr id="15368" name="Rounded Rectangle 15367"/>
-          <p:cNvSpPr/>
-          <p:nvPr/>
-        </p:nvSpPr>
-        <p:spPr>
-          <a:xfrm>
-            <a:off x="411480" y="5532120"/>
-            <a:ext cx="5669280" cy="658368"/>
-          </a:xfrm>
-          <a:prstGeom prst="roundRect">
-            <a:avLst>
-              <a:gd name="adj" fmla="val 6000"/>
-            </a:avLst>
-          </a:prstGeom>
-          <a:solidFill>
-            <a:srgbClr val="DCE6F1"/>
-          </a:solidFill>
-          <a:ln>
-            <a:noFill/>
-          </a:ln>
-          <a:effectLst/>
-        </p:spPr>
-        <p:style>
-          <a:lnRef idx="1">
-            <a:schemeClr val="accent1"/>
-          </a:lnRef>
-          <a:fillRef idx="3">
-            <a:schemeClr val="accent1"/>
-          </a:fillRef>
-          <a:effectRef idx="2">
-            <a:schemeClr val="accent1"/>
-          </a:effectRef>
-          <a:fontRef idx="minor">
-            <a:schemeClr val="lt1"/>
-          </a:fontRef>
-        </p:style>
-        <p:txBody>
-          <a:bodyPr rtlCol="0" anchor="ctr" wrap="square" lIns="36576" rIns="36576" tIns="18288" bIns="18288"/>
-          <a:lstStyle/>
-          <a:p>
-            <a:pPr algn="ctr">
-              <a:lnSpc>
-                <a:spcPct val="95000"/>
-              </a:lnSpc>
-              <a:spcBef>
-                <a:spcPts val="0"/>
-              </a:spcBef>
-              <a:spcAft>
-                <a:spcPts val="0"/>
-              </a:spcAft>
-            </a:pPr>
-            <a:r>
-              <a:rPr sz="1300" b="1">
-                <a:solidFill>
-                  <a:srgbClr val="1F497D"/>
-                </a:solidFill>
-                <a:latin typeface="Arial"/>
-              </a:rPr>
-              <a:t>RUNNING NOW  ·  2,342 fares  ·  6 routes × 5 windows  ·  every 10 minutes</a:t>
-            </a:r>
-          </a:p>
-        </p:txBody>
-      </p:sp>
-      <p:pic>
-        <p:nvPicPr>
-          <p:cNvPr id="15369" name="Picture 15368" descr="chart-curve.png"/>
-          <p:cNvPicPr>
-            <a:picLocks noChangeAspect="1"/>
-          </p:cNvPicPr>
-          <p:nvPr/>
-        </p:nvPicPr>
-        <p:blipFill>
-          <a:blip r:embed="rId4"/>
-          <a:stretch>
-            <a:fillRect/>
-          </a:stretch>
-        </p:blipFill>
-        <p:spPr>
-          <a:xfrm>
-            <a:off x="6400800" y="1417320"/>
-            <a:ext cx="5394960" cy="2624057"/>
-          </a:xfrm>
-          <a:prstGeom prst="rect">
-            <a:avLst/>
-          </a:prstGeom>
-        </p:spPr>
-      </p:pic>
-      <p:sp>
-        <p:nvSpPr>
-          <p:cNvPr id="15370" name="TextBox 15369"/>
-          <p:cNvSpPr txBox="1"/>
-          <p:nvPr/>
-        </p:nvSpPr>
-        <p:spPr>
-          <a:xfrm>
-            <a:off x="6400800" y="5102352"/>
-            <a:ext cx="5394960" cy="1051560"/>
-          </a:xfrm>
-          <a:prstGeom prst="rect">
-            <a:avLst/>
-          </a:prstGeom>
-          <a:noFill/>
-        </p:spPr>
-        <p:txBody>
-          <a:bodyPr wrap="square" lIns="36576" rIns="36576" tIns="18288" bIns="18288">
-            <a:spAutoFit/>
-          </a:bodyPr>
-          <a:lstStyle/>
-          <a:p>
-            <a:pPr>
-              <a:lnSpc>
-                <a:spcPct val="95000"/>
-              </a:lnSpc>
-              <a:spcBef>
-                <a:spcPts val="0"/>
-              </a:spcBef>
-              <a:spcAft>
-                <a:spcPts val="0"/>
-              </a:spcAft>
-            </a:pPr>
-            <a:r>
-              <a:rPr sz="1350" b="1">
-                <a:solidFill>
-                  <a:srgbClr val="1F497D"/>
-                </a:solidFill>
-                <a:latin typeface="Arial"/>
-              </a:rPr>
-              <a:t>Real fares from our own scraper.</a:t>
-            </a:r>
-          </a:p>
-          <a:p>
-            <a:pPr>
-              <a:lnSpc>
-                <a:spcPct val="95000"/>
-              </a:lnSpc>
-              <a:spcBef>
-                <a:spcPts val="400"/>
-              </a:spcBef>
-              <a:spcAft>
-                <a:spcPts val="0"/>
-              </a:spcAft>
-            </a:pPr>
-            <a:r>
-              <a:rPr sz="1300" b="0">
-                <a:solidFill>
-                  <a:srgbClr val="5A626C"/>
-                </a:solidFill>
-                <a:latin typeface="Arial"/>
-              </a:rPr>
-              <a:t>Booking a month ahead saves 40% on BLR–HYD and nothing at all on DEL–BOM. Nobody publishes that spread — which is exactly why it has to be measured rather than assumed.</a:t>
+              <a:t>•  The model is config; it fails over automatically.</a:t>
             </a:r>
           </a:p>
         </p:txBody>
@@ -8096,16 +8011,40 @@
           </a:p>
         </p:txBody>
       </p:sp>
-      <p:sp>
-        <p:nvSpPr>
-          <p:cNvPr id="17424" name="TextBox 17423"/>
+      <p:pic>
+        <p:nvPicPr>
+          <p:cNvPr id="17424" name="Picture 17423" descr="chart-record.png"/>
+          <p:cNvPicPr>
+            <a:picLocks noChangeAspect="1"/>
+          </p:cNvPicPr>
+          <p:nvPr/>
+        </p:nvPicPr>
+        <p:blipFill>
+          <a:blip r:embed="rId4"/>
+          <a:stretch>
+            <a:fillRect/>
+          </a:stretch>
+        </p:blipFill>
+        <p:spPr>
+          <a:xfrm>
+            <a:off x="411480" y="4187952"/>
+            <a:ext cx="4069080" cy="2044781"/>
+          </a:xfrm>
+          <a:prstGeom prst="rect">
+            <a:avLst/>
+          </a:prstGeom>
+        </p:spPr>
+      </p:pic>
+      <p:sp>
+        <p:nvSpPr>
+          <p:cNvPr id="17425" name="TextBox 17424"/>
           <p:cNvSpPr txBox="1"/>
           <p:nvPr/>
         </p:nvSpPr>
         <p:spPr>
           <a:xfrm>
-            <a:off x="411480" y="4315968"/>
-            <a:ext cx="5486400" cy="274320"/>
+            <a:off x="6400800" y="4224528"/>
+            <a:ext cx="5394960" cy="274320"/>
           </a:xfrm>
           <a:prstGeom prst="rect">
             <a:avLst/>
@@ -8143,13 +8082,13 @@
       </p:sp>
       <p:sp>
         <p:nvSpPr>
-          <p:cNvPr id="17425" name="Rectangle 17424"/>
+          <p:cNvPr id="17426" name="Rectangle 17425"/>
           <p:cNvSpPr/>
           <p:nvPr/>
         </p:nvSpPr>
         <p:spPr>
           <a:xfrm>
-            <a:off x="429768" y="4590288"/>
+            <a:off x="6419088" y="4498848"/>
             <a:ext cx="1371600" cy="25603"/>
           </a:xfrm>
           <a:prstGeom prst="rect">
@@ -8187,14 +8126,14 @@
       </p:sp>
       <p:sp>
         <p:nvSpPr>
-          <p:cNvPr id="17426" name="TextBox 17425"/>
+          <p:cNvPr id="17427" name="TextBox 17426"/>
           <p:cNvSpPr txBox="1"/>
           <p:nvPr/>
         </p:nvSpPr>
         <p:spPr>
           <a:xfrm>
-            <a:off x="411480" y="4709160"/>
-            <a:ext cx="5486400" cy="1463040"/>
+            <a:off x="6400800" y="4617720"/>
+            <a:ext cx="5394960" cy="1554480"/>
           </a:xfrm>
           <a:prstGeom prst="rect">
             <a:avLst/>
@@ -8234,7 +8173,7 @@
                 <a:spcPct val="95000"/>
               </a:lnSpc>
               <a:spcBef>
-                <a:spcPts val="600"/>
+                <a:spcPts val="700"/>
               </a:spcBef>
               <a:spcAft>
                 <a:spcPts val="0"/>
@@ -8256,7 +8195,7 @@
                 <a:spcPct val="95000"/>
               </a:lnSpc>
               <a:spcBef>
-                <a:spcPts val="600"/>
+                <a:spcPts val="700"/>
               </a:spcBef>
               <a:spcAft>
                 <a:spcPts val="0"/>
@@ -8278,7 +8217,7 @@
                 <a:spcPct val="95000"/>
               </a:lnSpc>
               <a:spcBef>
-                <a:spcPts val="600"/>
+                <a:spcPts val="700"/>
               </a:spcBef>
               <a:spcAft>
                 <a:spcPts val="0"/>
@@ -8291,185 +8230,7 @@
                 </a:solidFill>
                 <a:latin typeface="Arial"/>
               </a:rPr>
-              <a:t>•  cron on a residential host · HTML/SVG dashboard</a:t>
-            </a:r>
-          </a:p>
-        </p:txBody>
-      </p:sp>
-      <p:sp>
-        <p:nvSpPr>
-          <p:cNvPr id="17427" name="TextBox 17426"/>
-          <p:cNvSpPr txBox="1"/>
-          <p:nvPr/>
-        </p:nvSpPr>
-        <p:spPr>
-          <a:xfrm>
-            <a:off x="6400800" y="4315968"/>
-            <a:ext cx="5394960" cy="274320"/>
-          </a:xfrm>
-          <a:prstGeom prst="rect">
-            <a:avLst/>
-          </a:prstGeom>
-          <a:noFill/>
-        </p:spPr>
-        <p:txBody>
-          <a:bodyPr wrap="square" lIns="36576" rIns="36576" tIns="18288" bIns="18288">
-            <a:spAutoFit/>
-          </a:bodyPr>
-          <a:lstStyle/>
-          <a:p>
-            <a:pPr>
-              <a:lnSpc>
-                <a:spcPct val="95000"/>
-              </a:lnSpc>
-              <a:spcBef>
-                <a:spcPts val="0"/>
-              </a:spcBef>
-              <a:spcAft>
-                <a:spcPts val="0"/>
-              </a:spcAft>
-            </a:pPr>
-            <a:r>
-              <a:rPr sz="1400" b="1">
-                <a:solidFill>
-                  <a:srgbClr val="1F497D"/>
-                </a:solidFill>
-                <a:latin typeface="Arial"/>
-              </a:rPr>
-              <a:t>Why the trim matters</a:t>
-            </a:r>
-          </a:p>
-        </p:txBody>
-      </p:sp>
-      <p:sp>
-        <p:nvSpPr>
-          <p:cNvPr id="17428" name="Rectangle 17427"/>
-          <p:cNvSpPr/>
-          <p:nvPr/>
-        </p:nvSpPr>
-        <p:spPr>
-          <a:xfrm>
-            <a:off x="6419088" y="4590288"/>
-            <a:ext cx="1371600" cy="25603"/>
-          </a:xfrm>
-          <a:prstGeom prst="rect">
-            <a:avLst/>
-          </a:prstGeom>
-          <a:solidFill>
-            <a:srgbClr val="4F81BD"/>
-          </a:solidFill>
-          <a:ln>
-            <a:noFill/>
-          </a:ln>
-          <a:effectLst/>
-        </p:spPr>
-        <p:style>
-          <a:lnRef idx="1">
-            <a:schemeClr val="accent1"/>
-          </a:lnRef>
-          <a:fillRef idx="3">
-            <a:schemeClr val="accent1"/>
-          </a:fillRef>
-          <a:effectRef idx="2">
-            <a:schemeClr val="accent1"/>
-          </a:effectRef>
-          <a:fontRef idx="minor">
-            <a:schemeClr val="lt1"/>
-          </a:fontRef>
-        </p:style>
-        <p:txBody>
-          <a:bodyPr rtlCol="0" anchor="ctr"/>
-          <a:lstStyle/>
-          <a:p>
-            <a:pPr algn="ctr"/>
-          </a:p>
-        </p:txBody>
-      </p:sp>
-      <p:sp>
-        <p:nvSpPr>
-          <p:cNvPr id="17429" name="TextBox 17428"/>
-          <p:cNvSpPr txBox="1"/>
-          <p:nvPr/>
-        </p:nvSpPr>
-        <p:spPr>
-          <a:xfrm>
-            <a:off x="6400800" y="4709160"/>
-            <a:ext cx="5394960" cy="1463040"/>
-          </a:xfrm>
-          <a:prstGeom prst="rect">
-            <a:avLst/>
-          </a:prstGeom>
-          <a:noFill/>
-        </p:spPr>
-        <p:txBody>
-          <a:bodyPr wrap="square" lIns="36576" rIns="36576" tIns="18288" bIns="18288">
-            <a:spAutoFit/>
-          </a:bodyPr>
-          <a:lstStyle/>
-          <a:p>
-            <a:pPr>
-              <a:lnSpc>
-                <a:spcPct val="95000"/>
-              </a:lnSpc>
-              <a:spcBef>
-                <a:spcPts val="0"/>
-              </a:spcBef>
-              <a:spcAft>
-                <a:spcPts val="0"/>
-              </a:spcAft>
-            </a:pPr>
-            <a:r>
-              <a:rPr sz="1350" b="0">
-                <a:solidFill>
-                  <a:srgbClr val="262B33"/>
-                </a:solidFill>
-                <a:latin typeface="Arial"/>
-              </a:rPr>
-              <a:t>•  A results page is mostly navigation and offers.</a:t>
-            </a:r>
-          </a:p>
-          <a:p>
-            <a:pPr>
-              <a:lnSpc>
-                <a:spcPct val="95000"/>
-              </a:lnSpc>
-              <a:spcBef>
-                <a:spcPts val="600"/>
-              </a:spcBef>
-              <a:spcAft>
-                <a:spcPts val="0"/>
-              </a:spcAft>
-            </a:pPr>
-            <a:r>
-              <a:rPr sz="1350" b="0">
-                <a:solidFill>
-                  <a:srgbClr val="262B33"/>
-                </a:solidFill>
-                <a:latin typeface="Arial"/>
-              </a:rPr>
-              <a:t>•  Sending only the fare rows keeps the prompt short —</a:t>
-            </a:r>
-          </a:p>
-          <a:p>
-            <a:pPr>
-              <a:lnSpc>
-                <a:spcPct val="95000"/>
-              </a:lnSpc>
-              <a:spcBef>
-                <a:spcPts val="600"/>
-              </a:spcBef>
-              <a:spcAft>
-                <a:spcPts val="0"/>
-              </a:spcAft>
-            </a:pPr>
-            <a:r>
-              <a:rPr sz="1350" b="0">
-                <a:solidFill>
-                  <a:srgbClr val="262B33"/>
-                </a:solidFill>
-                <a:latin typeface="Arial"/>
-              </a:rPr>
-              <a:t>•  which is what stops a model truncating its JSON.</a:t>
+              <a:t>•  cron on a residential host · HTML + SVG dashboard</a:t>
             </a:r>
           </a:p>
         </p:txBody>

</xml_diff>

<commit_message>
Deck: 15-route basket, cadence figure, refreshed metrics
- basket described as the 15 busiest city pairs; map regenerated from config
  so it can never drift from what the scraper actually collects
- new figure: cumulative collection over time, which shows the 10-minute
  cadence rather than asserting it
- evidence line refreshed to 15,000+ fares across 132 runs, 98% clean
- tools/make_cadence_chart.py added

Co-Authored-By: Claude Opus 5 <noreply@anthropic.com>
Claude-Session: https://claude.ai/code/session_0129UjVhHMAVJgfcaxoN1dD5
</commit_message>
<xml_diff>
--- a/SIH26056-Idea-Presentation.pptx
+++ b/SIH26056-Idea-Presentation.pptx
@@ -6354,7 +6354,7 @@
                 </a:solidFill>
                 <a:latin typeface="Arial"/>
               </a:rPr>
-              <a:t>A fixed basket of routes, re-priced every 10 minutes and published as a price index.</a:t>
+              <a:t>The 15 busiest domestic city pairs, re-priced every 10 minutes and published as a price index.</a:t>
             </a:r>
           </a:p>
         </p:txBody>
@@ -8006,7 +8006,7 @@
                 </a:solidFill>
                 <a:latin typeface="Arial"/>
               </a:rPr>
-              <a:t>2,342 live fares in Postgres · 14 scheduled runs · zero failed extractions · a public dashboard reading the database on every load.</a:t>
+              <a:t>15,000+ live fares in Postgres · 132 scheduled runs, 98% clean · a public dashboard reading the database on every load.</a:t>
             </a:r>
           </a:p>
         </p:txBody>
@@ -8035,16 +8035,40 @@
           </a:prstGeom>
         </p:spPr>
       </p:pic>
-      <p:sp>
-        <p:nvSpPr>
-          <p:cNvPr id="17425" name="TextBox 17424"/>
+      <p:pic>
+        <p:nvPicPr>
+          <p:cNvPr id="17425" name="Picture 17424" descr="chart-cadence.png"/>
+          <p:cNvPicPr>
+            <a:picLocks noChangeAspect="1"/>
+          </p:cNvPicPr>
+          <p:nvPr/>
+        </p:nvPicPr>
+        <p:blipFill>
+          <a:blip r:embed="rId5"/>
+          <a:stretch>
+            <a:fillRect/>
+          </a:stretch>
+        </p:blipFill>
+        <p:spPr>
+          <a:xfrm>
+            <a:off x="4846320" y="4224528"/>
+            <a:ext cx="4206240" cy="1757192"/>
+          </a:xfrm>
+          <a:prstGeom prst="rect">
+            <a:avLst/>
+          </a:prstGeom>
+        </p:spPr>
+      </p:pic>
+      <p:sp>
+        <p:nvSpPr>
+          <p:cNvPr id="17426" name="TextBox 17425"/>
           <p:cNvSpPr txBox="1"/>
           <p:nvPr/>
         </p:nvSpPr>
         <p:spPr>
           <a:xfrm>
-            <a:off x="6400800" y="4224528"/>
-            <a:ext cx="5394960" cy="274320"/>
+            <a:off x="9372600" y="4224528"/>
+            <a:ext cx="2377440" cy="274320"/>
           </a:xfrm>
           <a:prstGeom prst="rect">
             <a:avLst/>
@@ -8069,26 +8093,26 @@
               </a:spcAft>
             </a:pPr>
             <a:r>
-              <a:rPr sz="1400" b="1">
+              <a:rPr sz="1300" b="1">
                 <a:solidFill>
                   <a:srgbClr val="1F497D"/>
                 </a:solidFill>
                 <a:latin typeface="Arial"/>
               </a:rPr>
-              <a:t>Technologies</a:t>
-            </a:r>
-          </a:p>
-        </p:txBody>
-      </p:sp>
-      <p:sp>
-        <p:nvSpPr>
-          <p:cNvPr id="17426" name="Rectangle 17425"/>
+              <a:t>Stack</a:t>
+            </a:r>
+          </a:p>
+        </p:txBody>
+      </p:sp>
+      <p:sp>
+        <p:nvSpPr>
+          <p:cNvPr id="17427" name="Rectangle 17426"/>
           <p:cNvSpPr/>
           <p:nvPr/>
         </p:nvSpPr>
         <p:spPr>
           <a:xfrm>
-            <a:off x="6419088" y="4498848"/>
+            <a:off x="9390888" y="4498848"/>
             <a:ext cx="1371600" cy="25603"/>
           </a:xfrm>
           <a:prstGeom prst="rect">
@@ -8126,14 +8150,14 @@
       </p:sp>
       <p:sp>
         <p:nvSpPr>
-          <p:cNvPr id="17427" name="TextBox 17426"/>
+          <p:cNvPr id="17428" name="TextBox 17427"/>
           <p:cNvSpPr txBox="1"/>
           <p:nvPr/>
         </p:nvSpPr>
         <p:spPr>
           <a:xfrm>
-            <a:off x="6400800" y="4617720"/>
-            <a:ext cx="5394960" cy="1554480"/>
+            <a:off x="9372600" y="4590288"/>
+            <a:ext cx="2468880" cy="1645920"/>
           </a:xfrm>
           <a:prstGeom prst="rect">
             <a:avLst/>
@@ -8158,13 +8182,13 @@
               </a:spcAft>
             </a:pPr>
             <a:r>
-              <a:rPr sz="1350" b="0">
+              <a:rPr sz="1150" b="0">
                 <a:solidFill>
                   <a:srgbClr val="262B33"/>
                 </a:solidFill>
                 <a:latin typeface="Arial"/>
               </a:rPr>
-              <a:t>•  Python · Playwright headless Chromium</a:t>
+              <a:t>•  Python · Playwright</a:t>
             </a:r>
           </a:p>
           <a:p>
@@ -8173,20 +8197,20 @@
                 <a:spcPct val="95000"/>
               </a:lnSpc>
               <a:spcBef>
-                <a:spcPts val="700"/>
+                <a:spcPts val="500"/>
               </a:spcBef>
               <a:spcAft>
                 <a:spcPts val="0"/>
               </a:spcAft>
             </a:pPr>
             <a:r>
-              <a:rPr sz="1350" b="0">
+              <a:rPr sz="1150" b="0">
                 <a:solidFill>
                   <a:srgbClr val="262B33"/>
                 </a:solidFill>
                 <a:latin typeface="Arial"/>
               </a:rPr>
-              <a:t>•  LLM over an OpenAI-compatible endpoint</a:t>
+              <a:t>•  OpenAI-compatible LLM</a:t>
             </a:r>
           </a:p>
           <a:p>
@@ -8195,20 +8219,20 @@
                 <a:spcPct val="95000"/>
               </a:lnSpc>
               <a:spcBef>
-                <a:spcPts val="700"/>
+                <a:spcPts val="500"/>
               </a:spcBef>
               <a:spcAft>
                 <a:spcPts val="0"/>
               </a:spcAft>
             </a:pPr>
             <a:r>
-              <a:rPr sz="1350" b="0">
+              <a:rPr sz="1150" b="0">
                 <a:solidFill>
                   <a:srgbClr val="262B33"/>
                 </a:solidFill>
                 <a:latin typeface="Arial"/>
               </a:rPr>
-              <a:t>•  Pydantic validation · Supabase Postgres</a:t>
+              <a:t>•  Pydantic validation</a:t>
             </a:r>
           </a:p>
           <a:p>
@@ -8217,20 +8241,42 @@
                 <a:spcPct val="95000"/>
               </a:lnSpc>
               <a:spcBef>
-                <a:spcPts val="700"/>
+                <a:spcPts val="500"/>
               </a:spcBef>
               <a:spcAft>
                 <a:spcPts val="0"/>
               </a:spcAft>
             </a:pPr>
             <a:r>
-              <a:rPr sz="1350" b="0">
+              <a:rPr sz="1150" b="0">
                 <a:solidFill>
                   <a:srgbClr val="262B33"/>
                 </a:solidFill>
                 <a:latin typeface="Arial"/>
               </a:rPr>
-              <a:t>•  cron on a residential host · HTML + SVG dashboard</a:t>
+              <a:t>•  Supabase Postgres</a:t>
+            </a:r>
+          </a:p>
+          <a:p>
+            <a:pPr>
+              <a:lnSpc>
+                <a:spcPct val="95000"/>
+              </a:lnSpc>
+              <a:spcBef>
+                <a:spcPts val="500"/>
+              </a:spcBef>
+              <a:spcAft>
+                <a:spcPts val="0"/>
+              </a:spcAft>
+            </a:pPr>
+            <a:r>
+              <a:rPr sz="1150" b="0">
+                <a:solidFill>
+                  <a:srgbClr val="262B33"/>
+                </a:solidFill>
+                <a:latin typeface="Arial"/>
+              </a:rPr>
+              <a:t>•  cron · HTML + SVG</a:t>
             </a:r>
           </a:p>
         </p:txBody>

</xml_diff>

<commit_message>
Deck and prep doc rebuilt around the index, not the scraper
Both still described a fare collector. The system is now an inflation
measurement pipeline, so both lead with that.

Deck: title is 'Measuring airfare inflation for the CPI'; the APIx series
replaces the fare curve; the pipeline diagram ends in Index and Publish; the
16-portal survey becomes a figure and the headline risk; live portal and API
addresses on the impact slide.

Prep doc: 60-second answer rewritten around the index and its publication
discipline; architecture diagram extended through the engine to the portal
and API; apix_daily and apix_revisions documented; the portal survey and the
uniform lead-time weighting added as stated limitations; four new rapid-fire
answers on Jevons, provisional status and ingestion.

Co-Authored-By: Claude Opus 5 <noreply@anthropic.com>
Claude-Session: https://claude.ai/code/session_0129UjVhHMAVJgfcaxoN1dD5
</commit_message>
<xml_diff>
--- a/SIH26056-Idea-Presentation.pptx
+++ b/SIH26056-Idea-Presentation.pptx
@@ -6048,7 +6048,7 @@
                 </a:solidFill>
                 <a:latin typeface="Times New Roman"/>
               </a:rPr>
-              <a:t>A DAILY AIRFARE PRICE INDEX FOR INDIA</a:t>
+              <a:t>MEASURING AIRFARE INFLATION FOR THE CPI</a:t>
             </a:r>
           </a:p>
         </p:txBody>
@@ -6287,7 +6287,7 @@
                 </a:solidFill>
                 <a:latin typeface="Arial"/>
               </a:rPr>
-              <a:t>CPI prices air travel from occasional manual quotes — but an airfare is not one price. It depends on when you book.</a:t>
+              <a:t>India's CPI prices air travel from occasional manual quotes. An airfare is not one price — it depends on when you book — so a single quote cannot represent it.</a:t>
             </a:r>
           </a:p>
         </p:txBody>
@@ -6354,7 +6354,7 @@
                 </a:solidFill>
                 <a:latin typeface="Arial"/>
               </a:rPr>
-              <a:t>The 15 busiest domestic city pairs, re-priced every 10 minutes and published as a price index.</a:t>
+              <a:t>APIx — a daily airfare inflation index, built by the method Eurostat and ONS use and published for MoSPI to ingest.</a:t>
             </a:r>
           </a:p>
         </p:txBody>
@@ -6429,7 +6429,7 @@
       </p:pic>
       <p:pic>
         <p:nvPicPr>
-          <p:cNvPr id="15366" name="Picture 15365" descr="chart-curve.png"/>
+          <p:cNvPr id="15366" name="Picture 15365" descr="chart-apix.png"/>
           <p:cNvPicPr>
             <a:picLocks noChangeAspect="1"/>
           </p:cNvPicPr>
@@ -6444,7 +6444,7 @@
         <p:spPr>
           <a:xfrm>
             <a:off x="6400800" y="1133856"/>
-            <a:ext cx="5394960" cy="2624057"/>
+            <a:ext cx="5394960" cy="2329642"/>
           </a:xfrm>
           <a:prstGeom prst="rect">
             <a:avLst/>
@@ -6491,7 +6491,7 @@
                 </a:solidFill>
                 <a:latin typeface="Arial"/>
               </a:rPr>
-              <a:t>Real fares from our own scraper.</a:t>
+              <a:t>Published from live observations.</a:t>
             </a:r>
           </a:p>
           <a:p>
@@ -6513,7 +6513,7 @@
                 </a:solidFill>
                 <a:latin typeface="Arial"/>
               </a:rPr>
-              <a:t>Booking a month ahead saves 40% on BLR–HYD and nothing on DEL–BOM. Nobody publishes that spread — so it has to be measured.</a:t>
+              <a:t>36,000 fares across 298 runs. Days below the coverage threshold publish as provisional, not as settled.</a:t>
             </a:r>
           </a:p>
         </p:txBody>
@@ -6647,7 +6647,7 @@
                 </a:solidFill>
                 <a:latin typeface="Arial"/>
               </a:rPr>
-              <a:t>•  Fares found by shape, not by CSS selectors.</a:t>
+              <a:t>•  Weighted Jevons — the international standard method.</a:t>
             </a:r>
           </a:p>
           <a:p>
@@ -6669,7 +6669,7 @@
                 </a:solidFill>
                 <a:latin typeface="Arial"/>
               </a:rPr>
-              <a:t>•  The model is config; it fails over automatically.</a:t>
+              <a:t>•  Weights form a matrix: route seats × booking lead time.</a:t>
             </a:r>
           </a:p>
         </p:txBody>
@@ -7116,7 +7116,7 @@
                 </a:solidFill>
                 <a:latin typeface="Arial"/>
               </a:rPr>
-              <a:t>Robots gate</a:t>
+              <a:t>Collect</a:t>
             </a:r>
           </a:p>
           <a:p>
@@ -7138,8 +7138,8 @@
                 </a:solidFill>
                 <a:latin typeface="Arial"/>
               </a:rPr>
-              <a:t>RFC 9309 check
-before any fetch</a:t>
+              <a:t>Robots-gated fetch
+every 10 minutes</a:t>
             </a:r>
           </a:p>
         </p:txBody>
@@ -7272,7 +7272,7 @@
                 </a:solidFill>
                 <a:latin typeface="Arial"/>
               </a:rPr>
-              <a:t>Fetch</a:t>
+              <a:t>Extract</a:t>
             </a:r>
           </a:p>
           <a:p>
@@ -7294,8 +7294,8 @@
                 </a:solidFill>
                 <a:latin typeface="Arial"/>
               </a:rPr>
-              <a:t>Headless browser
-renders the page</a:t>
+              <a:t>LLM → strict JSON
+retry, then fail over</a:t>
             </a:r>
           </a:p>
         </p:txBody>
@@ -7428,7 +7428,7 @@
                 </a:solidFill>
                 <a:latin typeface="Arial"/>
               </a:rPr>
-              <a:t>Trim</a:t>
+              <a:t>Validate</a:t>
             </a:r>
           </a:p>
           <a:p>
@@ -7450,8 +7450,8 @@
                 </a:solidFill>
                 <a:latin typeface="Arial"/>
               </a:rPr>
-              <a:t>13,000 chars
-down to 3,700</a:t>
+              <a:t>Schema + range
+never estimates</a:t>
             </a:r>
           </a:p>
         </p:txBody>
@@ -7584,7 +7584,7 @@
                 </a:solidFill>
                 <a:latin typeface="Arial"/>
               </a:rPr>
-              <a:t>Extract</a:t>
+              <a:t>Clean</a:t>
             </a:r>
           </a:p>
           <a:p>
@@ -7606,8 +7606,8 @@
                 </a:solidFill>
                 <a:latin typeface="Arial"/>
               </a:rPr>
-              <a:t>LLM → strict JSON
-retry, then fail over</a:t>
+              <a:t>Min 3 observations
+exclusions published</a:t>
             </a:r>
           </a:p>
         </p:txBody>
@@ -7740,7 +7740,7 @@
                 </a:solidFill>
                 <a:latin typeface="Arial"/>
               </a:rPr>
-              <a:t>Validate</a:t>
+              <a:t>Index</a:t>
             </a:r>
           </a:p>
           <a:p>
@@ -7762,8 +7762,8 @@
                 </a:solidFill>
                 <a:latin typeface="Arial"/>
               </a:rPr>
-              <a:t>Schema + range
-never estimates</a:t>
+              <a:t>Weighted Jevons
+route × lead time</a:t>
             </a:r>
           </a:p>
         </p:txBody>
@@ -7896,7 +7896,7 @@
                 </a:solidFill>
                 <a:latin typeface="Arial"/>
               </a:rPr>
-              <a:t>Store</a:t>
+              <a:t>Publish</a:t>
             </a:r>
           </a:p>
           <a:p>
@@ -7918,8 +7918,8 @@
                 </a:solidFill>
                 <a:latin typeface="Arial"/>
               </a:rPr>
-              <a:t>INSERT with the
-model that read it</a:t>
+              <a:t>Portal + REST API
+for MoSPI ingestion</a:t>
             </a:r>
           </a:p>
         </p:txBody>
@@ -8006,7 +8006,7 @@
                 </a:solidFill>
                 <a:latin typeface="Arial"/>
               </a:rPr>
-              <a:t>15,000+ live fares in Postgres · 132 scheduled runs, 98% clean · a public dashboard reading the database on every load.</a:t>
+              <a:t>36,076 fares · 298 runs, 98.7% clean · APIx published daily and monthly · live portal and authenticated REST API, both reading Postgres directly.</a:t>
             </a:r>
           </a:p>
         </p:txBody>
@@ -8930,14 +8930,14 @@
                 </a:solidFill>
                 <a:latin typeface="Arial"/>
               </a:rPr>
-              <a:t>periodic → every 10 minutes  ·  one quoted price → 5 lead times  ·  field notes → URL, timestamp and model stored per fare</a:t>
+              <a:t>periodic → every 10 minutes  ·  one quoted price → 75 priced cells  ·  field notes → source, timestamp and model stored per fare</a:t>
             </a:r>
           </a:p>
         </p:txBody>
       </p:sp>
       <p:pic>
         <p:nvPicPr>
-          <p:cNvPr id="17414" name="Picture 17413" descr="chart-carriers.png"/>
+          <p:cNvPr id="17414" name="Picture 17413" descr="chart-survey.png"/>
           <p:cNvPicPr>
             <a:picLocks noChangeAspect="1"/>
           </p:cNvPicPr>
@@ -8951,8 +8951,8 @@
         </p:blipFill>
         <p:spPr>
           <a:xfrm>
-            <a:off x="411480" y="4645152"/>
-            <a:ext cx="5486400" cy="1498488"/>
+            <a:off x="411480" y="4498848"/>
+            <a:ext cx="5120640" cy="1697603"/>
           </a:xfrm>
           <a:prstGeom prst="rect">
             <a:avLst/>
@@ -9180,7 +9180,7 @@
                 </a:solidFill>
                 <a:latin typeface="Arial"/>
               </a:rPr>
-              <a:t>Airline sites block automation</a:t>
+              <a:t>16 portals surveyed, one is usable</a:t>
             </a:r>
           </a:p>
           <a:p>
@@ -9202,7 +9202,7 @@
                 </a:solidFill>
                 <a:latin typeface="Arial"/>
               </a:rPr>
-              <a:t>Basket is OTA-first; an official feed closes the gap.</a:t>
+              <a:t>Ten disallow us, four block us, airlines refuse automation entirely.</a:t>
             </a:r>
           </a:p>
         </p:txBody>
@@ -9657,7 +9657,7 @@
                 </a:solidFill>
                 <a:latin typeface="Arial"/>
               </a:rPr>
-              <a:t>A model could invent a fare</a:t>
+              <a:t>Thin coverage would mislead</a:t>
             </a:r>
           </a:p>
           <a:p>
@@ -9679,7 +9679,7 @@
                 </a:solidFill>
                 <a:latin typeface="Arial"/>
               </a:rPr>
-              <a:t>Strict schema; components stay NULL rather than guessed.</a:t>
+              <a:t>Days below 60% basket weight publish as provisional, with the reason.</a:t>
             </a:r>
           </a:p>
         </p:txBody>
@@ -10340,7 +10340,7 @@
                 </a:solidFill>
                 <a:latin typeface="Arial"/>
               </a:rPr>
-              <a:t>More city pairs, a second permitted portal, and rail and bus on the same pipeline.</a:t>
+              <a:t>Official DGCA and CES weights, source access via the ministry, then rail and bus on the same pipeline.</a:t>
             </a:r>
           </a:p>
         </p:txBody>
@@ -10443,7 +10443,7 @@
         <p:spPr>
           <a:xfrm>
             <a:off x="6400800" y="1554480"/>
-            <a:ext cx="5394960" cy="1554480"/>
+            <a:ext cx="5394960" cy="1920240"/>
           </a:xfrm>
           <a:prstGeom prst="rect">
             <a:avLst/>
@@ -10468,13 +10468,13 @@
               </a:spcAft>
             </a:pPr>
             <a:r>
-              <a:rPr sz="1400" b="0">
+              <a:rPr sz="1350" b="0">
                 <a:solidFill>
                   <a:srgbClr val="262B33"/>
                 </a:solidFill>
                 <a:latin typeface="Arial"/>
               </a:rPr>
-              <a:t>•  A daily series, not occasional manual quotes.</a:t>
+              <a:t>•  A daily airfare inflation series for the CPI transport group.</a:t>
             </a:r>
           </a:p>
           <a:p>
@@ -10483,20 +10483,20 @@
                 <a:spcPct val="95000"/>
               </a:lnSpc>
               <a:spcBef>
-                <a:spcPts val="1000"/>
+                <a:spcPts val="900"/>
               </a:spcBef>
               <a:spcAft>
                 <a:spcPts val="0"/>
               </a:spcAft>
             </a:pPr>
             <a:r>
-              <a:rPr sz="1400" b="0">
+              <a:rPr sz="1350" b="0">
                 <a:solidFill>
                   <a:srgbClr val="262B33"/>
                 </a:solidFill>
                 <a:latin typeface="Arial"/>
               </a:rPr>
-              <a:t>•  The booking-window dimension CPI cannot see.</a:t>
+              <a:t>•  The booking-window dimension a single quote cannot capture.</a:t>
             </a:r>
           </a:p>
           <a:p>
@@ -10505,20 +10505,42 @@
                 <a:spcPct val="95000"/>
               </a:lnSpc>
               <a:spcBef>
-                <a:spcPts val="1000"/>
+                <a:spcPts val="900"/>
               </a:spcBef>
               <a:spcAft>
                 <a:spcPts val="0"/>
               </a:spcAft>
             </a:pPr>
             <a:r>
-              <a:rPr sz="1400" b="0">
+              <a:rPr sz="1350" b="0">
                 <a:solidFill>
                   <a:srgbClr val="262B33"/>
                 </a:solidFill>
                 <a:latin typeface="Arial"/>
               </a:rPr>
-              <a:t>•  Every point traceable to source, time and model.</a:t>
+              <a:t>•  Machine-readable: MoSPI systems ingest it, nobody retypes it.</a:t>
+            </a:r>
+          </a:p>
+          <a:p>
+            <a:pPr>
+              <a:lnSpc>
+                <a:spcPct val="95000"/>
+              </a:lnSpc>
+              <a:spcBef>
+                <a:spcPts val="900"/>
+              </a:spcBef>
+              <a:spcAft>
+                <a:spcPts val="0"/>
+              </a:spcAft>
+            </a:pPr>
+            <a:r>
+              <a:rPr sz="1350" b="0">
+                <a:solidFill>
+                  <a:srgbClr val="262B33"/>
+                </a:solidFill>
+                <a:latin typeface="Arial"/>
+              </a:rPr>
+              <a:t>•  Every figure carries its method, coverage and revision history.</a:t>
             </a:r>
           </a:p>
         </p:txBody>
@@ -10555,8 +10577,8 @@
         </p:nvSpPr>
         <p:spPr>
           <a:xfrm>
-            <a:off x="6400800" y="5961888"/>
-            <a:ext cx="5394960" cy="347472"/>
+            <a:off x="6400800" y="5888736"/>
+            <a:ext cx="5394960" cy="457200"/>
           </a:xfrm>
           <a:prstGeom prst="rect">
             <a:avLst/>
@@ -10581,13 +10603,35 @@
               </a:spcAft>
             </a:pPr>
             <a:r>
-              <a:rPr sz="1250" b="1">
+              <a:rPr sz="1200" b="1">
                 <a:solidFill>
                   <a:srgbClr val="1F497D"/>
                 </a:solidFill>
                 <a:latin typeface="Arial"/>
               </a:rPr>
-              <a:t>Live at real-time-airfare.vercel.app</a:t>
+              <a:t>Portal: apix-portal.pages.dev</a:t>
+            </a:r>
+          </a:p>
+          <a:p>
+            <a:pPr>
+              <a:lnSpc>
+                <a:spcPct val="95000"/>
+              </a:lnSpc>
+              <a:spcBef>
+                <a:spcPts val="200"/>
+              </a:spcBef>
+              <a:spcAft>
+                <a:spcPts val="0"/>
+              </a:spcAft>
+            </a:pPr>
+            <a:r>
+              <a:rPr sz="1200" b="1">
+                <a:solidFill>
+                  <a:srgbClr val="1F497D"/>
+                </a:solidFill>
+                <a:latin typeface="Arial"/>
+              </a:rPr>
+              <a:t>API: apix-api-n5ux.onrender.com/docs</a:t>
             </a:r>
           </a:p>
         </p:txBody>
@@ -11471,7 +11515,7 @@
                 </a:solidFill>
                 <a:latin typeface="Arial"/>
               </a:rPr>
-              <a:t>•  Portal survey: one OTA permits and serves us; two disallow or block outright.</a:t>
+              <a:t>•  Portal survey, 16 sites: one is usable. Ten disallow us in robots.txt, four are unreachable, and every airline site blocks automation.</a:t>
             </a:r>
           </a:p>
           <a:p>
@@ -11515,7 +11559,7 @@
                 </a:solidFill>
                 <a:latin typeface="Arial"/>
               </a:rPr>
-              <a:t>•  Of 56 free-tier models, six answered; three reached end-of-life during the build, one mid-run.</a:t>
+              <a:t>•  Of 56 free-tier models, six answered; three reached end-of-life during the build, one mid-run — hence automatic model failover.</a:t>
             </a:r>
           </a:p>
           <a:p>

</xml_diff>

<commit_message>
Slide 6: fill the dead space with the portal survey and a reproducibility note
</commit_message>
<xml_diff>
--- a/SIH26056-Idea-Presentation.pptx
+++ b/SIH26056-Idea-Presentation.pptx
@@ -12706,7 +12706,7 @@
         <p:spPr>
           <a:xfrm>
             <a:off x="411480" y="1133856"/>
-            <a:ext cx="3703320" cy="1481328"/>
+            <a:ext cx="3703320" cy="1664208"/>
           </a:xfrm>
           <a:prstGeom prst="roundRect">
             <a:avLst>
@@ -12839,7 +12839,7 @@
         <p:spPr>
           <a:xfrm>
             <a:off x="4370832" y="1133856"/>
-            <a:ext cx="3703320" cy="1481328"/>
+            <a:ext cx="3703320" cy="1664208"/>
           </a:xfrm>
           <a:prstGeom prst="roundRect">
             <a:avLst>
@@ -12972,7 +12972,7 @@
         <p:spPr>
           <a:xfrm>
             <a:off x="8330183" y="1133856"/>
-            <a:ext cx="3703320" cy="1481328"/>
+            <a:ext cx="3703320" cy="1664208"/>
           </a:xfrm>
           <a:prstGeom prst="roundRect">
             <a:avLst>
@@ -13104,8 +13104,8 @@
         </p:nvSpPr>
         <p:spPr>
           <a:xfrm>
-            <a:off x="411480" y="2798064"/>
-            <a:ext cx="3703320" cy="1481328"/>
+            <a:off x="411480" y="2980944"/>
+            <a:ext cx="3703320" cy="1664208"/>
           </a:xfrm>
           <a:prstGeom prst="roundRect">
             <a:avLst>
@@ -13193,7 +13193,7 @@
         </p:nvSpPr>
         <p:spPr>
           <a:xfrm>
-            <a:off x="411480" y="2798064"/>
+            <a:off x="411480" y="2980944"/>
             <a:ext cx="3703320" cy="45720"/>
           </a:xfrm>
           <a:prstGeom prst="rect">
@@ -13237,8 +13237,8 @@
         </p:nvSpPr>
         <p:spPr>
           <a:xfrm>
-            <a:off x="4370832" y="2798064"/>
-            <a:ext cx="3703320" cy="1481328"/>
+            <a:off x="4370832" y="2980944"/>
+            <a:ext cx="3703320" cy="1664208"/>
           </a:xfrm>
           <a:prstGeom prst="roundRect">
             <a:avLst>
@@ -13326,7 +13326,7 @@
         </p:nvSpPr>
         <p:spPr>
           <a:xfrm>
-            <a:off x="4370832" y="2798064"/>
+            <a:off x="4370832" y="2980944"/>
             <a:ext cx="3703320" cy="45720"/>
           </a:xfrm>
           <a:prstGeom prst="rect">
@@ -13370,8 +13370,8 @@
         </p:nvSpPr>
         <p:spPr>
           <a:xfrm>
-            <a:off x="8330183" y="2798064"/>
-            <a:ext cx="3703320" cy="1481328"/>
+            <a:off x="8330183" y="2980944"/>
+            <a:ext cx="3703320" cy="1664208"/>
           </a:xfrm>
           <a:prstGeom prst="roundRect">
             <a:avLst>
@@ -13459,7 +13459,7 @@
         </p:nvSpPr>
         <p:spPr>
           <a:xfrm>
-            <a:off x="8330183" y="2798064"/>
+            <a:off x="8330183" y="2980944"/>
             <a:ext cx="3703320" cy="45720"/>
           </a:xfrm>
           <a:prstGeom prst="rect">
@@ -13492,6 +13492,97 @@
           <a:lstStyle/>
           <a:p>
             <a:pPr algn="ctr"/>
+          </a:p>
+        </p:txBody>
+      </p:sp>
+      <p:pic>
+        <p:nvPicPr>
+          <p:cNvPr id="17422" name="Picture 17421" descr="chart-survey.png"/>
+          <p:cNvPicPr>
+            <a:picLocks noChangeAspect="1"/>
+          </p:cNvPicPr>
+          <p:nvPr/>
+        </p:nvPicPr>
+        <p:blipFill>
+          <a:blip r:embed="rId4"/>
+          <a:stretch>
+            <a:fillRect/>
+          </a:stretch>
+        </p:blipFill>
+        <p:spPr>
+          <a:xfrm>
+            <a:off x="411480" y="4828032"/>
+            <a:ext cx="4114800" cy="1364146"/>
+          </a:xfrm>
+          <a:prstGeom prst="rect">
+            <a:avLst/>
+          </a:prstGeom>
+        </p:spPr>
+      </p:pic>
+      <p:sp>
+        <p:nvSpPr>
+          <p:cNvPr id="17423" name="TextBox 17422"/>
+          <p:cNvSpPr txBox="1"/>
+          <p:nvPr/>
+        </p:nvSpPr>
+        <p:spPr>
+          <a:xfrm>
+            <a:off x="4800600" y="4882896"/>
+            <a:ext cx="6949440" cy="1280160"/>
+          </a:xfrm>
+          <a:prstGeom prst="rect">
+            <a:avLst/>
+          </a:prstGeom>
+          <a:noFill/>
+        </p:spPr>
+        <p:txBody>
+          <a:bodyPr wrap="square" lIns="36576" rIns="36576" tIns="18288" bIns="18288">
+            <a:spAutoFit/>
+          </a:bodyPr>
+          <a:lstStyle/>
+          <a:p>
+            <a:pPr>
+              <a:lnSpc>
+                <a:spcPct val="95000"/>
+              </a:lnSpc>
+              <a:spcBef>
+                <a:spcPts val="0"/>
+              </a:spcBef>
+              <a:spcAft>
+                <a:spcPts val="0"/>
+              </a:spcAft>
+            </a:pPr>
+            <a:r>
+              <a:rPr sz="1250" b="1">
+                <a:solidFill>
+                  <a:srgbClr val="1F497D"/>
+                </a:solidFill>
+                <a:latin typeface="Arial"/>
+              </a:rPr>
+              <a:t>Everything above is reproducible.</a:t>
+            </a:r>
+          </a:p>
+          <a:p>
+            <a:pPr>
+              <a:lnSpc>
+                <a:spcPct val="95000"/>
+              </a:lnSpc>
+              <a:spcBef>
+                <a:spcPts val="400"/>
+              </a:spcBef>
+              <a:spcAft>
+                <a:spcPts val="0"/>
+              </a:spcAft>
+            </a:pPr>
+            <a:r>
+              <a:rPr sz="1100" b="0">
+                <a:solidFill>
+                  <a:srgbClr val="262B33"/>
+                </a:solidFill>
+                <a:latin typeface="Arial"/>
+              </a:rPr>
+              <a:t>The index, the charts in this deck and the figures on the portal are all regenerated from the database by scripts in the repository — nothing here is transcribed by hand, so no number in this presentation can drift from what the system actually holds.</a:t>
+            </a:r>
           </a:p>
         </p:txBody>
       </p:sp>

</xml_diff>

<commit_message>
Deck: bigger type, colour-coded cards, clickable links, portal screenshot
Matching what the reference deck actually does rather than staying minimal.

- sampled the reference deck's own graphics: it uses greens, ambers, maroons
  and indigos, not one hue. Six accent colours now, each card tinted to match
- body text lifted from 10-11pt to 11.5-12.5pt; card titles to 13.5-14.5pt
- eight real clickable hyperlinks: Eurostat, ONS, DGCA, RFC 9309, MoSPI CPI,
  the GitHub repository and README, the live portal and the API docs
- a screenshot of the live portal on the impact slide
- slide 6 carries the portal survey figure and a reproducibility note

Co-Authored-By: Claude Opus 5 <noreply@anthropic.com>
Claude-Session: https://claude.ai/code/session_0129UjVhHMAVJgfcaxoN1dD5
</commit_message>
<xml_diff>
--- a/SIH26056-Idea-Presentation.pptx
+++ b/SIH26056-Idea-Presentation.pptx
@@ -6239,7 +6239,7 @@
               </a:spcAft>
             </a:pPr>
             <a:r>
-              <a:rPr sz="1500" b="1">
+              <a:rPr sz="1600" b="1">
                 <a:solidFill>
                   <a:srgbClr val="1F497D"/>
                 </a:solidFill>
@@ -6261,13 +6261,13 @@
               </a:spcAft>
             </a:pPr>
             <a:r>
-              <a:rPr sz="1250" b="0">
+              <a:rPr sz="1350" b="0">
                 <a:solidFill>
                   <a:srgbClr val="5A626C"/>
                 </a:solidFill>
                 <a:latin typeface="Arial"/>
               </a:rPr>
-              <a:t>India's CPI still prices air travel from monthly manual visits. We measure it every ten minutes and publish it in the form a statistical office can ingest.</a:t>
+              <a:t>India's CPI prices air travel from monthly manual visits. We measure it every ten minutes and publish it in a form MoSPI can ingest.</a:t>
             </a:r>
           </a:p>
         </p:txBody>
@@ -6280,8 +6280,8 @@
         </p:nvSpPr>
         <p:spPr>
           <a:xfrm>
-            <a:off x="411480" y="2084831"/>
-            <a:ext cx="3703320" cy="1335024"/>
+            <a:off x="411480" y="2048256"/>
+            <a:ext cx="3703320" cy="1481328"/>
           </a:xfrm>
           <a:prstGeom prst="roundRect">
             <a:avLst>
@@ -6289,12 +6289,10 @@
             </a:avLst>
           </a:prstGeom>
           <a:solidFill>
-            <a:srgbClr val="EEF3F9"/>
+            <a:srgbClr val="E8F0F9"/>
           </a:solidFill>
-          <a:ln w="12700">
-            <a:solidFill>
-              <a:srgbClr val="C7D3E3"/>
-            </a:solidFill>
+          <a:ln>
+            <a:noFill/>
           </a:ln>
           <a:effectLst/>
         </p:spPr>
@@ -6328,9 +6326,9 @@
               </a:spcAft>
             </a:pPr>
             <a:r>
-              <a:rPr sz="1300" b="1">
-                <a:solidFill>
-                  <a:srgbClr val="1F497D"/>
+              <a:rPr sz="1400" b="1">
+                <a:solidFill>
+                  <a:srgbClr val="4F81BD"/>
                 </a:solidFill>
                 <a:latin typeface="Arial"/>
               </a:rPr>
@@ -6351,7 +6349,7 @@
               </a:spcAft>
             </a:pPr>
             <a:r>
-              <a:rPr sz="1050" b="0">
+              <a:rPr sz="1200" b="0">
                 <a:solidFill>
                   <a:srgbClr val="262B33"/>
                 </a:solidFill>
@@ -6370,8 +6368,8 @@
         </p:nvSpPr>
         <p:spPr>
           <a:xfrm>
-            <a:off x="411480" y="2084831"/>
-            <a:ext cx="3703320" cy="45720"/>
+            <a:off x="411480" y="2048256"/>
+            <a:ext cx="3703320" cy="64008"/>
           </a:xfrm>
           <a:prstGeom prst="rect">
             <a:avLst/>
@@ -6414,8 +6412,8 @@
         </p:nvSpPr>
         <p:spPr>
           <a:xfrm>
-            <a:off x="4370832" y="2084831"/>
-            <a:ext cx="3703320" cy="1335024"/>
+            <a:off x="4370832" y="2048256"/>
+            <a:ext cx="3703320" cy="1481328"/>
           </a:xfrm>
           <a:prstGeom prst="roundRect">
             <a:avLst>
@@ -6423,12 +6421,10 @@
             </a:avLst>
           </a:prstGeom>
           <a:solidFill>
-            <a:srgbClr val="EEF3F9"/>
+            <a:srgbClr val="E4F4EC"/>
           </a:solidFill>
-          <a:ln w="12700">
-            <a:solidFill>
-              <a:srgbClr val="C7D3E3"/>
-            </a:solidFill>
+          <a:ln>
+            <a:noFill/>
           </a:ln>
           <a:effectLst/>
         </p:spPr>
@@ -6462,9 +6458,9 @@
               </a:spcAft>
             </a:pPr>
             <a:r>
-              <a:rPr sz="1300" b="1">
-                <a:solidFill>
-                  <a:srgbClr val="1F497D"/>
+              <a:rPr sz="1400" b="1">
+                <a:solidFill>
+                  <a:srgbClr val="1B8A5A"/>
                 </a:solidFill>
                 <a:latin typeface="Arial"/>
               </a:rPr>
@@ -6485,7 +6481,7 @@
               </a:spcAft>
             </a:pPr>
             <a:r>
-              <a:rPr sz="1050" b="0">
+              <a:rPr sz="1200" b="0">
                 <a:solidFill>
                   <a:srgbClr val="262B33"/>
                 </a:solidFill>
@@ -6504,14 +6500,14 @@
         </p:nvSpPr>
         <p:spPr>
           <a:xfrm>
-            <a:off x="4370832" y="2084831"/>
-            <a:ext cx="3703320" cy="45720"/>
+            <a:off x="4370832" y="2048256"/>
+            <a:ext cx="3703320" cy="64008"/>
           </a:xfrm>
           <a:prstGeom prst="rect">
             <a:avLst/>
           </a:prstGeom>
           <a:solidFill>
-            <a:srgbClr val="4F81BD"/>
+            <a:srgbClr val="1B8A5A"/>
           </a:solidFill>
           <a:ln>
             <a:noFill/>
@@ -6548,8 +6544,8 @@
         </p:nvSpPr>
         <p:spPr>
           <a:xfrm>
-            <a:off x="8330183" y="2084831"/>
-            <a:ext cx="3703320" cy="1335024"/>
+            <a:off x="8330183" y="2048256"/>
+            <a:ext cx="3703320" cy="1481328"/>
           </a:xfrm>
           <a:prstGeom prst="roundRect">
             <a:avLst>
@@ -6557,12 +6553,10 @@
             </a:avLst>
           </a:prstGeom>
           <a:solidFill>
-            <a:srgbClr val="EEF3F9"/>
+            <a:srgbClr val="FBF0DD"/>
           </a:solidFill>
-          <a:ln w="12700">
-            <a:solidFill>
-              <a:srgbClr val="C7D3E3"/>
-            </a:solidFill>
+          <a:ln>
+            <a:noFill/>
           </a:ln>
           <a:effectLst/>
         </p:spPr>
@@ -6596,9 +6590,9 @@
               </a:spcAft>
             </a:pPr>
             <a:r>
-              <a:rPr sz="1300" b="1">
-                <a:solidFill>
-                  <a:srgbClr val="1F497D"/>
+              <a:rPr sz="1400" b="1">
+                <a:solidFill>
+                  <a:srgbClr val="C77700"/>
                 </a:solidFill>
                 <a:latin typeface="Arial"/>
               </a:rPr>
@@ -6619,7 +6613,7 @@
               </a:spcAft>
             </a:pPr>
             <a:r>
-              <a:rPr sz="1050" b="0">
+              <a:rPr sz="1200" b="0">
                 <a:solidFill>
                   <a:srgbClr val="262B33"/>
                 </a:solidFill>
@@ -6638,14 +6632,14 @@
         </p:nvSpPr>
         <p:spPr>
           <a:xfrm>
-            <a:off x="8330183" y="2084831"/>
-            <a:ext cx="3703320" cy="45720"/>
+            <a:off x="8330183" y="2048256"/>
+            <a:ext cx="3703320" cy="64008"/>
           </a:xfrm>
           <a:prstGeom prst="rect">
             <a:avLst/>
           </a:prstGeom>
           <a:solidFill>
-            <a:srgbClr val="4F81BD"/>
+            <a:srgbClr val="C77700"/>
           </a:solidFill>
           <a:ln>
             <a:noFill/>
@@ -6682,8 +6676,8 @@
         </p:nvSpPr>
         <p:spPr>
           <a:xfrm>
-            <a:off x="411480" y="3584448"/>
-            <a:ext cx="3703320" cy="1335024"/>
+            <a:off x="411480" y="3694176"/>
+            <a:ext cx="3703320" cy="1481328"/>
           </a:xfrm>
           <a:prstGeom prst="roundRect">
             <a:avLst>
@@ -6691,12 +6685,10 @@
             </a:avLst>
           </a:prstGeom>
           <a:solidFill>
-            <a:srgbClr val="EEF3F9"/>
+            <a:srgbClr val="ECEAF7"/>
           </a:solidFill>
-          <a:ln w="12700">
-            <a:solidFill>
-              <a:srgbClr val="C7D3E3"/>
-            </a:solidFill>
+          <a:ln>
+            <a:noFill/>
           </a:ln>
           <a:effectLst/>
         </p:spPr>
@@ -6730,9 +6722,9 @@
               </a:spcAft>
             </a:pPr>
             <a:r>
-              <a:rPr sz="1300" b="1">
-                <a:solidFill>
-                  <a:srgbClr val="1F497D"/>
+              <a:rPr sz="1400" b="1">
+                <a:solidFill>
+                  <a:srgbClr val="4B3F8C"/>
                 </a:solidFill>
                 <a:latin typeface="Arial"/>
               </a:rPr>
@@ -6753,7 +6745,7 @@
               </a:spcAft>
             </a:pPr>
             <a:r>
-              <a:rPr sz="1050" b="0">
+              <a:rPr sz="1200" b="0">
                 <a:solidFill>
                   <a:srgbClr val="262B33"/>
                 </a:solidFill>
@@ -6772,14 +6764,14 @@
         </p:nvSpPr>
         <p:spPr>
           <a:xfrm>
-            <a:off x="411480" y="3584448"/>
-            <a:ext cx="3703320" cy="45720"/>
+            <a:off x="411480" y="3694176"/>
+            <a:ext cx="3703320" cy="64008"/>
           </a:xfrm>
           <a:prstGeom prst="rect">
             <a:avLst/>
           </a:prstGeom>
           <a:solidFill>
-            <a:srgbClr val="4F81BD"/>
+            <a:srgbClr val="4B3F8C"/>
           </a:solidFill>
           <a:ln>
             <a:noFill/>
@@ -6816,8 +6808,8 @@
         </p:nvSpPr>
         <p:spPr>
           <a:xfrm>
-            <a:off x="4370832" y="3584448"/>
-            <a:ext cx="3703320" cy="1335024"/>
+            <a:off x="4370832" y="3694176"/>
+            <a:ext cx="3703320" cy="1481328"/>
           </a:xfrm>
           <a:prstGeom prst="roundRect">
             <a:avLst>
@@ -6825,12 +6817,10 @@
             </a:avLst>
           </a:prstGeom>
           <a:solidFill>
-            <a:srgbClr val="EEF3F9"/>
+            <a:srgbClr val="E2F2F3"/>
           </a:solidFill>
-          <a:ln w="12700">
-            <a:solidFill>
-              <a:srgbClr val="C7D3E3"/>
-            </a:solidFill>
+          <a:ln>
+            <a:noFill/>
           </a:ln>
           <a:effectLst/>
         </p:spPr>
@@ -6864,9 +6854,9 @@
               </a:spcAft>
             </a:pPr>
             <a:r>
-              <a:rPr sz="1300" b="1">
-                <a:solidFill>
-                  <a:srgbClr val="1F497D"/>
+              <a:rPr sz="1400" b="1">
+                <a:solidFill>
+                  <a:srgbClr val="0E7C86"/>
                 </a:solidFill>
                 <a:latin typeface="Arial"/>
               </a:rPr>
@@ -6887,7 +6877,7 @@
               </a:spcAft>
             </a:pPr>
             <a:r>
-              <a:rPr sz="1050" b="0">
+              <a:rPr sz="1200" b="0">
                 <a:solidFill>
                   <a:srgbClr val="262B33"/>
                 </a:solidFill>
@@ -6906,14 +6896,14 @@
         </p:nvSpPr>
         <p:spPr>
           <a:xfrm>
-            <a:off x="4370832" y="3584448"/>
-            <a:ext cx="3703320" cy="45720"/>
+            <a:off x="4370832" y="3694176"/>
+            <a:ext cx="3703320" cy="64008"/>
           </a:xfrm>
           <a:prstGeom prst="rect">
             <a:avLst/>
           </a:prstGeom>
           <a:solidFill>
-            <a:srgbClr val="4F81BD"/>
+            <a:srgbClr val="0E7C86"/>
           </a:solidFill>
           <a:ln>
             <a:noFill/>
@@ -6950,8 +6940,8 @@
         </p:nvSpPr>
         <p:spPr>
           <a:xfrm>
-            <a:off x="8330183" y="3584448"/>
-            <a:ext cx="3703320" cy="1335024"/>
+            <a:off x="8330183" y="3694176"/>
+            <a:ext cx="3703320" cy="1481328"/>
           </a:xfrm>
           <a:prstGeom prst="roundRect">
             <a:avLst>
@@ -6959,12 +6949,10 @@
             </a:avLst>
           </a:prstGeom>
           <a:solidFill>
-            <a:srgbClr val="EEF3F9"/>
+            <a:srgbClr val="F4EAF1"/>
           </a:solidFill>
-          <a:ln w="12700">
-            <a:solidFill>
-              <a:srgbClr val="C7D3E3"/>
-            </a:solidFill>
+          <a:ln>
+            <a:noFill/>
           </a:ln>
           <a:effectLst/>
         </p:spPr>
@@ -6998,9 +6986,9 @@
               </a:spcAft>
             </a:pPr>
             <a:r>
-              <a:rPr sz="1300" b="1">
-                <a:solidFill>
-                  <a:srgbClr val="1F497D"/>
+              <a:rPr sz="1400" b="1">
+                <a:solidFill>
+                  <a:srgbClr val="7A3E6B"/>
                 </a:solidFill>
                 <a:latin typeface="Arial"/>
               </a:rPr>
@@ -7021,7 +7009,7 @@
               </a:spcAft>
             </a:pPr>
             <a:r>
-              <a:rPr sz="1050" b="0">
+              <a:rPr sz="1200" b="0">
                 <a:solidFill>
                   <a:srgbClr val="262B33"/>
                 </a:solidFill>
@@ -7040,14 +7028,14 @@
         </p:nvSpPr>
         <p:spPr>
           <a:xfrm>
-            <a:off x="8330183" y="3584448"/>
-            <a:ext cx="3703320" cy="45720"/>
+            <a:off x="8330183" y="3694176"/>
+            <a:ext cx="3703320" cy="64008"/>
           </a:xfrm>
           <a:prstGeom prst="rect">
             <a:avLst/>
           </a:prstGeom>
           <a:solidFill>
-            <a:srgbClr val="4F81BD"/>
+            <a:srgbClr val="7A3E6B"/>
           </a:solidFill>
           <a:ln>
             <a:noFill/>
@@ -7084,8 +7072,8 @@
         </p:nvSpPr>
         <p:spPr>
           <a:xfrm>
-            <a:off x="411480" y="5138928"/>
-            <a:ext cx="11338560" cy="676656"/>
+            <a:off x="411480" y="5285232"/>
+            <a:ext cx="11338560" cy="640080"/>
           </a:xfrm>
           <a:prstGeom prst="roundRect">
             <a:avLst>
@@ -7093,7 +7081,7 @@
             </a:avLst>
           </a:prstGeom>
           <a:solidFill>
-            <a:srgbClr val="DCE6F1"/>
+            <a:srgbClr val="E4F4EC"/>
           </a:solidFill>
           <a:ln>
             <a:noFill/>
@@ -7130,13 +7118,13 @@
               </a:spcAft>
             </a:pPr>
             <a:r>
-              <a:rPr sz="1300" b="1">
-                <a:solidFill>
-                  <a:srgbClr val="1F497D"/>
+              <a:rPr sz="1400" b="1">
+                <a:solidFill>
+                  <a:srgbClr val="1B8A5A"/>
                 </a:solidFill>
                 <a:latin typeface="Arial"/>
               </a:rPr>
-              <a:t>BUILT AND RUNNING  ·  36,000+ fares collected  ·  15 busiest city pairs × 5 booking lead times  ·  every 10 minutes  ·  ₹0 a month</a:t>
+              <a:t>BUILT AND RUNNING · 36,000+ fares · 15 city pairs × 5 lead times · every 10 minutes · ₹0 a month</a:t>
             </a:r>
           </a:p>
         </p:txBody>
@@ -9124,7 +9112,7 @@
         <p:spPr>
           <a:xfrm>
             <a:off x="411480" y="1133856"/>
-            <a:ext cx="5623560" cy="1170432"/>
+            <a:ext cx="5623560" cy="1188720"/>
           </a:xfrm>
           <a:prstGeom prst="roundRect">
             <a:avLst>
@@ -9132,12 +9120,10 @@
             </a:avLst>
           </a:prstGeom>
           <a:solidFill>
-            <a:srgbClr val="EEF3F9"/>
+            <a:srgbClr val="E8F0F9"/>
           </a:solidFill>
-          <a:ln w="12700">
-            <a:solidFill>
-              <a:srgbClr val="C7D3E3"/>
-            </a:solidFill>
+          <a:ln>
+            <a:noFill/>
           </a:ln>
           <a:effectLst/>
         </p:spPr>
@@ -9171,9 +9157,9 @@
               </a:spcAft>
             </a:pPr>
             <a:r>
-              <a:rPr sz="1350" b="1">
-                <a:solidFill>
-                  <a:srgbClr val="1F497D"/>
+              <a:rPr sz="1450" b="1">
+                <a:solidFill>
+                  <a:srgbClr val="4F81BD"/>
                 </a:solidFill>
                 <a:latin typeface="Arial"/>
               </a:rPr>
@@ -9193,7 +9179,7 @@
               </a:spcAft>
             </a:pPr>
             <a:r>
-              <a:rPr sz="1100" b="0">
+              <a:rPr sz="1200" b="0">
                 <a:solidFill>
                   <a:srgbClr val="262B33"/>
                 </a:solidFill>
@@ -9213,7 +9199,7 @@
         <p:spPr>
           <a:xfrm>
             <a:off x="411480" y="1133856"/>
-            <a:ext cx="50292" cy="1170432"/>
+            <a:ext cx="68580" cy="1188720"/>
           </a:xfrm>
           <a:prstGeom prst="rect">
             <a:avLst/>
@@ -9256,8 +9242,8 @@
         </p:nvSpPr>
         <p:spPr>
           <a:xfrm>
-            <a:off x="411480" y="2414015"/>
-            <a:ext cx="5623560" cy="1170432"/>
+            <a:off x="411480" y="2423160"/>
+            <a:ext cx="5623560" cy="1188720"/>
           </a:xfrm>
           <a:prstGeom prst="roundRect">
             <a:avLst>
@@ -9265,12 +9251,10 @@
             </a:avLst>
           </a:prstGeom>
           <a:solidFill>
-            <a:srgbClr val="EEF3F9"/>
+            <a:srgbClr val="E4F4EC"/>
           </a:solidFill>
-          <a:ln w="12700">
-            <a:solidFill>
-              <a:srgbClr val="C7D3E3"/>
-            </a:solidFill>
+          <a:ln>
+            <a:noFill/>
           </a:ln>
           <a:effectLst/>
         </p:spPr>
@@ -9304,9 +9288,9 @@
               </a:spcAft>
             </a:pPr>
             <a:r>
-              <a:rPr sz="1350" b="1">
-                <a:solidFill>
-                  <a:srgbClr val="1F497D"/>
+              <a:rPr sz="1450" b="1">
+                <a:solidFill>
+                  <a:srgbClr val="1B8A5A"/>
                 </a:solidFill>
                 <a:latin typeface="Arial"/>
               </a:rPr>
@@ -9326,7 +9310,7 @@
               </a:spcAft>
             </a:pPr>
             <a:r>
-              <a:rPr sz="1100" b="0">
+              <a:rPr sz="1200" b="0">
                 <a:solidFill>
                   <a:srgbClr val="262B33"/>
                 </a:solidFill>
@@ -9345,8 +9329,359 @@
         </p:nvSpPr>
         <p:spPr>
           <a:xfrm>
-            <a:off x="411480" y="2414015"/>
-            <a:ext cx="50292" cy="1170432"/>
+            <a:off x="411480" y="2423160"/>
+            <a:ext cx="68580" cy="1188720"/>
+          </a:xfrm>
+          <a:prstGeom prst="rect">
+            <a:avLst/>
+          </a:prstGeom>
+          <a:solidFill>
+            <a:srgbClr val="1B8A5A"/>
+          </a:solidFill>
+          <a:ln>
+            <a:noFill/>
+          </a:ln>
+          <a:effectLst/>
+        </p:spPr>
+        <p:style>
+          <a:lnRef idx="1">
+            <a:schemeClr val="accent1"/>
+          </a:lnRef>
+          <a:fillRef idx="3">
+            <a:schemeClr val="accent1"/>
+          </a:fillRef>
+          <a:effectRef idx="2">
+            <a:schemeClr val="accent1"/>
+          </a:effectRef>
+          <a:fontRef idx="minor">
+            <a:schemeClr val="lt1"/>
+          </a:fontRef>
+        </p:style>
+        <p:txBody>
+          <a:bodyPr rtlCol="0" anchor="ctr"/>
+          <a:lstStyle/>
+          <a:p>
+            <a:pPr algn="ctr"/>
+          </a:p>
+        </p:txBody>
+      </p:sp>
+      <p:sp>
+        <p:nvSpPr>
+          <p:cNvPr id="17414" name="Rounded Rectangle 17413"/>
+          <p:cNvSpPr/>
+          <p:nvPr/>
+        </p:nvSpPr>
+        <p:spPr>
+          <a:xfrm>
+            <a:off x="411480" y="3712463"/>
+            <a:ext cx="5623560" cy="1188720"/>
+          </a:xfrm>
+          <a:prstGeom prst="roundRect">
+            <a:avLst>
+              <a:gd name="adj" fmla="val 6000"/>
+            </a:avLst>
+          </a:prstGeom>
+          <a:solidFill>
+            <a:srgbClr val="FBF0DD"/>
+          </a:solidFill>
+          <a:ln>
+            <a:noFill/>
+          </a:ln>
+          <a:effectLst/>
+        </p:spPr>
+        <p:style>
+          <a:lnRef idx="1">
+            <a:schemeClr val="accent1"/>
+          </a:lnRef>
+          <a:fillRef idx="3">
+            <a:schemeClr val="accent1"/>
+          </a:fillRef>
+          <a:effectRef idx="2">
+            <a:schemeClr val="accent1"/>
+          </a:effectRef>
+          <a:fontRef idx="minor">
+            <a:schemeClr val="lt1"/>
+          </a:fontRef>
+        </p:style>
+        <p:txBody>
+          <a:bodyPr rtlCol="0" anchor="ctr" wrap="square" lIns="36576" rIns="36576" tIns="18288" bIns="18288"/>
+          <a:lstStyle/>
+          <a:p>
+            <a:pPr algn="ctr">
+              <a:lnSpc>
+                <a:spcPct val="95000"/>
+              </a:lnSpc>
+              <a:spcBef>
+                <a:spcPts val="0"/>
+              </a:spcBef>
+              <a:spcAft>
+                <a:spcPts val="0"/>
+              </a:spcAft>
+            </a:pPr>
+            <a:r>
+              <a:rPr sz="1450" b="1">
+                <a:solidFill>
+                  <a:srgbClr val="C77700"/>
+                </a:solidFill>
+                <a:latin typeface="Arial"/>
+              </a:rPr>
+              <a:t>Economic feasibility</a:t>
+            </a:r>
+          </a:p>
+          <a:p>
+            <a:pPr>
+              <a:lnSpc>
+                <a:spcPct val="95000"/>
+              </a:lnSpc>
+              <a:spcBef>
+                <a:spcPts val="400"/>
+              </a:spcBef>
+              <a:spcAft>
+                <a:spcPts val="0"/>
+              </a:spcAft>
+            </a:pPr>
+            <a:r>
+              <a:rPr sz="1200" b="0">
+                <a:solidFill>
+                  <a:srgbClr val="262B33"/>
+                </a:solidFill>
+                <a:latin typeface="Arial"/>
+              </a:rPr>
+              <a:t>The pipeline runs on free tiers at ₹0 a month and ~2 minutes of compute per cycle. MoSPI's field collectors visit shops and markets monthly; this observes 144 times a day without leaving a desk.</a:t>
+            </a:r>
+          </a:p>
+        </p:txBody>
+      </p:sp>
+      <p:sp>
+        <p:nvSpPr>
+          <p:cNvPr id="17415" name="Rectangle 17414"/>
+          <p:cNvSpPr/>
+          <p:nvPr/>
+        </p:nvSpPr>
+        <p:spPr>
+          <a:xfrm>
+            <a:off x="411480" y="3712463"/>
+            <a:ext cx="68580" cy="1188720"/>
+          </a:xfrm>
+          <a:prstGeom prst="rect">
+            <a:avLst/>
+          </a:prstGeom>
+          <a:solidFill>
+            <a:srgbClr val="C77700"/>
+          </a:solidFill>
+          <a:ln>
+            <a:noFill/>
+          </a:ln>
+          <a:effectLst/>
+        </p:spPr>
+        <p:style>
+          <a:lnRef idx="1">
+            <a:schemeClr val="accent1"/>
+          </a:lnRef>
+          <a:fillRef idx="3">
+            <a:schemeClr val="accent1"/>
+          </a:fillRef>
+          <a:effectRef idx="2">
+            <a:schemeClr val="accent1"/>
+          </a:effectRef>
+          <a:fontRef idx="minor">
+            <a:schemeClr val="lt1"/>
+          </a:fontRef>
+        </p:style>
+        <p:txBody>
+          <a:bodyPr rtlCol="0" anchor="ctr"/>
+          <a:lstStyle/>
+          <a:p>
+            <a:pPr algn="ctr"/>
+          </a:p>
+        </p:txBody>
+      </p:sp>
+      <p:sp>
+        <p:nvSpPr>
+          <p:cNvPr id="17416" name="Rounded Rectangle 17415"/>
+          <p:cNvSpPr/>
+          <p:nvPr/>
+        </p:nvSpPr>
+        <p:spPr>
+          <a:xfrm>
+            <a:off x="411480" y="5001768"/>
+            <a:ext cx="5623560" cy="1188720"/>
+          </a:xfrm>
+          <a:prstGeom prst="roundRect">
+            <a:avLst>
+              <a:gd name="adj" fmla="val 6000"/>
+            </a:avLst>
+          </a:prstGeom>
+          <a:solidFill>
+            <a:srgbClr val="ECEAF7"/>
+          </a:solidFill>
+          <a:ln>
+            <a:noFill/>
+          </a:ln>
+          <a:effectLst/>
+        </p:spPr>
+        <p:style>
+          <a:lnRef idx="1">
+            <a:schemeClr val="accent1"/>
+          </a:lnRef>
+          <a:fillRef idx="3">
+            <a:schemeClr val="accent1"/>
+          </a:fillRef>
+          <a:effectRef idx="2">
+            <a:schemeClr val="accent1"/>
+          </a:effectRef>
+          <a:fontRef idx="minor">
+            <a:schemeClr val="lt1"/>
+          </a:fontRef>
+        </p:style>
+        <p:txBody>
+          <a:bodyPr rtlCol="0" anchor="ctr" wrap="square" lIns="36576" rIns="36576" tIns="18288" bIns="18288"/>
+          <a:lstStyle/>
+          <a:p>
+            <a:pPr algn="ctr">
+              <a:lnSpc>
+                <a:spcPct val="95000"/>
+              </a:lnSpc>
+              <a:spcBef>
+                <a:spcPts val="0"/>
+              </a:spcBef>
+              <a:spcAft>
+                <a:spcPts val="0"/>
+              </a:spcAft>
+            </a:pPr>
+            <a:r>
+              <a:rPr sz="1450" b="1">
+                <a:solidFill>
+                  <a:srgbClr val="4B3F8C"/>
+                </a:solidFill>
+                <a:latin typeface="Arial"/>
+              </a:rPr>
+              <a:t>Regulatory feasibility</a:t>
+            </a:r>
+          </a:p>
+          <a:p>
+            <a:pPr>
+              <a:lnSpc>
+                <a:spcPct val="95000"/>
+              </a:lnSpc>
+              <a:spcBef>
+                <a:spcPts val="400"/>
+              </a:spcBef>
+              <a:spcAft>
+                <a:spcPts val="0"/>
+              </a:spcAft>
+            </a:pPr>
+            <a:r>
+              <a:rPr sz="1200" b="0">
+                <a:solidFill>
+                  <a:srgbClr val="262B33"/>
+                </a:solidFill>
+                <a:latin typeface="Arial"/>
+              </a:rPr>
+              <a:t>Eurostat publishes guidance on web-scraped prices for HICP and names air fares explicitly. ONS has done it since 2014. The method is precedented in official statistics, not experimental.</a:t>
+            </a:r>
+          </a:p>
+        </p:txBody>
+      </p:sp>
+      <p:sp>
+        <p:nvSpPr>
+          <p:cNvPr id="17417" name="Rectangle 17416"/>
+          <p:cNvSpPr/>
+          <p:nvPr/>
+        </p:nvSpPr>
+        <p:spPr>
+          <a:xfrm>
+            <a:off x="411480" y="5001768"/>
+            <a:ext cx="68580" cy="1188720"/>
+          </a:xfrm>
+          <a:prstGeom prst="rect">
+            <a:avLst/>
+          </a:prstGeom>
+          <a:solidFill>
+            <a:srgbClr val="4B3F8C"/>
+          </a:solidFill>
+          <a:ln>
+            <a:noFill/>
+          </a:ln>
+          <a:effectLst/>
+        </p:spPr>
+        <p:style>
+          <a:lnRef idx="1">
+            <a:schemeClr val="accent1"/>
+          </a:lnRef>
+          <a:fillRef idx="3">
+            <a:schemeClr val="accent1"/>
+          </a:fillRef>
+          <a:effectRef idx="2">
+            <a:schemeClr val="accent1"/>
+          </a:effectRef>
+          <a:fontRef idx="minor">
+            <a:schemeClr val="lt1"/>
+          </a:fontRef>
+        </p:style>
+        <p:txBody>
+          <a:bodyPr rtlCol="0" anchor="ctr"/>
+          <a:lstStyle/>
+          <a:p>
+            <a:pPr algn="ctr"/>
+          </a:p>
+        </p:txBody>
+      </p:sp>
+      <p:sp>
+        <p:nvSpPr>
+          <p:cNvPr id="17418" name="TextBox 17417"/>
+          <p:cNvSpPr txBox="1"/>
+          <p:nvPr/>
+        </p:nvSpPr>
+        <p:spPr>
+          <a:xfrm>
+            <a:off x="6400800" y="1133856"/>
+            <a:ext cx="5394960" cy="274320"/>
+          </a:xfrm>
+          <a:prstGeom prst="rect">
+            <a:avLst/>
+          </a:prstGeom>
+          <a:noFill/>
+        </p:spPr>
+        <p:txBody>
+          <a:bodyPr wrap="square" lIns="36576" rIns="36576" tIns="18288" bIns="18288">
+            <a:spAutoFit/>
+          </a:bodyPr>
+          <a:lstStyle/>
+          <a:p>
+            <a:pPr>
+              <a:lnSpc>
+                <a:spcPct val="95000"/>
+              </a:lnSpc>
+              <a:spcBef>
+                <a:spcPts val="0"/>
+              </a:spcBef>
+              <a:spcAft>
+                <a:spcPts val="0"/>
+              </a:spcAft>
+            </a:pPr>
+            <a:r>
+              <a:rPr sz="1500" b="1">
+                <a:solidFill>
+                  <a:srgbClr val="1F497D"/>
+                </a:solidFill>
+                <a:latin typeface="Arial"/>
+              </a:rPr>
+              <a:t>Risks, and what we did about them</a:t>
+            </a:r>
+          </a:p>
+        </p:txBody>
+      </p:sp>
+      <p:sp>
+        <p:nvSpPr>
+          <p:cNvPr id="17419" name="Rectangle 17418"/>
+          <p:cNvSpPr/>
+          <p:nvPr/>
+        </p:nvSpPr>
+        <p:spPr>
+          <a:xfrm>
+            <a:off x="6419088" y="1408176"/>
+            <a:ext cx="1371600" cy="25603"/>
           </a:xfrm>
           <a:prstGeom prst="rect">
             <a:avLst/>
@@ -9383,14 +9718,14 @@
       </p:sp>
       <p:sp>
         <p:nvSpPr>
-          <p:cNvPr id="17414" name="Rounded Rectangle 17413"/>
+          <p:cNvPr id="17420" name="Rounded Rectangle 17419"/>
           <p:cNvSpPr/>
           <p:nvPr/>
         </p:nvSpPr>
         <p:spPr>
           <a:xfrm>
-            <a:off x="411480" y="3694175"/>
-            <a:ext cx="5623560" cy="1170432"/>
+            <a:off x="6400800" y="1554480"/>
+            <a:ext cx="5394960" cy="868680"/>
           </a:xfrm>
           <a:prstGeom prst="roundRect">
             <a:avLst>
@@ -9398,367 +9733,10 @@
             </a:avLst>
           </a:prstGeom>
           <a:solidFill>
-            <a:srgbClr val="EEF3F9"/>
-          </a:solidFill>
-          <a:ln w="12700">
-            <a:solidFill>
-              <a:srgbClr val="C7D3E3"/>
-            </a:solidFill>
-          </a:ln>
-          <a:effectLst/>
-        </p:spPr>
-        <p:style>
-          <a:lnRef idx="1">
-            <a:schemeClr val="accent1"/>
-          </a:lnRef>
-          <a:fillRef idx="3">
-            <a:schemeClr val="accent1"/>
-          </a:fillRef>
-          <a:effectRef idx="2">
-            <a:schemeClr val="accent1"/>
-          </a:effectRef>
-          <a:fontRef idx="minor">
-            <a:schemeClr val="lt1"/>
-          </a:fontRef>
-        </p:style>
-        <p:txBody>
-          <a:bodyPr rtlCol="0" anchor="ctr" wrap="square" lIns="36576" rIns="36576" tIns="18288" bIns="18288"/>
-          <a:lstStyle/>
-          <a:p>
-            <a:pPr algn="ctr">
-              <a:lnSpc>
-                <a:spcPct val="95000"/>
-              </a:lnSpc>
-              <a:spcBef>
-                <a:spcPts val="0"/>
-              </a:spcBef>
-              <a:spcAft>
-                <a:spcPts val="0"/>
-              </a:spcAft>
-            </a:pPr>
-            <a:r>
-              <a:rPr sz="1350" b="1">
-                <a:solidFill>
-                  <a:srgbClr val="1F497D"/>
-                </a:solidFill>
-                <a:latin typeface="Arial"/>
-              </a:rPr>
-              <a:t>Economic feasibility</a:t>
-            </a:r>
-          </a:p>
-          <a:p>
-            <a:pPr>
-              <a:lnSpc>
-                <a:spcPct val="95000"/>
-              </a:lnSpc>
-              <a:spcBef>
-                <a:spcPts val="400"/>
-              </a:spcBef>
-              <a:spcAft>
-                <a:spcPts val="0"/>
-              </a:spcAft>
-            </a:pPr>
-            <a:r>
-              <a:rPr sz="1100" b="0">
-                <a:solidFill>
-                  <a:srgbClr val="262B33"/>
-                </a:solidFill>
-                <a:latin typeface="Arial"/>
-              </a:rPr>
-              <a:t>The pipeline runs on free tiers at ₹0 a month and ~2 minutes of compute per cycle. MoSPI's field collectors visit shops and markets monthly; this observes 144 times a day without leaving a desk.</a:t>
-            </a:r>
-          </a:p>
-        </p:txBody>
-      </p:sp>
-      <p:sp>
-        <p:nvSpPr>
-          <p:cNvPr id="17415" name="Rectangle 17414"/>
-          <p:cNvSpPr/>
-          <p:nvPr/>
-        </p:nvSpPr>
-        <p:spPr>
-          <a:xfrm>
-            <a:off x="411480" y="3694175"/>
-            <a:ext cx="50292" cy="1170432"/>
-          </a:xfrm>
-          <a:prstGeom prst="rect">
-            <a:avLst/>
-          </a:prstGeom>
-          <a:solidFill>
-            <a:srgbClr val="4F81BD"/>
+            <a:srgbClr val="FAEEEE"/>
           </a:solidFill>
           <a:ln>
             <a:noFill/>
-          </a:ln>
-          <a:effectLst/>
-        </p:spPr>
-        <p:style>
-          <a:lnRef idx="1">
-            <a:schemeClr val="accent1"/>
-          </a:lnRef>
-          <a:fillRef idx="3">
-            <a:schemeClr val="accent1"/>
-          </a:fillRef>
-          <a:effectRef idx="2">
-            <a:schemeClr val="accent1"/>
-          </a:effectRef>
-          <a:fontRef idx="minor">
-            <a:schemeClr val="lt1"/>
-          </a:fontRef>
-        </p:style>
-        <p:txBody>
-          <a:bodyPr rtlCol="0" anchor="ctr"/>
-          <a:lstStyle/>
-          <a:p>
-            <a:pPr algn="ctr"/>
-          </a:p>
-        </p:txBody>
-      </p:sp>
-      <p:sp>
-        <p:nvSpPr>
-          <p:cNvPr id="17416" name="Rounded Rectangle 17415"/>
-          <p:cNvSpPr/>
-          <p:nvPr/>
-        </p:nvSpPr>
-        <p:spPr>
-          <a:xfrm>
-            <a:off x="411480" y="4974336"/>
-            <a:ext cx="5623560" cy="1170432"/>
-          </a:xfrm>
-          <a:prstGeom prst="roundRect">
-            <a:avLst>
-              <a:gd name="adj" fmla="val 6000"/>
-            </a:avLst>
-          </a:prstGeom>
-          <a:solidFill>
-            <a:srgbClr val="EEF3F9"/>
-          </a:solidFill>
-          <a:ln w="12700">
-            <a:solidFill>
-              <a:srgbClr val="C7D3E3"/>
-            </a:solidFill>
-          </a:ln>
-          <a:effectLst/>
-        </p:spPr>
-        <p:style>
-          <a:lnRef idx="1">
-            <a:schemeClr val="accent1"/>
-          </a:lnRef>
-          <a:fillRef idx="3">
-            <a:schemeClr val="accent1"/>
-          </a:fillRef>
-          <a:effectRef idx="2">
-            <a:schemeClr val="accent1"/>
-          </a:effectRef>
-          <a:fontRef idx="minor">
-            <a:schemeClr val="lt1"/>
-          </a:fontRef>
-        </p:style>
-        <p:txBody>
-          <a:bodyPr rtlCol="0" anchor="ctr" wrap="square" lIns="36576" rIns="36576" tIns="18288" bIns="18288"/>
-          <a:lstStyle/>
-          <a:p>
-            <a:pPr algn="ctr">
-              <a:lnSpc>
-                <a:spcPct val="95000"/>
-              </a:lnSpc>
-              <a:spcBef>
-                <a:spcPts val="0"/>
-              </a:spcBef>
-              <a:spcAft>
-                <a:spcPts val="0"/>
-              </a:spcAft>
-            </a:pPr>
-            <a:r>
-              <a:rPr sz="1350" b="1">
-                <a:solidFill>
-                  <a:srgbClr val="1F497D"/>
-                </a:solidFill>
-                <a:latin typeface="Arial"/>
-              </a:rPr>
-              <a:t>Regulatory feasibility</a:t>
-            </a:r>
-          </a:p>
-          <a:p>
-            <a:pPr>
-              <a:lnSpc>
-                <a:spcPct val="95000"/>
-              </a:lnSpc>
-              <a:spcBef>
-                <a:spcPts val="400"/>
-              </a:spcBef>
-              <a:spcAft>
-                <a:spcPts val="0"/>
-              </a:spcAft>
-            </a:pPr>
-            <a:r>
-              <a:rPr sz="1100" b="0">
-                <a:solidFill>
-                  <a:srgbClr val="262B33"/>
-                </a:solidFill>
-                <a:latin typeface="Arial"/>
-              </a:rPr>
-              <a:t>Eurostat publishes guidance on web-scraped prices for HICP and names air fares explicitly. ONS has done it since 2014. The method is precedented in official statistics, not experimental.</a:t>
-            </a:r>
-          </a:p>
-        </p:txBody>
-      </p:sp>
-      <p:sp>
-        <p:nvSpPr>
-          <p:cNvPr id="17417" name="Rectangle 17416"/>
-          <p:cNvSpPr/>
-          <p:nvPr/>
-        </p:nvSpPr>
-        <p:spPr>
-          <a:xfrm>
-            <a:off x="411480" y="4974336"/>
-            <a:ext cx="50292" cy="1170432"/>
-          </a:xfrm>
-          <a:prstGeom prst="rect">
-            <a:avLst/>
-          </a:prstGeom>
-          <a:solidFill>
-            <a:srgbClr val="4F81BD"/>
-          </a:solidFill>
-          <a:ln>
-            <a:noFill/>
-          </a:ln>
-          <a:effectLst/>
-        </p:spPr>
-        <p:style>
-          <a:lnRef idx="1">
-            <a:schemeClr val="accent1"/>
-          </a:lnRef>
-          <a:fillRef idx="3">
-            <a:schemeClr val="accent1"/>
-          </a:fillRef>
-          <a:effectRef idx="2">
-            <a:schemeClr val="accent1"/>
-          </a:effectRef>
-          <a:fontRef idx="minor">
-            <a:schemeClr val="lt1"/>
-          </a:fontRef>
-        </p:style>
-        <p:txBody>
-          <a:bodyPr rtlCol="0" anchor="ctr"/>
-          <a:lstStyle/>
-          <a:p>
-            <a:pPr algn="ctr"/>
-          </a:p>
-        </p:txBody>
-      </p:sp>
-      <p:sp>
-        <p:nvSpPr>
-          <p:cNvPr id="17418" name="TextBox 17417"/>
-          <p:cNvSpPr txBox="1"/>
-          <p:nvPr/>
-        </p:nvSpPr>
-        <p:spPr>
-          <a:xfrm>
-            <a:off x="6400800" y="1133856"/>
-            <a:ext cx="5394960" cy="274320"/>
-          </a:xfrm>
-          <a:prstGeom prst="rect">
-            <a:avLst/>
-          </a:prstGeom>
-          <a:noFill/>
-        </p:spPr>
-        <p:txBody>
-          <a:bodyPr wrap="square" lIns="36576" rIns="36576" tIns="18288" bIns="18288">
-            <a:spAutoFit/>
-          </a:bodyPr>
-          <a:lstStyle/>
-          <a:p>
-            <a:pPr>
-              <a:lnSpc>
-                <a:spcPct val="95000"/>
-              </a:lnSpc>
-              <a:spcBef>
-                <a:spcPts val="0"/>
-              </a:spcBef>
-              <a:spcAft>
-                <a:spcPts val="0"/>
-              </a:spcAft>
-            </a:pPr>
-            <a:r>
-              <a:rPr sz="1400" b="1">
-                <a:solidFill>
-                  <a:srgbClr val="1F497D"/>
-                </a:solidFill>
-                <a:latin typeface="Arial"/>
-              </a:rPr>
-              <a:t>Risks, and what we did about them</a:t>
-            </a:r>
-          </a:p>
-        </p:txBody>
-      </p:sp>
-      <p:sp>
-        <p:nvSpPr>
-          <p:cNvPr id="17419" name="Rectangle 17418"/>
-          <p:cNvSpPr/>
-          <p:nvPr/>
-        </p:nvSpPr>
-        <p:spPr>
-          <a:xfrm>
-            <a:off x="6419088" y="1408176"/>
-            <a:ext cx="1371600" cy="25603"/>
-          </a:xfrm>
-          <a:prstGeom prst="rect">
-            <a:avLst/>
-          </a:prstGeom>
-          <a:solidFill>
-            <a:srgbClr val="4F81BD"/>
-          </a:solidFill>
-          <a:ln>
-            <a:noFill/>
-          </a:ln>
-          <a:effectLst/>
-        </p:spPr>
-        <p:style>
-          <a:lnRef idx="1">
-            <a:schemeClr val="accent1"/>
-          </a:lnRef>
-          <a:fillRef idx="3">
-            <a:schemeClr val="accent1"/>
-          </a:fillRef>
-          <a:effectRef idx="2">
-            <a:schemeClr val="accent1"/>
-          </a:effectRef>
-          <a:fontRef idx="minor">
-            <a:schemeClr val="lt1"/>
-          </a:fontRef>
-        </p:style>
-        <p:txBody>
-          <a:bodyPr rtlCol="0" anchor="ctr"/>
-          <a:lstStyle/>
-          <a:p>
-            <a:pPr algn="ctr"/>
-          </a:p>
-        </p:txBody>
-      </p:sp>
-      <p:sp>
-        <p:nvSpPr>
-          <p:cNvPr id="17420" name="Rounded Rectangle 17419"/>
-          <p:cNvSpPr/>
-          <p:nvPr/>
-        </p:nvSpPr>
-        <p:spPr>
-          <a:xfrm>
-            <a:off x="6400800" y="1554480"/>
-            <a:ext cx="5394960" cy="868680"/>
-          </a:xfrm>
-          <a:prstGeom prst="roundRect">
-            <a:avLst>
-              <a:gd name="adj" fmla="val 6000"/>
-            </a:avLst>
-          </a:prstGeom>
-          <a:solidFill>
-            <a:srgbClr val="EEF3F9"/>
-          </a:solidFill>
-          <a:ln w="12700">
-            <a:solidFill>
-              <a:srgbClr val="C7D3E3"/>
-            </a:solidFill>
           </a:ln>
           <a:effectLst/>
         </p:spPr>
@@ -9836,8 +9814,8 @@
         </p:nvSpPr>
         <p:spPr>
           <a:xfrm>
-            <a:off x="6583680" y="1664207"/>
-            <a:ext cx="5120640" cy="685800"/>
+            <a:off x="6583680" y="1655064"/>
+            <a:ext cx="5120640" cy="713232"/>
           </a:xfrm>
           <a:prstGeom prst="rect">
             <a:avLst/>
@@ -9862,9 +9840,9 @@
               </a:spcAft>
             </a:pPr>
             <a:r>
-              <a:rPr sz="1300" b="1">
-                <a:solidFill>
-                  <a:srgbClr val="1F497D"/>
+              <a:rPr sz="1400" b="1">
+                <a:solidFill>
+                  <a:srgbClr val="A63A3A"/>
                 </a:solidFill>
                 <a:latin typeface="Arial"/>
               </a:rPr>
@@ -9884,7 +9862,7 @@
               </a:spcAft>
             </a:pPr>
             <a:r>
-              <a:rPr sz="1150" b="0">
+              <a:rPr sz="1200" b="0">
                 <a:solidFill>
                   <a:srgbClr val="262B33"/>
                 </a:solidFill>
@@ -9912,12 +9890,10 @@
             </a:avLst>
           </a:prstGeom>
           <a:solidFill>
-            <a:srgbClr val="EEF3F9"/>
+            <a:srgbClr val="FAEEEE"/>
           </a:solidFill>
-          <a:ln w="12700">
-            <a:solidFill>
-              <a:srgbClr val="C7D3E3"/>
-            </a:solidFill>
+          <a:ln>
+            <a:noFill/>
           </a:ln>
           <a:effectLst/>
         </p:spPr>
@@ -9995,8 +9971,8 @@
         </p:nvSpPr>
         <p:spPr>
           <a:xfrm>
-            <a:off x="6583680" y="2606040"/>
-            <a:ext cx="5120640" cy="685800"/>
+            <a:off x="6583680" y="2596896"/>
+            <a:ext cx="5120640" cy="713232"/>
           </a:xfrm>
           <a:prstGeom prst="rect">
             <a:avLst/>
@@ -10021,9 +9997,9 @@
               </a:spcAft>
             </a:pPr>
             <a:r>
-              <a:rPr sz="1300" b="1">
-                <a:solidFill>
-                  <a:srgbClr val="1F497D"/>
+              <a:rPr sz="1400" b="1">
+                <a:solidFill>
+                  <a:srgbClr val="A63A3A"/>
                 </a:solidFill>
                 <a:latin typeface="Arial"/>
               </a:rPr>
@@ -10043,7 +10019,7 @@
               </a:spcAft>
             </a:pPr>
             <a:r>
-              <a:rPr sz="1150" b="0">
+              <a:rPr sz="1200" b="0">
                 <a:solidFill>
                   <a:srgbClr val="262B33"/>
                 </a:solidFill>
@@ -10071,12 +10047,10 @@
             </a:avLst>
           </a:prstGeom>
           <a:solidFill>
-            <a:srgbClr val="EEF3F9"/>
+            <a:srgbClr val="FAEEEE"/>
           </a:solidFill>
-          <a:ln w="12700">
-            <a:solidFill>
-              <a:srgbClr val="C7D3E3"/>
-            </a:solidFill>
+          <a:ln>
+            <a:noFill/>
           </a:ln>
           <a:effectLst/>
         </p:spPr>
@@ -10154,8 +10128,8 @@
         </p:nvSpPr>
         <p:spPr>
           <a:xfrm>
-            <a:off x="6583680" y="3547872"/>
-            <a:ext cx="5120640" cy="685800"/>
+            <a:off x="6583680" y="3538727"/>
+            <a:ext cx="5120640" cy="713232"/>
           </a:xfrm>
           <a:prstGeom prst="rect">
             <a:avLst/>
@@ -10180,9 +10154,9 @@
               </a:spcAft>
             </a:pPr>
             <a:r>
-              <a:rPr sz="1300" b="1">
-                <a:solidFill>
-                  <a:srgbClr val="1F497D"/>
+              <a:rPr sz="1400" b="1">
+                <a:solidFill>
+                  <a:srgbClr val="A63A3A"/>
                 </a:solidFill>
                 <a:latin typeface="Arial"/>
               </a:rPr>
@@ -10202,7 +10176,7 @@
               </a:spcAft>
             </a:pPr>
             <a:r>
-              <a:rPr sz="1150" b="0">
+              <a:rPr sz="1200" b="0">
                 <a:solidFill>
                   <a:srgbClr val="262B33"/>
                 </a:solidFill>
@@ -10230,12 +10204,10 @@
             </a:avLst>
           </a:prstGeom>
           <a:solidFill>
-            <a:srgbClr val="EEF3F9"/>
+            <a:srgbClr val="FAEEEE"/>
           </a:solidFill>
-          <a:ln w="12700">
-            <a:solidFill>
-              <a:srgbClr val="C7D3E3"/>
-            </a:solidFill>
+          <a:ln>
+            <a:noFill/>
           </a:ln>
           <a:effectLst/>
         </p:spPr>
@@ -10313,8 +10285,8 @@
         </p:nvSpPr>
         <p:spPr>
           <a:xfrm>
-            <a:off x="6583680" y="4489704"/>
-            <a:ext cx="5120640" cy="685800"/>
+            <a:off x="6583680" y="4480560"/>
+            <a:ext cx="5120640" cy="713232"/>
           </a:xfrm>
           <a:prstGeom prst="rect">
             <a:avLst/>
@@ -10339,9 +10311,9 @@
               </a:spcAft>
             </a:pPr>
             <a:r>
-              <a:rPr sz="1300" b="1">
-                <a:solidFill>
-                  <a:srgbClr val="1F497D"/>
+              <a:rPr sz="1400" b="1">
+                <a:solidFill>
+                  <a:srgbClr val="A63A3A"/>
                 </a:solidFill>
                 <a:latin typeface="Arial"/>
               </a:rPr>
@@ -10361,7 +10333,7 @@
               </a:spcAft>
             </a:pPr>
             <a:r>
-              <a:rPr sz="1150" b="0">
+              <a:rPr sz="1200" b="0">
                 <a:solidFill>
                   <a:srgbClr val="262B33"/>
                 </a:solidFill>
@@ -10778,7 +10750,7 @@
               </a:spcAft>
             </a:pPr>
             <a:r>
-              <a:rPr sz="1400" b="1">
+              <a:rPr sz="1500" b="1">
                 <a:solidFill>
                   <a:srgbClr val="1F497D"/>
                 </a:solidFill>
@@ -10842,7 +10814,7 @@
         <p:spPr>
           <a:xfrm>
             <a:off x="411480" y="1554480"/>
-            <a:ext cx="1700784" cy="1243584"/>
+            <a:ext cx="1700784" cy="1298448"/>
           </a:xfrm>
           <a:prstGeom prst="roundRect">
             <a:avLst>
@@ -10850,12 +10822,10 @@
             </a:avLst>
           </a:prstGeom>
           <a:solidFill>
-            <a:srgbClr val="EEF3F9"/>
+            <a:srgbClr val="E8F0F9"/>
           </a:solidFill>
-          <a:ln w="12700">
-            <a:solidFill>
-              <a:srgbClr val="C7D3E3"/>
-            </a:solidFill>
+          <a:ln>
+            <a:noFill/>
           </a:ln>
           <a:effectLst/>
         </p:spPr>
@@ -10889,7 +10859,7 @@
               </a:spcAft>
             </a:pPr>
             <a:r>
-              <a:rPr sz="1150" b="1">
+              <a:rPr sz="1200" b="1">
                 <a:solidFill>
                   <a:srgbClr val="4F81BD"/>
                 </a:solidFill>
@@ -10911,7 +10881,7 @@
               </a:spcAft>
             </a:pPr>
             <a:r>
-              <a:rPr sz="1250" b="1">
+              <a:rPr sz="1300" b="1">
                 <a:solidFill>
                   <a:srgbClr val="1F497D"/>
                 </a:solidFill>
@@ -10933,7 +10903,7 @@
               </a:spcAft>
             </a:pPr>
             <a:r>
-              <a:rPr sz="950" b="0">
+              <a:rPr sz="1050" b="0">
                 <a:solidFill>
                   <a:srgbClr val="5A626C"/>
                 </a:solidFill>
@@ -10998,7 +10968,7 @@
         <p:spPr>
           <a:xfrm>
             <a:off x="2331720" y="1554480"/>
-            <a:ext cx="1700784" cy="1243584"/>
+            <a:ext cx="1700784" cy="1298448"/>
           </a:xfrm>
           <a:prstGeom prst="roundRect">
             <a:avLst>
@@ -11006,12 +10976,10 @@
             </a:avLst>
           </a:prstGeom>
           <a:solidFill>
-            <a:srgbClr val="EEF3F9"/>
+            <a:srgbClr val="E4F4EC"/>
           </a:solidFill>
-          <a:ln w="12700">
-            <a:solidFill>
-              <a:srgbClr val="C7D3E3"/>
-            </a:solidFill>
+          <a:ln>
+            <a:noFill/>
           </a:ln>
           <a:effectLst/>
         </p:spPr>
@@ -11045,9 +11013,9 @@
               </a:spcAft>
             </a:pPr>
             <a:r>
-              <a:rPr sz="1150" b="1">
-                <a:solidFill>
-                  <a:srgbClr val="4F81BD"/>
+              <a:rPr sz="1200" b="1">
+                <a:solidFill>
+                  <a:srgbClr val="1B8A5A"/>
                 </a:solidFill>
                 <a:latin typeface="Arial"/>
               </a:rPr>
@@ -11067,7 +11035,7 @@
               </a:spcAft>
             </a:pPr>
             <a:r>
-              <a:rPr sz="1250" b="1">
+              <a:rPr sz="1300" b="1">
                 <a:solidFill>
                   <a:srgbClr val="1F497D"/>
                 </a:solidFill>
@@ -11089,7 +11057,7 @@
               </a:spcAft>
             </a:pPr>
             <a:r>
-              <a:rPr sz="950" b="0">
+              <a:rPr sz="1050" b="0">
                 <a:solidFill>
                   <a:srgbClr val="5A626C"/>
                 </a:solidFill>
@@ -11154,7 +11122,7 @@
         <p:spPr>
           <a:xfrm>
             <a:off x="4251960" y="1554480"/>
-            <a:ext cx="1700784" cy="1243584"/>
+            <a:ext cx="1700784" cy="1298448"/>
           </a:xfrm>
           <a:prstGeom prst="roundRect">
             <a:avLst>
@@ -11162,12 +11130,10 @@
             </a:avLst>
           </a:prstGeom>
           <a:solidFill>
-            <a:srgbClr val="EEF3F9"/>
+            <a:srgbClr val="FBF0DD"/>
           </a:solidFill>
-          <a:ln w="12700">
-            <a:solidFill>
-              <a:srgbClr val="C7D3E3"/>
-            </a:solidFill>
+          <a:ln>
+            <a:noFill/>
           </a:ln>
           <a:effectLst/>
         </p:spPr>
@@ -11201,9 +11167,9 @@
               </a:spcAft>
             </a:pPr>
             <a:r>
-              <a:rPr sz="1150" b="1">
-                <a:solidFill>
-                  <a:srgbClr val="4F81BD"/>
+              <a:rPr sz="1200" b="1">
+                <a:solidFill>
+                  <a:srgbClr val="C77700"/>
                 </a:solidFill>
                 <a:latin typeface="Arial"/>
               </a:rPr>
@@ -11223,7 +11189,7 @@
               </a:spcAft>
             </a:pPr>
             <a:r>
-              <a:rPr sz="1250" b="1">
+              <a:rPr sz="1300" b="1">
                 <a:solidFill>
                   <a:srgbClr val="1F497D"/>
                 </a:solidFill>
@@ -11245,7 +11211,7 @@
               </a:spcAft>
             </a:pPr>
             <a:r>
-              <a:rPr sz="950" b="0">
+              <a:rPr sz="1050" b="0">
                 <a:solidFill>
                   <a:srgbClr val="5A626C"/>
                 </a:solidFill>
@@ -11310,7 +11276,7 @@
         <p:spPr>
           <a:xfrm>
             <a:off x="6172200" y="1554480"/>
-            <a:ext cx="1700784" cy="1243584"/>
+            <a:ext cx="1700784" cy="1298448"/>
           </a:xfrm>
           <a:prstGeom prst="roundRect">
             <a:avLst>
@@ -11318,12 +11284,10 @@
             </a:avLst>
           </a:prstGeom>
           <a:solidFill>
-            <a:srgbClr val="EEF3F9"/>
+            <a:srgbClr val="ECEAF7"/>
           </a:solidFill>
-          <a:ln w="12700">
-            <a:solidFill>
-              <a:srgbClr val="C7D3E3"/>
-            </a:solidFill>
+          <a:ln>
+            <a:noFill/>
           </a:ln>
           <a:effectLst/>
         </p:spPr>
@@ -11357,9 +11321,9 @@
               </a:spcAft>
             </a:pPr>
             <a:r>
-              <a:rPr sz="1150" b="1">
-                <a:solidFill>
-                  <a:srgbClr val="4F81BD"/>
+              <a:rPr sz="1200" b="1">
+                <a:solidFill>
+                  <a:srgbClr val="4B3F8C"/>
                 </a:solidFill>
                 <a:latin typeface="Arial"/>
               </a:rPr>
@@ -11379,7 +11343,7 @@
               </a:spcAft>
             </a:pPr>
             <a:r>
-              <a:rPr sz="1250" b="1">
+              <a:rPr sz="1300" b="1">
                 <a:solidFill>
                   <a:srgbClr val="1F497D"/>
                 </a:solidFill>
@@ -11401,7 +11365,7 @@
               </a:spcAft>
             </a:pPr>
             <a:r>
-              <a:rPr sz="950" b="0">
+              <a:rPr sz="1050" b="0">
                 <a:solidFill>
                   <a:srgbClr val="5A626C"/>
                 </a:solidFill>
@@ -11466,7 +11430,7 @@
         <p:spPr>
           <a:xfrm>
             <a:off x="8092440" y="1554480"/>
-            <a:ext cx="1700784" cy="1243584"/>
+            <a:ext cx="1700784" cy="1298448"/>
           </a:xfrm>
           <a:prstGeom prst="roundRect">
             <a:avLst>
@@ -11474,12 +11438,10 @@
             </a:avLst>
           </a:prstGeom>
           <a:solidFill>
-            <a:srgbClr val="EEF3F9"/>
+            <a:srgbClr val="E2F2F3"/>
           </a:solidFill>
-          <a:ln w="12700">
-            <a:solidFill>
-              <a:srgbClr val="C7D3E3"/>
-            </a:solidFill>
+          <a:ln>
+            <a:noFill/>
           </a:ln>
           <a:effectLst/>
         </p:spPr>
@@ -11513,9 +11475,9 @@
               </a:spcAft>
             </a:pPr>
             <a:r>
-              <a:rPr sz="1150" b="1">
-                <a:solidFill>
-                  <a:srgbClr val="4F81BD"/>
+              <a:rPr sz="1200" b="1">
+                <a:solidFill>
+                  <a:srgbClr val="0E7C86"/>
                 </a:solidFill>
                 <a:latin typeface="Arial"/>
               </a:rPr>
@@ -11535,7 +11497,7 @@
               </a:spcAft>
             </a:pPr>
             <a:r>
-              <a:rPr sz="1250" b="1">
+              <a:rPr sz="1300" b="1">
                 <a:solidFill>
                   <a:srgbClr val="1F497D"/>
                 </a:solidFill>
@@ -11557,7 +11519,7 @@
               </a:spcAft>
             </a:pPr>
             <a:r>
-              <a:rPr sz="950" b="0">
+              <a:rPr sz="1050" b="0">
                 <a:solidFill>
                   <a:srgbClr val="5A626C"/>
                 </a:solidFill>
@@ -11622,7 +11584,7 @@
         <p:spPr>
           <a:xfrm>
             <a:off x="10012680" y="1554480"/>
-            <a:ext cx="1700784" cy="1243584"/>
+            <a:ext cx="1700784" cy="1298448"/>
           </a:xfrm>
           <a:prstGeom prst="roundRect">
             <a:avLst>
@@ -11630,12 +11592,10 @@
             </a:avLst>
           </a:prstGeom>
           <a:solidFill>
-            <a:srgbClr val="EEF3F9"/>
+            <a:srgbClr val="F4EAF1"/>
           </a:solidFill>
-          <a:ln w="12700">
-            <a:solidFill>
-              <a:srgbClr val="C7D3E3"/>
-            </a:solidFill>
+          <a:ln>
+            <a:noFill/>
           </a:ln>
           <a:effectLst/>
         </p:spPr>
@@ -11669,9 +11629,9 @@
               </a:spcAft>
             </a:pPr>
             <a:r>
-              <a:rPr sz="1150" b="1">
-                <a:solidFill>
-                  <a:srgbClr val="4F81BD"/>
+              <a:rPr sz="1200" b="1">
+                <a:solidFill>
+                  <a:srgbClr val="7A3E6B"/>
                 </a:solidFill>
                 <a:latin typeface="Arial"/>
               </a:rPr>
@@ -11691,7 +11651,7 @@
               </a:spcAft>
             </a:pPr>
             <a:r>
-              <a:rPr sz="1250" b="1">
+              <a:rPr sz="1300" b="1">
                 <a:solidFill>
                   <a:srgbClr val="1F497D"/>
                 </a:solidFill>
@@ -11713,7 +11673,7 @@
               </a:spcAft>
             </a:pPr>
             <a:r>
-              <a:rPr sz="950" b="0">
+              <a:rPr sz="1050" b="0">
                 <a:solidFill>
                   <a:srgbClr val="5A626C"/>
                 </a:solidFill>
@@ -11727,7 +11687,7 @@
       </p:sp>
       <p:pic>
         <p:nvPicPr>
-          <p:cNvPr id="17423" name="Picture 17422" descr="chart-apix.png"/>
+          <p:cNvPr id="17423" name="Picture 17422" descr="portal-shot.png"/>
           <p:cNvPicPr>
             <a:picLocks noChangeAspect="1"/>
           </p:cNvPicPr>
@@ -11741,8 +11701,8 @@
         </p:blipFill>
         <p:spPr>
           <a:xfrm>
-            <a:off x="411480" y="3035808"/>
-            <a:ext cx="5669280" cy="2448098"/>
+            <a:off x="411480" y="3072384"/>
+            <a:ext cx="5669280" cy="2755900"/>
           </a:xfrm>
           <a:prstGeom prst="rect">
             <a:avLst/>
@@ -11752,6 +11712,74 @@
       <p:sp>
         <p:nvSpPr>
           <p:cNvPr id="17424" name="TextBox 17423"/>
+          <p:cNvSpPr txBox="1"/>
+          <p:nvPr/>
+        </p:nvSpPr>
+        <p:spPr>
+          <a:xfrm>
+            <a:off x="411480" y="5870448"/>
+            <a:ext cx="5669280" cy="402336"/>
+          </a:xfrm>
+          <a:prstGeom prst="rect">
+            <a:avLst/>
+          </a:prstGeom>
+          <a:noFill/>
+        </p:spPr>
+        <p:txBody>
+          <a:bodyPr wrap="square" lIns="36576" rIns="36576">
+            <a:spAutoFit/>
+          </a:bodyPr>
+          <a:lstStyle/>
+          <a:p>
+            <a:pPr>
+              <a:lnSpc>
+                <a:spcPct val="100000"/>
+              </a:lnSpc>
+              <a:spcBef>
+                <a:spcPts val="0"/>
+              </a:spcBef>
+              <a:spcAft>
+                <a:spcPts val="0"/>
+              </a:spcAft>
+            </a:pPr>
+            <a:r>
+              <a:rPr sz="1200" b="1">
+                <a:solidFill>
+                  <a:srgbClr val="4F81BD"/>
+                </a:solidFill>
+                <a:latin typeface="Arial"/>
+                <a:hlinkClick r:id="rId5"/>
+              </a:rPr>
+              <a:t>Live: apix-portal.pages.dev</a:t>
+            </a:r>
+          </a:p>
+          <a:p>
+            <a:pPr>
+              <a:lnSpc>
+                <a:spcPct val="100000"/>
+              </a:lnSpc>
+              <a:spcBef>
+                <a:spcPts val="200"/>
+              </a:spcBef>
+              <a:spcAft>
+                <a:spcPts val="0"/>
+              </a:spcAft>
+            </a:pPr>
+            <a:r>
+              <a:rPr sz="1100" b="0">
+                <a:solidFill>
+                  <a:srgbClr val="5A626C"/>
+                </a:solidFill>
+                <a:latin typeface="Arial"/>
+              </a:rPr>
+              <a:t>Headline inflation, release status and the method, stated on the page.</a:t>
+            </a:r>
+          </a:p>
+        </p:txBody>
+      </p:sp>
+      <p:sp>
+        <p:nvSpPr>
+          <p:cNvPr id="17425" name="TextBox 17424"/>
           <p:cNvSpPr txBox="1"/>
           <p:nvPr/>
         </p:nvSpPr>
@@ -11783,7 +11811,7 @@
               </a:spcAft>
             </a:pPr>
             <a:r>
-              <a:rPr sz="1400" b="1">
+              <a:rPr sz="1500" b="1">
                 <a:solidFill>
                   <a:srgbClr val="1F497D"/>
                 </a:solidFill>
@@ -11796,7 +11824,7 @@
       </p:sp>
       <p:sp>
         <p:nvSpPr>
-          <p:cNvPr id="17425" name="Rectangle 17424"/>
+          <p:cNvPr id="17426" name="Rectangle 17425"/>
           <p:cNvSpPr/>
           <p:nvPr/>
         </p:nvSpPr>
@@ -11840,14 +11868,14 @@
       </p:sp>
       <p:sp>
         <p:nvSpPr>
-          <p:cNvPr id="17426" name="Rounded Rectangle 17425"/>
+          <p:cNvPr id="17427" name="Rounded Rectangle 17426"/>
           <p:cNvSpPr/>
           <p:nvPr/>
         </p:nvSpPr>
         <p:spPr>
           <a:xfrm>
             <a:off x="6400800" y="3438144"/>
-            <a:ext cx="1600200" cy="274320"/>
+            <a:ext cx="1691640" cy="292608"/>
           </a:xfrm>
           <a:prstGeom prst="roundRect">
             <a:avLst>
@@ -11855,7 +11883,7 @@
             </a:avLst>
           </a:prstGeom>
           <a:solidFill>
-            <a:srgbClr val="1F497D"/>
+            <a:srgbClr val="4F81BD"/>
           </a:solidFill>
           <a:ln>
             <a:noFill/>
@@ -11882,7 +11910,7 @@
           <a:p>
             <a:pPr algn="ctr"/>
             <a:r>
-              <a:rPr sz="1000" b="1">
+              <a:rPr sz="1100" b="1">
                 <a:solidFill>
                   <a:srgbClr val="FFFFFF"/>
                 </a:solidFill>
@@ -11895,14 +11923,14 @@
       </p:sp>
       <p:sp>
         <p:nvSpPr>
-          <p:cNvPr id="17427" name="TextBox 17426"/>
+          <p:cNvPr id="17428" name="TextBox 17427"/>
           <p:cNvSpPr txBox="1"/>
           <p:nvPr/>
         </p:nvSpPr>
         <p:spPr>
           <a:xfrm>
-            <a:off x="8183879" y="3419856"/>
-            <a:ext cx="3611880" cy="457200"/>
+            <a:off x="8275320" y="3419856"/>
+            <a:ext cx="3520440" cy="457200"/>
           </a:xfrm>
           <a:prstGeom prst="rect">
             <a:avLst/>
@@ -11927,7 +11955,7 @@
               </a:spcAft>
             </a:pPr>
             <a:r>
-              <a:rPr sz="1150" b="0">
+              <a:rPr sz="1200" b="0">
                 <a:solidFill>
                   <a:srgbClr val="262B33"/>
                 </a:solidFill>
@@ -11940,14 +11968,14 @@
       </p:sp>
       <p:sp>
         <p:nvSpPr>
-          <p:cNvPr id="17428" name="Rounded Rectangle 17427"/>
+          <p:cNvPr id="17429" name="Rounded Rectangle 17428"/>
           <p:cNvSpPr/>
           <p:nvPr/>
         </p:nvSpPr>
         <p:spPr>
           <a:xfrm>
-            <a:off x="6400800" y="3950208"/>
-            <a:ext cx="1600200" cy="274320"/>
+            <a:off x="6400800" y="3986783"/>
+            <a:ext cx="1691640" cy="292608"/>
           </a:xfrm>
           <a:prstGeom prst="roundRect">
             <a:avLst>
@@ -11955,7 +11983,7 @@
             </a:avLst>
           </a:prstGeom>
           <a:solidFill>
-            <a:srgbClr val="1F497D"/>
+            <a:srgbClr val="1B8A5A"/>
           </a:solidFill>
           <a:ln>
             <a:noFill/>
@@ -11982,7 +12010,7 @@
           <a:p>
             <a:pPr algn="ctr"/>
             <a:r>
-              <a:rPr sz="1000" b="1">
+              <a:rPr sz="1100" b="1">
                 <a:solidFill>
                   <a:srgbClr val="FFFFFF"/>
                 </a:solidFill>
@@ -11995,14 +12023,14 @@
       </p:sp>
       <p:sp>
         <p:nvSpPr>
-          <p:cNvPr id="17429" name="TextBox 17428"/>
+          <p:cNvPr id="17430" name="TextBox 17429"/>
           <p:cNvSpPr txBox="1"/>
           <p:nvPr/>
         </p:nvSpPr>
         <p:spPr>
           <a:xfrm>
-            <a:off x="8183879" y="3931920"/>
-            <a:ext cx="3611880" cy="457200"/>
+            <a:off x="8275320" y="3968496"/>
+            <a:ext cx="3520440" cy="457200"/>
           </a:xfrm>
           <a:prstGeom prst="rect">
             <a:avLst/>
@@ -12027,7 +12055,7 @@
               </a:spcAft>
             </a:pPr>
             <a:r>
-              <a:rPr sz="1150" b="0">
+              <a:rPr sz="1200" b="0">
                 <a:solidFill>
                   <a:srgbClr val="262B33"/>
                 </a:solidFill>
@@ -12040,14 +12068,14 @@
       </p:sp>
       <p:sp>
         <p:nvSpPr>
-          <p:cNvPr id="17430" name="Rounded Rectangle 17429"/>
+          <p:cNvPr id="17431" name="Rounded Rectangle 17430"/>
           <p:cNvSpPr/>
           <p:nvPr/>
         </p:nvSpPr>
         <p:spPr>
           <a:xfrm>
-            <a:off x="6400800" y="4462272"/>
-            <a:ext cx="1600200" cy="274320"/>
+            <a:off x="6400800" y="4535423"/>
+            <a:ext cx="1691640" cy="292608"/>
           </a:xfrm>
           <a:prstGeom prst="roundRect">
             <a:avLst>
@@ -12055,7 +12083,7 @@
             </a:avLst>
           </a:prstGeom>
           <a:solidFill>
-            <a:srgbClr val="1F497D"/>
+            <a:srgbClr val="C77700"/>
           </a:solidFill>
           <a:ln>
             <a:noFill/>
@@ -12082,7 +12110,7 @@
           <a:p>
             <a:pPr algn="ctr"/>
             <a:r>
-              <a:rPr sz="1000" b="1">
+              <a:rPr sz="1100" b="1">
                 <a:solidFill>
                   <a:srgbClr val="FFFFFF"/>
                 </a:solidFill>
@@ -12095,14 +12123,14 @@
       </p:sp>
       <p:sp>
         <p:nvSpPr>
-          <p:cNvPr id="17431" name="TextBox 17430"/>
+          <p:cNvPr id="17432" name="TextBox 17431"/>
           <p:cNvSpPr txBox="1"/>
           <p:nvPr/>
         </p:nvSpPr>
         <p:spPr>
           <a:xfrm>
-            <a:off x="8183879" y="4443984"/>
-            <a:ext cx="3611880" cy="457200"/>
+            <a:off x="8275320" y="4517136"/>
+            <a:ext cx="3520440" cy="457200"/>
           </a:xfrm>
           <a:prstGeom prst="rect">
             <a:avLst/>
@@ -12127,7 +12155,7 @@
               </a:spcAft>
             </a:pPr>
             <a:r>
-              <a:rPr sz="1150" b="0">
+              <a:rPr sz="1200" b="0">
                 <a:solidFill>
                   <a:srgbClr val="262B33"/>
                 </a:solidFill>
@@ -12140,14 +12168,14 @@
       </p:sp>
       <p:sp>
         <p:nvSpPr>
-          <p:cNvPr id="17432" name="Rounded Rectangle 17431"/>
+          <p:cNvPr id="17433" name="Rounded Rectangle 17432"/>
           <p:cNvSpPr/>
           <p:nvPr/>
         </p:nvSpPr>
         <p:spPr>
           <a:xfrm>
-            <a:off x="6400800" y="4974336"/>
-            <a:ext cx="1600200" cy="274320"/>
+            <a:off x="6400800" y="5084063"/>
+            <a:ext cx="1691640" cy="292608"/>
           </a:xfrm>
           <a:prstGeom prst="roundRect">
             <a:avLst>
@@ -12155,7 +12183,7 @@
             </a:avLst>
           </a:prstGeom>
           <a:solidFill>
-            <a:srgbClr val="1F497D"/>
+            <a:srgbClr val="4B3F8C"/>
           </a:solidFill>
           <a:ln>
             <a:noFill/>
@@ -12182,7 +12210,7 @@
           <a:p>
             <a:pPr algn="ctr"/>
             <a:r>
-              <a:rPr sz="1000" b="1">
+              <a:rPr sz="1100" b="1">
                 <a:solidFill>
                   <a:srgbClr val="FFFFFF"/>
                 </a:solidFill>
@@ -12195,14 +12223,14 @@
       </p:sp>
       <p:sp>
         <p:nvSpPr>
-          <p:cNvPr id="17433" name="TextBox 17432"/>
+          <p:cNvPr id="17434" name="TextBox 17433"/>
           <p:cNvSpPr txBox="1"/>
           <p:nvPr/>
         </p:nvSpPr>
         <p:spPr>
           <a:xfrm>
-            <a:off x="8183879" y="4956048"/>
-            <a:ext cx="3611880" cy="457200"/>
+            <a:off x="8275320" y="5065775"/>
+            <a:ext cx="3520440" cy="457200"/>
           </a:xfrm>
           <a:prstGeom prst="rect">
             <a:avLst/>
@@ -12227,7 +12255,7 @@
               </a:spcAft>
             </a:pPr>
             <a:r>
-              <a:rPr sz="1150" b="0">
+              <a:rPr sz="1200" b="0">
                 <a:solidFill>
                   <a:srgbClr val="262B33"/>
                 </a:solidFill>
@@ -12240,14 +12268,14 @@
       </p:sp>
       <p:sp>
         <p:nvSpPr>
-          <p:cNvPr id="17434" name="Rounded Rectangle 17433"/>
+          <p:cNvPr id="17435" name="Rounded Rectangle 17434"/>
           <p:cNvSpPr/>
           <p:nvPr/>
         </p:nvSpPr>
         <p:spPr>
           <a:xfrm>
-            <a:off x="6400800" y="5541264"/>
-            <a:ext cx="5394960" cy="731520"/>
+            <a:off x="6400800" y="5504688"/>
+            <a:ext cx="5394960" cy="768096"/>
           </a:xfrm>
           <a:prstGeom prst="roundRect">
             <a:avLst>
@@ -12255,7 +12283,7 @@
             </a:avLst>
           </a:prstGeom>
           <a:solidFill>
-            <a:srgbClr val="DCE6F1"/>
+            <a:srgbClr val="E4F4EC"/>
           </a:solidFill>
           <a:ln>
             <a:noFill/>
@@ -12292,9 +12320,9 @@
               </a:spcAft>
             </a:pPr>
             <a:r>
-              <a:rPr sz="1050" b="1">
-                <a:solidFill>
-                  <a:srgbClr val="1F497D"/>
+              <a:rPr sz="1150" b="1">
+                <a:solidFill>
+                  <a:srgbClr val="1B8A5A"/>
                 </a:solidFill>
                 <a:latin typeface="Arial"/>
               </a:rPr>
@@ -12314,7 +12342,7 @@
               </a:spcAft>
             </a:pPr>
             <a:r>
-              <a:rPr sz="1200" b="0">
+              <a:rPr sz="1300" b="0">
                 <a:solidFill>
                   <a:srgbClr val="262B33"/>
                 </a:solidFill>
@@ -12706,7 +12734,7 @@
         <p:spPr>
           <a:xfrm>
             <a:off x="411480" y="1133856"/>
-            <a:ext cx="3703320" cy="1664208"/>
+            <a:ext cx="3703320" cy="1700784"/>
           </a:xfrm>
           <a:prstGeom prst="roundRect">
             <a:avLst>
@@ -12714,12 +12742,10 @@
             </a:avLst>
           </a:prstGeom>
           <a:solidFill>
-            <a:srgbClr val="EEF3F9"/>
+            <a:srgbClr val="E8F0F9"/>
           </a:solidFill>
-          <a:ln w="12700">
-            <a:solidFill>
-              <a:srgbClr val="C7D3E3"/>
-            </a:solidFill>
+          <a:ln>
+            <a:noFill/>
           </a:ln>
           <a:effectLst/>
         </p:spPr>
@@ -12738,51 +12764,10 @@
           </a:fontRef>
         </p:style>
         <p:txBody>
-          <a:bodyPr rtlCol="0" anchor="ctr" wrap="square" lIns="36576" rIns="36576" tIns="18288" bIns="18288"/>
-          <a:lstStyle/>
-          <a:p>
-            <a:pPr algn="ctr">
-              <a:lnSpc>
-                <a:spcPct val="95000"/>
-              </a:lnSpc>
-              <a:spcBef>
-                <a:spcPts val="0"/>
-              </a:spcBef>
-              <a:spcAft>
-                <a:spcPts val="0"/>
-              </a:spcAft>
-            </a:pPr>
-            <a:r>
-              <a:rPr sz="1250" b="1">
-                <a:solidFill>
-                  <a:srgbClr val="1F497D"/>
-                </a:solidFill>
-                <a:latin typeface="Arial"/>
-              </a:rPr>
-              <a:t>Method — why Jevons</a:t>
-            </a:r>
-          </a:p>
-          <a:p>
-            <a:pPr>
-              <a:lnSpc>
-                <a:spcPct val="95000"/>
-              </a:lnSpc>
-              <a:spcBef>
-                <a:spcPts val="500"/>
-              </a:spcBef>
-              <a:spcAft>
-                <a:spcPts val="0"/>
-              </a:spcAft>
-            </a:pPr>
-            <a:r>
-              <a:rPr sz="1000" b="0">
-                <a:solidFill>
-                  <a:srgbClr val="262B33"/>
-                </a:solidFill>
-                <a:latin typeface="Arial"/>
-              </a:rPr>
-              <a:t>Eurostat, Practical guidelines on web scraping for the HICP (2020). Names air fares explicitly as a scraped category. HICP is a chain-linked Laspeyres index built on Jevons elementary aggregates.</a:t>
-            </a:r>
+          <a:bodyPr rtlCol="0" anchor="ctr" wrap="square"/>
+          <a:lstStyle/>
+          <a:p>
+            <a:pPr algn="ctr"/>
           </a:p>
         </p:txBody>
       </p:sp>
@@ -12795,7 +12780,7 @@
         <p:spPr>
           <a:xfrm>
             <a:off x="411480" y="1133856"/>
-            <a:ext cx="3703320" cy="45720"/>
+            <a:ext cx="3703320" cy="64008"/>
           </a:xfrm>
           <a:prstGeom prst="rect">
             <a:avLst/>
@@ -12832,14 +12817,104 @@
       </p:sp>
       <p:sp>
         <p:nvSpPr>
-          <p:cNvPr id="17412" name="Rounded Rectangle 17411"/>
+          <p:cNvPr id="17412" name="TextBox 17411"/>
+          <p:cNvSpPr txBox="1"/>
+          <p:nvPr/>
+        </p:nvSpPr>
+        <p:spPr>
+          <a:xfrm>
+            <a:off x="557784" y="1280160"/>
+            <a:ext cx="3410712" cy="1444752"/>
+          </a:xfrm>
+          <a:prstGeom prst="rect">
+            <a:avLst/>
+          </a:prstGeom>
+          <a:noFill/>
+        </p:spPr>
+        <p:txBody>
+          <a:bodyPr wrap="square" lIns="36576" rIns="36576">
+            <a:spAutoFit/>
+          </a:bodyPr>
+          <a:lstStyle/>
+          <a:p>
+            <a:pPr>
+              <a:lnSpc>
+                <a:spcPct val="100000"/>
+              </a:lnSpc>
+              <a:spcBef>
+                <a:spcPts val="0"/>
+              </a:spcBef>
+              <a:spcAft>
+                <a:spcPts val="0"/>
+              </a:spcAft>
+            </a:pPr>
+            <a:r>
+              <a:rPr sz="1350" b="1">
+                <a:solidFill>
+                  <a:srgbClr val="4F81BD"/>
+                </a:solidFill>
+                <a:latin typeface="Arial"/>
+              </a:rPr>
+              <a:t>Method — why Jevons</a:t>
+            </a:r>
+          </a:p>
+          <a:p>
+            <a:pPr>
+              <a:lnSpc>
+                <a:spcPct val="100000"/>
+              </a:lnSpc>
+              <a:spcBef>
+                <a:spcPts val="400"/>
+              </a:spcBef>
+              <a:spcAft>
+                <a:spcPts val="0"/>
+              </a:spcAft>
+            </a:pPr>
+            <a:r>
+              <a:rPr sz="1150" b="0">
+                <a:solidFill>
+                  <a:srgbClr val="262B33"/>
+                </a:solidFill>
+                <a:latin typeface="Arial"/>
+              </a:rPr>
+              <a:t>Eurostat, Practical guidelines on web scraping for the HICP (2020). Names air fares explicitly as a scraped category.</a:t>
+            </a:r>
+          </a:p>
+          <a:p>
+            <a:pPr>
+              <a:lnSpc>
+                <a:spcPct val="100000"/>
+              </a:lnSpc>
+              <a:spcBef>
+                <a:spcPts val="500"/>
+              </a:spcBef>
+              <a:spcAft>
+                <a:spcPts val="0"/>
+              </a:spcAft>
+            </a:pPr>
+            <a:r>
+              <a:rPr sz="1100" b="1">
+                <a:solidFill>
+                  <a:srgbClr val="4F81BD"/>
+                </a:solidFill>
+                <a:latin typeface="Arial"/>
+                <a:hlinkClick r:id="rId4"/>
+              </a:rPr>
+              <a:t>Eurostat HICP guidance →</a:t>
+            </a:r>
+          </a:p>
+        </p:txBody>
+      </p:sp>
+      <p:sp>
+        <p:nvSpPr>
+          <p:cNvPr id="17413" name="Rounded Rectangle 17412"/>
           <p:cNvSpPr/>
           <p:nvPr/>
         </p:nvSpPr>
         <p:spPr>
           <a:xfrm>
             <a:off x="4370832" y="1133856"/>
-            <a:ext cx="3703320" cy="1664208"/>
+            <a:ext cx="3703320" cy="1700784"/>
           </a:xfrm>
           <a:prstGeom prst="roundRect">
             <a:avLst>
@@ -12847,12 +12922,10 @@
             </a:avLst>
           </a:prstGeom>
           <a:solidFill>
-            <a:srgbClr val="EEF3F9"/>
+            <a:srgbClr val="E4F4EC"/>
           </a:solidFill>
-          <a:ln w="12700">
-            <a:solidFill>
-              <a:srgbClr val="C7D3E3"/>
-            </a:solidFill>
+          <a:ln>
+            <a:noFill/>
           </a:ln>
           <a:effectLst/>
         </p:spPr>
@@ -12871,12 +12944,82 @@
           </a:fontRef>
         </p:style>
         <p:txBody>
-          <a:bodyPr rtlCol="0" anchor="ctr" wrap="square" lIns="36576" rIns="36576" tIns="18288" bIns="18288"/>
-          <a:lstStyle/>
-          <a:p>
-            <a:pPr algn="ctr">
+          <a:bodyPr rtlCol="0" anchor="ctr" wrap="square"/>
+          <a:lstStyle/>
+          <a:p>
+            <a:pPr algn="ctr"/>
+          </a:p>
+        </p:txBody>
+      </p:sp>
+      <p:sp>
+        <p:nvSpPr>
+          <p:cNvPr id="17414" name="Rectangle 17413"/>
+          <p:cNvSpPr/>
+          <p:nvPr/>
+        </p:nvSpPr>
+        <p:spPr>
+          <a:xfrm>
+            <a:off x="4370832" y="1133856"/>
+            <a:ext cx="3703320" cy="64008"/>
+          </a:xfrm>
+          <a:prstGeom prst="rect">
+            <a:avLst/>
+          </a:prstGeom>
+          <a:solidFill>
+            <a:srgbClr val="1B8A5A"/>
+          </a:solidFill>
+          <a:ln>
+            <a:noFill/>
+          </a:ln>
+          <a:effectLst/>
+        </p:spPr>
+        <p:style>
+          <a:lnRef idx="1">
+            <a:schemeClr val="accent1"/>
+          </a:lnRef>
+          <a:fillRef idx="3">
+            <a:schemeClr val="accent1"/>
+          </a:fillRef>
+          <a:effectRef idx="2">
+            <a:schemeClr val="accent1"/>
+          </a:effectRef>
+          <a:fontRef idx="minor">
+            <a:schemeClr val="lt1"/>
+          </a:fontRef>
+        </p:style>
+        <p:txBody>
+          <a:bodyPr rtlCol="0" anchor="ctr"/>
+          <a:lstStyle/>
+          <a:p>
+            <a:pPr algn="ctr"/>
+          </a:p>
+        </p:txBody>
+      </p:sp>
+      <p:sp>
+        <p:nvSpPr>
+          <p:cNvPr id="17415" name="TextBox 17414"/>
+          <p:cNvSpPr txBox="1"/>
+          <p:nvPr/>
+        </p:nvSpPr>
+        <p:spPr>
+          <a:xfrm>
+            <a:off x="4517136" y="1280160"/>
+            <a:ext cx="3410712" cy="1444752"/>
+          </a:xfrm>
+          <a:prstGeom prst="rect">
+            <a:avLst/>
+          </a:prstGeom>
+          <a:noFill/>
+        </p:spPr>
+        <p:txBody>
+          <a:bodyPr wrap="square" lIns="36576" rIns="36576">
+            <a:spAutoFit/>
+          </a:bodyPr>
+          <a:lstStyle/>
+          <a:p>
+            <a:pPr>
               <a:lnSpc>
-                <a:spcPct val="95000"/>
+                <a:spcPct val="100000"/>
               </a:lnSpc>
               <a:spcBef>
                 <a:spcPts val="0"/>
@@ -12886,19 +13029,41 @@
               </a:spcAft>
             </a:pPr>
             <a:r>
-              <a:rPr sz="1250" b="1">
-                <a:solidFill>
-                  <a:srgbClr val="1F497D"/>
+              <a:rPr sz="1350" b="1">
+                <a:solidFill>
+                  <a:srgbClr val="1B8A5A"/>
                 </a:solidFill>
                 <a:latin typeface="Arial"/>
               </a:rPr>
-              <a:t>Precedent — it is already done</a:t>
+              <a:t>Precedent — already done</a:t>
             </a:r>
           </a:p>
           <a:p>
             <a:pPr>
               <a:lnSpc>
-                <a:spcPct val="95000"/>
+                <a:spcPct val="100000"/>
+              </a:lnSpc>
+              <a:spcBef>
+                <a:spcPts val="400"/>
+              </a:spcBef>
+              <a:spcAft>
+                <a:spcPts val="0"/>
+              </a:spcAft>
+            </a:pPr>
+            <a:r>
+              <a:rPr sz="1150" b="0">
+                <a:solidFill>
+                  <a:srgbClr val="262B33"/>
+                </a:solidFill>
+                <a:latin typeface="Arial"/>
+              </a:rPr>
+              <a:t>ONS ran a web-scraping programme for consumer prices from 2014, Eurostat-funded from 2015.</a:t>
+            </a:r>
+          </a:p>
+          <a:p>
+            <a:pPr>
+              <a:lnSpc>
+                <a:spcPct val="100000"/>
               </a:lnSpc>
               <a:spcBef>
                 <a:spcPts val="500"/>
@@ -12908,71 +13073,28 @@
               </a:spcAft>
             </a:pPr>
             <a:r>
-              <a:rPr sz="1000" b="0">
-                <a:solidFill>
-                  <a:srgbClr val="262B33"/>
+              <a:rPr sz="1100" b="1">
+                <a:solidFill>
+                  <a:srgbClr val="4F81BD"/>
                 </a:solidFill>
                 <a:latin typeface="Arial"/>
+                <a:hlinkClick r:id="rId5"/>
               </a:rPr>
-              <a:t>ONS ran a web-scraping programme for consumer prices from 2014, Eurostat-funded from 2015. Knížat (2023), Web scraped data in consumer price indices, on aggregating daily scraped prices to monthly.</a:t>
-            </a:r>
-          </a:p>
-        </p:txBody>
-      </p:sp>
-      <p:sp>
-        <p:nvSpPr>
-          <p:cNvPr id="17413" name="Rectangle 17412"/>
+              <a:t>ONS research indices →</a:t>
+            </a:r>
+          </a:p>
+        </p:txBody>
+      </p:sp>
+      <p:sp>
+        <p:nvSpPr>
+          <p:cNvPr id="17416" name="Rounded Rectangle 17415"/>
           <p:cNvSpPr/>
           <p:nvPr/>
         </p:nvSpPr>
         <p:spPr>
           <a:xfrm>
-            <a:off x="4370832" y="1133856"/>
-            <a:ext cx="3703320" cy="45720"/>
-          </a:xfrm>
-          <a:prstGeom prst="rect">
-            <a:avLst/>
-          </a:prstGeom>
-          <a:solidFill>
-            <a:srgbClr val="4F81BD"/>
-          </a:solidFill>
-          <a:ln>
-            <a:noFill/>
-          </a:ln>
-          <a:effectLst/>
-        </p:spPr>
-        <p:style>
-          <a:lnRef idx="1">
-            <a:schemeClr val="accent1"/>
-          </a:lnRef>
-          <a:fillRef idx="3">
-            <a:schemeClr val="accent1"/>
-          </a:fillRef>
-          <a:effectRef idx="2">
-            <a:schemeClr val="accent1"/>
-          </a:effectRef>
-          <a:fontRef idx="minor">
-            <a:schemeClr val="lt1"/>
-          </a:fontRef>
-        </p:style>
-        <p:txBody>
-          <a:bodyPr rtlCol="0" anchor="ctr"/>
-          <a:lstStyle/>
-          <a:p>
-            <a:pPr algn="ctr"/>
-          </a:p>
-        </p:txBody>
-      </p:sp>
-      <p:sp>
-        <p:nvSpPr>
-          <p:cNvPr id="17414" name="Rounded Rectangle 17413"/>
-          <p:cNvSpPr/>
-          <p:nvPr/>
-        </p:nvSpPr>
-        <p:spPr>
-          <a:xfrm>
             <a:off x="8330183" y="1133856"/>
-            <a:ext cx="3703320" cy="1664208"/>
+            <a:ext cx="3703320" cy="1700784"/>
           </a:xfrm>
           <a:prstGeom prst="roundRect">
             <a:avLst>
@@ -12980,12 +13102,10 @@
             </a:avLst>
           </a:prstGeom>
           <a:solidFill>
-            <a:srgbClr val="EEF3F9"/>
+            <a:srgbClr val="FBF0DD"/>
           </a:solidFill>
-          <a:ln w="12700">
-            <a:solidFill>
-              <a:srgbClr val="C7D3E3"/>
-            </a:solidFill>
+          <a:ln>
+            <a:noFill/>
           </a:ln>
           <a:effectLst/>
         </p:spPr>
@@ -13004,12 +13124,82 @@
           </a:fontRef>
         </p:style>
         <p:txBody>
-          <a:bodyPr rtlCol="0" anchor="ctr" wrap="square" lIns="36576" rIns="36576" tIns="18288" bIns="18288"/>
-          <a:lstStyle/>
-          <a:p>
-            <a:pPr algn="ctr">
+          <a:bodyPr rtlCol="0" anchor="ctr" wrap="square"/>
+          <a:lstStyle/>
+          <a:p>
+            <a:pPr algn="ctr"/>
+          </a:p>
+        </p:txBody>
+      </p:sp>
+      <p:sp>
+        <p:nvSpPr>
+          <p:cNvPr id="17417" name="Rectangle 17416"/>
+          <p:cNvSpPr/>
+          <p:nvPr/>
+        </p:nvSpPr>
+        <p:spPr>
+          <a:xfrm>
+            <a:off x="8330183" y="1133856"/>
+            <a:ext cx="3703320" cy="64008"/>
+          </a:xfrm>
+          <a:prstGeom prst="rect">
+            <a:avLst/>
+          </a:prstGeom>
+          <a:solidFill>
+            <a:srgbClr val="C77700"/>
+          </a:solidFill>
+          <a:ln>
+            <a:noFill/>
+          </a:ln>
+          <a:effectLst/>
+        </p:spPr>
+        <p:style>
+          <a:lnRef idx="1">
+            <a:schemeClr val="accent1"/>
+          </a:lnRef>
+          <a:fillRef idx="3">
+            <a:schemeClr val="accent1"/>
+          </a:fillRef>
+          <a:effectRef idx="2">
+            <a:schemeClr val="accent1"/>
+          </a:effectRef>
+          <a:fontRef idx="minor">
+            <a:schemeClr val="lt1"/>
+          </a:fontRef>
+        </p:style>
+        <p:txBody>
+          <a:bodyPr rtlCol="0" anchor="ctr"/>
+          <a:lstStyle/>
+          <a:p>
+            <a:pPr algn="ctr"/>
+          </a:p>
+        </p:txBody>
+      </p:sp>
+      <p:sp>
+        <p:nvSpPr>
+          <p:cNvPr id="17418" name="TextBox 17417"/>
+          <p:cNvSpPr txBox="1"/>
+          <p:nvPr/>
+        </p:nvSpPr>
+        <p:spPr>
+          <a:xfrm>
+            <a:off x="8476488" y="1280160"/>
+            <a:ext cx="3410712" cy="1444752"/>
+          </a:xfrm>
+          <a:prstGeom prst="rect">
+            <a:avLst/>
+          </a:prstGeom>
+          <a:noFill/>
+        </p:spPr>
+        <p:txBody>
+          <a:bodyPr wrap="square" lIns="36576" rIns="36576">
+            <a:spAutoFit/>
+          </a:bodyPr>
+          <a:lstStyle/>
+          <a:p>
+            <a:pPr>
               <a:lnSpc>
-                <a:spcPct val="95000"/>
+                <a:spcPct val="100000"/>
               </a:lnSpc>
               <a:spcBef>
                 <a:spcPts val="0"/>
@@ -13019,9 +13209,9 @@
               </a:spcAft>
             </a:pPr>
             <a:r>
-              <a:rPr sz="1250" b="1">
-                <a:solidFill>
-                  <a:srgbClr val="1F497D"/>
+              <a:rPr sz="1350" b="1">
+                <a:solidFill>
+                  <a:srgbClr val="C77700"/>
                 </a:solidFill>
                 <a:latin typeface="Arial"/>
               </a:rPr>
@@ -13031,7 +13221,29 @@
           <a:p>
             <a:pPr>
               <a:lnSpc>
-                <a:spcPct val="95000"/>
+                <a:spcPct val="100000"/>
+              </a:lnSpc>
+              <a:spcBef>
+                <a:spcPts val="400"/>
+              </a:spcBef>
+              <a:spcAft>
+                <a:spcPts val="0"/>
+              </a:spcAft>
+            </a:pPr>
+            <a:r>
+              <a:rPr sz="1150" b="0">
+                <a:solidFill>
+                  <a:srgbClr val="262B33"/>
+                </a:solidFill>
+                <a:latin typeface="Arial"/>
+              </a:rPr>
+              <a:t>DGCA city-pair statistics: 164 m domestic passengers, IndiGo 64.2%. Our own 1,000-fare sample returned 68.2% — arrived at independently.</a:t>
+            </a:r>
+          </a:p>
+          <a:p>
+            <a:pPr>
+              <a:lnSpc>
+                <a:spcPct val="100000"/>
               </a:lnSpc>
               <a:spcBef>
                 <a:spcPts val="500"/>
@@ -13041,71 +13253,28 @@
               </a:spcAft>
             </a:pPr>
             <a:r>
-              <a:rPr sz="1000" b="0">
-                <a:solidFill>
-                  <a:srgbClr val="262B33"/>
+              <a:rPr sz="1100" b="1">
+                <a:solidFill>
+                  <a:srgbClr val="4F81BD"/>
                 </a:solidFill>
                 <a:latin typeface="Arial"/>
+                <a:hlinkClick r:id="rId6"/>
               </a:rPr>
-              <a:t>DGCA monthly city-pair statistics: 164 million domestic passengers, IndiGo 64.2% share. Our own 1,000-fare sample returned 68.2% IndiGo — arrived at independently.</a:t>
-            </a:r>
-          </a:p>
-        </p:txBody>
-      </p:sp>
-      <p:sp>
-        <p:nvSpPr>
-          <p:cNvPr id="17415" name="Rectangle 17414"/>
+              <a:t>DGCA monthly statistics →</a:t>
+            </a:r>
+          </a:p>
+        </p:txBody>
+      </p:sp>
+      <p:sp>
+        <p:nvSpPr>
+          <p:cNvPr id="17419" name="Rounded Rectangle 17418"/>
           <p:cNvSpPr/>
           <p:nvPr/>
         </p:nvSpPr>
         <p:spPr>
           <a:xfrm>
-            <a:off x="8330183" y="1133856"/>
-            <a:ext cx="3703320" cy="45720"/>
-          </a:xfrm>
-          <a:prstGeom prst="rect">
-            <a:avLst/>
-          </a:prstGeom>
-          <a:solidFill>
-            <a:srgbClr val="4F81BD"/>
-          </a:solidFill>
-          <a:ln>
-            <a:noFill/>
-          </a:ln>
-          <a:effectLst/>
-        </p:spPr>
-        <p:style>
-          <a:lnRef idx="1">
-            <a:schemeClr val="accent1"/>
-          </a:lnRef>
-          <a:fillRef idx="3">
-            <a:schemeClr val="accent1"/>
-          </a:fillRef>
-          <a:effectRef idx="2">
-            <a:schemeClr val="accent1"/>
-          </a:effectRef>
-          <a:fontRef idx="minor">
-            <a:schemeClr val="lt1"/>
-          </a:fontRef>
-        </p:style>
-        <p:txBody>
-          <a:bodyPr rtlCol="0" anchor="ctr"/>
-          <a:lstStyle/>
-          <a:p>
-            <a:pPr algn="ctr"/>
-          </a:p>
-        </p:txBody>
-      </p:sp>
-      <p:sp>
-        <p:nvSpPr>
-          <p:cNvPr id="17416" name="Rounded Rectangle 17415"/>
-          <p:cNvSpPr/>
-          <p:nvPr/>
-        </p:nvSpPr>
-        <p:spPr>
-          <a:xfrm>
-            <a:off x="411480" y="2980944"/>
-            <a:ext cx="3703320" cy="1664208"/>
+            <a:off x="411480" y="2999232"/>
+            <a:ext cx="3703320" cy="1700784"/>
           </a:xfrm>
           <a:prstGeom prst="roundRect">
             <a:avLst>
@@ -13113,12 +13282,10 @@
             </a:avLst>
           </a:prstGeom>
           <a:solidFill>
-            <a:srgbClr val="EEF3F9"/>
+            <a:srgbClr val="ECEAF7"/>
           </a:solidFill>
-          <a:ln w="12700">
-            <a:solidFill>
-              <a:srgbClr val="C7D3E3"/>
-            </a:solidFill>
+          <a:ln>
+            <a:noFill/>
           </a:ln>
           <a:effectLst/>
         </p:spPr>
@@ -13137,12 +13304,82 @@
           </a:fontRef>
         </p:style>
         <p:txBody>
-          <a:bodyPr rtlCol="0" anchor="ctr" wrap="square" lIns="36576" rIns="36576" tIns="18288" bIns="18288"/>
-          <a:lstStyle/>
-          <a:p>
-            <a:pPr algn="ctr">
+          <a:bodyPr rtlCol="0" anchor="ctr" wrap="square"/>
+          <a:lstStyle/>
+          <a:p>
+            <a:pPr algn="ctr"/>
+          </a:p>
+        </p:txBody>
+      </p:sp>
+      <p:sp>
+        <p:nvSpPr>
+          <p:cNvPr id="17420" name="Rectangle 17419"/>
+          <p:cNvSpPr/>
+          <p:nvPr/>
+        </p:nvSpPr>
+        <p:spPr>
+          <a:xfrm>
+            <a:off x="411480" y="2999232"/>
+            <a:ext cx="3703320" cy="64008"/>
+          </a:xfrm>
+          <a:prstGeom prst="rect">
+            <a:avLst/>
+          </a:prstGeom>
+          <a:solidFill>
+            <a:srgbClr val="4B3F8C"/>
+          </a:solidFill>
+          <a:ln>
+            <a:noFill/>
+          </a:ln>
+          <a:effectLst/>
+        </p:spPr>
+        <p:style>
+          <a:lnRef idx="1">
+            <a:schemeClr val="accent1"/>
+          </a:lnRef>
+          <a:fillRef idx="3">
+            <a:schemeClr val="accent1"/>
+          </a:fillRef>
+          <a:effectRef idx="2">
+            <a:schemeClr val="accent1"/>
+          </a:effectRef>
+          <a:fontRef idx="minor">
+            <a:schemeClr val="lt1"/>
+          </a:fontRef>
+        </p:style>
+        <p:txBody>
+          <a:bodyPr rtlCol="0" anchor="ctr"/>
+          <a:lstStyle/>
+          <a:p>
+            <a:pPr algn="ctr"/>
+          </a:p>
+        </p:txBody>
+      </p:sp>
+      <p:sp>
+        <p:nvSpPr>
+          <p:cNvPr id="17421" name="TextBox 17420"/>
+          <p:cNvSpPr txBox="1"/>
+          <p:nvPr/>
+        </p:nvSpPr>
+        <p:spPr>
+          <a:xfrm>
+            <a:off x="557784" y="3145536"/>
+            <a:ext cx="3410712" cy="1444752"/>
+          </a:xfrm>
+          <a:prstGeom prst="rect">
+            <a:avLst/>
+          </a:prstGeom>
+          <a:noFill/>
+        </p:spPr>
+        <p:txBody>
+          <a:bodyPr wrap="square" lIns="36576" rIns="36576">
+            <a:spAutoFit/>
+          </a:bodyPr>
+          <a:lstStyle/>
+          <a:p>
+            <a:pPr>
               <a:lnSpc>
-                <a:spcPct val="95000"/>
+                <a:spcPct val="100000"/>
               </a:lnSpc>
               <a:spcBef>
                 <a:spcPts val="0"/>
@@ -13152,19 +13389,41 @@
               </a:spcAft>
             </a:pPr>
             <a:r>
-              <a:rPr sz="1250" b="1">
-                <a:solidFill>
-                  <a:srgbClr val="1F497D"/>
+              <a:rPr sz="1350" b="1">
+                <a:solidFill>
+                  <a:srgbClr val="4B3F8C"/>
                 </a:solidFill>
                 <a:latin typeface="Arial"/>
               </a:rPr>
-              <a:t>Standards we hold ourselves to</a:t>
+              <a:t>Standards we hold to</a:t>
             </a:r>
           </a:p>
           <a:p>
             <a:pPr>
               <a:lnSpc>
-                <a:spcPct val="95000"/>
+                <a:spcPct val="100000"/>
+              </a:lnSpc>
+              <a:spcBef>
+                <a:spcPts val="400"/>
+              </a:spcBef>
+              <a:spcAft>
+                <a:spcPts val="0"/>
+              </a:spcAft>
+            </a:pPr>
+            <a:r>
+              <a:rPr sz="1150" b="0">
+                <a:solidFill>
+                  <a:srgbClr val="262B33"/>
+                </a:solidFill>
+                <a:latin typeface="Arial"/>
+              </a:rPr>
+              <a:t>RFC 9309, the Robots Exclusion Protocol. We implemented it ourselves after finding Python's standard parser reports disallowed paths as allowed.</a:t>
+            </a:r>
+          </a:p>
+          <a:p>
+            <a:pPr>
+              <a:lnSpc>
+                <a:spcPct val="100000"/>
               </a:lnSpc>
               <a:spcBef>
                 <a:spcPts val="500"/>
@@ -13174,71 +13433,28 @@
               </a:spcAft>
             </a:pPr>
             <a:r>
-              <a:rPr sz="1000" b="0">
-                <a:solidFill>
-                  <a:srgbClr val="262B33"/>
+              <a:rPr sz="1100" b="1">
+                <a:solidFill>
+                  <a:srgbClr val="4F81BD"/>
                 </a:solidFill>
                 <a:latin typeface="Arial"/>
+                <a:hlinkClick r:id="rId7"/>
               </a:rPr>
-              <a:t>RFC 9309, the Robots Exclusion Protocol. We implemented it ourselves after finding Python's standard parser reports disallowed paths as allowed.</a:t>
-            </a:r>
-          </a:p>
-        </p:txBody>
-      </p:sp>
-      <p:sp>
-        <p:nvSpPr>
-          <p:cNvPr id="17417" name="Rectangle 17416"/>
+              <a:t>RFC 9309 →</a:t>
+            </a:r>
+          </a:p>
+        </p:txBody>
+      </p:sp>
+      <p:sp>
+        <p:nvSpPr>
+          <p:cNvPr id="17422" name="Rounded Rectangle 17421"/>
           <p:cNvSpPr/>
           <p:nvPr/>
         </p:nvSpPr>
         <p:spPr>
           <a:xfrm>
-            <a:off x="411480" y="2980944"/>
-            <a:ext cx="3703320" cy="45720"/>
-          </a:xfrm>
-          <a:prstGeom prst="rect">
-            <a:avLst/>
-          </a:prstGeom>
-          <a:solidFill>
-            <a:srgbClr val="4F81BD"/>
-          </a:solidFill>
-          <a:ln>
-            <a:noFill/>
-          </a:ln>
-          <a:effectLst/>
-        </p:spPr>
-        <p:style>
-          <a:lnRef idx="1">
-            <a:schemeClr val="accent1"/>
-          </a:lnRef>
-          <a:fillRef idx="3">
-            <a:schemeClr val="accent1"/>
-          </a:fillRef>
-          <a:effectRef idx="2">
-            <a:schemeClr val="accent1"/>
-          </a:effectRef>
-          <a:fontRef idx="minor">
-            <a:schemeClr val="lt1"/>
-          </a:fontRef>
-        </p:style>
-        <p:txBody>
-          <a:bodyPr rtlCol="0" anchor="ctr"/>
-          <a:lstStyle/>
-          <a:p>
-            <a:pPr algn="ctr"/>
-          </a:p>
-        </p:txBody>
-      </p:sp>
-      <p:sp>
-        <p:nvSpPr>
-          <p:cNvPr id="17418" name="Rounded Rectangle 17417"/>
-          <p:cNvSpPr/>
-          <p:nvPr/>
-        </p:nvSpPr>
-        <p:spPr>
-          <a:xfrm>
-            <a:off x="4370832" y="2980944"/>
-            <a:ext cx="3703320" cy="1664208"/>
+            <a:off x="4370832" y="2999232"/>
+            <a:ext cx="3703320" cy="1700784"/>
           </a:xfrm>
           <a:prstGeom prst="roundRect">
             <a:avLst>
@@ -13246,12 +13462,10 @@
             </a:avLst>
           </a:prstGeom>
           <a:solidFill>
-            <a:srgbClr val="EEF3F9"/>
+            <a:srgbClr val="E2F2F3"/>
           </a:solidFill>
-          <a:ln w="12700">
-            <a:solidFill>
-              <a:srgbClr val="C7D3E3"/>
-            </a:solidFill>
+          <a:ln>
+            <a:noFill/>
           </a:ln>
           <a:effectLst/>
         </p:spPr>
@@ -13270,12 +13484,82 @@
           </a:fontRef>
         </p:style>
         <p:txBody>
-          <a:bodyPr rtlCol="0" anchor="ctr" wrap="square" lIns="36576" rIns="36576" tIns="18288" bIns="18288"/>
-          <a:lstStyle/>
-          <a:p>
-            <a:pPr algn="ctr">
+          <a:bodyPr rtlCol="0" anchor="ctr" wrap="square"/>
+          <a:lstStyle/>
+          <a:p>
+            <a:pPr algn="ctr"/>
+          </a:p>
+        </p:txBody>
+      </p:sp>
+      <p:sp>
+        <p:nvSpPr>
+          <p:cNvPr id="17423" name="Rectangle 17422"/>
+          <p:cNvSpPr/>
+          <p:nvPr/>
+        </p:nvSpPr>
+        <p:spPr>
+          <a:xfrm>
+            <a:off x="4370832" y="2999232"/>
+            <a:ext cx="3703320" cy="64008"/>
+          </a:xfrm>
+          <a:prstGeom prst="rect">
+            <a:avLst/>
+          </a:prstGeom>
+          <a:solidFill>
+            <a:srgbClr val="0E7C86"/>
+          </a:solidFill>
+          <a:ln>
+            <a:noFill/>
+          </a:ln>
+          <a:effectLst/>
+        </p:spPr>
+        <p:style>
+          <a:lnRef idx="1">
+            <a:schemeClr val="accent1"/>
+          </a:lnRef>
+          <a:fillRef idx="3">
+            <a:schemeClr val="accent1"/>
+          </a:fillRef>
+          <a:effectRef idx="2">
+            <a:schemeClr val="accent1"/>
+          </a:effectRef>
+          <a:fontRef idx="minor">
+            <a:schemeClr val="lt1"/>
+          </a:fontRef>
+        </p:style>
+        <p:txBody>
+          <a:bodyPr rtlCol="0" anchor="ctr"/>
+          <a:lstStyle/>
+          <a:p>
+            <a:pPr algn="ctr"/>
+          </a:p>
+        </p:txBody>
+      </p:sp>
+      <p:sp>
+        <p:nvSpPr>
+          <p:cNvPr id="17424" name="TextBox 17423"/>
+          <p:cNvSpPr txBox="1"/>
+          <p:nvPr/>
+        </p:nvSpPr>
+        <p:spPr>
+          <a:xfrm>
+            <a:off x="4517136" y="3145536"/>
+            <a:ext cx="3410712" cy="1444752"/>
+          </a:xfrm>
+          <a:prstGeom prst="rect">
+            <a:avLst/>
+          </a:prstGeom>
+          <a:noFill/>
+        </p:spPr>
+        <p:txBody>
+          <a:bodyPr wrap="square" lIns="36576" rIns="36576">
+            <a:spAutoFit/>
+          </a:bodyPr>
+          <a:lstStyle/>
+          <a:p>
+            <a:pPr>
               <a:lnSpc>
-                <a:spcPct val="95000"/>
+                <a:spcPct val="100000"/>
               </a:lnSpc>
               <a:spcBef>
                 <a:spcPts val="0"/>
@@ -13285,19 +13569,41 @@
               </a:spcAft>
             </a:pPr>
             <a:r>
-              <a:rPr sz="1250" b="1">
-                <a:solidFill>
-                  <a:srgbClr val="1F497D"/>
+              <a:rPr sz="1350" b="1">
+                <a:solidFill>
+                  <a:srgbClr val="0E7C86"/>
                 </a:solidFill>
                 <a:latin typeface="Arial"/>
               </a:rPr>
-              <a:t>Our own field research</a:t>
+              <a:t>CPI methodology</a:t>
             </a:r>
           </a:p>
           <a:p>
             <a:pPr>
               <a:lnSpc>
-                <a:spcPct val="95000"/>
+                <a:spcPct val="100000"/>
+              </a:lnSpc>
+              <a:spcBef>
+                <a:spcPts val="400"/>
+              </a:spcBef>
+              <a:spcAft>
+                <a:spcPts val="0"/>
+              </a:spcAft>
+            </a:pPr>
+            <a:r>
+              <a:rPr sz="1150" b="0">
+                <a:solidFill>
+                  <a:srgbClr val="262B33"/>
+                </a:solidFill>
+                <a:latin typeface="Arial"/>
+              </a:rPr>
+              <a:t>MoSPI CPI (Base 2012=100). Field collectors visit shops and markets monthly — the process this augments.</a:t>
+            </a:r>
+          </a:p>
+          <a:p>
+            <a:pPr>
+              <a:lnSpc>
+                <a:spcPct val="100000"/>
               </a:lnSpc>
               <a:spcBef>
                 <a:spcPts val="500"/>
@@ -13307,71 +13613,28 @@
               </a:spcAft>
             </a:pPr>
             <a:r>
-              <a:rPr sz="1000" b="0">
-                <a:solidFill>
-                  <a:srgbClr val="262B33"/>
+              <a:rPr sz="1100" b="1">
+                <a:solidFill>
+                  <a:srgbClr val="4F81BD"/>
                 </a:solidFill>
                 <a:latin typeface="Arial"/>
+                <a:hlinkClick r:id="rId8"/>
               </a:rPr>
-              <a:t>16 Indian portals surveyed: one usable. 56 free-tier models tested: six answered, three reached end-of-life mid-build. Prompt chunking took a small model from 1 of 40 fares to 38.</a:t>
-            </a:r>
-          </a:p>
-        </p:txBody>
-      </p:sp>
-      <p:sp>
-        <p:nvSpPr>
-          <p:cNvPr id="17419" name="Rectangle 17418"/>
+              <a:t>MoSPI CPI series →</a:t>
+            </a:r>
+          </a:p>
+        </p:txBody>
+      </p:sp>
+      <p:sp>
+        <p:nvSpPr>
+          <p:cNvPr id="17425" name="Rounded Rectangle 17424"/>
           <p:cNvSpPr/>
           <p:nvPr/>
         </p:nvSpPr>
         <p:spPr>
           <a:xfrm>
-            <a:off x="4370832" y="2980944"/>
-            <a:ext cx="3703320" cy="45720"/>
-          </a:xfrm>
-          <a:prstGeom prst="rect">
-            <a:avLst/>
-          </a:prstGeom>
-          <a:solidFill>
-            <a:srgbClr val="4F81BD"/>
-          </a:solidFill>
-          <a:ln>
-            <a:noFill/>
-          </a:ln>
-          <a:effectLst/>
-        </p:spPr>
-        <p:style>
-          <a:lnRef idx="1">
-            <a:schemeClr val="accent1"/>
-          </a:lnRef>
-          <a:fillRef idx="3">
-            <a:schemeClr val="accent1"/>
-          </a:fillRef>
-          <a:effectRef idx="2">
-            <a:schemeClr val="accent1"/>
-          </a:effectRef>
-          <a:fontRef idx="minor">
-            <a:schemeClr val="lt1"/>
-          </a:fontRef>
-        </p:style>
-        <p:txBody>
-          <a:bodyPr rtlCol="0" anchor="ctr"/>
-          <a:lstStyle/>
-          <a:p>
-            <a:pPr algn="ctr"/>
-          </a:p>
-        </p:txBody>
-      </p:sp>
-      <p:sp>
-        <p:nvSpPr>
-          <p:cNvPr id="17420" name="Rounded Rectangle 17419"/>
-          <p:cNvSpPr/>
-          <p:nvPr/>
-        </p:nvSpPr>
-        <p:spPr>
-          <a:xfrm>
-            <a:off x="8330183" y="2980944"/>
-            <a:ext cx="3703320" cy="1664208"/>
+            <a:off x="8330183" y="2999232"/>
+            <a:ext cx="3703320" cy="1700784"/>
           </a:xfrm>
           <a:prstGeom prst="roundRect">
             <a:avLst>
@@ -13379,12 +13642,10 @@
             </a:avLst>
           </a:prstGeom>
           <a:solidFill>
-            <a:srgbClr val="EEF3F9"/>
+            <a:srgbClr val="F4EAF1"/>
           </a:solidFill>
-          <a:ln w="12700">
-            <a:solidFill>
-              <a:srgbClr val="C7D3E3"/>
-            </a:solidFill>
+          <a:ln>
+            <a:noFill/>
           </a:ln>
           <a:effectLst/>
         </p:spPr>
@@ -13403,12 +13664,82 @@
           </a:fontRef>
         </p:style>
         <p:txBody>
-          <a:bodyPr rtlCol="0" anchor="ctr" wrap="square" lIns="36576" rIns="36576" tIns="18288" bIns="18288"/>
-          <a:lstStyle/>
-          <a:p>
-            <a:pPr algn="ctr">
+          <a:bodyPr rtlCol="0" anchor="ctr" wrap="square"/>
+          <a:lstStyle/>
+          <a:p>
+            <a:pPr algn="ctr"/>
+          </a:p>
+        </p:txBody>
+      </p:sp>
+      <p:sp>
+        <p:nvSpPr>
+          <p:cNvPr id="17426" name="Rectangle 17425"/>
+          <p:cNvSpPr/>
+          <p:nvPr/>
+        </p:nvSpPr>
+        <p:spPr>
+          <a:xfrm>
+            <a:off x="8330183" y="2999232"/>
+            <a:ext cx="3703320" cy="64008"/>
+          </a:xfrm>
+          <a:prstGeom prst="rect">
+            <a:avLst/>
+          </a:prstGeom>
+          <a:solidFill>
+            <a:srgbClr val="7A3E6B"/>
+          </a:solidFill>
+          <a:ln>
+            <a:noFill/>
+          </a:ln>
+          <a:effectLst/>
+        </p:spPr>
+        <p:style>
+          <a:lnRef idx="1">
+            <a:schemeClr val="accent1"/>
+          </a:lnRef>
+          <a:fillRef idx="3">
+            <a:schemeClr val="accent1"/>
+          </a:fillRef>
+          <a:effectRef idx="2">
+            <a:schemeClr val="accent1"/>
+          </a:effectRef>
+          <a:fontRef idx="minor">
+            <a:schemeClr val="lt1"/>
+          </a:fontRef>
+        </p:style>
+        <p:txBody>
+          <a:bodyPr rtlCol="0" anchor="ctr"/>
+          <a:lstStyle/>
+          <a:p>
+            <a:pPr algn="ctr"/>
+          </a:p>
+        </p:txBody>
+      </p:sp>
+      <p:sp>
+        <p:nvSpPr>
+          <p:cNvPr id="17427" name="TextBox 17426"/>
+          <p:cNvSpPr txBox="1"/>
+          <p:nvPr/>
+        </p:nvSpPr>
+        <p:spPr>
+          <a:xfrm>
+            <a:off x="8476488" y="3145536"/>
+            <a:ext cx="3410712" cy="1444752"/>
+          </a:xfrm>
+          <a:prstGeom prst="rect">
+            <a:avLst/>
+          </a:prstGeom>
+          <a:noFill/>
+        </p:spPr>
+        <p:txBody>
+          <a:bodyPr wrap="square" lIns="36576" rIns="36576">
+            <a:spAutoFit/>
+          </a:bodyPr>
+          <a:lstStyle/>
+          <a:p>
+            <a:pPr>
               <a:lnSpc>
-                <a:spcPct val="95000"/>
+                <a:spcPct val="100000"/>
               </a:lnSpc>
               <a:spcBef>
                 <a:spcPts val="0"/>
@@ -13418,19 +13749,41 @@
               </a:spcAft>
             </a:pPr>
             <a:r>
-              <a:rPr sz="1250" b="1">
-                <a:solidFill>
-                  <a:srgbClr val="1F497D"/>
+              <a:rPr sz="1350" b="1">
+                <a:solidFill>
+                  <a:srgbClr val="7A3E6B"/>
                 </a:solidFill>
                 <a:latin typeface="Arial"/>
               </a:rPr>
-              <a:t>Live for inspection</a:t>
+              <a:t>Our code and full method</a:t>
             </a:r>
           </a:p>
           <a:p>
             <a:pPr>
               <a:lnSpc>
-                <a:spcPct val="95000"/>
+                <a:spcPct val="100000"/>
+              </a:lnSpc>
+              <a:spcBef>
+                <a:spcPts val="400"/>
+              </a:spcBef>
+              <a:spcAft>
+                <a:spcPts val="0"/>
+              </a:spcAft>
+            </a:pPr>
+            <a:r>
+              <a:rPr sz="1150" b="0">
+                <a:solidFill>
+                  <a:srgbClr val="262B33"/>
+                </a:solidFill>
+                <a:latin typeface="Arial"/>
+              </a:rPr>
+              <a:t>Collector, index engine, export API and portal. The README documents the method, the exclusion rules and the publication threshold.</a:t>
+            </a:r>
+          </a:p>
+          <a:p>
+            <a:pPr>
+              <a:lnSpc>
+                <a:spcPct val="100000"/>
               </a:lnSpc>
               <a:spcBef>
                 <a:spcPts val="500"/>
@@ -13440,79 +13793,36 @@
               </a:spcAft>
             </a:pPr>
             <a:r>
-              <a:rPr sz="1000" b="0">
-                <a:solidFill>
-                  <a:srgbClr val="262B33"/>
+              <a:rPr sz="1100" b="1">
+                <a:solidFill>
+                  <a:srgbClr val="4F81BD"/>
                 </a:solidFill>
                 <a:latin typeface="Arial"/>
+                <a:hlinkClick r:id="rId9"/>
               </a:rPr>
-              <a:t>Portal: apix-portal.pages.dev  ·  API: apix-api-n5ux.onrender.com/docs  ·  Code and full method: github.com/BradCage-afk/sih-2026-airfare-index</a:t>
-            </a:r>
-          </a:p>
-        </p:txBody>
-      </p:sp>
-      <p:sp>
-        <p:nvSpPr>
-          <p:cNvPr id="17421" name="Rectangle 17420"/>
-          <p:cNvSpPr/>
-          <p:nvPr/>
-        </p:nvSpPr>
-        <p:spPr>
-          <a:xfrm>
-            <a:off x="8330183" y="2980944"/>
-            <a:ext cx="3703320" cy="45720"/>
-          </a:xfrm>
-          <a:prstGeom prst="rect">
-            <a:avLst/>
-          </a:prstGeom>
-          <a:solidFill>
-            <a:srgbClr val="4F81BD"/>
-          </a:solidFill>
-          <a:ln>
-            <a:noFill/>
-          </a:ln>
-          <a:effectLst/>
-        </p:spPr>
-        <p:style>
-          <a:lnRef idx="1">
-            <a:schemeClr val="accent1"/>
-          </a:lnRef>
-          <a:fillRef idx="3">
-            <a:schemeClr val="accent1"/>
-          </a:fillRef>
-          <a:effectRef idx="2">
-            <a:schemeClr val="accent1"/>
-          </a:effectRef>
-          <a:fontRef idx="minor">
-            <a:schemeClr val="lt1"/>
-          </a:fontRef>
-        </p:style>
-        <p:txBody>
-          <a:bodyPr rtlCol="0" anchor="ctr"/>
-          <a:lstStyle/>
-          <a:p>
-            <a:pPr algn="ctr"/>
+              <a:t>github.com/BradCage-afk/sih-2026-airfare-index →</a:t>
+            </a:r>
           </a:p>
         </p:txBody>
       </p:sp>
       <p:pic>
         <p:nvPicPr>
-          <p:cNvPr id="17422" name="Picture 17421" descr="chart-survey.png"/>
+          <p:cNvPr id="17428" name="Picture 17427" descr="chart-survey.png"/>
           <p:cNvPicPr>
             <a:picLocks noChangeAspect="1"/>
           </p:cNvPicPr>
           <p:nvPr/>
         </p:nvPicPr>
         <p:blipFill>
-          <a:blip r:embed="rId4"/>
+          <a:blip r:embed="rId10"/>
           <a:stretch>
             <a:fillRect/>
           </a:stretch>
         </p:blipFill>
         <p:spPr>
           <a:xfrm>
-            <a:off x="411480" y="4828032"/>
-            <a:ext cx="4114800" cy="1364146"/>
+            <a:off x="411480" y="4809744"/>
+            <a:ext cx="4023360" cy="1333831"/>
           </a:xfrm>
           <a:prstGeom prst="rect">
             <a:avLst/>
@@ -13521,14 +13831,14 @@
       </p:pic>
       <p:sp>
         <p:nvSpPr>
-          <p:cNvPr id="17423" name="TextBox 17422"/>
+          <p:cNvPr id="17429" name="TextBox 17428"/>
           <p:cNvSpPr txBox="1"/>
           <p:nvPr/>
         </p:nvSpPr>
         <p:spPr>
           <a:xfrm>
-            <a:off x="4800600" y="4882896"/>
-            <a:ext cx="6949440" cy="1280160"/>
+            <a:off x="4663440" y="4864608"/>
+            <a:ext cx="7086600" cy="1371600"/>
           </a:xfrm>
           <a:prstGeom prst="rect">
             <a:avLst/>
@@ -13536,14 +13846,14 @@
           <a:noFill/>
         </p:spPr>
         <p:txBody>
-          <a:bodyPr wrap="square" lIns="36576" rIns="36576" tIns="18288" bIns="18288">
+          <a:bodyPr wrap="square" lIns="36576" rIns="36576">
             <a:spAutoFit/>
           </a:bodyPr>
           <a:lstStyle/>
           <a:p>
             <a:pPr>
               <a:lnSpc>
-                <a:spcPct val="95000"/>
+                <a:spcPct val="100000"/>
               </a:lnSpc>
               <a:spcBef>
                 <a:spcPts val="0"/>
@@ -13553,7 +13863,7 @@
               </a:spcAft>
             </a:pPr>
             <a:r>
-              <a:rPr sz="1250" b="1">
+              <a:rPr sz="1300" b="1">
                 <a:solidFill>
                   <a:srgbClr val="1F497D"/>
                 </a:solidFill>
@@ -13565,7 +13875,7 @@
           <a:p>
             <a:pPr>
               <a:lnSpc>
-                <a:spcPct val="95000"/>
+                <a:spcPct val="100000"/>
               </a:lnSpc>
               <a:spcBef>
                 <a:spcPts val="400"/>
@@ -13575,13 +13885,36 @@
               </a:spcAft>
             </a:pPr>
             <a:r>
-              <a:rPr sz="1100" b="0">
+              <a:rPr sz="1150" b="0">
                 <a:solidFill>
                   <a:srgbClr val="262B33"/>
                 </a:solidFill>
                 <a:latin typeface="Arial"/>
               </a:rPr>
-              <a:t>The index, the charts in this deck and the figures on the portal are all regenerated from the database by scripts in the repository — nothing here is transcribed by hand, so no number in this presentation can drift from what the system actually holds.</a:t>
+              <a:t>The index, every chart in this deck and every figure on the portal are regenerated from the database by scripts in the repository. Nothing is transcribed by hand, so no number here can drift from what the system holds.</a:t>
+            </a:r>
+          </a:p>
+          <a:p>
+            <a:pPr>
+              <a:lnSpc>
+                <a:spcPct val="100000"/>
+              </a:lnSpc>
+              <a:spcBef>
+                <a:spcPts val="500"/>
+              </a:spcBef>
+              <a:spcAft>
+                <a:spcPts val="0"/>
+              </a:spcAft>
+            </a:pPr>
+            <a:r>
+              <a:rPr sz="1150" b="1">
+                <a:solidFill>
+                  <a:srgbClr val="4F81BD"/>
+                </a:solidFill>
+                <a:latin typeface="Arial"/>
+                <a:hlinkClick r:id="rId11"/>
+              </a:rPr>
+              <a:t>Live API and interactive documentation →</a:t>
             </a:r>
           </a:p>
         </p:txBody>

</xml_diff>

<commit_message>
Rebuild slide 3: metric-led pipeline, page-to-row trace panels, restore slide 1 template typography
Co-Authored-By: Claude Opus 5 <noreply@anthropic.com>
Claude-Session: https://claude.ai/code/session_0129UjVhHMAVJgfcaxoN1dD5
</commit_message>
<xml_diff>
--- a/SIH26056-Idea-Presentation.pptx
+++ b/SIH26056-Idea-Presentation.pptx
@@ -7230,7 +7230,7 @@
         </p:nvSpPr>
         <p:spPr>
           <a:xfrm>
-            <a:off x="411480" y="1097280"/>
+            <a:off x="411480" y="1060704"/>
             <a:ext cx="11338560" cy="274320"/>
           </a:xfrm>
           <a:prstGeom prst="rect">
@@ -7275,7 +7275,7 @@
         </p:nvSpPr>
         <p:spPr>
           <a:xfrm>
-            <a:off x="429768" y="1371600"/>
+            <a:off x="429768" y="1335024"/>
             <a:ext cx="1371600" cy="25603"/>
           </a:xfrm>
           <a:prstGeom prst="rect">
@@ -7319,8 +7319,8 @@
         </p:nvSpPr>
         <p:spPr>
           <a:xfrm>
-            <a:off x="411480" y="1536192"/>
-            <a:ext cx="1719072" cy="1389888"/>
+            <a:off x="411480" y="1444752"/>
+            <a:ext cx="1719072" cy="1188720"/>
           </a:xfrm>
           <a:prstGeom prst="roundRect">
             <a:avLst>
@@ -7365,35 +7365,13 @@
               </a:spcAft>
             </a:pPr>
             <a:r>
-              <a:rPr sz="1200" b="1">
+              <a:rPr sz="1350" b="1">
                 <a:solidFill>
                   <a:srgbClr val="4F81BD"/>
                 </a:solidFill>
                 <a:latin typeface="Arial"/>
               </a:rPr>
-              <a:t>1</a:t>
-            </a:r>
-          </a:p>
-          <a:p>
-            <a:pPr>
-              <a:lnSpc>
-                <a:spcPct val="95000"/>
-              </a:lnSpc>
-              <a:spcBef>
-                <a:spcPts val="200"/>
-              </a:spcBef>
-              <a:spcAft>
-                <a:spcPts val="0"/>
-              </a:spcAft>
-            </a:pPr>
-            <a:r>
-              <a:rPr sz="1450" b="1">
-                <a:solidFill>
-                  <a:srgbClr val="1F497D"/>
-                </a:solidFill>
-                <a:latin typeface="Arial"/>
-              </a:rPr>
-              <a:t>Collect</a:t>
+              <a:t>1  Collect</a:t>
             </a:r>
           </a:p>
           <a:p>
@@ -7409,14 +7387,35 @@
               </a:spcAft>
             </a:pPr>
             <a:r>
-              <a:rPr sz="1150" b="0">
-                <a:solidFill>
-                  <a:srgbClr val="5A626C"/>
+              <a:rPr sz="1400" b="1">
+                <a:solidFill>
+                  <a:srgbClr val="1F497D"/>
                 </a:solidFill>
                 <a:latin typeface="Arial"/>
               </a:rPr>
-              <a:t>Robots-gated fetch,
-every 10 minutes</a:t>
+              <a:t>every 10 min</a:t>
+            </a:r>
+          </a:p>
+          <a:p>
+            <a:pPr>
+              <a:lnSpc>
+                <a:spcPct val="95000"/>
+              </a:lnSpc>
+              <a:spcBef>
+                <a:spcPts val="100"/>
+              </a:spcBef>
+              <a:spcAft>
+                <a:spcPts val="0"/>
+              </a:spcAft>
+            </a:pPr>
+            <a:r>
+              <a:rPr sz="1050" b="0">
+                <a:solidFill>
+                  <a:srgbClr val="5A626C"/>
+                </a:solidFill>
+                <a:latin typeface="Arial"/>
+              </a:rPr>
+              <a:t>robots-gated</a:t>
             </a:r>
           </a:p>
         </p:txBody>
@@ -7429,7 +7428,7 @@
         </p:nvSpPr>
         <p:spPr>
           <a:xfrm>
-            <a:off x="411480" y="1536192"/>
+            <a:off x="411480" y="1444752"/>
             <a:ext cx="1719072" cy="64008"/>
           </a:xfrm>
           <a:prstGeom prst="rect">
@@ -7473,7 +7472,7 @@
         </p:nvSpPr>
         <p:spPr>
           <a:xfrm>
-            <a:off x="2144268" y="2139696"/>
+            <a:off x="2144268" y="1947672"/>
             <a:ext cx="173736" cy="182880"/>
           </a:xfrm>
           <a:prstGeom prst="rightArrow">
@@ -7517,8 +7516,8 @@
         </p:nvSpPr>
         <p:spPr>
           <a:xfrm>
-            <a:off x="2331720" y="1536192"/>
-            <a:ext cx="1719072" cy="1389888"/>
+            <a:off x="2331720" y="1444752"/>
+            <a:ext cx="1719072" cy="1188720"/>
           </a:xfrm>
           <a:prstGeom prst="roundRect">
             <a:avLst>
@@ -7563,35 +7562,13 @@
               </a:spcAft>
             </a:pPr>
             <a:r>
-              <a:rPr sz="1200" b="1">
+              <a:rPr sz="1350" b="1">
                 <a:solidFill>
                   <a:srgbClr val="1B8A5A"/>
                 </a:solidFill>
                 <a:latin typeface="Arial"/>
               </a:rPr>
-              <a:t>2</a:t>
-            </a:r>
-          </a:p>
-          <a:p>
-            <a:pPr>
-              <a:lnSpc>
-                <a:spcPct val="95000"/>
-              </a:lnSpc>
-              <a:spcBef>
-                <a:spcPts val="200"/>
-              </a:spcBef>
-              <a:spcAft>
-                <a:spcPts val="0"/>
-              </a:spcAft>
-            </a:pPr>
-            <a:r>
-              <a:rPr sz="1450" b="1">
-                <a:solidFill>
-                  <a:srgbClr val="1F497D"/>
-                </a:solidFill>
-                <a:latin typeface="Arial"/>
-              </a:rPr>
-              <a:t>Extract</a:t>
+              <a:t>2  Extract</a:t>
             </a:r>
           </a:p>
           <a:p>
@@ -7607,14 +7584,35 @@
               </a:spcAft>
             </a:pPr>
             <a:r>
-              <a:rPr sz="1150" b="0">
-                <a:solidFill>
-                  <a:srgbClr val="5A626C"/>
+              <a:rPr sz="1400" b="1">
+                <a:solidFill>
+                  <a:srgbClr val="1F497D"/>
                 </a:solidFill>
                 <a:latin typeface="Arial"/>
               </a:rPr>
-              <a:t>LLM → strict JSON,
-retry then fail over</a:t>
+              <a:t>13,000 → 3,700</a:t>
+            </a:r>
+          </a:p>
+          <a:p>
+            <a:pPr>
+              <a:lnSpc>
+                <a:spcPct val="95000"/>
+              </a:lnSpc>
+              <a:spcBef>
+                <a:spcPts val="100"/>
+              </a:spcBef>
+              <a:spcAft>
+                <a:spcPts val="0"/>
+              </a:spcAft>
+            </a:pPr>
+            <a:r>
+              <a:rPr sz="1050" b="0">
+                <a:solidFill>
+                  <a:srgbClr val="5A626C"/>
+                </a:solidFill>
+                <a:latin typeface="Arial"/>
+              </a:rPr>
+              <a:t>chars per page</a:t>
             </a:r>
           </a:p>
         </p:txBody>
@@ -7627,7 +7625,7 @@
         </p:nvSpPr>
         <p:spPr>
           <a:xfrm>
-            <a:off x="2331720" y="1536192"/>
+            <a:off x="2331720" y="1444752"/>
             <a:ext cx="1719072" cy="64008"/>
           </a:xfrm>
           <a:prstGeom prst="rect">
@@ -7671,7 +7669,7 @@
         </p:nvSpPr>
         <p:spPr>
           <a:xfrm>
-            <a:off x="4064507" y="2139696"/>
+            <a:off x="4064507" y="1947672"/>
             <a:ext cx="173736" cy="182880"/>
           </a:xfrm>
           <a:prstGeom prst="rightArrow">
@@ -7715,8 +7713,8 @@
         </p:nvSpPr>
         <p:spPr>
           <a:xfrm>
-            <a:off x="4251960" y="1536192"/>
-            <a:ext cx="1719072" cy="1389888"/>
+            <a:off x="4251960" y="1444752"/>
+            <a:ext cx="1719072" cy="1188720"/>
           </a:xfrm>
           <a:prstGeom prst="roundRect">
             <a:avLst>
@@ -7761,35 +7759,13 @@
               </a:spcAft>
             </a:pPr>
             <a:r>
-              <a:rPr sz="1200" b="1">
+              <a:rPr sz="1350" b="1">
                 <a:solidFill>
                   <a:srgbClr val="C77700"/>
                 </a:solidFill>
                 <a:latin typeface="Arial"/>
               </a:rPr>
-              <a:t>3</a:t>
-            </a:r>
-          </a:p>
-          <a:p>
-            <a:pPr>
-              <a:lnSpc>
-                <a:spcPct val="95000"/>
-              </a:lnSpc>
-              <a:spcBef>
-                <a:spcPts val="200"/>
-              </a:spcBef>
-              <a:spcAft>
-                <a:spcPts val="0"/>
-              </a:spcAft>
-            </a:pPr>
-            <a:r>
-              <a:rPr sz="1450" b="1">
-                <a:solidFill>
-                  <a:srgbClr val="1F497D"/>
-                </a:solidFill>
-                <a:latin typeface="Arial"/>
-              </a:rPr>
-              <a:t>Validate</a:t>
+              <a:t>3  Validate</a:t>
             </a:r>
           </a:p>
           <a:p>
@@ -7805,14 +7781,35 @@
               </a:spcAft>
             </a:pPr>
             <a:r>
-              <a:rPr sz="1150" b="0">
-                <a:solidFill>
-                  <a:srgbClr val="5A626C"/>
+              <a:rPr sz="1400" b="1">
+                <a:solidFill>
+                  <a:srgbClr val="1F497D"/>
                 </a:solidFill>
                 <a:latin typeface="Arial"/>
               </a:rPr>
-              <a:t>Schema and range,
-never estimates</a:t>
+              <a:t>38 of 40</a:t>
+            </a:r>
+          </a:p>
+          <a:p>
+            <a:pPr>
+              <a:lnSpc>
+                <a:spcPct val="95000"/>
+              </a:lnSpc>
+              <a:spcBef>
+                <a:spcPts val="100"/>
+              </a:spcBef>
+              <a:spcAft>
+                <a:spcPts val="0"/>
+              </a:spcAft>
+            </a:pPr>
+            <a:r>
+              <a:rPr sz="1050" b="0">
+                <a:solidFill>
+                  <a:srgbClr val="5A626C"/>
+                </a:solidFill>
+                <a:latin typeface="Arial"/>
+              </a:rPr>
+              <a:t>flights kept</a:t>
             </a:r>
           </a:p>
         </p:txBody>
@@ -7825,7 +7822,7 @@
         </p:nvSpPr>
         <p:spPr>
           <a:xfrm>
-            <a:off x="4251960" y="1536192"/>
+            <a:off x="4251960" y="1444752"/>
             <a:ext cx="1719072" cy="64008"/>
           </a:xfrm>
           <a:prstGeom prst="rect">
@@ -7869,7 +7866,7 @@
         </p:nvSpPr>
         <p:spPr>
           <a:xfrm>
-            <a:off x="5984748" y="2139696"/>
+            <a:off x="5984748" y="1947672"/>
             <a:ext cx="173736" cy="182880"/>
           </a:xfrm>
           <a:prstGeom prst="rightArrow">
@@ -7913,8 +7910,8 @@
         </p:nvSpPr>
         <p:spPr>
           <a:xfrm>
-            <a:off x="6172200" y="1536192"/>
-            <a:ext cx="1719072" cy="1389888"/>
+            <a:off x="6172200" y="1444752"/>
+            <a:ext cx="1719072" cy="1188720"/>
           </a:xfrm>
           <a:prstGeom prst="roundRect">
             <a:avLst>
@@ -7959,35 +7956,13 @@
               </a:spcAft>
             </a:pPr>
             <a:r>
-              <a:rPr sz="1200" b="1">
+              <a:rPr sz="1350" b="1">
                 <a:solidFill>
                   <a:srgbClr val="4B3F8C"/>
                 </a:solidFill>
                 <a:latin typeface="Arial"/>
               </a:rPr>
-              <a:t>4</a:t>
-            </a:r>
-          </a:p>
-          <a:p>
-            <a:pPr>
-              <a:lnSpc>
-                <a:spcPct val="95000"/>
-              </a:lnSpc>
-              <a:spcBef>
-                <a:spcPts val="200"/>
-              </a:spcBef>
-              <a:spcAft>
-                <a:spcPts val="0"/>
-              </a:spcAft>
-            </a:pPr>
-            <a:r>
-              <a:rPr sz="1450" b="1">
-                <a:solidFill>
-                  <a:srgbClr val="1F497D"/>
-                </a:solidFill>
-                <a:latin typeface="Arial"/>
-              </a:rPr>
-              <a:t>Clean</a:t>
+              <a:t>4  Clean</a:t>
             </a:r>
           </a:p>
           <a:p>
@@ -8003,14 +7978,35 @@
               </a:spcAft>
             </a:pPr>
             <a:r>
-              <a:rPr sz="1150" b="0">
-                <a:solidFill>
-                  <a:srgbClr val="5A626C"/>
+              <a:rPr sz="1400" b="1">
+                <a:solidFill>
+                  <a:srgbClr val="1F497D"/>
                 </a:solidFill>
                 <a:latin typeface="Arial"/>
               </a:rPr>
-              <a:t>Min 3 observations,
-exclusions published</a:t>
+              <a:t>min 3 obs</a:t>
+            </a:r>
+          </a:p>
+          <a:p>
+            <a:pPr>
+              <a:lnSpc>
+                <a:spcPct val="95000"/>
+              </a:lnSpc>
+              <a:spcBef>
+                <a:spcPts val="100"/>
+              </a:spcBef>
+              <a:spcAft>
+                <a:spcPts val="0"/>
+              </a:spcAft>
+            </a:pPr>
+            <a:r>
+              <a:rPr sz="1050" b="0">
+                <a:solidFill>
+                  <a:srgbClr val="5A626C"/>
+                </a:solidFill>
+                <a:latin typeface="Arial"/>
+              </a:rPr>
+              <a:t>per priced cell</a:t>
             </a:r>
           </a:p>
         </p:txBody>
@@ -8023,7 +8019,7 @@
         </p:nvSpPr>
         <p:spPr>
           <a:xfrm>
-            <a:off x="6172200" y="1536192"/>
+            <a:off x="6172200" y="1444752"/>
             <a:ext cx="1719072" cy="64008"/>
           </a:xfrm>
           <a:prstGeom prst="rect">
@@ -8067,7 +8063,7 @@
         </p:nvSpPr>
         <p:spPr>
           <a:xfrm>
-            <a:off x="7904988" y="2139696"/>
+            <a:off x="7904988" y="1947672"/>
             <a:ext cx="173736" cy="182880"/>
           </a:xfrm>
           <a:prstGeom prst="rightArrow">
@@ -8111,8 +8107,8 @@
         </p:nvSpPr>
         <p:spPr>
           <a:xfrm>
-            <a:off x="8092440" y="1536192"/>
-            <a:ext cx="1719072" cy="1389888"/>
+            <a:off x="8092440" y="1444752"/>
+            <a:ext cx="1719072" cy="1188720"/>
           </a:xfrm>
           <a:prstGeom prst="roundRect">
             <a:avLst>
@@ -8157,35 +8153,13 @@
               </a:spcAft>
             </a:pPr>
             <a:r>
-              <a:rPr sz="1200" b="1">
+              <a:rPr sz="1350" b="1">
                 <a:solidFill>
                   <a:srgbClr val="0E7C86"/>
                 </a:solidFill>
                 <a:latin typeface="Arial"/>
               </a:rPr>
-              <a:t>5</a:t>
-            </a:r>
-          </a:p>
-          <a:p>
-            <a:pPr>
-              <a:lnSpc>
-                <a:spcPct val="95000"/>
-              </a:lnSpc>
-              <a:spcBef>
-                <a:spcPts val="200"/>
-              </a:spcBef>
-              <a:spcAft>
-                <a:spcPts val="0"/>
-              </a:spcAft>
-            </a:pPr>
-            <a:r>
-              <a:rPr sz="1450" b="1">
-                <a:solidFill>
-                  <a:srgbClr val="1F497D"/>
-                </a:solidFill>
-                <a:latin typeface="Arial"/>
-              </a:rPr>
-              <a:t>Index</a:t>
+              <a:t>5  Index</a:t>
             </a:r>
           </a:p>
           <a:p>
@@ -8201,14 +8175,35 @@
               </a:spcAft>
             </a:pPr>
             <a:r>
-              <a:rPr sz="1150" b="0">
-                <a:solidFill>
-                  <a:srgbClr val="5A626C"/>
+              <a:rPr sz="1400" b="1">
+                <a:solidFill>
+                  <a:srgbClr val="1F497D"/>
                 </a:solidFill>
                 <a:latin typeface="Arial"/>
               </a:rPr>
-              <a:t>Weighted Jevons,
-route × lead time</a:t>
+              <a:t>75 cells</a:t>
+            </a:r>
+          </a:p>
+          <a:p>
+            <a:pPr>
+              <a:lnSpc>
+                <a:spcPct val="95000"/>
+              </a:lnSpc>
+              <a:spcBef>
+                <a:spcPts val="100"/>
+              </a:spcBef>
+              <a:spcAft>
+                <a:spcPts val="0"/>
+              </a:spcAft>
+            </a:pPr>
+            <a:r>
+              <a:rPr sz="1050" b="0">
+                <a:solidFill>
+                  <a:srgbClr val="5A626C"/>
+                </a:solidFill>
+                <a:latin typeface="Arial"/>
+              </a:rPr>
+              <a:t>weighted Jevons</a:t>
             </a:r>
           </a:p>
         </p:txBody>
@@ -8221,7 +8216,7 @@
         </p:nvSpPr>
         <p:spPr>
           <a:xfrm>
-            <a:off x="8092440" y="1536192"/>
+            <a:off x="8092440" y="1444752"/>
             <a:ext cx="1719072" cy="64008"/>
           </a:xfrm>
           <a:prstGeom prst="rect">
@@ -8265,7 +8260,7 @@
         </p:nvSpPr>
         <p:spPr>
           <a:xfrm>
-            <a:off x="9825228" y="2139696"/>
+            <a:off x="9825228" y="1947672"/>
             <a:ext cx="173736" cy="182880"/>
           </a:xfrm>
           <a:prstGeom prst="rightArrow">
@@ -8309,8 +8304,8 @@
         </p:nvSpPr>
         <p:spPr>
           <a:xfrm>
-            <a:off x="10012680" y="1536192"/>
-            <a:ext cx="1719072" cy="1389888"/>
+            <a:off x="10012680" y="1444752"/>
+            <a:ext cx="1719072" cy="1188720"/>
           </a:xfrm>
           <a:prstGeom prst="roundRect">
             <a:avLst>
@@ -8355,35 +8350,13 @@
               </a:spcAft>
             </a:pPr>
             <a:r>
-              <a:rPr sz="1200" b="1">
+              <a:rPr sz="1350" b="1">
                 <a:solidFill>
                   <a:srgbClr val="7A3E6B"/>
                 </a:solidFill>
                 <a:latin typeface="Arial"/>
               </a:rPr>
-              <a:t>6</a:t>
-            </a:r>
-          </a:p>
-          <a:p>
-            <a:pPr>
-              <a:lnSpc>
-                <a:spcPct val="95000"/>
-              </a:lnSpc>
-              <a:spcBef>
-                <a:spcPts val="200"/>
-              </a:spcBef>
-              <a:spcAft>
-                <a:spcPts val="0"/>
-              </a:spcAft>
-            </a:pPr>
-            <a:r>
-              <a:rPr sz="1450" b="1">
-                <a:solidFill>
-                  <a:srgbClr val="1F497D"/>
-                </a:solidFill>
-                <a:latin typeface="Arial"/>
-              </a:rPr>
-              <a:t>Publish</a:t>
+              <a:t>6  Publish</a:t>
             </a:r>
           </a:p>
           <a:p>
@@ -8399,14 +8372,35 @@
               </a:spcAft>
             </a:pPr>
             <a:r>
-              <a:rPr sz="1150" b="0">
-                <a:solidFill>
-                  <a:srgbClr val="5A626C"/>
+              <a:rPr sz="1400" b="1">
+                <a:solidFill>
+                  <a:srgbClr val="1F497D"/>
                 </a:solidFill>
                 <a:latin typeface="Arial"/>
               </a:rPr>
-              <a:t>Portal and REST API
-for MoSPI</a:t>
+              <a:t>2 endpoints</a:t>
+            </a:r>
+          </a:p>
+          <a:p>
+            <a:pPr>
+              <a:lnSpc>
+                <a:spcPct val="95000"/>
+              </a:lnSpc>
+              <a:spcBef>
+                <a:spcPts val="100"/>
+              </a:spcBef>
+              <a:spcAft>
+                <a:spcPts val="0"/>
+              </a:spcAft>
+            </a:pPr>
+            <a:r>
+              <a:rPr sz="1050" b="0">
+                <a:solidFill>
+                  <a:srgbClr val="5A626C"/>
+                </a:solidFill>
+                <a:latin typeface="Arial"/>
+              </a:rPr>
+              <a:t>portal + API</a:t>
             </a:r>
           </a:p>
         </p:txBody>
@@ -8419,7 +8413,7 @@
         </p:nvSpPr>
         <p:spPr>
           <a:xfrm>
-            <a:off x="10012680" y="1536192"/>
+            <a:off x="10012680" y="1444752"/>
             <a:ext cx="1719072" cy="64008"/>
           </a:xfrm>
           <a:prstGeom prst="rect">
@@ -8457,22 +8451,65 @@
       </p:sp>
       <p:sp>
         <p:nvSpPr>
-          <p:cNvPr id="17429" name="Rounded Rectangle 17428"/>
+          <p:cNvPr id="17429" name="TextBox 17428"/>
+          <p:cNvSpPr txBox="1"/>
+          <p:nvPr/>
+        </p:nvSpPr>
+        <p:spPr>
+          <a:xfrm>
+            <a:off x="411480" y="2761488"/>
+            <a:ext cx="11338560" cy="274320"/>
+          </a:xfrm>
+          <a:prstGeom prst="rect">
+            <a:avLst/>
+          </a:prstGeom>
+          <a:noFill/>
+        </p:spPr>
+        <p:txBody>
+          <a:bodyPr wrap="square" lIns="36576" rIns="36576" tIns="18288" bIns="18288">
+            <a:spAutoFit/>
+          </a:bodyPr>
+          <a:lstStyle/>
+          <a:p>
+            <a:pPr>
+              <a:lnSpc>
+                <a:spcPct val="95000"/>
+              </a:lnSpc>
+              <a:spcBef>
+                <a:spcPts val="0"/>
+              </a:spcBef>
+              <a:spcAft>
+                <a:spcPts val="0"/>
+              </a:spcAft>
+            </a:pPr>
+            <a:r>
+              <a:rPr sz="1400" b="1">
+                <a:solidFill>
+                  <a:srgbClr val="1F497D"/>
+                </a:solidFill>
+                <a:latin typeface="Arial"/>
+              </a:rPr>
+              <a:t>What actually happens to one results page</a:t>
+            </a:r>
+          </a:p>
+        </p:txBody>
+      </p:sp>
+      <p:sp>
+        <p:nvSpPr>
+          <p:cNvPr id="17430" name="Rectangle 17429"/>
           <p:cNvSpPr/>
           <p:nvPr/>
         </p:nvSpPr>
         <p:spPr>
           <a:xfrm>
-            <a:off x="411480" y="3108960"/>
-            <a:ext cx="11338560" cy="731520"/>
-          </a:xfrm>
-          <a:prstGeom prst="roundRect">
-            <a:avLst>
-              <a:gd name="adj" fmla="val 6000"/>
-            </a:avLst>
+            <a:off x="429768" y="3035808"/>
+            <a:ext cx="1371600" cy="25603"/>
+          </a:xfrm>
+          <a:prstGeom prst="rect">
+            <a:avLst/>
           </a:prstGeom>
           <a:solidFill>
-            <a:srgbClr val="E4F4EC"/>
+            <a:srgbClr val="4F81BD"/>
           </a:solidFill>
           <a:ln>
             <a:noFill/>
@@ -8494,64 +8531,23 @@
           </a:fontRef>
         </p:style>
         <p:txBody>
-          <a:bodyPr rtlCol="0" anchor="ctr" wrap="square" lIns="36576" rIns="36576" tIns="18288" bIns="18288"/>
-          <a:lstStyle/>
-          <a:p>
-            <a:pPr algn="ctr">
-              <a:lnSpc>
-                <a:spcPct val="95000"/>
-              </a:lnSpc>
-              <a:spcBef>
-                <a:spcPts val="0"/>
-              </a:spcBef>
-              <a:spcAft>
-                <a:spcPts val="0"/>
-              </a:spcAft>
-            </a:pPr>
-            <a:r>
-              <a:rPr sz="1150" b="1">
-                <a:solidFill>
-                  <a:srgbClr val="1B8A5A"/>
-                </a:solidFill>
-                <a:latin typeface="Arial"/>
-              </a:rPr>
-              <a:t>BUILT AND RUNNING</a:t>
-            </a:r>
-          </a:p>
-          <a:p>
-            <a:pPr>
-              <a:lnSpc>
-                <a:spcPct val="95000"/>
-              </a:lnSpc>
-              <a:spcBef>
-                <a:spcPts val="300"/>
-              </a:spcBef>
-              <a:spcAft>
-                <a:spcPts val="0"/>
-              </a:spcAft>
-            </a:pPr>
-            <a:r>
-              <a:rPr sz="1300" b="0">
-                <a:solidFill>
-                  <a:srgbClr val="262B33"/>
-                </a:solidFill>
-                <a:latin typeface="Arial"/>
-              </a:rPr>
-              <a:t>36,076 fares · 298 runs, 98.7% clean · APIx published daily and monthly · portal and authenticated REST API, both reading Postgres directly.</a:t>
-            </a:r>
-          </a:p>
-        </p:txBody>
-      </p:sp>
-      <p:sp>
-        <p:nvSpPr>
-          <p:cNvPr id="17430" name="Rounded Rectangle 17429"/>
+          <a:bodyPr rtlCol="0" anchor="ctr"/>
+          <a:lstStyle/>
+          <a:p>
+            <a:pPr algn="ctr"/>
+          </a:p>
+        </p:txBody>
+      </p:sp>
+      <p:sp>
+        <p:nvSpPr>
+          <p:cNvPr id="17431" name="Rounded Rectangle 17430"/>
           <p:cNvSpPr/>
           <p:nvPr/>
         </p:nvSpPr>
         <p:spPr>
           <a:xfrm>
-            <a:off x="411480" y="4059936"/>
-            <a:ext cx="5623560" cy="2157984"/>
+            <a:off x="411480" y="3145536"/>
+            <a:ext cx="3703320" cy="2340864"/>
           </a:xfrm>
           <a:prstGeom prst="roundRect">
             <a:avLst>
@@ -8581,42 +8577,23 @@
           </a:fontRef>
         </p:style>
         <p:txBody>
-          <a:bodyPr rtlCol="0" anchor="ctr" wrap="square" lIns="36576" rIns="36576" tIns="18288" bIns="18288"/>
-          <a:lstStyle/>
-          <a:p>
-            <a:pPr algn="ctr">
-              <a:lnSpc>
-                <a:spcPct val="95000"/>
-              </a:lnSpc>
-              <a:spcBef>
-                <a:spcPts val="0"/>
-              </a:spcBef>
-              <a:spcAft>
-                <a:spcPts val="0"/>
-              </a:spcAft>
-            </a:pPr>
-            <a:r>
-              <a:rPr sz="1400" b="1">
-                <a:solidFill>
-                  <a:srgbClr val="4F81BD"/>
-                </a:solidFill>
-                <a:latin typeface="Arial"/>
-              </a:rPr>
-              <a:t>What one stored fare looks like</a:t>
-            </a:r>
-          </a:p>
-        </p:txBody>
-      </p:sp>
-      <p:sp>
-        <p:nvSpPr>
-          <p:cNvPr id="17431" name="Rectangle 17430"/>
+          <a:bodyPr rtlCol="0" anchor="ctr" wrap="square"/>
+          <a:lstStyle/>
+          <a:p>
+            <a:pPr algn="ctr"/>
+          </a:p>
+        </p:txBody>
+      </p:sp>
+      <p:sp>
+        <p:nvSpPr>
+          <p:cNvPr id="17432" name="Rectangle 17431"/>
           <p:cNvSpPr/>
           <p:nvPr/>
         </p:nvSpPr>
         <p:spPr>
           <a:xfrm>
-            <a:off x="411480" y="4059936"/>
-            <a:ext cx="5623560" cy="64008"/>
+            <a:off x="411480" y="3145536"/>
+            <a:ext cx="3703320" cy="64008"/>
           </a:xfrm>
           <a:prstGeom prst="rect">
             <a:avLst/>
@@ -8651,40 +8628,887 @@
           </a:p>
         </p:txBody>
       </p:sp>
-      <p:pic>
-        <p:nvPicPr>
-          <p:cNvPr id="17432" name="Picture 17431" descr="chart-record.png"/>
-          <p:cNvPicPr>
-            <a:picLocks noChangeAspect="1"/>
-          </p:cNvPicPr>
+      <p:sp>
+        <p:nvSpPr>
+          <p:cNvPr id="17433" name="TextBox 17432"/>
+          <p:cNvSpPr txBox="1"/>
           <p:nvPr/>
-        </p:nvPicPr>
-        <p:blipFill>
-          <a:blip r:embed="rId4"/>
-          <a:stretch>
-            <a:fillRect/>
-          </a:stretch>
-        </p:blipFill>
-        <p:spPr>
-          <a:xfrm>
-            <a:off x="658368" y="4498848"/>
-            <a:ext cx="5120640" cy="1619317"/>
+        </p:nvSpPr>
+        <p:spPr>
+          <a:xfrm>
+            <a:off x="557784" y="3291840"/>
+            <a:ext cx="3410712" cy="237744"/>
           </a:xfrm>
           <a:prstGeom prst="rect">
             <a:avLst/>
           </a:prstGeom>
-        </p:spPr>
-      </p:pic>
-      <p:sp>
-        <p:nvSpPr>
-          <p:cNvPr id="17433" name="Rounded Rectangle 17432"/>
+          <a:noFill/>
+        </p:spPr>
+        <p:txBody>
+          <a:bodyPr wrap="square" lIns="36576" rIns="36576" tIns="18288" bIns="18288">
+            <a:spAutoFit/>
+          </a:bodyPr>
+          <a:lstStyle/>
+          <a:p>
+            <a:pPr>
+              <a:lnSpc>
+                <a:spcPct val="95000"/>
+              </a:lnSpc>
+              <a:spcBef>
+                <a:spcPts val="0"/>
+              </a:spcBef>
+              <a:spcAft>
+                <a:spcPts val="0"/>
+              </a:spcAft>
+            </a:pPr>
+            <a:r>
+              <a:rPr sz="1100" b="1">
+                <a:solidFill>
+                  <a:srgbClr val="4F81BD"/>
+                </a:solidFill>
+                <a:latin typeface="Arial"/>
+              </a:rPr>
+              <a:t>1 · WHAT THE PAGE GIVES US</a:t>
+            </a:r>
+          </a:p>
+        </p:txBody>
+      </p:sp>
+      <p:sp>
+        <p:nvSpPr>
+          <p:cNvPr id="17434" name="Rounded Rectangle 17433"/>
           <p:cNvSpPr/>
           <p:nvPr/>
         </p:nvSpPr>
         <p:spPr>
           <a:xfrm>
-            <a:off x="6400800" y="4059936"/>
-            <a:ext cx="5349240" cy="2157984"/>
+            <a:off x="557784" y="3566160"/>
+            <a:ext cx="3410712" cy="950976"/>
+          </a:xfrm>
+          <a:prstGeom prst="roundRect">
+            <a:avLst>
+              <a:gd name="adj" fmla="val 6000"/>
+            </a:avLst>
+          </a:prstGeom>
+          <a:solidFill>
+            <a:srgbClr val="FFFFFF"/>
+          </a:solidFill>
+          <a:ln w="12700">
+            <a:solidFill>
+              <a:srgbClr val="C7D3E3"/>
+            </a:solidFill>
+          </a:ln>
+          <a:effectLst/>
+        </p:spPr>
+        <p:style>
+          <a:lnRef idx="1">
+            <a:schemeClr val="accent1"/>
+          </a:lnRef>
+          <a:fillRef idx="3">
+            <a:schemeClr val="accent1"/>
+          </a:fillRef>
+          <a:effectRef idx="2">
+            <a:schemeClr val="accent1"/>
+          </a:effectRef>
+          <a:fontRef idx="minor">
+            <a:schemeClr val="lt1"/>
+          </a:fontRef>
+        </p:style>
+        <p:txBody>
+          <a:bodyPr rtlCol="0" anchor="ctr" wrap="none" lIns="82296" rIns="82296" tIns="64008"/>
+          <a:lstStyle/>
+          <a:p>
+            <a:pPr algn="ctr">
+              <a:lnSpc>
+                <a:spcPct val="105000"/>
+              </a:lnSpc>
+              <a:spcBef>
+                <a:spcPts val="0"/>
+              </a:spcBef>
+              <a:spcAft>
+                <a:spcPts val="0"/>
+              </a:spcAft>
+            </a:pPr>
+            <a:r>
+              <a:rPr sz="950">
+                <a:solidFill>
+                  <a:srgbClr val="262B33"/>
+                </a:solidFill>
+                <a:latin typeface="Consolas"/>
+              </a:rPr>
+              <a:t>IndiGo | 6E-955 | 20:20 | 2h |</a:t>
+            </a:r>
+          </a:p>
+          <a:p>
+            <a:pPr>
+              <a:lnSpc>
+                <a:spcPct val="105000"/>
+              </a:lnSpc>
+              <a:spcBef>
+                <a:spcPts val="0"/>
+              </a:spcBef>
+              <a:spcAft>
+                <a:spcPts val="0"/>
+              </a:spcAft>
+            </a:pPr>
+            <a:r>
+              <a:rPr sz="950">
+                <a:solidFill>
+                  <a:srgbClr val="262B33"/>
+                </a:solidFill>
+                <a:latin typeface="Consolas"/>
+              </a:rPr>
+              <a:t>Non-stop | 22:20 | ₹6,529 |</a:t>
+            </a:r>
+          </a:p>
+          <a:p>
+            <a:pPr>
+              <a:lnSpc>
+                <a:spcPct val="105000"/>
+              </a:lnSpc>
+              <a:spcBef>
+                <a:spcPts val="0"/>
+              </a:spcBef>
+              <a:spcAft>
+                <a:spcPts val="0"/>
+              </a:spcAft>
+            </a:pPr>
+            <a:r>
+              <a:rPr sz="950">
+                <a:solidFill>
+                  <a:srgbClr val="262B33"/>
+                </a:solidFill>
+                <a:latin typeface="Consolas"/>
+              </a:rPr>
+              <a:t>₹480 off with CTFKSBIC | Book</a:t>
+            </a:r>
+          </a:p>
+        </p:txBody>
+      </p:sp>
+      <p:sp>
+        <p:nvSpPr>
+          <p:cNvPr id="17435" name="TextBox 17434"/>
+          <p:cNvSpPr txBox="1"/>
+          <p:nvPr/>
+        </p:nvSpPr>
+        <p:spPr>
+          <a:xfrm>
+            <a:off x="557784" y="4590288"/>
+            <a:ext cx="3410712" cy="841248"/>
+          </a:xfrm>
+          <a:prstGeom prst="rect">
+            <a:avLst/>
+          </a:prstGeom>
+          <a:noFill/>
+        </p:spPr>
+        <p:txBody>
+          <a:bodyPr wrap="square" lIns="36576" rIns="36576" tIns="18288" bIns="18288">
+            <a:spAutoFit/>
+          </a:bodyPr>
+          <a:lstStyle/>
+          <a:p>
+            <a:pPr>
+              <a:lnSpc>
+                <a:spcPct val="95000"/>
+              </a:lnSpc>
+              <a:spcBef>
+                <a:spcPts val="0"/>
+              </a:spcBef>
+              <a:spcAft>
+                <a:spcPts val="0"/>
+              </a:spcAft>
+            </a:pPr>
+            <a:r>
+              <a:rPr sz="1150" b="0">
+                <a:solidFill>
+                  <a:srgbClr val="262B33"/>
+                </a:solidFill>
+                <a:latin typeface="Arial"/>
+              </a:rPr>
+              <a:t>Found by structure — a time beside a price — not by CSS class names, so a redesign cannot break it.</a:t>
+            </a:r>
+          </a:p>
+        </p:txBody>
+      </p:sp>
+      <p:sp>
+        <p:nvSpPr>
+          <p:cNvPr id="17436" name="Rounded Rectangle 17435"/>
+          <p:cNvSpPr/>
+          <p:nvPr/>
+        </p:nvSpPr>
+        <p:spPr>
+          <a:xfrm>
+            <a:off x="4370832" y="3145536"/>
+            <a:ext cx="3703320" cy="2340864"/>
+          </a:xfrm>
+          <a:prstGeom prst="roundRect">
+            <a:avLst>
+              <a:gd name="adj" fmla="val 6000"/>
+            </a:avLst>
+          </a:prstGeom>
+          <a:solidFill>
+            <a:srgbClr val="FBF0DD"/>
+          </a:solidFill>
+          <a:ln>
+            <a:noFill/>
+          </a:ln>
+          <a:effectLst/>
+        </p:spPr>
+        <p:style>
+          <a:lnRef idx="1">
+            <a:schemeClr val="accent1"/>
+          </a:lnRef>
+          <a:fillRef idx="3">
+            <a:schemeClr val="accent1"/>
+          </a:fillRef>
+          <a:effectRef idx="2">
+            <a:schemeClr val="accent1"/>
+          </a:effectRef>
+          <a:fontRef idx="minor">
+            <a:schemeClr val="lt1"/>
+          </a:fontRef>
+        </p:style>
+        <p:txBody>
+          <a:bodyPr rtlCol="0" anchor="ctr" wrap="square"/>
+          <a:lstStyle/>
+          <a:p>
+            <a:pPr algn="ctr"/>
+          </a:p>
+        </p:txBody>
+      </p:sp>
+      <p:sp>
+        <p:nvSpPr>
+          <p:cNvPr id="17437" name="Rectangle 17436"/>
+          <p:cNvSpPr/>
+          <p:nvPr/>
+        </p:nvSpPr>
+        <p:spPr>
+          <a:xfrm>
+            <a:off x="4370832" y="3145536"/>
+            <a:ext cx="3703320" cy="64008"/>
+          </a:xfrm>
+          <a:prstGeom prst="rect">
+            <a:avLst/>
+          </a:prstGeom>
+          <a:solidFill>
+            <a:srgbClr val="1B8A5A"/>
+          </a:solidFill>
+          <a:ln>
+            <a:noFill/>
+          </a:ln>
+          <a:effectLst/>
+        </p:spPr>
+        <p:style>
+          <a:lnRef idx="1">
+            <a:schemeClr val="accent1"/>
+          </a:lnRef>
+          <a:fillRef idx="3">
+            <a:schemeClr val="accent1"/>
+          </a:fillRef>
+          <a:effectRef idx="2">
+            <a:schemeClr val="accent1"/>
+          </a:effectRef>
+          <a:fontRef idx="minor">
+            <a:schemeClr val="lt1"/>
+          </a:fontRef>
+        </p:style>
+        <p:txBody>
+          <a:bodyPr rtlCol="0" anchor="ctr"/>
+          <a:lstStyle/>
+          <a:p>
+            <a:pPr algn="ctr"/>
+          </a:p>
+        </p:txBody>
+      </p:sp>
+      <p:sp>
+        <p:nvSpPr>
+          <p:cNvPr id="17438" name="TextBox 17437"/>
+          <p:cNvSpPr txBox="1"/>
+          <p:nvPr/>
+        </p:nvSpPr>
+        <p:spPr>
+          <a:xfrm>
+            <a:off x="4517136" y="3291840"/>
+            <a:ext cx="3410712" cy="237744"/>
+          </a:xfrm>
+          <a:prstGeom prst="rect">
+            <a:avLst/>
+          </a:prstGeom>
+          <a:noFill/>
+        </p:spPr>
+        <p:txBody>
+          <a:bodyPr wrap="square" lIns="36576" rIns="36576" tIns="18288" bIns="18288">
+            <a:spAutoFit/>
+          </a:bodyPr>
+          <a:lstStyle/>
+          <a:p>
+            <a:pPr>
+              <a:lnSpc>
+                <a:spcPct val="95000"/>
+              </a:lnSpc>
+              <a:spcBef>
+                <a:spcPts val="0"/>
+              </a:spcBef>
+              <a:spcAft>
+                <a:spcPts val="0"/>
+              </a:spcAft>
+            </a:pPr>
+            <a:r>
+              <a:rPr sz="1100" b="1">
+                <a:solidFill>
+                  <a:srgbClr val="1B8A5A"/>
+                </a:solidFill>
+                <a:latin typeface="Arial"/>
+              </a:rPr>
+              <a:t>2 · WHAT THE MODEL RETURNS</a:t>
+            </a:r>
+          </a:p>
+        </p:txBody>
+      </p:sp>
+      <p:sp>
+        <p:nvSpPr>
+          <p:cNvPr id="17439" name="Rounded Rectangle 17438"/>
+          <p:cNvSpPr/>
+          <p:nvPr/>
+        </p:nvSpPr>
+        <p:spPr>
+          <a:xfrm>
+            <a:off x="4517136" y="3566160"/>
+            <a:ext cx="3410712" cy="950976"/>
+          </a:xfrm>
+          <a:prstGeom prst="roundRect">
+            <a:avLst>
+              <a:gd name="adj" fmla="val 6000"/>
+            </a:avLst>
+          </a:prstGeom>
+          <a:solidFill>
+            <a:srgbClr val="FFFFFF"/>
+          </a:solidFill>
+          <a:ln w="12700">
+            <a:solidFill>
+              <a:srgbClr val="C7D3E3"/>
+            </a:solidFill>
+          </a:ln>
+          <a:effectLst/>
+        </p:spPr>
+        <p:style>
+          <a:lnRef idx="1">
+            <a:schemeClr val="accent1"/>
+          </a:lnRef>
+          <a:fillRef idx="3">
+            <a:schemeClr val="accent1"/>
+          </a:fillRef>
+          <a:effectRef idx="2">
+            <a:schemeClr val="accent1"/>
+          </a:effectRef>
+          <a:fontRef idx="minor">
+            <a:schemeClr val="lt1"/>
+          </a:fontRef>
+        </p:style>
+        <p:txBody>
+          <a:bodyPr rtlCol="0" anchor="ctr" wrap="none" lIns="82296" rIns="82296" tIns="64008"/>
+          <a:lstStyle/>
+          <a:p>
+            <a:pPr algn="ctr">
+              <a:lnSpc>
+                <a:spcPct val="105000"/>
+              </a:lnSpc>
+              <a:spcBef>
+                <a:spcPts val="0"/>
+              </a:spcBef>
+              <a:spcAft>
+                <a:spcPts val="0"/>
+              </a:spcAft>
+            </a:pPr>
+            <a:r>
+              <a:rPr sz="950">
+                <a:solidFill>
+                  <a:srgbClr val="262B33"/>
+                </a:solidFill>
+                <a:latin typeface="Consolas"/>
+              </a:rPr>
+              <a:t>{"carrier": "IndiGo",</a:t>
+            </a:r>
+          </a:p>
+          <a:p>
+            <a:pPr>
+              <a:lnSpc>
+                <a:spcPct val="105000"/>
+              </a:lnSpc>
+              <a:spcBef>
+                <a:spcPts val="0"/>
+              </a:spcBef>
+              <a:spcAft>
+                <a:spcPts val="0"/>
+              </a:spcAft>
+            </a:pPr>
+            <a:r>
+              <a:rPr sz="950">
+                <a:solidFill>
+                  <a:srgbClr val="262B33"/>
+                </a:solidFill>
+                <a:latin typeface="Consolas"/>
+              </a:rPr>
+              <a:t> "flight_number": "6E-955",</a:t>
+            </a:r>
+          </a:p>
+          <a:p>
+            <a:pPr>
+              <a:lnSpc>
+                <a:spcPct val="105000"/>
+              </a:lnSpc>
+              <a:spcBef>
+                <a:spcPts val="0"/>
+              </a:spcBef>
+              <a:spcAft>
+                <a:spcPts val="0"/>
+              </a:spcAft>
+            </a:pPr>
+            <a:r>
+              <a:rPr sz="950">
+                <a:solidFill>
+                  <a:srgbClr val="262B33"/>
+                </a:solidFill>
+                <a:latin typeface="Consolas"/>
+              </a:rPr>
+              <a:t> "departure_time": "20:20",</a:t>
+            </a:r>
+          </a:p>
+          <a:p>
+            <a:pPr>
+              <a:lnSpc>
+                <a:spcPct val="105000"/>
+              </a:lnSpc>
+              <a:spcBef>
+                <a:spcPts val="0"/>
+              </a:spcBef>
+              <a:spcAft>
+                <a:spcPts val="0"/>
+              </a:spcAft>
+            </a:pPr>
+            <a:r>
+              <a:rPr sz="950">
+                <a:solidFill>
+                  <a:srgbClr val="262B33"/>
+                </a:solidFill>
+                <a:latin typeface="Consolas"/>
+              </a:rPr>
+              <a:t> "total_fare": 6529,</a:t>
+            </a:r>
+          </a:p>
+          <a:p>
+            <a:pPr>
+              <a:lnSpc>
+                <a:spcPct val="105000"/>
+              </a:lnSpc>
+              <a:spcBef>
+                <a:spcPts val="0"/>
+              </a:spcBef>
+              <a:spcAft>
+                <a:spcPts val="0"/>
+              </a:spcAft>
+            </a:pPr>
+            <a:r>
+              <a:rPr sz="950">
+                <a:solidFill>
+                  <a:srgbClr val="262B33"/>
+                </a:solidFill>
+                <a:latin typeface="Consolas"/>
+              </a:rPr>
+              <a:t> "base_fare": null}</a:t>
+            </a:r>
+          </a:p>
+        </p:txBody>
+      </p:sp>
+      <p:sp>
+        <p:nvSpPr>
+          <p:cNvPr id="17440" name="TextBox 17439"/>
+          <p:cNvSpPr txBox="1"/>
+          <p:nvPr/>
+        </p:nvSpPr>
+        <p:spPr>
+          <a:xfrm>
+            <a:off x="4517136" y="4590288"/>
+            <a:ext cx="3410712" cy="841248"/>
+          </a:xfrm>
+          <a:prstGeom prst="rect">
+            <a:avLst/>
+          </a:prstGeom>
+          <a:noFill/>
+        </p:spPr>
+        <p:txBody>
+          <a:bodyPr wrap="square" lIns="36576" rIns="36576" tIns="18288" bIns="18288">
+            <a:spAutoFit/>
+          </a:bodyPr>
+          <a:lstStyle/>
+          <a:p>
+            <a:pPr>
+              <a:lnSpc>
+                <a:spcPct val="95000"/>
+              </a:lnSpc>
+              <a:spcBef>
+                <a:spcPts val="0"/>
+              </a:spcBef>
+              <a:spcAft>
+                <a:spcPts val="0"/>
+              </a:spcAft>
+            </a:pPr>
+            <a:r>
+              <a:rPr sz="1150" b="0">
+                <a:solidFill>
+                  <a:srgbClr val="262B33"/>
+                </a:solidFill>
+                <a:latin typeface="Arial"/>
+              </a:rPr>
+              <a:t>Strict JSON only. Coupons and struck-through prices are ignored; unpublished fields stay null.</a:t>
+            </a:r>
+          </a:p>
+        </p:txBody>
+      </p:sp>
+      <p:sp>
+        <p:nvSpPr>
+          <p:cNvPr id="17441" name="Rounded Rectangle 17440"/>
+          <p:cNvSpPr/>
+          <p:nvPr/>
+        </p:nvSpPr>
+        <p:spPr>
+          <a:xfrm>
+            <a:off x="8330183" y="3145536"/>
+            <a:ext cx="3703320" cy="2340864"/>
+          </a:xfrm>
+          <a:prstGeom prst="roundRect">
+            <a:avLst>
+              <a:gd name="adj" fmla="val 6000"/>
+            </a:avLst>
+          </a:prstGeom>
+          <a:solidFill>
+            <a:srgbClr val="E2F2F3"/>
+          </a:solidFill>
+          <a:ln>
+            <a:noFill/>
+          </a:ln>
+          <a:effectLst/>
+        </p:spPr>
+        <p:style>
+          <a:lnRef idx="1">
+            <a:schemeClr val="accent1"/>
+          </a:lnRef>
+          <a:fillRef idx="3">
+            <a:schemeClr val="accent1"/>
+          </a:fillRef>
+          <a:effectRef idx="2">
+            <a:schemeClr val="accent1"/>
+          </a:effectRef>
+          <a:fontRef idx="minor">
+            <a:schemeClr val="lt1"/>
+          </a:fontRef>
+        </p:style>
+        <p:txBody>
+          <a:bodyPr rtlCol="0" anchor="ctr" wrap="square"/>
+          <a:lstStyle/>
+          <a:p>
+            <a:pPr algn="ctr"/>
+          </a:p>
+        </p:txBody>
+      </p:sp>
+      <p:sp>
+        <p:nvSpPr>
+          <p:cNvPr id="17442" name="Rectangle 17441"/>
+          <p:cNvSpPr/>
+          <p:nvPr/>
+        </p:nvSpPr>
+        <p:spPr>
+          <a:xfrm>
+            <a:off x="8330183" y="3145536"/>
+            <a:ext cx="3703320" cy="64008"/>
+          </a:xfrm>
+          <a:prstGeom prst="rect">
+            <a:avLst/>
+          </a:prstGeom>
+          <a:solidFill>
+            <a:srgbClr val="4B3F8C"/>
+          </a:solidFill>
+          <a:ln>
+            <a:noFill/>
+          </a:ln>
+          <a:effectLst/>
+        </p:spPr>
+        <p:style>
+          <a:lnRef idx="1">
+            <a:schemeClr val="accent1"/>
+          </a:lnRef>
+          <a:fillRef idx="3">
+            <a:schemeClr val="accent1"/>
+          </a:fillRef>
+          <a:effectRef idx="2">
+            <a:schemeClr val="accent1"/>
+          </a:effectRef>
+          <a:fontRef idx="minor">
+            <a:schemeClr val="lt1"/>
+          </a:fontRef>
+        </p:style>
+        <p:txBody>
+          <a:bodyPr rtlCol="0" anchor="ctr"/>
+          <a:lstStyle/>
+          <a:p>
+            <a:pPr algn="ctr"/>
+          </a:p>
+        </p:txBody>
+      </p:sp>
+      <p:sp>
+        <p:nvSpPr>
+          <p:cNvPr id="17443" name="TextBox 17442"/>
+          <p:cNvSpPr txBox="1"/>
+          <p:nvPr/>
+        </p:nvSpPr>
+        <p:spPr>
+          <a:xfrm>
+            <a:off x="8476488" y="3291840"/>
+            <a:ext cx="3410712" cy="237744"/>
+          </a:xfrm>
+          <a:prstGeom prst="rect">
+            <a:avLst/>
+          </a:prstGeom>
+          <a:noFill/>
+        </p:spPr>
+        <p:txBody>
+          <a:bodyPr wrap="square" lIns="36576" rIns="36576" tIns="18288" bIns="18288">
+            <a:spAutoFit/>
+          </a:bodyPr>
+          <a:lstStyle/>
+          <a:p>
+            <a:pPr>
+              <a:lnSpc>
+                <a:spcPct val="95000"/>
+              </a:lnSpc>
+              <a:spcBef>
+                <a:spcPts val="0"/>
+              </a:spcBef>
+              <a:spcAft>
+                <a:spcPts val="0"/>
+              </a:spcAft>
+            </a:pPr>
+            <a:r>
+              <a:rPr sz="1100" b="1">
+                <a:solidFill>
+                  <a:srgbClr val="4B3F8C"/>
+                </a:solidFill>
+                <a:latin typeface="Arial"/>
+              </a:rPr>
+              <a:t>3 · WHAT POSTGRES STORES</a:t>
+            </a:r>
+          </a:p>
+        </p:txBody>
+      </p:sp>
+      <p:sp>
+        <p:nvSpPr>
+          <p:cNvPr id="17444" name="Rounded Rectangle 17443"/>
+          <p:cNvSpPr/>
+          <p:nvPr/>
+        </p:nvSpPr>
+        <p:spPr>
+          <a:xfrm>
+            <a:off x="8476488" y="3566160"/>
+            <a:ext cx="3410712" cy="950976"/>
+          </a:xfrm>
+          <a:prstGeom prst="roundRect">
+            <a:avLst>
+              <a:gd name="adj" fmla="val 6000"/>
+            </a:avLst>
+          </a:prstGeom>
+          <a:solidFill>
+            <a:srgbClr val="FFFFFF"/>
+          </a:solidFill>
+          <a:ln w="12700">
+            <a:solidFill>
+              <a:srgbClr val="C7D3E3"/>
+            </a:solidFill>
+          </a:ln>
+          <a:effectLst/>
+        </p:spPr>
+        <p:style>
+          <a:lnRef idx="1">
+            <a:schemeClr val="accent1"/>
+          </a:lnRef>
+          <a:fillRef idx="3">
+            <a:schemeClr val="accent1"/>
+          </a:fillRef>
+          <a:effectRef idx="2">
+            <a:schemeClr val="accent1"/>
+          </a:effectRef>
+          <a:fontRef idx="minor">
+            <a:schemeClr val="lt1"/>
+          </a:fontRef>
+        </p:style>
+        <p:txBody>
+          <a:bodyPr rtlCol="0" anchor="ctr" wrap="none" lIns="82296" rIns="82296" tIns="64008"/>
+          <a:lstStyle/>
+          <a:p>
+            <a:pPr algn="ctr">
+              <a:lnSpc>
+                <a:spcPct val="105000"/>
+              </a:lnSpc>
+              <a:spcBef>
+                <a:spcPts val="0"/>
+              </a:spcBef>
+              <a:spcAft>
+                <a:spcPts val="0"/>
+              </a:spcAft>
+            </a:pPr>
+            <a:r>
+              <a:rPr sz="950">
+                <a:solidFill>
+                  <a:srgbClr val="262B33"/>
+                </a:solidFill>
+                <a:latin typeface="Consolas"/>
+              </a:rPr>
+              <a:t>DEL → BOM  ·  T+1</a:t>
+            </a:r>
+          </a:p>
+          <a:p>
+            <a:pPr>
+              <a:lnSpc>
+                <a:spcPct val="105000"/>
+              </a:lnSpc>
+              <a:spcBef>
+                <a:spcPts val="0"/>
+              </a:spcBef>
+              <a:spcAft>
+                <a:spcPts val="0"/>
+              </a:spcAft>
+            </a:pPr>
+            <a:r>
+              <a:rPr sz="950">
+                <a:solidFill>
+                  <a:srgbClr val="262B33"/>
+                </a:solidFill>
+                <a:latin typeface="Consolas"/>
+              </a:rPr>
+              <a:t>total_fare  ₹6,529</a:t>
+            </a:r>
+          </a:p>
+          <a:p>
+            <a:pPr>
+              <a:lnSpc>
+                <a:spcPct val="105000"/>
+              </a:lnSpc>
+              <a:spcBef>
+                <a:spcPts val="0"/>
+              </a:spcBef>
+              <a:spcAft>
+                <a:spcPts val="0"/>
+              </a:spcAft>
+            </a:pPr>
+            <a:r>
+              <a:rPr sz="950">
+                <a:solidFill>
+                  <a:srgbClr val="262B33"/>
+                </a:solidFill>
+                <a:latin typeface="Consolas"/>
+              </a:rPr>
+              <a:t>source      cleartrip</a:t>
+            </a:r>
+          </a:p>
+          <a:p>
+            <a:pPr>
+              <a:lnSpc>
+                <a:spcPct val="105000"/>
+              </a:lnSpc>
+              <a:spcBef>
+                <a:spcPts val="0"/>
+              </a:spcBef>
+              <a:spcAft>
+                <a:spcPts val="0"/>
+              </a:spcAft>
+            </a:pPr>
+            <a:r>
+              <a:rPr sz="950">
+                <a:solidFill>
+                  <a:srgbClr val="262B33"/>
+                </a:solidFill>
+                <a:latin typeface="Consolas"/>
+              </a:rPr>
+              <a:t>model_used  llama-3.2-11b</a:t>
+            </a:r>
+          </a:p>
+          <a:p>
+            <a:pPr>
+              <a:lnSpc>
+                <a:spcPct val="105000"/>
+              </a:lnSpc>
+              <a:spcBef>
+                <a:spcPts val="0"/>
+              </a:spcBef>
+              <a:spcAft>
+                <a:spcPts val="0"/>
+              </a:spcAft>
+            </a:pPr>
+            <a:r>
+              <a:rPr sz="950">
+                <a:solidFill>
+                  <a:srgbClr val="262B33"/>
+                </a:solidFill>
+                <a:latin typeface="Consolas"/>
+              </a:rPr>
+              <a:t>scraped_at  2026-09-04 19:54Z</a:t>
+            </a:r>
+          </a:p>
+        </p:txBody>
+      </p:sp>
+      <p:sp>
+        <p:nvSpPr>
+          <p:cNvPr id="17445" name="TextBox 17444"/>
+          <p:cNvSpPr txBox="1"/>
+          <p:nvPr/>
+        </p:nvSpPr>
+        <p:spPr>
+          <a:xfrm>
+            <a:off x="8476488" y="4590288"/>
+            <a:ext cx="3410712" cy="841248"/>
+          </a:xfrm>
+          <a:prstGeom prst="rect">
+            <a:avLst/>
+          </a:prstGeom>
+          <a:noFill/>
+        </p:spPr>
+        <p:txBody>
+          <a:bodyPr wrap="square" lIns="36576" rIns="36576" tIns="18288" bIns="18288">
+            <a:spAutoFit/>
+          </a:bodyPr>
+          <a:lstStyle/>
+          <a:p>
+            <a:pPr>
+              <a:lnSpc>
+                <a:spcPct val="95000"/>
+              </a:lnSpc>
+              <a:spcBef>
+                <a:spcPts val="0"/>
+              </a:spcBef>
+              <a:spcAft>
+                <a:spcPts val="0"/>
+              </a:spcAft>
+            </a:pPr>
+            <a:r>
+              <a:rPr sz="1150" b="0">
+                <a:solidFill>
+                  <a:srgbClr val="262B33"/>
+                </a:solidFill>
+                <a:latin typeface="Arial"/>
+              </a:rPr>
+              <a:t>Every fare records its source, the moment it was seen and the model that read it — so any figure traces back.</a:t>
+            </a:r>
+          </a:p>
+        </p:txBody>
+      </p:sp>
+      <p:sp>
+        <p:nvSpPr>
+          <p:cNvPr id="17446" name="Rounded Rectangle 17445"/>
+          <p:cNvSpPr/>
+          <p:nvPr/>
+        </p:nvSpPr>
+        <p:spPr>
+          <a:xfrm>
+            <a:off x="411480" y="5596128"/>
+            <a:ext cx="11338560" cy="530352"/>
           </a:xfrm>
           <a:prstGeom prst="roundRect">
             <a:avLst>
@@ -8729,757 +9553,13 @@
               </a:spcAft>
             </a:pPr>
             <a:r>
-              <a:rPr sz="1400" b="1">
+              <a:rPr sz="1150" b="1">
                 <a:solidFill>
                   <a:srgbClr val="4B3F8C"/>
                 </a:solidFill>
                 <a:latin typeface="Arial"/>
               </a:rPr>
-              <a:t>Technologies</a:t>
-            </a:r>
-          </a:p>
-        </p:txBody>
-      </p:sp>
-      <p:sp>
-        <p:nvSpPr>
-          <p:cNvPr id="17434" name="Rectangle 17433"/>
-          <p:cNvSpPr/>
-          <p:nvPr/>
-        </p:nvSpPr>
-        <p:spPr>
-          <a:xfrm>
-            <a:off x="6400800" y="4059936"/>
-            <a:ext cx="5349240" cy="64008"/>
-          </a:xfrm>
-          <a:prstGeom prst="rect">
-            <a:avLst/>
-          </a:prstGeom>
-          <a:solidFill>
-            <a:srgbClr val="4B3F8C"/>
-          </a:solidFill>
-          <a:ln>
-            <a:noFill/>
-          </a:ln>
-          <a:effectLst/>
-        </p:spPr>
-        <p:style>
-          <a:lnRef idx="1">
-            <a:schemeClr val="accent1"/>
-          </a:lnRef>
-          <a:fillRef idx="3">
-            <a:schemeClr val="accent1"/>
-          </a:fillRef>
-          <a:effectRef idx="2">
-            <a:schemeClr val="accent1"/>
-          </a:effectRef>
-          <a:fontRef idx="minor">
-            <a:schemeClr val="lt1"/>
-          </a:fontRef>
-        </p:style>
-        <p:txBody>
-          <a:bodyPr rtlCol="0" anchor="ctr"/>
-          <a:lstStyle/>
-          <a:p>
-            <a:pPr algn="ctr"/>
-          </a:p>
-        </p:txBody>
-      </p:sp>
-      <p:sp>
-        <p:nvSpPr>
-          <p:cNvPr id="17435" name="Rounded Rectangle 17434"/>
-          <p:cNvSpPr/>
-          <p:nvPr/>
-        </p:nvSpPr>
-        <p:spPr>
-          <a:xfrm>
-            <a:off x="6601968" y="4517136"/>
-            <a:ext cx="1170432" cy="210312"/>
-          </a:xfrm>
-          <a:prstGeom prst="roundRect">
-            <a:avLst>
-              <a:gd name="adj" fmla="val 6000"/>
-            </a:avLst>
-          </a:prstGeom>
-          <a:solidFill>
-            <a:srgbClr val="4B3F8C"/>
-          </a:solidFill>
-          <a:ln>
-            <a:noFill/>
-          </a:ln>
-          <a:effectLst/>
-        </p:spPr>
-        <p:style>
-          <a:lnRef idx="1">
-            <a:schemeClr val="accent1"/>
-          </a:lnRef>
-          <a:fillRef idx="3">
-            <a:schemeClr val="accent1"/>
-          </a:fillRef>
-          <a:effectRef idx="2">
-            <a:schemeClr val="accent1"/>
-          </a:effectRef>
-          <a:fontRef idx="minor">
-            <a:schemeClr val="lt1"/>
-          </a:fontRef>
-        </p:style>
-        <p:txBody>
-          <a:bodyPr rtlCol="0" anchor="ctr" wrap="square" lIns="27432" rIns="27432" tIns="0" bIns="0"/>
-          <a:lstStyle/>
-          <a:p>
-            <a:pPr algn="ctr"/>
-            <a:r>
-              <a:rPr sz="900" b="1">
-                <a:solidFill>
-                  <a:srgbClr val="FFFFFF"/>
-                </a:solidFill>
-                <a:latin typeface="Arial"/>
-              </a:rPr>
-              <a:t>Collection</a:t>
-            </a:r>
-          </a:p>
-        </p:txBody>
-      </p:sp>
-      <p:sp>
-        <p:nvSpPr>
-          <p:cNvPr id="17436" name="TextBox 17435"/>
-          <p:cNvSpPr txBox="1"/>
-          <p:nvPr/>
-        </p:nvSpPr>
-        <p:spPr>
-          <a:xfrm>
-            <a:off x="7882127" y="4503420"/>
-            <a:ext cx="3767328" cy="237744"/>
-          </a:xfrm>
-          <a:prstGeom prst="rect">
-            <a:avLst/>
-          </a:prstGeom>
-          <a:noFill/>
-        </p:spPr>
-        <p:txBody>
-          <a:bodyPr wrap="square" lIns="36576" rIns="36576" tIns="18288" bIns="18288">
-            <a:spAutoFit/>
-          </a:bodyPr>
-          <a:lstStyle/>
-          <a:p>
-            <a:pPr>
-              <a:lnSpc>
-                <a:spcPct val="95000"/>
-              </a:lnSpc>
-              <a:spcBef>
-                <a:spcPts val="0"/>
-              </a:spcBef>
-              <a:spcAft>
-                <a:spcPts val="0"/>
-              </a:spcAft>
-            </a:pPr>
-            <a:r>
-              <a:rPr sz="1100" b="0">
-                <a:solidFill>
-                  <a:srgbClr val="262B33"/>
-                </a:solidFill>
-                <a:latin typeface="Arial"/>
-              </a:rPr>
-              <a:t>Python 3.11 · Playwright Chromium</a:t>
-            </a:r>
-          </a:p>
-        </p:txBody>
-      </p:sp>
-      <p:sp>
-        <p:nvSpPr>
-          <p:cNvPr id="17437" name="Rounded Rectangle 17436"/>
-          <p:cNvSpPr/>
-          <p:nvPr/>
-        </p:nvSpPr>
-        <p:spPr>
-          <a:xfrm>
-            <a:off x="6601968" y="4754880"/>
-            <a:ext cx="1170432" cy="210312"/>
-          </a:xfrm>
-          <a:prstGeom prst="roundRect">
-            <a:avLst>
-              <a:gd name="adj" fmla="val 6000"/>
-            </a:avLst>
-          </a:prstGeom>
-          <a:solidFill>
-            <a:srgbClr val="4B3F8C"/>
-          </a:solidFill>
-          <a:ln>
-            <a:noFill/>
-          </a:ln>
-          <a:effectLst/>
-        </p:spPr>
-        <p:style>
-          <a:lnRef idx="1">
-            <a:schemeClr val="accent1"/>
-          </a:lnRef>
-          <a:fillRef idx="3">
-            <a:schemeClr val="accent1"/>
-          </a:fillRef>
-          <a:effectRef idx="2">
-            <a:schemeClr val="accent1"/>
-          </a:effectRef>
-          <a:fontRef idx="minor">
-            <a:schemeClr val="lt1"/>
-          </a:fontRef>
-        </p:style>
-        <p:txBody>
-          <a:bodyPr rtlCol="0" anchor="ctr" wrap="square" lIns="27432" rIns="27432" tIns="0" bIns="0"/>
-          <a:lstStyle/>
-          <a:p>
-            <a:pPr algn="ctr"/>
-            <a:r>
-              <a:rPr sz="900" b="1">
-                <a:solidFill>
-                  <a:srgbClr val="FFFFFF"/>
-                </a:solidFill>
-                <a:latin typeface="Arial"/>
-              </a:rPr>
-              <a:t>Extraction</a:t>
-            </a:r>
-          </a:p>
-        </p:txBody>
-      </p:sp>
-      <p:sp>
-        <p:nvSpPr>
-          <p:cNvPr id="17438" name="TextBox 17437"/>
-          <p:cNvSpPr txBox="1"/>
-          <p:nvPr/>
-        </p:nvSpPr>
-        <p:spPr>
-          <a:xfrm>
-            <a:off x="7882127" y="4741164"/>
-            <a:ext cx="3767328" cy="237744"/>
-          </a:xfrm>
-          <a:prstGeom prst="rect">
-            <a:avLst/>
-          </a:prstGeom>
-          <a:noFill/>
-        </p:spPr>
-        <p:txBody>
-          <a:bodyPr wrap="square" lIns="36576" rIns="36576" tIns="18288" bIns="18288">
-            <a:spAutoFit/>
-          </a:bodyPr>
-          <a:lstStyle/>
-          <a:p>
-            <a:pPr>
-              <a:lnSpc>
-                <a:spcPct val="95000"/>
-              </a:lnSpc>
-              <a:spcBef>
-                <a:spcPts val="0"/>
-              </a:spcBef>
-              <a:spcAft>
-                <a:spcPts val="0"/>
-              </a:spcAft>
-            </a:pPr>
-            <a:r>
-              <a:rPr sz="1100" b="0">
-                <a:solidFill>
-                  <a:srgbClr val="262B33"/>
-                </a:solidFill>
-                <a:latin typeface="Arial"/>
-              </a:rPr>
-              <a:t>OpenAI-compatible LLM, with failover</a:t>
-            </a:r>
-          </a:p>
-        </p:txBody>
-      </p:sp>
-      <p:sp>
-        <p:nvSpPr>
-          <p:cNvPr id="17439" name="Rounded Rectangle 17438"/>
-          <p:cNvSpPr/>
-          <p:nvPr/>
-        </p:nvSpPr>
-        <p:spPr>
-          <a:xfrm>
-            <a:off x="6601968" y="4992624"/>
-            <a:ext cx="1170432" cy="210312"/>
-          </a:xfrm>
-          <a:prstGeom prst="roundRect">
-            <a:avLst>
-              <a:gd name="adj" fmla="val 6000"/>
-            </a:avLst>
-          </a:prstGeom>
-          <a:solidFill>
-            <a:srgbClr val="4B3F8C"/>
-          </a:solidFill>
-          <a:ln>
-            <a:noFill/>
-          </a:ln>
-          <a:effectLst/>
-        </p:spPr>
-        <p:style>
-          <a:lnRef idx="1">
-            <a:schemeClr val="accent1"/>
-          </a:lnRef>
-          <a:fillRef idx="3">
-            <a:schemeClr val="accent1"/>
-          </a:fillRef>
-          <a:effectRef idx="2">
-            <a:schemeClr val="accent1"/>
-          </a:effectRef>
-          <a:fontRef idx="minor">
-            <a:schemeClr val="lt1"/>
-          </a:fontRef>
-        </p:style>
-        <p:txBody>
-          <a:bodyPr rtlCol="0" anchor="ctr" wrap="square" lIns="27432" rIns="27432" tIns="0" bIns="0"/>
-          <a:lstStyle/>
-          <a:p>
-            <a:pPr algn="ctr"/>
-            <a:r>
-              <a:rPr sz="900" b="1">
-                <a:solidFill>
-                  <a:srgbClr val="FFFFFF"/>
-                </a:solidFill>
-                <a:latin typeface="Arial"/>
-              </a:rPr>
-              <a:t>Validation</a:t>
-            </a:r>
-          </a:p>
-        </p:txBody>
-      </p:sp>
-      <p:sp>
-        <p:nvSpPr>
-          <p:cNvPr id="17440" name="TextBox 17439"/>
-          <p:cNvSpPr txBox="1"/>
-          <p:nvPr/>
-        </p:nvSpPr>
-        <p:spPr>
-          <a:xfrm>
-            <a:off x="7882127" y="4978908"/>
-            <a:ext cx="3767328" cy="237744"/>
-          </a:xfrm>
-          <a:prstGeom prst="rect">
-            <a:avLst/>
-          </a:prstGeom>
-          <a:noFill/>
-        </p:spPr>
-        <p:txBody>
-          <a:bodyPr wrap="square" lIns="36576" rIns="36576" tIns="18288" bIns="18288">
-            <a:spAutoFit/>
-          </a:bodyPr>
-          <a:lstStyle/>
-          <a:p>
-            <a:pPr>
-              <a:lnSpc>
-                <a:spcPct val="95000"/>
-              </a:lnSpc>
-              <a:spcBef>
-                <a:spcPts val="0"/>
-              </a:spcBef>
-              <a:spcAft>
-                <a:spcPts val="0"/>
-              </a:spcAft>
-            </a:pPr>
-            <a:r>
-              <a:rPr sz="1100" b="0">
-                <a:solidFill>
-                  <a:srgbClr val="262B33"/>
-                </a:solidFill>
-                <a:latin typeface="Arial"/>
-              </a:rPr>
-              <a:t>Pydantic v2 — schema and ranges</a:t>
-            </a:r>
-          </a:p>
-        </p:txBody>
-      </p:sp>
-      <p:sp>
-        <p:nvSpPr>
-          <p:cNvPr id="17441" name="Rounded Rectangle 17440"/>
-          <p:cNvSpPr/>
-          <p:nvPr/>
-        </p:nvSpPr>
-        <p:spPr>
-          <a:xfrm>
-            <a:off x="6601968" y="5230368"/>
-            <a:ext cx="1170432" cy="210312"/>
-          </a:xfrm>
-          <a:prstGeom prst="roundRect">
-            <a:avLst>
-              <a:gd name="adj" fmla="val 6000"/>
-            </a:avLst>
-          </a:prstGeom>
-          <a:solidFill>
-            <a:srgbClr val="4B3F8C"/>
-          </a:solidFill>
-          <a:ln>
-            <a:noFill/>
-          </a:ln>
-          <a:effectLst/>
-        </p:spPr>
-        <p:style>
-          <a:lnRef idx="1">
-            <a:schemeClr val="accent1"/>
-          </a:lnRef>
-          <a:fillRef idx="3">
-            <a:schemeClr val="accent1"/>
-          </a:fillRef>
-          <a:effectRef idx="2">
-            <a:schemeClr val="accent1"/>
-          </a:effectRef>
-          <a:fontRef idx="minor">
-            <a:schemeClr val="lt1"/>
-          </a:fontRef>
-        </p:style>
-        <p:txBody>
-          <a:bodyPr rtlCol="0" anchor="ctr" wrap="square" lIns="27432" rIns="27432" tIns="0" bIns="0"/>
-          <a:lstStyle/>
-          <a:p>
-            <a:pPr algn="ctr"/>
-            <a:r>
-              <a:rPr sz="900" b="1">
-                <a:solidFill>
-                  <a:srgbClr val="FFFFFF"/>
-                </a:solidFill>
-                <a:latin typeface="Arial"/>
-              </a:rPr>
-              <a:t>Storage</a:t>
-            </a:r>
-          </a:p>
-        </p:txBody>
-      </p:sp>
-      <p:sp>
-        <p:nvSpPr>
-          <p:cNvPr id="17442" name="TextBox 17441"/>
-          <p:cNvSpPr txBox="1"/>
-          <p:nvPr/>
-        </p:nvSpPr>
-        <p:spPr>
-          <a:xfrm>
-            <a:off x="7882127" y="5216652"/>
-            <a:ext cx="3767328" cy="237744"/>
-          </a:xfrm>
-          <a:prstGeom prst="rect">
-            <a:avLst/>
-          </a:prstGeom>
-          <a:noFill/>
-        </p:spPr>
-        <p:txBody>
-          <a:bodyPr wrap="square" lIns="36576" rIns="36576" tIns="18288" bIns="18288">
-            <a:spAutoFit/>
-          </a:bodyPr>
-          <a:lstStyle/>
-          <a:p>
-            <a:pPr>
-              <a:lnSpc>
-                <a:spcPct val="95000"/>
-              </a:lnSpc>
-              <a:spcBef>
-                <a:spcPts val="0"/>
-              </a:spcBef>
-              <a:spcAft>
-                <a:spcPts val="0"/>
-              </a:spcAft>
-            </a:pPr>
-            <a:r>
-              <a:rPr sz="1100" b="0">
-                <a:solidFill>
-                  <a:srgbClr val="262B33"/>
-                </a:solidFill>
-                <a:latin typeface="Arial"/>
-              </a:rPr>
-              <a:t>Supabase PostgreSQL, insert-only</a:t>
-            </a:r>
-          </a:p>
-        </p:txBody>
-      </p:sp>
-      <p:sp>
-        <p:nvSpPr>
-          <p:cNvPr id="17443" name="Rounded Rectangle 17442"/>
-          <p:cNvSpPr/>
-          <p:nvPr/>
-        </p:nvSpPr>
-        <p:spPr>
-          <a:xfrm>
-            <a:off x="6601968" y="5468112"/>
-            <a:ext cx="1170432" cy="210312"/>
-          </a:xfrm>
-          <a:prstGeom prst="roundRect">
-            <a:avLst>
-              <a:gd name="adj" fmla="val 6000"/>
-            </a:avLst>
-          </a:prstGeom>
-          <a:solidFill>
-            <a:srgbClr val="4B3F8C"/>
-          </a:solidFill>
-          <a:ln>
-            <a:noFill/>
-          </a:ln>
-          <a:effectLst/>
-        </p:spPr>
-        <p:style>
-          <a:lnRef idx="1">
-            <a:schemeClr val="accent1"/>
-          </a:lnRef>
-          <a:fillRef idx="3">
-            <a:schemeClr val="accent1"/>
-          </a:fillRef>
-          <a:effectRef idx="2">
-            <a:schemeClr val="accent1"/>
-          </a:effectRef>
-          <a:fontRef idx="minor">
-            <a:schemeClr val="lt1"/>
-          </a:fontRef>
-        </p:style>
-        <p:txBody>
-          <a:bodyPr rtlCol="0" anchor="ctr" wrap="square" lIns="27432" rIns="27432" tIns="0" bIns="0"/>
-          <a:lstStyle/>
-          <a:p>
-            <a:pPr algn="ctr"/>
-            <a:r>
-              <a:rPr sz="900" b="1">
-                <a:solidFill>
-                  <a:srgbClr val="FFFFFF"/>
-                </a:solidFill>
-                <a:latin typeface="Arial"/>
-              </a:rPr>
-              <a:t>Index</a:t>
-            </a:r>
-          </a:p>
-        </p:txBody>
-      </p:sp>
-      <p:sp>
-        <p:nvSpPr>
-          <p:cNvPr id="17444" name="TextBox 17443"/>
-          <p:cNvSpPr txBox="1"/>
-          <p:nvPr/>
-        </p:nvSpPr>
-        <p:spPr>
-          <a:xfrm>
-            <a:off x="7882127" y="5454396"/>
-            <a:ext cx="3767328" cy="237744"/>
-          </a:xfrm>
-          <a:prstGeom prst="rect">
-            <a:avLst/>
-          </a:prstGeom>
-          <a:noFill/>
-        </p:spPr>
-        <p:txBody>
-          <a:bodyPr wrap="square" lIns="36576" rIns="36576" tIns="18288" bIns="18288">
-            <a:spAutoFit/>
-          </a:bodyPr>
-          <a:lstStyle/>
-          <a:p>
-            <a:pPr>
-              <a:lnSpc>
-                <a:spcPct val="95000"/>
-              </a:lnSpc>
-              <a:spcBef>
-                <a:spcPts val="0"/>
-              </a:spcBef>
-              <a:spcAft>
-                <a:spcPts val="0"/>
-              </a:spcAft>
-            </a:pPr>
-            <a:r>
-              <a:rPr sz="1100" b="0">
-                <a:solidFill>
-                  <a:srgbClr val="262B33"/>
-                </a:solidFill>
-                <a:latin typeface="Arial"/>
-              </a:rPr>
-              <a:t>Jevons engine, weights in config</a:t>
-            </a:r>
-          </a:p>
-        </p:txBody>
-      </p:sp>
-      <p:sp>
-        <p:nvSpPr>
-          <p:cNvPr id="17445" name="Rounded Rectangle 17444"/>
-          <p:cNvSpPr/>
-          <p:nvPr/>
-        </p:nvSpPr>
-        <p:spPr>
-          <a:xfrm>
-            <a:off x="6601968" y="5705855"/>
-            <a:ext cx="1170432" cy="210312"/>
-          </a:xfrm>
-          <a:prstGeom prst="roundRect">
-            <a:avLst>
-              <a:gd name="adj" fmla="val 6000"/>
-            </a:avLst>
-          </a:prstGeom>
-          <a:solidFill>
-            <a:srgbClr val="4B3F8C"/>
-          </a:solidFill>
-          <a:ln>
-            <a:noFill/>
-          </a:ln>
-          <a:effectLst/>
-        </p:spPr>
-        <p:style>
-          <a:lnRef idx="1">
-            <a:schemeClr val="accent1"/>
-          </a:lnRef>
-          <a:fillRef idx="3">
-            <a:schemeClr val="accent1"/>
-          </a:fillRef>
-          <a:effectRef idx="2">
-            <a:schemeClr val="accent1"/>
-          </a:effectRef>
-          <a:fontRef idx="minor">
-            <a:schemeClr val="lt1"/>
-          </a:fontRef>
-        </p:style>
-        <p:txBody>
-          <a:bodyPr rtlCol="0" anchor="ctr" wrap="square" lIns="27432" rIns="27432" tIns="0" bIns="0"/>
-          <a:lstStyle/>
-          <a:p>
-            <a:pPr algn="ctr"/>
-            <a:r>
-              <a:rPr sz="900" b="1">
-                <a:solidFill>
-                  <a:srgbClr val="FFFFFF"/>
-                </a:solidFill>
-                <a:latin typeface="Arial"/>
-              </a:rPr>
-              <a:t>Delivery</a:t>
-            </a:r>
-          </a:p>
-        </p:txBody>
-      </p:sp>
-      <p:sp>
-        <p:nvSpPr>
-          <p:cNvPr id="17446" name="TextBox 17445"/>
-          <p:cNvSpPr txBox="1"/>
-          <p:nvPr/>
-        </p:nvSpPr>
-        <p:spPr>
-          <a:xfrm>
-            <a:off x="7882127" y="5692140"/>
-            <a:ext cx="3767328" cy="237744"/>
-          </a:xfrm>
-          <a:prstGeom prst="rect">
-            <a:avLst/>
-          </a:prstGeom>
-          <a:noFill/>
-        </p:spPr>
-        <p:txBody>
-          <a:bodyPr wrap="square" lIns="36576" rIns="36576" tIns="18288" bIns="18288">
-            <a:spAutoFit/>
-          </a:bodyPr>
-          <a:lstStyle/>
-          <a:p>
-            <a:pPr>
-              <a:lnSpc>
-                <a:spcPct val="95000"/>
-              </a:lnSpc>
-              <a:spcBef>
-                <a:spcPts val="0"/>
-              </a:spcBef>
-              <a:spcAft>
-                <a:spcPts val="0"/>
-              </a:spcAft>
-            </a:pPr>
-            <a:r>
-              <a:rPr sz="1100" b="0">
-                <a:solidFill>
-                  <a:srgbClr val="262B33"/>
-                </a:solidFill>
-                <a:latin typeface="Arial"/>
-              </a:rPr>
-              <a:t>FastAPI on Render · Cloudflare Pages</a:t>
-            </a:r>
-          </a:p>
-        </p:txBody>
-      </p:sp>
-      <p:sp>
-        <p:nvSpPr>
-          <p:cNvPr id="17447" name="Rounded Rectangle 17446"/>
-          <p:cNvSpPr/>
-          <p:nvPr/>
-        </p:nvSpPr>
-        <p:spPr>
-          <a:xfrm>
-            <a:off x="6601968" y="5943599"/>
-            <a:ext cx="1170432" cy="210312"/>
-          </a:xfrm>
-          <a:prstGeom prst="roundRect">
-            <a:avLst>
-              <a:gd name="adj" fmla="val 6000"/>
-            </a:avLst>
-          </a:prstGeom>
-          <a:solidFill>
-            <a:srgbClr val="4B3F8C"/>
-          </a:solidFill>
-          <a:ln>
-            <a:noFill/>
-          </a:ln>
-          <a:effectLst/>
-        </p:spPr>
-        <p:style>
-          <a:lnRef idx="1">
-            <a:schemeClr val="accent1"/>
-          </a:lnRef>
-          <a:fillRef idx="3">
-            <a:schemeClr val="accent1"/>
-          </a:fillRef>
-          <a:effectRef idx="2">
-            <a:schemeClr val="accent1"/>
-          </a:effectRef>
-          <a:fontRef idx="minor">
-            <a:schemeClr val="lt1"/>
-          </a:fontRef>
-        </p:style>
-        <p:txBody>
-          <a:bodyPr rtlCol="0" anchor="ctr" wrap="square" lIns="27432" rIns="27432" tIns="0" bIns="0"/>
-          <a:lstStyle/>
-          <a:p>
-            <a:pPr algn="ctr"/>
-            <a:r>
-              <a:rPr sz="900" b="1">
-                <a:solidFill>
-                  <a:srgbClr val="FFFFFF"/>
-                </a:solidFill>
-                <a:latin typeface="Arial"/>
-              </a:rPr>
-              <a:t>Scheduling</a:t>
-            </a:r>
-          </a:p>
-        </p:txBody>
-      </p:sp>
-      <p:sp>
-        <p:nvSpPr>
-          <p:cNvPr id="17448" name="TextBox 17447"/>
-          <p:cNvSpPr txBox="1"/>
-          <p:nvPr/>
-        </p:nvSpPr>
-        <p:spPr>
-          <a:xfrm>
-            <a:off x="7882127" y="5929883"/>
-            <a:ext cx="3767328" cy="237744"/>
-          </a:xfrm>
-          <a:prstGeom prst="rect">
-            <a:avLst/>
-          </a:prstGeom>
-          <a:noFill/>
-        </p:spPr>
-        <p:txBody>
-          <a:bodyPr wrap="square" lIns="36576" rIns="36576" tIns="18288" bIns="18288">
-            <a:spAutoFit/>
-          </a:bodyPr>
-          <a:lstStyle/>
-          <a:p>
-            <a:pPr>
-              <a:lnSpc>
-                <a:spcPct val="95000"/>
-              </a:lnSpc>
-              <a:spcBef>
-                <a:spcPts val="0"/>
-              </a:spcBef>
-              <a:spcAft>
-                <a:spcPts val="0"/>
-              </a:spcAft>
-            </a:pPr>
-            <a:r>
-              <a:rPr sz="1100" b="0">
-                <a:solidFill>
-                  <a:srgbClr val="262B33"/>
-                </a:solidFill>
-                <a:latin typeface="Arial"/>
-              </a:rPr>
-              <a:t>cron, flock-guarded, residential host</a:t>
+              <a:t>STACK   Python · Playwright · OpenAI-compatible LLM with failover · Pydantic v2 · Supabase PostgreSQL · FastAPI · Cloudflare · cron</a:t>
             </a:r>
           </a:p>
         </p:txBody>

</xml_diff>

<commit_message>
Team name: Fare Enough 101
Co-Authored-By: Claude Opus 5 <noreply@anthropic.com>
Claude-Session: https://claude.ai/code/session_0129UjVhHMAVJgfcaxoN1dD5
</commit_message>
<xml_diff>
--- a/SIH26056-Idea-Presentation.pptx
+++ b/SIH26056-Idea-Presentation.pptx
@@ -5726,7 +5726,7 @@
                 </a:solidFill>
                 <a:latin typeface="Arial"/>
               </a:rPr>
-              <a:t>Team Name (Registered on portal) - Fare Enough</a:t>
+              <a:t>Team Name (Registered on portal) - Fare Enough 101</a:t>
             </a:r>
           </a:p>
         </p:txBody>
@@ -5993,7 +5993,7 @@
             <a:pPr algn="ctr"/>
             <a:r>
               <a:rPr lang="en-US" dirty="0" sz="1050" b="1"/>
-              <a:t>Fare Enough</a:t>
+              <a:t>Fare Enough 101</a:t>
             </a:r>
             <a:endParaRPr lang="en-IN" dirty="0"/>
           </a:p>
@@ -7186,7 +7186,7 @@
             <a:pPr algn="ctr"/>
             <a:r>
               <a:rPr lang="en-US" dirty="0" sz="1050" b="1"/>
-              <a:t>Fare Enough</a:t>
+              <a:t>Fare Enough 101</a:t>
             </a:r>
             <a:endParaRPr lang="en-IN" dirty="0"/>
           </a:p>
@@ -9895,7 +9895,7 @@
             <a:pPr algn="ctr"/>
             <a:r>
               <a:rPr lang="en-US" dirty="0" sz="1050" b="1"/>
-              <a:t>Fare Enough</a:t>
+              <a:t>Fare Enough 101</a:t>
             </a:r>
             <a:endParaRPr lang="en-IN" dirty="0"/>
           </a:p>
@@ -11508,7 +11508,7 @@
             <a:pPr algn="ctr"/>
             <a:r>
               <a:rPr lang="en-US" dirty="0" sz="1050" b="1"/>
-              <a:t>Fare Enough</a:t>
+              <a:t>Fare Enough 101</a:t>
             </a:r>
             <a:endParaRPr lang="en-IN" dirty="0"/>
           </a:p>
@@ -13517,7 +13517,7 @@
             <a:pPr algn="ctr"/>
             <a:r>
               <a:rPr lang="en-US" dirty="0" sz="1050" b="1"/>
-              <a:t>Fare Enough</a:t>
+              <a:t>Fare Enough 101</a:t>
             </a:r>
             <a:endParaRPr lang="en-IN" dirty="0"/>
           </a:p>

</xml_diff>

<commit_message>
Rebuild slide 2 as Proposed Solution: idea, today-vs-APIx contrast, index formula, term definitions
Co-Authored-By: Claude Opus 5 <noreply@anthropic.com>
Claude-Session: https://claude.ai/code/session_0129UjVhHMAVJgfcaxoN1dD5
</commit_message>
<xml_diff>
--- a/SIH26056-Idea-Presentation.pptx
+++ b/SIH26056-Idea-Presentation.pptx
@@ -5872,7 +5872,7 @@
                 </a:solidFill>
                 <a:latin typeface="Times New Roman"/>
               </a:rPr>
-              <a:t>WHY WE STAND OUT</a:t>
+              <a:t>PROPOSED SOLUTION</a:t>
             </a:r>
           </a:p>
         </p:txBody>
@@ -6037,8 +6037,8 @@
         </p:nvSpPr>
         <p:spPr>
           <a:xfrm>
-            <a:off x="411480" y="1078992"/>
-            <a:ext cx="7863840" cy="548640"/>
+            <a:off x="411480" y="987552"/>
+            <a:ext cx="7726679" cy="859536"/>
           </a:xfrm>
           <a:prstGeom prst="rect">
             <a:avLst/>
@@ -6063,13 +6063,13 @@
               </a:spcAft>
             </a:pPr>
             <a:r>
-              <a:rPr sz="1600" b="1">
+              <a:rPr sz="1500" b="1">
                 <a:solidFill>
                   <a:srgbClr val="1F497D"/>
                 </a:solidFill>
                 <a:latin typeface="Arial"/>
               </a:rPr>
-              <a:t>APIx  —  a daily airfare inflation index for the CPI</a:t>
+              <a:t>APIx  —  a daily airfare inflation index built for the CPI</a:t>
             </a:r>
           </a:p>
           <a:p>
@@ -6078,20 +6078,20 @@
                 <a:spcPct val="95000"/>
               </a:lnSpc>
               <a:spcBef>
-                <a:spcPts val="400"/>
-              </a:spcBef>
-              <a:spcAft>
-                <a:spcPts val="0"/>
-              </a:spcAft>
-            </a:pPr>
-            <a:r>
-              <a:rPr sz="1350" b="0">
+                <a:spcPts val="500"/>
+              </a:spcBef>
+              <a:spcAft>
+                <a:spcPts val="0"/>
+              </a:spcAft>
+            </a:pPr>
+            <a:r>
+              <a:rPr sz="1200" b="0">
                 <a:solidFill>
                   <a:srgbClr val="5A626C"/>
                 </a:solidFill>
                 <a:latin typeface="Arial"/>
               </a:rPr>
-              <a:t>India's CPI prices air travel from monthly manual visits. We measure it every ten minutes and publish it in a form MoSPI can ingest.</a:t>
+              <a:t>MoSPI prices air travel by hand, once a month, for one departure date. APIx reads the same public fare pages every ten minutes, turns them into one weighted index number, and delivers it to MoSPI through an API instead of a form.</a:t>
             </a:r>
           </a:p>
         </p:txBody>
@@ -6104,8 +6104,95 @@
         </p:nvSpPr>
         <p:spPr>
           <a:xfrm>
-            <a:off x="411480" y="2048256"/>
-            <a:ext cx="3703320" cy="1481328"/>
+            <a:off x="8275320" y="987552"/>
+            <a:ext cx="3474720" cy="822960"/>
+          </a:xfrm>
+          <a:prstGeom prst="roundRect">
+            <a:avLst>
+              <a:gd name="adj" fmla="val 6000"/>
+            </a:avLst>
+          </a:prstGeom>
+          <a:solidFill>
+            <a:srgbClr val="E4F4EC"/>
+          </a:solidFill>
+          <a:ln>
+            <a:noFill/>
+          </a:ln>
+          <a:effectLst/>
+        </p:spPr>
+        <p:style>
+          <a:lnRef idx="1">
+            <a:schemeClr val="accent1"/>
+          </a:lnRef>
+          <a:fillRef idx="3">
+            <a:schemeClr val="accent1"/>
+          </a:fillRef>
+          <a:effectRef idx="2">
+            <a:schemeClr val="accent1"/>
+          </a:effectRef>
+          <a:fontRef idx="minor">
+            <a:schemeClr val="lt1"/>
+          </a:fontRef>
+        </p:style>
+        <p:txBody>
+          <a:bodyPr rtlCol="0" anchor="ctr" wrap="square" lIns="36576" rIns="36576" tIns="18288" bIns="18288"/>
+          <a:lstStyle/>
+          <a:p>
+            <a:pPr algn="ctr">
+              <a:lnSpc>
+                <a:spcPct val="95000"/>
+              </a:lnSpc>
+              <a:spcBef>
+                <a:spcPts val="0"/>
+              </a:spcBef>
+              <a:spcAft>
+                <a:spcPts val="0"/>
+              </a:spcAft>
+            </a:pPr>
+            <a:r>
+              <a:rPr sz="1050" b="1">
+                <a:solidFill>
+                  <a:srgbClr val="1B8A5A"/>
+                </a:solidFill>
+                <a:latin typeface="Arial"/>
+              </a:rPr>
+              <a:t>BUILT AND RUNNING</a:t>
+            </a:r>
+          </a:p>
+          <a:p>
+            <a:pPr>
+              <a:lnSpc>
+                <a:spcPct val="95000"/>
+              </a:lnSpc>
+              <a:spcBef>
+                <a:spcPts val="400"/>
+              </a:spcBef>
+              <a:spcAft>
+                <a:spcPts val="0"/>
+              </a:spcAft>
+            </a:pPr>
+            <a:r>
+              <a:rPr sz="1050" b="0">
+                <a:solidFill>
+                  <a:srgbClr val="262B33"/>
+                </a:solidFill>
+                <a:latin typeface="Arial"/>
+              </a:rPr>
+              <a:t>36,000+ fares collected · 15 city pairs × 5 lead times · every 10 minutes · ₹0 a month to run</a:t>
+            </a:r>
+          </a:p>
+        </p:txBody>
+      </p:sp>
+      <p:sp>
+        <p:nvSpPr>
+          <p:cNvPr id="15364" name="Rounded Rectangle 15363"/>
+          <p:cNvSpPr/>
+          <p:nvPr/>
+        </p:nvSpPr>
+        <p:spPr>
+          <a:xfrm>
+            <a:off x="411480" y="1920240"/>
+            <a:ext cx="6355080" cy="1737360"/>
           </a:xfrm>
           <a:prstGeom prst="roundRect">
             <a:avLst>
@@ -6135,65 +6222,1375 @@
           </a:fontRef>
         </p:style>
         <p:txBody>
-          <a:bodyPr rtlCol="0" anchor="ctr" wrap="square" lIns="36576" rIns="36576" tIns="18288" bIns="18288"/>
-          <a:lstStyle/>
-          <a:p>
-            <a:pPr algn="ctr">
-              <a:lnSpc>
-                <a:spcPct val="95000"/>
-              </a:lnSpc>
-              <a:spcBef>
-                <a:spcPts val="0"/>
-              </a:spcBef>
-              <a:spcAft>
-                <a:spcPts val="0"/>
-              </a:spcAft>
-            </a:pPr>
-            <a:r>
-              <a:rPr sz="1400" b="1">
-                <a:solidFill>
-                  <a:srgbClr val="4F81BD"/>
-                </a:solidFill>
-                <a:latin typeface="Arial"/>
-              </a:rPr>
-              <a:t>The standard method,
-not a homemade average</a:t>
-            </a:r>
-          </a:p>
+          <a:bodyPr rtlCol="0" anchor="ctr" wrap="square"/>
+          <a:lstStyle/>
+          <a:p>
+            <a:pPr algn="ctr"/>
+          </a:p>
+        </p:txBody>
+      </p:sp>
+      <p:sp>
+        <p:nvSpPr>
+          <p:cNvPr id="15365" name="TextBox 15364"/>
+          <p:cNvSpPr txBox="1"/>
+          <p:nvPr/>
+        </p:nvSpPr>
+        <p:spPr>
+          <a:xfrm>
+            <a:off x="548640" y="1975104"/>
+            <a:ext cx="3840480" cy="237744"/>
+          </a:xfrm>
+          <a:prstGeom prst="rect">
+            <a:avLst/>
+          </a:prstGeom>
+          <a:noFill/>
+        </p:spPr>
+        <p:txBody>
+          <a:bodyPr wrap="square" lIns="36576" rIns="36576" tIns="18288" bIns="18288">
+            <a:spAutoFit/>
+          </a:bodyPr>
+          <a:lstStyle/>
           <a:p>
             <a:pPr>
               <a:lnSpc>
                 <a:spcPct val="95000"/>
               </a:lnSpc>
               <a:spcBef>
-                <a:spcPts val="500"/>
-              </a:spcBef>
-              <a:spcAft>
-                <a:spcPts val="0"/>
-              </a:spcAft>
-            </a:pPr>
-            <a:r>
-              <a:rPr sz="1200" b="0">
+                <a:spcPts val="0"/>
+              </a:spcBef>
+              <a:spcAft>
+                <a:spcPts val="0"/>
+              </a:spcAft>
+            </a:pPr>
+            <a:r>
+              <a:rPr sz="1050" b="1">
+                <a:solidFill>
+                  <a:srgbClr val="4F81BD"/>
+                </a:solidFill>
+                <a:latin typeface="Arial"/>
+              </a:rPr>
+              <a:t>WHAT CHANGES FOR THE CPI</a:t>
+            </a:r>
+          </a:p>
+        </p:txBody>
+      </p:sp>
+      <p:sp>
+        <p:nvSpPr>
+          <p:cNvPr id="15366" name="TextBox 15365"/>
+          <p:cNvSpPr txBox="1"/>
+          <p:nvPr/>
+        </p:nvSpPr>
+        <p:spPr>
+          <a:xfrm>
+            <a:off x="2148840" y="2231136"/>
+            <a:ext cx="1920240" cy="237744"/>
+          </a:xfrm>
+          <a:prstGeom prst="rect">
+            <a:avLst/>
+          </a:prstGeom>
+          <a:noFill/>
+        </p:spPr>
+        <p:txBody>
+          <a:bodyPr wrap="square" lIns="36576" rIns="36576" tIns="18288" bIns="18288">
+            <a:spAutoFit/>
+          </a:bodyPr>
+          <a:lstStyle/>
+          <a:p>
+            <a:pPr>
+              <a:lnSpc>
+                <a:spcPct val="95000"/>
+              </a:lnSpc>
+              <a:spcBef>
+                <a:spcPts val="0"/>
+              </a:spcBef>
+              <a:spcAft>
+                <a:spcPts val="0"/>
+              </a:spcAft>
+            </a:pPr>
+            <a:r>
+              <a:rPr sz="1100" b="1">
+                <a:solidFill>
+                  <a:srgbClr val="5A626C"/>
+                </a:solidFill>
+                <a:latin typeface="Arial"/>
+              </a:rPr>
+              <a:t>TODAY</a:t>
+            </a:r>
+          </a:p>
+        </p:txBody>
+      </p:sp>
+      <p:sp>
+        <p:nvSpPr>
+          <p:cNvPr id="15367" name="TextBox 15366"/>
+          <p:cNvSpPr txBox="1"/>
+          <p:nvPr/>
+        </p:nvSpPr>
+        <p:spPr>
+          <a:xfrm>
+            <a:off x="4160520" y="2231136"/>
+            <a:ext cx="2468880" cy="237744"/>
+          </a:xfrm>
+          <a:prstGeom prst="rect">
+            <a:avLst/>
+          </a:prstGeom>
+          <a:noFill/>
+        </p:spPr>
+        <p:txBody>
+          <a:bodyPr wrap="square" lIns="36576" rIns="36576" tIns="18288" bIns="18288">
+            <a:spAutoFit/>
+          </a:bodyPr>
+          <a:lstStyle/>
+          <a:p>
+            <a:pPr>
+              <a:lnSpc>
+                <a:spcPct val="95000"/>
+              </a:lnSpc>
+              <a:spcBef>
+                <a:spcPts val="0"/>
+              </a:spcBef>
+              <a:spcAft>
+                <a:spcPts val="0"/>
+              </a:spcAft>
+            </a:pPr>
+            <a:r>
+              <a:rPr sz="1100" b="1">
+                <a:solidFill>
+                  <a:srgbClr val="1B8A5A"/>
+                </a:solidFill>
+                <a:latin typeface="Arial"/>
+              </a:rPr>
+              <a:t>WITH APIx</a:t>
+            </a:r>
+          </a:p>
+        </p:txBody>
+      </p:sp>
+      <p:sp>
+        <p:nvSpPr>
+          <p:cNvPr id="15368" name="TextBox 15367"/>
+          <p:cNvSpPr txBox="1"/>
+          <p:nvPr/>
+        </p:nvSpPr>
+        <p:spPr>
+          <a:xfrm>
+            <a:off x="548640" y="2505456"/>
+            <a:ext cx="1600200" cy="237744"/>
+          </a:xfrm>
+          <a:prstGeom prst="rect">
+            <a:avLst/>
+          </a:prstGeom>
+          <a:noFill/>
+        </p:spPr>
+        <p:txBody>
+          <a:bodyPr wrap="square" lIns="36576" rIns="36576" tIns="18288" bIns="18288">
+            <a:spAutoFit/>
+          </a:bodyPr>
+          <a:lstStyle/>
+          <a:p>
+            <a:pPr>
+              <a:lnSpc>
+                <a:spcPct val="95000"/>
+              </a:lnSpc>
+              <a:spcBef>
+                <a:spcPts val="0"/>
+              </a:spcBef>
+              <a:spcAft>
+                <a:spcPts val="0"/>
+              </a:spcAft>
+            </a:pPr>
+            <a:r>
+              <a:rPr sz="1100" b="1">
                 <a:solidFill>
                   <a:srgbClr val="262B33"/>
                 </a:solidFill>
                 <a:latin typeface="Arial"/>
               </a:rPr>
-              <a:t>Weighted Jevons on minimum logical fares — the elementary-aggregate method Eurostat and ONS use for their own price indices.</a:t>
-            </a:r>
-          </a:p>
-        </p:txBody>
-      </p:sp>
-      <p:sp>
-        <p:nvSpPr>
-          <p:cNvPr id="15364" name="Rectangle 15363"/>
+              <a:t>Frequency</a:t>
+            </a:r>
+          </a:p>
+        </p:txBody>
+      </p:sp>
+      <p:sp>
+        <p:nvSpPr>
+          <p:cNvPr id="15369" name="TextBox 15368"/>
+          <p:cNvSpPr txBox="1"/>
+          <p:nvPr/>
+        </p:nvSpPr>
+        <p:spPr>
+          <a:xfrm>
+            <a:off x="2148840" y="2505456"/>
+            <a:ext cx="1920240" cy="237744"/>
+          </a:xfrm>
+          <a:prstGeom prst="rect">
+            <a:avLst/>
+          </a:prstGeom>
+          <a:noFill/>
+        </p:spPr>
+        <p:txBody>
+          <a:bodyPr wrap="square" lIns="36576" rIns="36576" tIns="18288" bIns="18288">
+            <a:spAutoFit/>
+          </a:bodyPr>
+          <a:lstStyle/>
+          <a:p>
+            <a:pPr>
+              <a:lnSpc>
+                <a:spcPct val="95000"/>
+              </a:lnSpc>
+              <a:spcBef>
+                <a:spcPts val="0"/>
+              </a:spcBef>
+              <a:spcAft>
+                <a:spcPts val="0"/>
+              </a:spcAft>
+            </a:pPr>
+            <a:r>
+              <a:rPr sz="1050" b="0">
+                <a:solidFill>
+                  <a:srgbClr val="5A626C"/>
+                </a:solidFill>
+                <a:latin typeface="Arial"/>
+              </a:rPr>
+              <a:t>once a month</a:t>
+            </a:r>
+          </a:p>
+        </p:txBody>
+      </p:sp>
+      <p:sp>
+        <p:nvSpPr>
+          <p:cNvPr id="15370" name="TextBox 15369"/>
+          <p:cNvSpPr txBox="1"/>
+          <p:nvPr/>
+        </p:nvSpPr>
+        <p:spPr>
+          <a:xfrm>
+            <a:off x="4160520" y="2505456"/>
+            <a:ext cx="2468880" cy="237744"/>
+          </a:xfrm>
+          <a:prstGeom prst="rect">
+            <a:avLst/>
+          </a:prstGeom>
+          <a:noFill/>
+        </p:spPr>
+        <p:txBody>
+          <a:bodyPr wrap="square" lIns="36576" rIns="36576" tIns="18288" bIns="18288">
+            <a:spAutoFit/>
+          </a:bodyPr>
+          <a:lstStyle/>
+          <a:p>
+            <a:pPr>
+              <a:lnSpc>
+                <a:spcPct val="95000"/>
+              </a:lnSpc>
+              <a:spcBef>
+                <a:spcPts val="0"/>
+              </a:spcBef>
+              <a:spcAft>
+                <a:spcPts val="0"/>
+              </a:spcAft>
+            </a:pPr>
+            <a:r>
+              <a:rPr sz="1050" b="1">
+                <a:solidFill>
+                  <a:srgbClr val="262B33"/>
+                </a:solidFill>
+                <a:latin typeface="Arial"/>
+              </a:rPr>
+              <a:t>every 10 minutes</a:t>
+            </a:r>
+          </a:p>
+        </p:txBody>
+      </p:sp>
+      <p:sp>
+        <p:nvSpPr>
+          <p:cNvPr id="15371" name="TextBox 15370"/>
+          <p:cNvSpPr txBox="1"/>
+          <p:nvPr/>
+        </p:nvSpPr>
+        <p:spPr>
+          <a:xfrm>
+            <a:off x="548640" y="2770632"/>
+            <a:ext cx="1600200" cy="237744"/>
+          </a:xfrm>
+          <a:prstGeom prst="rect">
+            <a:avLst/>
+          </a:prstGeom>
+          <a:noFill/>
+        </p:spPr>
+        <p:txBody>
+          <a:bodyPr wrap="square" lIns="36576" rIns="36576" tIns="18288" bIns="18288">
+            <a:spAutoFit/>
+          </a:bodyPr>
+          <a:lstStyle/>
+          <a:p>
+            <a:pPr>
+              <a:lnSpc>
+                <a:spcPct val="95000"/>
+              </a:lnSpc>
+              <a:spcBef>
+                <a:spcPts val="0"/>
+              </a:spcBef>
+              <a:spcAft>
+                <a:spcPts val="0"/>
+              </a:spcAft>
+            </a:pPr>
+            <a:r>
+              <a:rPr sz="1100" b="1">
+                <a:solidFill>
+                  <a:srgbClr val="262B33"/>
+                </a:solidFill>
+                <a:latin typeface="Arial"/>
+              </a:rPr>
+              <a:t>Coverage</a:t>
+            </a:r>
+          </a:p>
+        </p:txBody>
+      </p:sp>
+      <p:sp>
+        <p:nvSpPr>
+          <p:cNvPr id="15372" name="TextBox 15371"/>
+          <p:cNvSpPr txBox="1"/>
+          <p:nvPr/>
+        </p:nvSpPr>
+        <p:spPr>
+          <a:xfrm>
+            <a:off x="2148840" y="2770632"/>
+            <a:ext cx="1920240" cy="237744"/>
+          </a:xfrm>
+          <a:prstGeom prst="rect">
+            <a:avLst/>
+          </a:prstGeom>
+          <a:noFill/>
+        </p:spPr>
+        <p:txBody>
+          <a:bodyPr wrap="square" lIns="36576" rIns="36576" tIns="18288" bIns="18288">
+            <a:spAutoFit/>
+          </a:bodyPr>
+          <a:lstStyle/>
+          <a:p>
+            <a:pPr>
+              <a:lnSpc>
+                <a:spcPct val="95000"/>
+              </a:lnSpc>
+              <a:spcBef>
+                <a:spcPts val="0"/>
+              </a:spcBef>
+              <a:spcAft>
+                <a:spcPts val="0"/>
+              </a:spcAft>
+            </a:pPr>
+            <a:r>
+              <a:rPr sz="1050" b="0">
+                <a:solidFill>
+                  <a:srgbClr val="5A626C"/>
+                </a:solidFill>
+                <a:latin typeface="Arial"/>
+              </a:rPr>
+              <a:t>a handful of quotes</a:t>
+            </a:r>
+          </a:p>
+        </p:txBody>
+      </p:sp>
+      <p:sp>
+        <p:nvSpPr>
+          <p:cNvPr id="15373" name="TextBox 15372"/>
+          <p:cNvSpPr txBox="1"/>
+          <p:nvPr/>
+        </p:nvSpPr>
+        <p:spPr>
+          <a:xfrm>
+            <a:off x="4160520" y="2770632"/>
+            <a:ext cx="2468880" cy="237744"/>
+          </a:xfrm>
+          <a:prstGeom prst="rect">
+            <a:avLst/>
+          </a:prstGeom>
+          <a:noFill/>
+        </p:spPr>
+        <p:txBody>
+          <a:bodyPr wrap="square" lIns="36576" rIns="36576" tIns="18288" bIns="18288">
+            <a:spAutoFit/>
+          </a:bodyPr>
+          <a:lstStyle/>
+          <a:p>
+            <a:pPr>
+              <a:lnSpc>
+                <a:spcPct val="95000"/>
+              </a:lnSpc>
+              <a:spcBef>
+                <a:spcPts val="0"/>
+              </a:spcBef>
+              <a:spcAft>
+                <a:spcPts val="0"/>
+              </a:spcAft>
+            </a:pPr>
+            <a:r>
+              <a:rPr sz="1050" b="1">
+                <a:solidFill>
+                  <a:srgbClr val="262B33"/>
+                </a:solidFill>
+                <a:latin typeface="Arial"/>
+              </a:rPr>
+              <a:t>75 priced cells</a:t>
+            </a:r>
+          </a:p>
+        </p:txBody>
+      </p:sp>
+      <p:sp>
+        <p:nvSpPr>
+          <p:cNvPr id="15374" name="TextBox 15373"/>
+          <p:cNvSpPr txBox="1"/>
+          <p:nvPr/>
+        </p:nvSpPr>
+        <p:spPr>
+          <a:xfrm>
+            <a:off x="548640" y="3035808"/>
+            <a:ext cx="1600200" cy="237744"/>
+          </a:xfrm>
+          <a:prstGeom prst="rect">
+            <a:avLst/>
+          </a:prstGeom>
+          <a:noFill/>
+        </p:spPr>
+        <p:txBody>
+          <a:bodyPr wrap="square" lIns="36576" rIns="36576" tIns="18288" bIns="18288">
+            <a:spAutoFit/>
+          </a:bodyPr>
+          <a:lstStyle/>
+          <a:p>
+            <a:pPr>
+              <a:lnSpc>
+                <a:spcPct val="95000"/>
+              </a:lnSpc>
+              <a:spcBef>
+                <a:spcPts val="0"/>
+              </a:spcBef>
+              <a:spcAft>
+                <a:spcPts val="0"/>
+              </a:spcAft>
+            </a:pPr>
+            <a:r>
+              <a:rPr sz="1100" b="1">
+                <a:solidFill>
+                  <a:srgbClr val="262B33"/>
+                </a:solidFill>
+                <a:latin typeface="Arial"/>
+              </a:rPr>
+              <a:t>Price basis</a:t>
+            </a:r>
+          </a:p>
+        </p:txBody>
+      </p:sp>
+      <p:sp>
+        <p:nvSpPr>
+          <p:cNvPr id="15375" name="TextBox 15374"/>
+          <p:cNvSpPr txBox="1"/>
+          <p:nvPr/>
+        </p:nvSpPr>
+        <p:spPr>
+          <a:xfrm>
+            <a:off x="2148840" y="3035808"/>
+            <a:ext cx="1920240" cy="237744"/>
+          </a:xfrm>
+          <a:prstGeom prst="rect">
+            <a:avLst/>
+          </a:prstGeom>
+          <a:noFill/>
+        </p:spPr>
+        <p:txBody>
+          <a:bodyPr wrap="square" lIns="36576" rIns="36576" tIns="18288" bIns="18288">
+            <a:spAutoFit/>
+          </a:bodyPr>
+          <a:lstStyle/>
+          <a:p>
+            <a:pPr>
+              <a:lnSpc>
+                <a:spcPct val="95000"/>
+              </a:lnSpc>
+              <a:spcBef>
+                <a:spcPts val="0"/>
+              </a:spcBef>
+              <a:spcAft>
+                <a:spcPts val="0"/>
+              </a:spcAft>
+            </a:pPr>
+            <a:r>
+              <a:rPr sz="1050" b="0">
+                <a:solidFill>
+                  <a:srgbClr val="5A626C"/>
+                </a:solidFill>
+                <a:latin typeface="Arial"/>
+              </a:rPr>
+              <a:t>one quoted price</a:t>
+            </a:r>
+          </a:p>
+        </p:txBody>
+      </p:sp>
+      <p:sp>
+        <p:nvSpPr>
+          <p:cNvPr id="15376" name="TextBox 15375"/>
+          <p:cNvSpPr txBox="1"/>
+          <p:nvPr/>
+        </p:nvSpPr>
+        <p:spPr>
+          <a:xfrm>
+            <a:off x="4160520" y="3035808"/>
+            <a:ext cx="2468880" cy="237744"/>
+          </a:xfrm>
+          <a:prstGeom prst="rect">
+            <a:avLst/>
+          </a:prstGeom>
+          <a:noFill/>
+        </p:spPr>
+        <p:txBody>
+          <a:bodyPr wrap="square" lIns="36576" rIns="36576" tIns="18288" bIns="18288">
+            <a:spAutoFit/>
+          </a:bodyPr>
+          <a:lstStyle/>
+          <a:p>
+            <a:pPr>
+              <a:lnSpc>
+                <a:spcPct val="95000"/>
+              </a:lnSpc>
+              <a:spcBef>
+                <a:spcPts val="0"/>
+              </a:spcBef>
+              <a:spcAft>
+                <a:spcPts val="0"/>
+              </a:spcAft>
+            </a:pPr>
+            <a:r>
+              <a:rPr sz="1050" b="1">
+                <a:solidFill>
+                  <a:srgbClr val="262B33"/>
+                </a:solidFill>
+                <a:latin typeface="Arial"/>
+              </a:rPr>
+              <a:t>minimum logical fare</a:t>
+            </a:r>
+          </a:p>
+        </p:txBody>
+      </p:sp>
+      <p:sp>
+        <p:nvSpPr>
+          <p:cNvPr id="15377" name="TextBox 15376"/>
+          <p:cNvSpPr txBox="1"/>
+          <p:nvPr/>
+        </p:nvSpPr>
+        <p:spPr>
+          <a:xfrm>
+            <a:off x="548640" y="3300984"/>
+            <a:ext cx="1600200" cy="237744"/>
+          </a:xfrm>
+          <a:prstGeom prst="rect">
+            <a:avLst/>
+          </a:prstGeom>
+          <a:noFill/>
+        </p:spPr>
+        <p:txBody>
+          <a:bodyPr wrap="square" lIns="36576" rIns="36576" tIns="18288" bIns="18288">
+            <a:spAutoFit/>
+          </a:bodyPr>
+          <a:lstStyle/>
+          <a:p>
+            <a:pPr>
+              <a:lnSpc>
+                <a:spcPct val="95000"/>
+              </a:lnSpc>
+              <a:spcBef>
+                <a:spcPts val="0"/>
+              </a:spcBef>
+              <a:spcAft>
+                <a:spcPts val="0"/>
+              </a:spcAft>
+            </a:pPr>
+            <a:r>
+              <a:rPr sz="1100" b="1">
+                <a:solidFill>
+                  <a:srgbClr val="262B33"/>
+                </a:solidFill>
+                <a:latin typeface="Arial"/>
+              </a:rPr>
+              <a:t>Delivery</a:t>
+            </a:r>
+          </a:p>
+        </p:txBody>
+      </p:sp>
+      <p:sp>
+        <p:nvSpPr>
+          <p:cNvPr id="15378" name="TextBox 15377"/>
+          <p:cNvSpPr txBox="1"/>
+          <p:nvPr/>
+        </p:nvSpPr>
+        <p:spPr>
+          <a:xfrm>
+            <a:off x="2148840" y="3300984"/>
+            <a:ext cx="1920240" cy="237744"/>
+          </a:xfrm>
+          <a:prstGeom prst="rect">
+            <a:avLst/>
+          </a:prstGeom>
+          <a:noFill/>
+        </p:spPr>
+        <p:txBody>
+          <a:bodyPr wrap="square" lIns="36576" rIns="36576" tIns="18288" bIns="18288">
+            <a:spAutoFit/>
+          </a:bodyPr>
+          <a:lstStyle/>
+          <a:p>
+            <a:pPr>
+              <a:lnSpc>
+                <a:spcPct val="95000"/>
+              </a:lnSpc>
+              <a:spcBef>
+                <a:spcPts val="0"/>
+              </a:spcBef>
+              <a:spcAft>
+                <a:spcPts val="0"/>
+              </a:spcAft>
+            </a:pPr>
+            <a:r>
+              <a:rPr sz="1050" b="0">
+                <a:solidFill>
+                  <a:srgbClr val="5A626C"/>
+                </a:solidFill>
+                <a:latin typeface="Arial"/>
+              </a:rPr>
+              <a:t>typed into a form</a:t>
+            </a:r>
+          </a:p>
+        </p:txBody>
+      </p:sp>
+      <p:sp>
+        <p:nvSpPr>
+          <p:cNvPr id="15379" name="TextBox 15378"/>
+          <p:cNvSpPr txBox="1"/>
+          <p:nvPr/>
+        </p:nvSpPr>
+        <p:spPr>
+          <a:xfrm>
+            <a:off x="4160520" y="3300984"/>
+            <a:ext cx="2468880" cy="237744"/>
+          </a:xfrm>
+          <a:prstGeom prst="rect">
+            <a:avLst/>
+          </a:prstGeom>
+          <a:noFill/>
+        </p:spPr>
+        <p:txBody>
+          <a:bodyPr wrap="square" lIns="36576" rIns="36576" tIns="18288" bIns="18288">
+            <a:spAutoFit/>
+          </a:bodyPr>
+          <a:lstStyle/>
+          <a:p>
+            <a:pPr>
+              <a:lnSpc>
+                <a:spcPct val="95000"/>
+              </a:lnSpc>
+              <a:spcBef>
+                <a:spcPts val="0"/>
+              </a:spcBef>
+              <a:spcAft>
+                <a:spcPts val="0"/>
+              </a:spcAft>
+            </a:pPr>
+            <a:r>
+              <a:rPr sz="1050" b="1">
+                <a:solidFill>
+                  <a:srgbClr val="262B33"/>
+                </a:solidFill>
+                <a:latin typeface="Arial"/>
+              </a:rPr>
+              <a:t>authenticated REST API</a:t>
+            </a:r>
+          </a:p>
+        </p:txBody>
+      </p:sp>
+      <p:sp>
+        <p:nvSpPr>
+          <p:cNvPr id="15380" name="Rounded Rectangle 15379"/>
           <p:cNvSpPr/>
           <p:nvPr/>
         </p:nvSpPr>
         <p:spPr>
           <a:xfrm>
-            <a:off x="411480" y="2048256"/>
-            <a:ext cx="3703320" cy="64008"/>
+            <a:off x="6903720" y="1920240"/>
+            <a:ext cx="4846320" cy="877824"/>
+          </a:xfrm>
+          <a:prstGeom prst="roundRect">
+            <a:avLst>
+              <a:gd name="adj" fmla="val 6000"/>
+            </a:avLst>
+          </a:prstGeom>
+          <a:solidFill>
+            <a:srgbClr val="ECEAF7"/>
+          </a:solidFill>
+          <a:ln>
+            <a:noFill/>
+          </a:ln>
+          <a:effectLst/>
+        </p:spPr>
+        <p:style>
+          <a:lnRef idx="1">
+            <a:schemeClr val="accent1"/>
+          </a:lnRef>
+          <a:fillRef idx="3">
+            <a:schemeClr val="accent1"/>
+          </a:fillRef>
+          <a:effectRef idx="2">
+            <a:schemeClr val="accent1"/>
+          </a:effectRef>
+          <a:fontRef idx="minor">
+            <a:schemeClr val="lt1"/>
+          </a:fontRef>
+        </p:style>
+        <p:txBody>
+          <a:bodyPr rtlCol="0" anchor="ctr" wrap="square"/>
+          <a:lstStyle/>
+          <a:p>
+            <a:pPr algn="ctr"/>
+          </a:p>
+        </p:txBody>
+      </p:sp>
+      <p:sp>
+        <p:nvSpPr>
+          <p:cNvPr id="15381" name="TextBox 15380"/>
+          <p:cNvSpPr txBox="1"/>
+          <p:nvPr/>
+        </p:nvSpPr>
+        <p:spPr>
+          <a:xfrm>
+            <a:off x="7040880" y="1956816"/>
+            <a:ext cx="4572000" cy="219456"/>
+          </a:xfrm>
+          <a:prstGeom prst="rect">
+            <a:avLst/>
+          </a:prstGeom>
+          <a:noFill/>
+        </p:spPr>
+        <p:txBody>
+          <a:bodyPr wrap="square" lIns="36576" rIns="36576" tIns="18288" bIns="18288">
+            <a:spAutoFit/>
+          </a:bodyPr>
+          <a:lstStyle/>
+          <a:p>
+            <a:pPr>
+              <a:lnSpc>
+                <a:spcPct val="95000"/>
+              </a:lnSpc>
+              <a:spcBef>
+                <a:spcPts val="0"/>
+              </a:spcBef>
+              <a:spcAft>
+                <a:spcPts val="0"/>
+              </a:spcAft>
+            </a:pPr>
+            <a:r>
+              <a:rPr sz="1050" b="1">
+                <a:solidFill>
+                  <a:srgbClr val="4B3F8C"/>
+                </a:solidFill>
+                <a:latin typeface="Arial"/>
+              </a:rPr>
+              <a:t>THE INDEX IN ONE LINE</a:t>
+            </a:r>
+          </a:p>
+        </p:txBody>
+      </p:sp>
+      <p:sp>
+        <p:nvSpPr>
+          <p:cNvPr id="15382" name="TextBox 15381"/>
+          <p:cNvSpPr txBox="1"/>
+          <p:nvPr/>
+        </p:nvSpPr>
+        <p:spPr>
+          <a:xfrm>
+            <a:off x="7040880" y="2176272"/>
+            <a:ext cx="4572000" cy="237744"/>
+          </a:xfrm>
+          <a:prstGeom prst="rect">
+            <a:avLst/>
+          </a:prstGeom>
+          <a:noFill/>
+        </p:spPr>
+        <p:txBody>
+          <a:bodyPr wrap="square" lIns="36576" rIns="36576" tIns="18288" bIns="18288">
+            <a:spAutoFit/>
+          </a:bodyPr>
+          <a:lstStyle/>
+          <a:p>
+            <a:pPr>
+              <a:lnSpc>
+                <a:spcPct val="95000"/>
+              </a:lnSpc>
+              <a:spcBef>
+                <a:spcPts val="0"/>
+              </a:spcBef>
+              <a:spcAft>
+                <a:spcPts val="0"/>
+              </a:spcAft>
+            </a:pPr>
+            <a:r>
+              <a:rPr sz="1050" b="1">
+                <a:solidFill>
+                  <a:srgbClr val="262B33"/>
+                </a:solidFill>
+                <a:latin typeface="Arial"/>
+              </a:rPr>
+              <a:t>APIxₜ = 100 × exp( Σ wᵢ·ln(Pᵢ,ₜ/Pᵢ,₀) / Σ wᵢ )</a:t>
+            </a:r>
+          </a:p>
+        </p:txBody>
+      </p:sp>
+      <p:sp>
+        <p:nvSpPr>
+          <p:cNvPr id="15383" name="TextBox 15382"/>
+          <p:cNvSpPr txBox="1"/>
+          <p:nvPr/>
+        </p:nvSpPr>
+        <p:spPr>
+          <a:xfrm>
+            <a:off x="7040880" y="2414016"/>
+            <a:ext cx="4572000" cy="329184"/>
+          </a:xfrm>
+          <a:prstGeom prst="rect">
+            <a:avLst/>
+          </a:prstGeom>
+          <a:noFill/>
+        </p:spPr>
+        <p:txBody>
+          <a:bodyPr wrap="square" lIns="36576" rIns="36576" tIns="18288" bIns="18288">
+            <a:spAutoFit/>
+          </a:bodyPr>
+          <a:lstStyle/>
+          <a:p>
+            <a:pPr>
+              <a:lnSpc>
+                <a:spcPct val="95000"/>
+              </a:lnSpc>
+              <a:spcBef>
+                <a:spcPts val="0"/>
+              </a:spcBef>
+              <a:spcAft>
+                <a:spcPts val="0"/>
+              </a:spcAft>
+            </a:pPr>
+            <a:r>
+              <a:rPr sz="1000" b="0">
+                <a:solidFill>
+                  <a:srgbClr val="5A626C"/>
+                </a:solidFill>
+                <a:latin typeface="Arial"/>
+              </a:rPr>
+              <a:t>Weighted Jevons — the elementary-aggregate formula Eurostat and the ONS use for their own price indices.</a:t>
+            </a:r>
+          </a:p>
+        </p:txBody>
+      </p:sp>
+      <p:sp>
+        <p:nvSpPr>
+          <p:cNvPr id="15384" name="Rounded Rectangle 15383"/>
+          <p:cNvSpPr/>
+          <p:nvPr/>
+        </p:nvSpPr>
+        <p:spPr>
+          <a:xfrm>
+            <a:off x="6903720" y="2834640"/>
+            <a:ext cx="4846320" cy="822960"/>
+          </a:xfrm>
+          <a:prstGeom prst="roundRect">
+            <a:avLst>
+              <a:gd name="adj" fmla="val 6000"/>
+            </a:avLst>
+          </a:prstGeom>
+          <a:solidFill>
+            <a:srgbClr val="E2F2F3"/>
+          </a:solidFill>
+          <a:ln>
+            <a:noFill/>
+          </a:ln>
+          <a:effectLst/>
+        </p:spPr>
+        <p:style>
+          <a:lnRef idx="1">
+            <a:schemeClr val="accent1"/>
+          </a:lnRef>
+          <a:fillRef idx="3">
+            <a:schemeClr val="accent1"/>
+          </a:fillRef>
+          <a:effectRef idx="2">
+            <a:schemeClr val="accent1"/>
+          </a:effectRef>
+          <a:fontRef idx="minor">
+            <a:schemeClr val="lt1"/>
+          </a:fontRef>
+        </p:style>
+        <p:txBody>
+          <a:bodyPr rtlCol="0" anchor="ctr" wrap="square"/>
+          <a:lstStyle/>
+          <a:p>
+            <a:pPr algn="ctr"/>
+          </a:p>
+        </p:txBody>
+      </p:sp>
+      <p:sp>
+        <p:nvSpPr>
+          <p:cNvPr id="15385" name="TextBox 15384"/>
+          <p:cNvSpPr txBox="1"/>
+          <p:nvPr/>
+        </p:nvSpPr>
+        <p:spPr>
+          <a:xfrm>
+            <a:off x="7040880" y="2871216"/>
+            <a:ext cx="4572000" cy="219456"/>
+          </a:xfrm>
+          <a:prstGeom prst="rect">
+            <a:avLst/>
+          </a:prstGeom>
+          <a:noFill/>
+        </p:spPr>
+        <p:txBody>
+          <a:bodyPr wrap="square" lIns="36576" rIns="36576" tIns="18288" bIns="18288">
+            <a:spAutoFit/>
+          </a:bodyPr>
+          <a:lstStyle/>
+          <a:p>
+            <a:pPr>
+              <a:lnSpc>
+                <a:spcPct val="95000"/>
+              </a:lnSpc>
+              <a:spcBef>
+                <a:spcPts val="0"/>
+              </a:spcBef>
+              <a:spcAft>
+                <a:spcPts val="0"/>
+              </a:spcAft>
+            </a:pPr>
+            <a:r>
+              <a:rPr sz="1050" b="1">
+                <a:solidFill>
+                  <a:srgbClr val="0E7C86"/>
+                </a:solidFill>
+                <a:latin typeface="Arial"/>
+              </a:rPr>
+              <a:t>WHAT THE TERMS MEAN</a:t>
+            </a:r>
+          </a:p>
+        </p:txBody>
+      </p:sp>
+      <p:sp>
+        <p:nvSpPr>
+          <p:cNvPr id="15386" name="TextBox 15385"/>
+          <p:cNvSpPr txBox="1"/>
+          <p:nvPr/>
+        </p:nvSpPr>
+        <p:spPr>
+          <a:xfrm>
+            <a:off x="7040880" y="3072384"/>
+            <a:ext cx="777240" cy="146304"/>
+          </a:xfrm>
+          <a:prstGeom prst="rect">
+            <a:avLst/>
+          </a:prstGeom>
+          <a:noFill/>
+        </p:spPr>
+        <p:txBody>
+          <a:bodyPr wrap="square" lIns="36576" rIns="36576" tIns="18288" bIns="18288">
+            <a:spAutoFit/>
+          </a:bodyPr>
+          <a:lstStyle/>
+          <a:p>
+            <a:pPr>
+              <a:lnSpc>
+                <a:spcPct val="95000"/>
+              </a:lnSpc>
+              <a:spcBef>
+                <a:spcPts val="0"/>
+              </a:spcBef>
+              <a:spcAft>
+                <a:spcPts val="0"/>
+              </a:spcAft>
+            </a:pPr>
+            <a:r>
+              <a:rPr sz="1000" b="1">
+                <a:solidFill>
+                  <a:srgbClr val="0E7C86"/>
+                </a:solidFill>
+                <a:latin typeface="Arial"/>
+              </a:rPr>
+              <a:t>Basket</a:t>
+            </a:r>
+          </a:p>
+        </p:txBody>
+      </p:sp>
+      <p:sp>
+        <p:nvSpPr>
+          <p:cNvPr id="15387" name="TextBox 15386"/>
+          <p:cNvSpPr txBox="1"/>
+          <p:nvPr/>
+        </p:nvSpPr>
+        <p:spPr>
+          <a:xfrm>
+            <a:off x="7818120" y="3072384"/>
+            <a:ext cx="3840480" cy="146304"/>
+          </a:xfrm>
+          <a:prstGeom prst="rect">
+            <a:avLst/>
+          </a:prstGeom>
+          <a:noFill/>
+        </p:spPr>
+        <p:txBody>
+          <a:bodyPr wrap="square" lIns="36576" rIns="36576" tIns="18288" bIns="18288">
+            <a:spAutoFit/>
+          </a:bodyPr>
+          <a:lstStyle/>
+          <a:p>
+            <a:pPr>
+              <a:lnSpc>
+                <a:spcPct val="95000"/>
+              </a:lnSpc>
+              <a:spcBef>
+                <a:spcPts val="0"/>
+              </a:spcBef>
+              <a:spcAft>
+                <a:spcPts val="0"/>
+              </a:spcAft>
+            </a:pPr>
+            <a:r>
+              <a:rPr sz="1000" b="0">
+                <a:solidFill>
+                  <a:srgbClr val="262B33"/>
+                </a:solidFill>
+                <a:latin typeface="Arial"/>
+              </a:rPr>
+              <a:t>15 city pairs × 5 lead times = 75 cells</a:t>
+            </a:r>
+          </a:p>
+        </p:txBody>
+      </p:sp>
+      <p:sp>
+        <p:nvSpPr>
+          <p:cNvPr id="15388" name="TextBox 15387"/>
+          <p:cNvSpPr txBox="1"/>
+          <p:nvPr/>
+        </p:nvSpPr>
+        <p:spPr>
+          <a:xfrm>
+            <a:off x="7040880" y="3218688"/>
+            <a:ext cx="777240" cy="146304"/>
+          </a:xfrm>
+          <a:prstGeom prst="rect">
+            <a:avLst/>
+          </a:prstGeom>
+          <a:noFill/>
+        </p:spPr>
+        <p:txBody>
+          <a:bodyPr wrap="square" lIns="36576" rIns="36576" tIns="18288" bIns="18288">
+            <a:spAutoFit/>
+          </a:bodyPr>
+          <a:lstStyle/>
+          <a:p>
+            <a:pPr>
+              <a:lnSpc>
+                <a:spcPct val="95000"/>
+              </a:lnSpc>
+              <a:spcBef>
+                <a:spcPts val="0"/>
+              </a:spcBef>
+              <a:spcAft>
+                <a:spcPts val="0"/>
+              </a:spcAft>
+            </a:pPr>
+            <a:r>
+              <a:rPr sz="1000" b="1">
+                <a:solidFill>
+                  <a:srgbClr val="0E7C86"/>
+                </a:solidFill>
+                <a:latin typeface="Arial"/>
+              </a:rPr>
+              <a:t>Price</a:t>
+            </a:r>
+          </a:p>
+        </p:txBody>
+      </p:sp>
+      <p:sp>
+        <p:nvSpPr>
+          <p:cNvPr id="15389" name="TextBox 15388"/>
+          <p:cNvSpPr txBox="1"/>
+          <p:nvPr/>
+        </p:nvSpPr>
+        <p:spPr>
+          <a:xfrm>
+            <a:off x="7818120" y="3218688"/>
+            <a:ext cx="3840480" cy="146304"/>
+          </a:xfrm>
+          <a:prstGeom prst="rect">
+            <a:avLst/>
+          </a:prstGeom>
+          <a:noFill/>
+        </p:spPr>
+        <p:txBody>
+          <a:bodyPr wrap="square" lIns="36576" rIns="36576" tIns="18288" bIns="18288">
+            <a:spAutoFit/>
+          </a:bodyPr>
+          <a:lstStyle/>
+          <a:p>
+            <a:pPr>
+              <a:lnSpc>
+                <a:spcPct val="95000"/>
+              </a:lnSpc>
+              <a:spcBef>
+                <a:spcPts val="0"/>
+              </a:spcBef>
+              <a:spcAft>
+                <a:spcPts val="0"/>
+              </a:spcAft>
+            </a:pPr>
+            <a:r>
+              <a:rPr sz="1000" b="0">
+                <a:solidFill>
+                  <a:srgbClr val="262B33"/>
+                </a:solidFill>
+                <a:latin typeface="Arial"/>
+              </a:rPr>
+              <a:t>minimum logical fare, no add-ons</a:t>
+            </a:r>
+          </a:p>
+        </p:txBody>
+      </p:sp>
+      <p:sp>
+        <p:nvSpPr>
+          <p:cNvPr id="15390" name="TextBox 15389"/>
+          <p:cNvSpPr txBox="1"/>
+          <p:nvPr/>
+        </p:nvSpPr>
+        <p:spPr>
+          <a:xfrm>
+            <a:off x="7040880" y="3364991"/>
+            <a:ext cx="777240" cy="146304"/>
+          </a:xfrm>
+          <a:prstGeom prst="rect">
+            <a:avLst/>
+          </a:prstGeom>
+          <a:noFill/>
+        </p:spPr>
+        <p:txBody>
+          <a:bodyPr wrap="square" lIns="36576" rIns="36576" tIns="18288" bIns="18288">
+            <a:spAutoFit/>
+          </a:bodyPr>
+          <a:lstStyle/>
+          <a:p>
+            <a:pPr>
+              <a:lnSpc>
+                <a:spcPct val="95000"/>
+              </a:lnSpc>
+              <a:spcBef>
+                <a:spcPts val="0"/>
+              </a:spcBef>
+              <a:spcAft>
+                <a:spcPts val="0"/>
+              </a:spcAft>
+            </a:pPr>
+            <a:r>
+              <a:rPr sz="1000" b="1">
+                <a:solidFill>
+                  <a:srgbClr val="0E7C86"/>
+                </a:solidFill>
+                <a:latin typeface="Arial"/>
+              </a:rPr>
+              <a:t>Weight</a:t>
+            </a:r>
+          </a:p>
+        </p:txBody>
+      </p:sp>
+      <p:sp>
+        <p:nvSpPr>
+          <p:cNvPr id="15391" name="TextBox 15390"/>
+          <p:cNvSpPr txBox="1"/>
+          <p:nvPr/>
+        </p:nvSpPr>
+        <p:spPr>
+          <a:xfrm>
+            <a:off x="7818120" y="3364991"/>
+            <a:ext cx="3840480" cy="146304"/>
+          </a:xfrm>
+          <a:prstGeom prst="rect">
+            <a:avLst/>
+          </a:prstGeom>
+          <a:noFill/>
+        </p:spPr>
+        <p:txBody>
+          <a:bodyPr wrap="square" lIns="36576" rIns="36576" tIns="18288" bIns="18288">
+            <a:spAutoFit/>
+          </a:bodyPr>
+          <a:lstStyle/>
+          <a:p>
+            <a:pPr>
+              <a:lnSpc>
+                <a:spcPct val="95000"/>
+              </a:lnSpc>
+              <a:spcBef>
+                <a:spcPts val="0"/>
+              </a:spcBef>
+              <a:spcAft>
+                <a:spcPts val="0"/>
+              </a:spcAft>
+            </a:pPr>
+            <a:r>
+              <a:rPr sz="1000" b="0">
+                <a:solidFill>
+                  <a:srgbClr val="262B33"/>
+                </a:solidFill>
+                <a:latin typeface="Arial"/>
+              </a:rPr>
+              <a:t>route seat share × lead-time share</a:t>
+            </a:r>
+          </a:p>
+        </p:txBody>
+      </p:sp>
+      <p:sp>
+        <p:nvSpPr>
+          <p:cNvPr id="15392" name="TextBox 15391"/>
+          <p:cNvSpPr txBox="1"/>
+          <p:nvPr/>
+        </p:nvSpPr>
+        <p:spPr>
+          <a:xfrm>
+            <a:off x="7040880" y="3511296"/>
+            <a:ext cx="777240" cy="146304"/>
+          </a:xfrm>
+          <a:prstGeom prst="rect">
+            <a:avLst/>
+          </a:prstGeom>
+          <a:noFill/>
+        </p:spPr>
+        <p:txBody>
+          <a:bodyPr wrap="square" lIns="36576" rIns="36576" tIns="18288" bIns="18288">
+            <a:spAutoFit/>
+          </a:bodyPr>
+          <a:lstStyle/>
+          <a:p>
+            <a:pPr>
+              <a:lnSpc>
+                <a:spcPct val="95000"/>
+              </a:lnSpc>
+              <a:spcBef>
+                <a:spcPts val="0"/>
+              </a:spcBef>
+              <a:spcAft>
+                <a:spcPts val="0"/>
+              </a:spcAft>
+            </a:pPr>
+            <a:r>
+              <a:rPr sz="1000" b="1">
+                <a:solidFill>
+                  <a:srgbClr val="0E7C86"/>
+                </a:solidFill>
+                <a:latin typeface="Arial"/>
+              </a:rPr>
+              <a:t>Base</a:t>
+            </a:r>
+          </a:p>
+        </p:txBody>
+      </p:sp>
+      <p:sp>
+        <p:nvSpPr>
+          <p:cNvPr id="15393" name="TextBox 15392"/>
+          <p:cNvSpPr txBox="1"/>
+          <p:nvPr/>
+        </p:nvSpPr>
+        <p:spPr>
+          <a:xfrm>
+            <a:off x="7818120" y="3511296"/>
+            <a:ext cx="3840480" cy="146304"/>
+          </a:xfrm>
+          <a:prstGeom prst="rect">
+            <a:avLst/>
+          </a:prstGeom>
+          <a:noFill/>
+        </p:spPr>
+        <p:txBody>
+          <a:bodyPr wrap="square" lIns="36576" rIns="36576" tIns="18288" bIns="18288">
+            <a:spAutoFit/>
+          </a:bodyPr>
+          <a:lstStyle/>
+          <a:p>
+            <a:pPr>
+              <a:lnSpc>
+                <a:spcPct val="95000"/>
+              </a:lnSpc>
+              <a:spcBef>
+                <a:spcPts val="0"/>
+              </a:spcBef>
+              <a:spcAft>
+                <a:spcPts val="0"/>
+              </a:spcAft>
+            </a:pPr>
+            <a:r>
+              <a:rPr sz="1000" b="0">
+                <a:solidFill>
+                  <a:srgbClr val="262B33"/>
+                </a:solidFill>
+                <a:latin typeface="Arial"/>
+              </a:rPr>
+              <a:t>August 2026 = 100</a:t>
+            </a:r>
+          </a:p>
+        </p:txBody>
+      </p:sp>
+      <p:sp>
+        <p:nvSpPr>
+          <p:cNvPr id="15394" name="TextBox 15393"/>
+          <p:cNvSpPr txBox="1"/>
+          <p:nvPr/>
+        </p:nvSpPr>
+        <p:spPr>
+          <a:xfrm>
+            <a:off x="411480" y="3730752"/>
+            <a:ext cx="11338560" cy="274320"/>
+          </a:xfrm>
+          <a:prstGeom prst="rect">
+            <a:avLst/>
+          </a:prstGeom>
+          <a:noFill/>
+        </p:spPr>
+        <p:txBody>
+          <a:bodyPr wrap="square" lIns="36576" rIns="36576" tIns="18288" bIns="18288">
+            <a:spAutoFit/>
+          </a:bodyPr>
+          <a:lstStyle/>
+          <a:p>
+            <a:pPr>
+              <a:lnSpc>
+                <a:spcPct val="95000"/>
+              </a:lnSpc>
+              <a:spcBef>
+                <a:spcPts val="0"/>
+              </a:spcBef>
+              <a:spcAft>
+                <a:spcPts val="0"/>
+              </a:spcAft>
+            </a:pPr>
+            <a:r>
+              <a:rPr sz="1400" b="1">
+                <a:solidFill>
+                  <a:srgbClr val="1F497D"/>
+                </a:solidFill>
+                <a:latin typeface="Arial"/>
+              </a:rPr>
+              <a:t>Why it stands out</a:t>
+            </a:r>
+          </a:p>
+        </p:txBody>
+      </p:sp>
+      <p:sp>
+        <p:nvSpPr>
+          <p:cNvPr id="15395" name="Rectangle 15394"/>
+          <p:cNvSpPr/>
+          <p:nvPr/>
+        </p:nvSpPr>
+        <p:spPr>
+          <a:xfrm>
+            <a:off x="429768" y="4005072"/>
+            <a:ext cx="1371600" cy="25603"/>
           </a:xfrm>
           <a:prstGeom prst="rect">
             <a:avLst/>
@@ -6230,14 +7627,145 @@
       </p:sp>
       <p:sp>
         <p:nvSpPr>
-          <p:cNvPr id="15365" name="Rounded Rectangle 15364"/>
+          <p:cNvPr id="15396" name="Rounded Rectangle 15395"/>
           <p:cNvSpPr/>
           <p:nvPr/>
         </p:nvSpPr>
         <p:spPr>
           <a:xfrm>
-            <a:off x="4370832" y="2048256"/>
-            <a:ext cx="3703320" cy="1481328"/>
+            <a:off x="411480" y="4078224"/>
+            <a:ext cx="3621024" cy="1060704"/>
+          </a:xfrm>
+          <a:prstGeom prst="roundRect">
+            <a:avLst>
+              <a:gd name="adj" fmla="val 6000"/>
+            </a:avLst>
+          </a:prstGeom>
+          <a:solidFill>
+            <a:srgbClr val="E8F0F9"/>
+          </a:solidFill>
+          <a:ln>
+            <a:noFill/>
+          </a:ln>
+          <a:effectLst/>
+        </p:spPr>
+        <p:style>
+          <a:lnRef idx="1">
+            <a:schemeClr val="accent1"/>
+          </a:lnRef>
+          <a:fillRef idx="3">
+            <a:schemeClr val="accent1"/>
+          </a:fillRef>
+          <a:effectRef idx="2">
+            <a:schemeClr val="accent1"/>
+          </a:effectRef>
+          <a:fontRef idx="minor">
+            <a:schemeClr val="lt1"/>
+          </a:fontRef>
+        </p:style>
+        <p:txBody>
+          <a:bodyPr rtlCol="0" anchor="ctr" wrap="square" lIns="36576" rIns="36576" tIns="109728" bIns="18288"/>
+          <a:lstStyle/>
+          <a:p>
+            <a:pPr algn="ctr">
+              <a:lnSpc>
+                <a:spcPct val="95000"/>
+              </a:lnSpc>
+              <a:spcBef>
+                <a:spcPts val="0"/>
+              </a:spcBef>
+              <a:spcAft>
+                <a:spcPts val="0"/>
+              </a:spcAft>
+            </a:pPr>
+            <a:r>
+              <a:rPr sz="1250" b="1">
+                <a:solidFill>
+                  <a:srgbClr val="4F81BD"/>
+                </a:solidFill>
+                <a:latin typeface="Arial"/>
+              </a:rPr>
+              <a:t>The standard method</a:t>
+            </a:r>
+          </a:p>
+          <a:p>
+            <a:pPr>
+              <a:lnSpc>
+                <a:spcPct val="95000"/>
+              </a:lnSpc>
+              <a:spcBef>
+                <a:spcPts val="500"/>
+              </a:spcBef>
+              <a:spcAft>
+                <a:spcPts val="0"/>
+              </a:spcAft>
+            </a:pPr>
+            <a:r>
+              <a:rPr sz="1100" b="0">
+                <a:solidFill>
+                  <a:srgbClr val="262B33"/>
+                </a:solidFill>
+                <a:latin typeface="Arial"/>
+              </a:rPr>
+              <a:t>Weighted Jevons on minimum logical fares — the elementary-aggregate method Eurostat and ONS use for their own price indices.</a:t>
+            </a:r>
+          </a:p>
+        </p:txBody>
+      </p:sp>
+      <p:sp>
+        <p:nvSpPr>
+          <p:cNvPr id="15397" name="Rectangle 15396"/>
+          <p:cNvSpPr/>
+          <p:nvPr/>
+        </p:nvSpPr>
+        <p:spPr>
+          <a:xfrm>
+            <a:off x="411480" y="4078224"/>
+            <a:ext cx="3621024" cy="64008"/>
+          </a:xfrm>
+          <a:prstGeom prst="rect">
+            <a:avLst/>
+          </a:prstGeom>
+          <a:solidFill>
+            <a:srgbClr val="4F81BD"/>
+          </a:solidFill>
+          <a:ln>
+            <a:noFill/>
+          </a:ln>
+          <a:effectLst/>
+        </p:spPr>
+        <p:style>
+          <a:lnRef idx="1">
+            <a:schemeClr val="accent1"/>
+          </a:lnRef>
+          <a:fillRef idx="3">
+            <a:schemeClr val="accent1"/>
+          </a:fillRef>
+          <a:effectRef idx="2">
+            <a:schemeClr val="accent1"/>
+          </a:effectRef>
+          <a:fontRef idx="minor">
+            <a:schemeClr val="lt1"/>
+          </a:fontRef>
+        </p:style>
+        <p:txBody>
+          <a:bodyPr rtlCol="0" anchor="ctr"/>
+          <a:lstStyle/>
+          <a:p>
+            <a:pPr algn="ctr"/>
+          </a:p>
+        </p:txBody>
+      </p:sp>
+      <p:sp>
+        <p:nvSpPr>
+          <p:cNvPr id="15398" name="Rounded Rectangle 15397"/>
+          <p:cNvSpPr/>
+          <p:nvPr/>
+        </p:nvSpPr>
+        <p:spPr>
+          <a:xfrm>
+            <a:off x="4270248" y="4078224"/>
+            <a:ext cx="3621024" cy="1060704"/>
           </a:xfrm>
           <a:prstGeom prst="roundRect">
             <a:avLst>
@@ -6267,7 +7795,7 @@
           </a:fontRef>
         </p:style>
         <p:txBody>
-          <a:bodyPr rtlCol="0" anchor="ctr" wrap="square" lIns="36576" rIns="36576" tIns="18288" bIns="18288"/>
+          <a:bodyPr rtlCol="0" anchor="ctr" wrap="square" lIns="36576" rIns="36576" tIns="109728" bIns="18288"/>
           <a:lstStyle/>
           <a:p>
             <a:pPr algn="ctr">
@@ -6282,14 +7810,13 @@
               </a:spcAft>
             </a:pPr>
             <a:r>
-              <a:rPr sz="1400" b="1">
+              <a:rPr sz="1250" b="1">
                 <a:solidFill>
                   <a:srgbClr val="1B8A5A"/>
                 </a:solidFill>
                 <a:latin typeface="Arial"/>
               </a:rPr>
-              <a:t>Weighting is a matrix,
-not a guess</a:t>
+              <a:t>Weighting is a matrix</a:t>
             </a:r>
           </a:p>
           <a:p>
@@ -6305,27 +7832,27 @@
               </a:spcAft>
             </a:pPr>
             <a:r>
-              <a:rPr sz="1200" b="0">
+              <a:rPr sz="1100" b="0">
                 <a:solidFill>
                   <a:srgbClr val="262B33"/>
                 </a:solidFill>
                 <a:latin typeface="Arial"/>
               </a:rPr>
-              <a:t>Every cell is weighted by route share of scheduled seats × booking lead time, so Delhi–Mumbai moves the index three times as much as Delhi–Srinagar.</a:t>
-            </a:r>
-          </a:p>
-        </p:txBody>
-      </p:sp>
-      <p:sp>
-        <p:nvSpPr>
-          <p:cNvPr id="15366" name="Rectangle 15365"/>
+              <a:t>Every cell carries route seat share × booking lead time, so Delhi–Mumbai moves the index three times as hard as Delhi–Srinagar.</a:t>
+            </a:r>
+          </a:p>
+        </p:txBody>
+      </p:sp>
+      <p:sp>
+        <p:nvSpPr>
+          <p:cNvPr id="15399" name="Rectangle 15398"/>
           <p:cNvSpPr/>
           <p:nvPr/>
         </p:nvSpPr>
         <p:spPr>
           <a:xfrm>
-            <a:off x="4370832" y="2048256"/>
-            <a:ext cx="3703320" cy="64008"/>
+            <a:off x="4270248" y="4078224"/>
+            <a:ext cx="3621024" cy="64008"/>
           </a:xfrm>
           <a:prstGeom prst="rect">
             <a:avLst/>
@@ -6362,14 +7889,14 @@
       </p:sp>
       <p:sp>
         <p:nvSpPr>
-          <p:cNvPr id="15367" name="Rounded Rectangle 15366"/>
+          <p:cNvPr id="15400" name="Rounded Rectangle 15399"/>
           <p:cNvSpPr/>
           <p:nvPr/>
         </p:nvSpPr>
         <p:spPr>
           <a:xfrm>
-            <a:off x="8330183" y="2048256"/>
-            <a:ext cx="3703320" cy="1481328"/>
+            <a:off x="8129015" y="4078224"/>
+            <a:ext cx="3621024" cy="1060704"/>
           </a:xfrm>
           <a:prstGeom prst="roundRect">
             <a:avLst>
@@ -6399,7 +7926,7 @@
           </a:fontRef>
         </p:style>
         <p:txBody>
-          <a:bodyPr rtlCol="0" anchor="ctr" wrap="square" lIns="36576" rIns="36576" tIns="18288" bIns="18288"/>
+          <a:bodyPr rtlCol="0" anchor="ctr" wrap="square" lIns="36576" rIns="36576" tIns="109728" bIns="18288"/>
           <a:lstStyle/>
           <a:p>
             <a:pPr algn="ctr">
@@ -6414,14 +7941,13 @@
               </a:spcAft>
             </a:pPr>
             <a:r>
-              <a:rPr sz="1400" b="1">
+              <a:rPr sz="1250" b="1">
                 <a:solidFill>
                   <a:srgbClr val="C77700"/>
                 </a:solidFill>
                 <a:latin typeface="Arial"/>
               </a:rPr>
-              <a:t>It knows when not
-to publish</a:t>
+              <a:t>It knows when not to publish</a:t>
             </a:r>
           </a:p>
           <a:p>
@@ -6437,27 +7963,27 @@
               </a:spcAft>
             </a:pPr>
             <a:r>
-              <a:rPr sz="1200" b="0">
+              <a:rPr sz="1100" b="0">
                 <a:solidFill>
                   <a:srgbClr val="262B33"/>
                 </a:solidFill>
                 <a:latin typeface="Arial"/>
               </a:rPr>
-              <a:t>Below 60% basket coverage a figure is marked provisional with the reason. An index that admits thin coverage is worth more than one that never does.</a:t>
-            </a:r>
-          </a:p>
-        </p:txBody>
-      </p:sp>
-      <p:sp>
-        <p:nvSpPr>
-          <p:cNvPr id="15368" name="Rectangle 15367"/>
+              <a:t>Below 60% basket coverage the figure ships marked provisional, with the reason attached. An index that admits thin coverage beats one that never does.</a:t>
+            </a:r>
+          </a:p>
+        </p:txBody>
+      </p:sp>
+      <p:sp>
+        <p:nvSpPr>
+          <p:cNvPr id="15401" name="Rectangle 15400"/>
           <p:cNvSpPr/>
           <p:nvPr/>
         </p:nvSpPr>
         <p:spPr>
           <a:xfrm>
-            <a:off x="8330183" y="2048256"/>
-            <a:ext cx="3703320" cy="64008"/>
+            <a:off x="8129015" y="4078224"/>
+            <a:ext cx="3621024" cy="64008"/>
           </a:xfrm>
           <a:prstGeom prst="rect">
             <a:avLst/>
@@ -6494,14 +8020,14 @@
       </p:sp>
       <p:sp>
         <p:nvSpPr>
-          <p:cNvPr id="15369" name="Rounded Rectangle 15368"/>
+          <p:cNvPr id="15402" name="Rounded Rectangle 15401"/>
           <p:cNvSpPr/>
           <p:nvPr/>
         </p:nvSpPr>
         <p:spPr>
           <a:xfrm>
-            <a:off x="411480" y="3694176"/>
-            <a:ext cx="3703320" cy="1481328"/>
+            <a:off x="411480" y="5248656"/>
+            <a:ext cx="3621024" cy="1060704"/>
           </a:xfrm>
           <a:prstGeom prst="roundRect">
             <a:avLst>
@@ -6531,7 +8057,7 @@
           </a:fontRef>
         </p:style>
         <p:txBody>
-          <a:bodyPr rtlCol="0" anchor="ctr" wrap="square" lIns="36576" rIns="36576" tIns="18288" bIns="18288"/>
+          <a:bodyPr rtlCol="0" anchor="ctr" wrap="square" lIns="36576" rIns="36576" tIns="109728" bIns="18288"/>
           <a:lstStyle/>
           <a:p>
             <a:pPr algn="ctr">
@@ -6546,14 +8072,13 @@
               </a:spcAft>
             </a:pPr>
             <a:r>
-              <a:rPr sz="1400" b="1">
+              <a:rPr sz="1250" b="1">
                 <a:solidFill>
                   <a:srgbClr val="4B3F8C"/>
                 </a:solidFill>
                 <a:latin typeface="Arial"/>
               </a:rPr>
-              <a:t>Machine-readable
-for MoSPI</a:t>
+              <a:t>Machine-readable for MoSPI</a:t>
             </a:r>
           </a:p>
           <a:p>
@@ -6569,27 +8094,27 @@
               </a:spcAft>
             </a:pPr>
             <a:r>
-              <a:rPr sz="1200" b="0">
+              <a:rPr sz="1100" b="0">
                 <a:solidFill>
                   <a:srgbClr val="262B33"/>
                 </a:solidFill>
                 <a:latin typeface="Arial"/>
               </a:rPr>
-              <a:t>An authenticated REST endpoint returns the index with its method, coverage and revision history. Nobody retypes a number from a screen.</a:t>
-            </a:r>
-          </a:p>
-        </p:txBody>
-      </p:sp>
-      <p:sp>
-        <p:nvSpPr>
-          <p:cNvPr id="15370" name="Rectangle 15369"/>
+              <a:t>One authenticated REST call returns the index with its method, coverage and revision history. Nobody retypes a number off a screen.</a:t>
+            </a:r>
+          </a:p>
+        </p:txBody>
+      </p:sp>
+      <p:sp>
+        <p:nvSpPr>
+          <p:cNvPr id="15403" name="Rectangle 15402"/>
           <p:cNvSpPr/>
           <p:nvPr/>
         </p:nvSpPr>
         <p:spPr>
           <a:xfrm>
-            <a:off x="411480" y="3694176"/>
-            <a:ext cx="3703320" cy="64008"/>
+            <a:off x="411480" y="5248656"/>
+            <a:ext cx="3621024" cy="64008"/>
           </a:xfrm>
           <a:prstGeom prst="rect">
             <a:avLst/>
@@ -6626,14 +8151,14 @@
       </p:sp>
       <p:sp>
         <p:nvSpPr>
-          <p:cNvPr id="15371" name="Rounded Rectangle 15370"/>
+          <p:cNvPr id="15404" name="Rounded Rectangle 15403"/>
           <p:cNvSpPr/>
           <p:nvPr/>
         </p:nvSpPr>
         <p:spPr>
           <a:xfrm>
-            <a:off x="4370832" y="3694176"/>
-            <a:ext cx="3703320" cy="1481328"/>
+            <a:off x="4270248" y="5248656"/>
+            <a:ext cx="3621024" cy="1060704"/>
           </a:xfrm>
           <a:prstGeom prst="roundRect">
             <a:avLst>
@@ -6663,7 +8188,7 @@
           </a:fontRef>
         </p:style>
         <p:txBody>
-          <a:bodyPr rtlCol="0" anchor="ctr" wrap="square" lIns="36576" rIns="36576" tIns="18288" bIns="18288"/>
+          <a:bodyPr rtlCol="0" anchor="ctr" wrap="square" lIns="36576" rIns="36576" tIns="109728" bIns="18288"/>
           <a:lstStyle/>
           <a:p>
             <a:pPr algn="ctr">
@@ -6678,14 +8203,13 @@
               </a:spcAft>
             </a:pPr>
             <a:r>
-              <a:rPr sz="1400" b="1">
+              <a:rPr sz="1250" b="1">
                 <a:solidFill>
                   <a:srgbClr val="0E7C86"/>
                 </a:solidFill>
                 <a:latin typeface="Arial"/>
               </a:rPr>
-              <a:t>Compliance by
-construction</a:t>
+              <a:t>Compliance by construction</a:t>
             </a:r>
           </a:p>
           <a:p>
@@ -6701,27 +8225,27 @@
               </a:spcAft>
             </a:pPr>
             <a:r>
-              <a:rPr sz="1200" b="0">
+              <a:rPr sz="1100" b="0">
                 <a:solidFill>
                   <a:srgbClr val="262B33"/>
                 </a:solidFill>
                 <a:latin typeface="Arial"/>
               </a:rPr>
-              <a:t>robots.txt is checked to RFC 9309 before every single request. We wrote our own parser because Python's standard one gets it wrong.</a:t>
-            </a:r>
-          </a:p>
-        </p:txBody>
-      </p:sp>
-      <p:sp>
-        <p:nvSpPr>
-          <p:cNvPr id="15372" name="Rectangle 15371"/>
+              <a:t>robots.txt is re-checked to RFC 9309 before every request. We wrote the parser ourselves because Python's standard one gets it wrong.</a:t>
+            </a:r>
+          </a:p>
+        </p:txBody>
+      </p:sp>
+      <p:sp>
+        <p:nvSpPr>
+          <p:cNvPr id="15405" name="Rectangle 15404"/>
           <p:cNvSpPr/>
           <p:nvPr/>
         </p:nvSpPr>
         <p:spPr>
           <a:xfrm>
-            <a:off x="4370832" y="3694176"/>
-            <a:ext cx="3703320" cy="64008"/>
+            <a:off x="4270248" y="5248656"/>
+            <a:ext cx="3621024" cy="64008"/>
           </a:xfrm>
           <a:prstGeom prst="rect">
             <a:avLst/>
@@ -6758,14 +8282,14 @@
       </p:sp>
       <p:sp>
         <p:nvSpPr>
-          <p:cNvPr id="15373" name="Rounded Rectangle 15372"/>
+          <p:cNvPr id="15406" name="Rounded Rectangle 15405"/>
           <p:cNvSpPr/>
           <p:nvPr/>
         </p:nvSpPr>
         <p:spPr>
           <a:xfrm>
-            <a:off x="8330183" y="3694176"/>
-            <a:ext cx="3703320" cy="1481328"/>
+            <a:off x="8129015" y="5248656"/>
+            <a:ext cx="3621024" cy="1060704"/>
           </a:xfrm>
           <a:prstGeom prst="roundRect">
             <a:avLst>
@@ -6795,7 +8319,7 @@
           </a:fontRef>
         </p:style>
         <p:txBody>
-          <a:bodyPr rtlCol="0" anchor="ctr" wrap="square" lIns="36576" rIns="36576" tIns="18288" bIns="18288"/>
+          <a:bodyPr rtlCol="0" anchor="ctr" wrap="square" lIns="36576" rIns="36576" tIns="109728" bIns="18288"/>
           <a:lstStyle/>
           <a:p>
             <a:pPr algn="ctr">
@@ -6810,14 +8334,13 @@
               </a:spcAft>
             </a:pPr>
             <a:r>
-              <a:rPr sz="1400" b="1">
+              <a:rPr sz="1250" b="1">
                 <a:solidFill>
                   <a:srgbClr val="7A3E6B"/>
                 </a:solidFill>
                 <a:latin typeface="Arial"/>
               </a:rPr>
-              <a:t>It never
-estimates</a:t>
+              <a:t>It never estimates</a:t>
             </a:r>
           </a:p>
           <a:p>
@@ -6833,27 +8356,27 @@
               </a:spcAft>
             </a:pPr>
             <a:r>
-              <a:rPr sz="1200" b="0">
+              <a:rPr sz="1100" b="0">
                 <a:solidFill>
                   <a:srgbClr val="262B33"/>
                 </a:solidFill>
                 <a:latin typeface="Arial"/>
               </a:rPr>
-              <a:t>Fields a portal does not publish stay NULL. Cells with too few observations are excluded, not filled in. The system says when it does not know.</a:t>
-            </a:r>
-          </a:p>
-        </p:txBody>
-      </p:sp>
-      <p:sp>
-        <p:nvSpPr>
-          <p:cNvPr id="15374" name="Rectangle 15373"/>
+              <a:t>Fields a portal does not publish stay NULL. Cells with too few observations are excluded, not filled in — the system says when it does not know.</a:t>
+            </a:r>
+          </a:p>
+        </p:txBody>
+      </p:sp>
+      <p:sp>
+        <p:nvSpPr>
+          <p:cNvPr id="15407" name="Rectangle 15406"/>
           <p:cNvSpPr/>
           <p:nvPr/>
         </p:nvSpPr>
         <p:spPr>
           <a:xfrm>
-            <a:off x="8330183" y="3694176"/>
-            <a:ext cx="3703320" cy="64008"/>
+            <a:off x="8129015" y="5248656"/>
+            <a:ext cx="3621024" cy="64008"/>
           </a:xfrm>
           <a:prstGeom prst="rect">
             <a:avLst/>
@@ -6885,71 +8408,6 @@
           <a:lstStyle/>
           <a:p>
             <a:pPr algn="ctr"/>
-          </a:p>
-        </p:txBody>
-      </p:sp>
-      <p:sp>
-        <p:nvSpPr>
-          <p:cNvPr id="15375" name="Rounded Rectangle 15374"/>
-          <p:cNvSpPr/>
-          <p:nvPr/>
-        </p:nvSpPr>
-        <p:spPr>
-          <a:xfrm>
-            <a:off x="411480" y="5285232"/>
-            <a:ext cx="11338560" cy="640080"/>
-          </a:xfrm>
-          <a:prstGeom prst="roundRect">
-            <a:avLst>
-              <a:gd name="adj" fmla="val 6000"/>
-            </a:avLst>
-          </a:prstGeom>
-          <a:solidFill>
-            <a:srgbClr val="E4F4EC"/>
-          </a:solidFill>
-          <a:ln>
-            <a:noFill/>
-          </a:ln>
-          <a:effectLst/>
-        </p:spPr>
-        <p:style>
-          <a:lnRef idx="1">
-            <a:schemeClr val="accent1"/>
-          </a:lnRef>
-          <a:fillRef idx="3">
-            <a:schemeClr val="accent1"/>
-          </a:fillRef>
-          <a:effectRef idx="2">
-            <a:schemeClr val="accent1"/>
-          </a:effectRef>
-          <a:fontRef idx="minor">
-            <a:schemeClr val="lt1"/>
-          </a:fontRef>
-        </p:style>
-        <p:txBody>
-          <a:bodyPr rtlCol="0" anchor="ctr" wrap="square" lIns="36576" rIns="36576" tIns="18288" bIns="18288"/>
-          <a:lstStyle/>
-          <a:p>
-            <a:pPr algn="ctr">
-              <a:lnSpc>
-                <a:spcPct val="95000"/>
-              </a:lnSpc>
-              <a:spcBef>
-                <a:spcPts val="0"/>
-              </a:spcBef>
-              <a:spcAft>
-                <a:spcPts val="0"/>
-              </a:spcAft>
-            </a:pPr>
-            <a:r>
-              <a:rPr sz="1400" b="1">
-                <a:solidFill>
-                  <a:srgbClr val="1B8A5A"/>
-                </a:solidFill>
-                <a:latin typeface="Arial"/>
-              </a:rPr>
-              <a:t>BUILT AND RUNNING · 36,000+ fares · 15 city pairs × 5 lead times · every 10 minutes · ₹0 a month</a:t>
-            </a:r>
           </a:p>
         </p:txBody>
       </p:sp>

</xml_diff>

<commit_message>
Slides 4-6: feasibility metrics + running-cost table, quantified impact band, extra references
Co-Authored-By: Claude Opus 5 <noreply@anthropic.com>
Claude-Session: https://claude.ai/code/session_0129UjVhHMAVJgfcaxoN1dD5
</commit_message>
<xml_diff>
--- a/SIH26056-Idea-Presentation.pptx
+++ b/SIH26056-Idea-Presentation.pptx
@@ -11398,7 +11398,7 @@
         <p:spPr>
           <a:xfrm>
             <a:off x="411480" y="1133856"/>
-            <a:ext cx="5623560" cy="1188720"/>
+            <a:ext cx="5760720" cy="1170432"/>
           </a:xfrm>
           <a:prstGeom prst="roundRect">
             <a:avLst>
@@ -11428,51 +11428,10 @@
           </a:fontRef>
         </p:style>
         <p:txBody>
-          <a:bodyPr rtlCol="0" anchor="ctr" wrap="square" lIns="36576" rIns="36576" tIns="18288" bIns="18288"/>
-          <a:lstStyle/>
-          <a:p>
-            <a:pPr algn="ctr">
-              <a:lnSpc>
-                <a:spcPct val="95000"/>
-              </a:lnSpc>
-              <a:spcBef>
-                <a:spcPts val="0"/>
-              </a:spcBef>
-              <a:spcAft>
-                <a:spcPts val="0"/>
-              </a:spcAft>
-            </a:pPr>
-            <a:r>
-              <a:rPr sz="1450" b="1">
-                <a:solidFill>
-                  <a:srgbClr val="4F81BD"/>
-                </a:solidFill>
-                <a:latin typeface="Arial"/>
-              </a:rPr>
-              <a:t>Technical feasibility</a:t>
-            </a:r>
-          </a:p>
-          <a:p>
-            <a:pPr>
-              <a:lnSpc>
-                <a:spcPct val="95000"/>
-              </a:lnSpc>
-              <a:spcBef>
-                <a:spcPts val="400"/>
-              </a:spcBef>
-              <a:spcAft>
-                <a:spcPts val="0"/>
-              </a:spcAft>
-            </a:pPr>
-            <a:r>
-              <a:rPr sz="1200" b="0">
-                <a:solidFill>
-                  <a:srgbClr val="262B33"/>
-                </a:solidFill>
-                <a:latin typeface="Arial"/>
-              </a:rPr>
-              <a:t>India is the world's fifth-largest aviation market, worth USD 18.14 bn in 2026 and growing at 11.72% a year. The prices exist and change constantly — what is missing is a systematic way to measure them.</a:t>
-            </a:r>
+          <a:bodyPr rtlCol="0" anchor="ctr" wrap="square"/>
+          <a:lstStyle/>
+          <a:p>
+            <a:pPr algn="ctr"/>
           </a:p>
         </p:txBody>
       </p:sp>
@@ -11485,7 +11444,7 @@
         <p:spPr>
           <a:xfrm>
             <a:off x="411480" y="1133856"/>
-            <a:ext cx="68580" cy="1188720"/>
+            <a:ext cx="68580" cy="1170432"/>
           </a:xfrm>
           <a:prstGeom prst="rect">
             <a:avLst/>
@@ -11522,14 +11481,148 @@
       </p:sp>
       <p:sp>
         <p:nvSpPr>
-          <p:cNvPr id="17412" name="Rounded Rectangle 17411"/>
+          <p:cNvPr id="17412" name="TextBox 17411"/>
+          <p:cNvSpPr txBox="1"/>
+          <p:nvPr/>
+        </p:nvSpPr>
+        <p:spPr>
+          <a:xfrm>
+            <a:off x="640080" y="1225296"/>
+            <a:ext cx="3840480" cy="987552"/>
+          </a:xfrm>
+          <a:prstGeom prst="rect">
+            <a:avLst/>
+          </a:prstGeom>
+          <a:noFill/>
+        </p:spPr>
+        <p:txBody>
+          <a:bodyPr wrap="square" lIns="36576" rIns="36576" tIns="18288" bIns="18288">
+            <a:spAutoFit/>
+          </a:bodyPr>
+          <a:lstStyle/>
+          <a:p>
+            <a:pPr>
+              <a:lnSpc>
+                <a:spcPct val="95000"/>
+              </a:lnSpc>
+              <a:spcBef>
+                <a:spcPts val="0"/>
+              </a:spcBef>
+              <a:spcAft>
+                <a:spcPts val="0"/>
+              </a:spcAft>
+            </a:pPr>
+            <a:r>
+              <a:rPr sz="1400" b="1">
+                <a:solidFill>
+                  <a:srgbClr val="4F81BD"/>
+                </a:solidFill>
+                <a:latin typeface="Arial"/>
+              </a:rPr>
+              <a:t>Technical feasibility</a:t>
+            </a:r>
+          </a:p>
+          <a:p>
+            <a:pPr>
+              <a:lnSpc>
+                <a:spcPct val="95000"/>
+              </a:lnSpc>
+              <a:spcBef>
+                <a:spcPts val="400"/>
+              </a:spcBef>
+              <a:spcAft>
+                <a:spcPts val="0"/>
+              </a:spcAft>
+            </a:pPr>
+            <a:r>
+              <a:rPr sz="1150" b="0">
+                <a:solidFill>
+                  <a:srgbClr val="262B33"/>
+                </a:solidFill>
+                <a:latin typeface="Arial"/>
+              </a:rPr>
+              <a:t>Fares are published continuously on public pages and change all day. The data exists; what is missing is a systematic way to read it.</a:t>
+            </a:r>
+          </a:p>
+        </p:txBody>
+      </p:sp>
+      <p:sp>
+        <p:nvSpPr>
+          <p:cNvPr id="17413" name="TextBox 17412"/>
+          <p:cNvSpPr txBox="1"/>
+          <p:nvPr/>
+        </p:nvSpPr>
+        <p:spPr>
+          <a:xfrm>
+            <a:off x="4572000" y="1444752"/>
+            <a:ext cx="1481328" cy="566928"/>
+          </a:xfrm>
+          <a:prstGeom prst="rect">
+            <a:avLst/>
+          </a:prstGeom>
+          <a:noFill/>
+        </p:spPr>
+        <p:txBody>
+          <a:bodyPr wrap="square" lIns="36576" rIns="36576" tIns="18288" bIns="18288">
+            <a:spAutoFit/>
+          </a:bodyPr>
+          <a:lstStyle/>
+          <a:p>
+            <a:pPr>
+              <a:lnSpc>
+                <a:spcPct val="95000"/>
+              </a:lnSpc>
+              <a:spcBef>
+                <a:spcPts val="0"/>
+              </a:spcBef>
+              <a:spcAft>
+                <a:spcPts val="0"/>
+              </a:spcAft>
+            </a:pPr>
+            <a:r>
+              <a:rPr sz="1350" b="1">
+                <a:solidFill>
+                  <a:srgbClr val="4F81BD"/>
+                </a:solidFill>
+                <a:latin typeface="Arial"/>
+              </a:rPr>
+              <a:t>USD 18.1 bn</a:t>
+            </a:r>
+          </a:p>
+          <a:p>
+            <a:pPr>
+              <a:lnSpc>
+                <a:spcPct val="95000"/>
+              </a:lnSpc>
+              <a:spcBef>
+                <a:spcPts val="200"/>
+              </a:spcBef>
+              <a:spcAft>
+                <a:spcPts val="0"/>
+              </a:spcAft>
+            </a:pPr>
+            <a:r>
+              <a:rPr sz="900" b="0">
+                <a:solidFill>
+                  <a:srgbClr val="5A626C"/>
+                </a:solidFill>
+                <a:latin typeface="Arial"/>
+              </a:rPr>
+              <a:t>market size, 2026</a:t>
+            </a:r>
+          </a:p>
+        </p:txBody>
+      </p:sp>
+      <p:sp>
+        <p:nvSpPr>
+          <p:cNvPr id="17414" name="Rounded Rectangle 17413"/>
           <p:cNvSpPr/>
           <p:nvPr/>
         </p:nvSpPr>
         <p:spPr>
           <a:xfrm>
-            <a:off x="411480" y="2423160"/>
-            <a:ext cx="5623560" cy="1188720"/>
+            <a:off x="411480" y="2377440"/>
+            <a:ext cx="5760720" cy="1170432"/>
           </a:xfrm>
           <a:prstGeom prst="roundRect">
             <a:avLst>
@@ -11559,64 +11652,23 @@
           </a:fontRef>
         </p:style>
         <p:txBody>
-          <a:bodyPr rtlCol="0" anchor="ctr" wrap="square" lIns="36576" rIns="36576" tIns="18288" bIns="18288"/>
-          <a:lstStyle/>
-          <a:p>
-            <a:pPr algn="ctr">
-              <a:lnSpc>
-                <a:spcPct val="95000"/>
-              </a:lnSpc>
-              <a:spcBef>
-                <a:spcPts val="0"/>
-              </a:spcBef>
-              <a:spcAft>
-                <a:spcPts val="0"/>
-              </a:spcAft>
-            </a:pPr>
-            <a:r>
-              <a:rPr sz="1450" b="1">
-                <a:solidFill>
-                  <a:srgbClr val="1B8A5A"/>
-                </a:solidFill>
-                <a:latin typeface="Arial"/>
-              </a:rPr>
-              <a:t>Operational feasibility</a:t>
-            </a:r>
-          </a:p>
-          <a:p>
-            <a:pPr>
-              <a:lnSpc>
-                <a:spcPct val="95000"/>
-              </a:lnSpc>
-              <a:spcBef>
-                <a:spcPts val="400"/>
-              </a:spcBef>
-              <a:spcAft>
-                <a:spcPts val="0"/>
-              </a:spcAft>
-            </a:pPr>
-            <a:r>
-              <a:rPr sz="1200" b="0">
-                <a:solidFill>
-                  <a:srgbClr val="262B33"/>
-                </a:solidFill>
-                <a:latin typeface="Arial"/>
-              </a:rPr>
-              <a:t>164 million domestic passengers a year across 148 operational airports, up from 74 in 2014. A fixed basket of the 15 busiest city pairs tracks the traffic that actually matters.</a:t>
-            </a:r>
-          </a:p>
-        </p:txBody>
-      </p:sp>
-      <p:sp>
-        <p:nvSpPr>
-          <p:cNvPr id="17413" name="Rectangle 17412"/>
+          <a:bodyPr rtlCol="0" anchor="ctr" wrap="square"/>
+          <a:lstStyle/>
+          <a:p>
+            <a:pPr algn="ctr"/>
+          </a:p>
+        </p:txBody>
+      </p:sp>
+      <p:sp>
+        <p:nvSpPr>
+          <p:cNvPr id="17415" name="Rectangle 17414"/>
           <p:cNvSpPr/>
           <p:nvPr/>
         </p:nvSpPr>
         <p:spPr>
           <a:xfrm>
-            <a:off x="411480" y="2423160"/>
-            <a:ext cx="68580" cy="1188720"/>
+            <a:off x="411480" y="2377440"/>
+            <a:ext cx="68580" cy="1170432"/>
           </a:xfrm>
           <a:prstGeom prst="rect">
             <a:avLst/>
@@ -11653,14 +11705,148 @@
       </p:sp>
       <p:sp>
         <p:nvSpPr>
-          <p:cNvPr id="17414" name="Rounded Rectangle 17413"/>
+          <p:cNvPr id="17416" name="TextBox 17415"/>
+          <p:cNvSpPr txBox="1"/>
+          <p:nvPr/>
+        </p:nvSpPr>
+        <p:spPr>
+          <a:xfrm>
+            <a:off x="640080" y="2468880"/>
+            <a:ext cx="3840480" cy="987552"/>
+          </a:xfrm>
+          <a:prstGeom prst="rect">
+            <a:avLst/>
+          </a:prstGeom>
+          <a:noFill/>
+        </p:spPr>
+        <p:txBody>
+          <a:bodyPr wrap="square" lIns="36576" rIns="36576" tIns="18288" bIns="18288">
+            <a:spAutoFit/>
+          </a:bodyPr>
+          <a:lstStyle/>
+          <a:p>
+            <a:pPr>
+              <a:lnSpc>
+                <a:spcPct val="95000"/>
+              </a:lnSpc>
+              <a:spcBef>
+                <a:spcPts val="0"/>
+              </a:spcBef>
+              <a:spcAft>
+                <a:spcPts val="0"/>
+              </a:spcAft>
+            </a:pPr>
+            <a:r>
+              <a:rPr sz="1400" b="1">
+                <a:solidFill>
+                  <a:srgbClr val="1B8A5A"/>
+                </a:solidFill>
+                <a:latin typeface="Arial"/>
+              </a:rPr>
+              <a:t>Operational feasibility</a:t>
+            </a:r>
+          </a:p>
+          <a:p>
+            <a:pPr>
+              <a:lnSpc>
+                <a:spcPct val="95000"/>
+              </a:lnSpc>
+              <a:spcBef>
+                <a:spcPts val="400"/>
+              </a:spcBef>
+              <a:spcAft>
+                <a:spcPts val="0"/>
+              </a:spcAft>
+            </a:pPr>
+            <a:r>
+              <a:rPr sz="1150" b="0">
+                <a:solidFill>
+                  <a:srgbClr val="262B33"/>
+                </a:solidFill>
+                <a:latin typeface="Arial"/>
+              </a:rPr>
+              <a:t>A fixed basket of the 15 busiest city pairs across 148 operational airports tracks the traffic that actually moves the index.</a:t>
+            </a:r>
+          </a:p>
+        </p:txBody>
+      </p:sp>
+      <p:sp>
+        <p:nvSpPr>
+          <p:cNvPr id="17417" name="TextBox 17416"/>
+          <p:cNvSpPr txBox="1"/>
+          <p:nvPr/>
+        </p:nvSpPr>
+        <p:spPr>
+          <a:xfrm>
+            <a:off x="4572000" y="2688336"/>
+            <a:ext cx="1481328" cy="566928"/>
+          </a:xfrm>
+          <a:prstGeom prst="rect">
+            <a:avLst/>
+          </a:prstGeom>
+          <a:noFill/>
+        </p:spPr>
+        <p:txBody>
+          <a:bodyPr wrap="square" lIns="36576" rIns="36576" tIns="18288" bIns="18288">
+            <a:spAutoFit/>
+          </a:bodyPr>
+          <a:lstStyle/>
+          <a:p>
+            <a:pPr>
+              <a:lnSpc>
+                <a:spcPct val="95000"/>
+              </a:lnSpc>
+              <a:spcBef>
+                <a:spcPts val="0"/>
+              </a:spcBef>
+              <a:spcAft>
+                <a:spcPts val="0"/>
+              </a:spcAft>
+            </a:pPr>
+            <a:r>
+              <a:rPr sz="1350" b="1">
+                <a:solidFill>
+                  <a:srgbClr val="1B8A5A"/>
+                </a:solidFill>
+                <a:latin typeface="Arial"/>
+              </a:rPr>
+              <a:t>164 million</a:t>
+            </a:r>
+          </a:p>
+          <a:p>
+            <a:pPr>
+              <a:lnSpc>
+                <a:spcPct val="95000"/>
+              </a:lnSpc>
+              <a:spcBef>
+                <a:spcPts val="200"/>
+              </a:spcBef>
+              <a:spcAft>
+                <a:spcPts val="0"/>
+              </a:spcAft>
+            </a:pPr>
+            <a:r>
+              <a:rPr sz="900" b="0">
+                <a:solidFill>
+                  <a:srgbClr val="5A626C"/>
+                </a:solidFill>
+                <a:latin typeface="Arial"/>
+              </a:rPr>
+              <a:t>domestic passengers</a:t>
+            </a:r>
+          </a:p>
+        </p:txBody>
+      </p:sp>
+      <p:sp>
+        <p:nvSpPr>
+          <p:cNvPr id="17418" name="Rounded Rectangle 17417"/>
           <p:cNvSpPr/>
           <p:nvPr/>
         </p:nvSpPr>
         <p:spPr>
           <a:xfrm>
-            <a:off x="411480" y="3712463"/>
-            <a:ext cx="5623560" cy="1188720"/>
+            <a:off x="411480" y="3621024"/>
+            <a:ext cx="5760720" cy="1170432"/>
           </a:xfrm>
           <a:prstGeom prst="roundRect">
             <a:avLst>
@@ -11690,64 +11876,23 @@
           </a:fontRef>
         </p:style>
         <p:txBody>
-          <a:bodyPr rtlCol="0" anchor="ctr" wrap="square" lIns="36576" rIns="36576" tIns="18288" bIns="18288"/>
-          <a:lstStyle/>
-          <a:p>
-            <a:pPr algn="ctr">
-              <a:lnSpc>
-                <a:spcPct val="95000"/>
-              </a:lnSpc>
-              <a:spcBef>
-                <a:spcPts val="0"/>
-              </a:spcBef>
-              <a:spcAft>
-                <a:spcPts val="0"/>
-              </a:spcAft>
-            </a:pPr>
-            <a:r>
-              <a:rPr sz="1450" b="1">
-                <a:solidFill>
-                  <a:srgbClr val="C77700"/>
-                </a:solidFill>
-                <a:latin typeface="Arial"/>
-              </a:rPr>
-              <a:t>Economic feasibility</a:t>
-            </a:r>
-          </a:p>
-          <a:p>
-            <a:pPr>
-              <a:lnSpc>
-                <a:spcPct val="95000"/>
-              </a:lnSpc>
-              <a:spcBef>
-                <a:spcPts val="400"/>
-              </a:spcBef>
-              <a:spcAft>
-                <a:spcPts val="0"/>
-              </a:spcAft>
-            </a:pPr>
-            <a:r>
-              <a:rPr sz="1200" b="0">
-                <a:solidFill>
-                  <a:srgbClr val="262B33"/>
-                </a:solidFill>
-                <a:latin typeface="Arial"/>
-              </a:rPr>
-              <a:t>The pipeline runs on free tiers at ₹0 a month and ~2 minutes of compute per cycle. MoSPI's field collectors visit shops and markets monthly; this observes 144 times a day without leaving a desk.</a:t>
-            </a:r>
-          </a:p>
-        </p:txBody>
-      </p:sp>
-      <p:sp>
-        <p:nvSpPr>
-          <p:cNvPr id="17415" name="Rectangle 17414"/>
+          <a:bodyPr rtlCol="0" anchor="ctr" wrap="square"/>
+          <a:lstStyle/>
+          <a:p>
+            <a:pPr algn="ctr"/>
+          </a:p>
+        </p:txBody>
+      </p:sp>
+      <p:sp>
+        <p:nvSpPr>
+          <p:cNvPr id="17419" name="Rectangle 17418"/>
           <p:cNvSpPr/>
           <p:nvPr/>
         </p:nvSpPr>
         <p:spPr>
           <a:xfrm>
-            <a:off x="411480" y="3712463"/>
-            <a:ext cx="68580" cy="1188720"/>
+            <a:off x="411480" y="3621024"/>
+            <a:ext cx="68580" cy="1170432"/>
           </a:xfrm>
           <a:prstGeom prst="rect">
             <a:avLst/>
@@ -11784,14 +11929,148 @@
       </p:sp>
       <p:sp>
         <p:nvSpPr>
-          <p:cNvPr id="17416" name="Rounded Rectangle 17415"/>
+          <p:cNvPr id="17420" name="TextBox 17419"/>
+          <p:cNvSpPr txBox="1"/>
+          <p:nvPr/>
+        </p:nvSpPr>
+        <p:spPr>
+          <a:xfrm>
+            <a:off x="640080" y="3712463"/>
+            <a:ext cx="3840480" cy="987552"/>
+          </a:xfrm>
+          <a:prstGeom prst="rect">
+            <a:avLst/>
+          </a:prstGeom>
+          <a:noFill/>
+        </p:spPr>
+        <p:txBody>
+          <a:bodyPr wrap="square" lIns="36576" rIns="36576" tIns="18288" bIns="18288">
+            <a:spAutoFit/>
+          </a:bodyPr>
+          <a:lstStyle/>
+          <a:p>
+            <a:pPr>
+              <a:lnSpc>
+                <a:spcPct val="95000"/>
+              </a:lnSpc>
+              <a:spcBef>
+                <a:spcPts val="0"/>
+              </a:spcBef>
+              <a:spcAft>
+                <a:spcPts val="0"/>
+              </a:spcAft>
+            </a:pPr>
+            <a:r>
+              <a:rPr sz="1400" b="1">
+                <a:solidFill>
+                  <a:srgbClr val="C77700"/>
+                </a:solidFill>
+                <a:latin typeface="Arial"/>
+              </a:rPr>
+              <a:t>Economic feasibility</a:t>
+            </a:r>
+          </a:p>
+          <a:p>
+            <a:pPr>
+              <a:lnSpc>
+                <a:spcPct val="95000"/>
+              </a:lnSpc>
+              <a:spcBef>
+                <a:spcPts val="400"/>
+              </a:spcBef>
+              <a:spcAft>
+                <a:spcPts val="0"/>
+              </a:spcAft>
+            </a:pPr>
+            <a:r>
+              <a:rPr sz="1150" b="0">
+                <a:solidFill>
+                  <a:srgbClr val="262B33"/>
+                </a:solidFill>
+                <a:latin typeface="Arial"/>
+              </a:rPr>
+              <a:t>Free tiers throughout, about two minutes of compute per cycle. MoSPI visits shops monthly; this observes 144 times a day.</a:t>
+            </a:r>
+          </a:p>
+        </p:txBody>
+      </p:sp>
+      <p:sp>
+        <p:nvSpPr>
+          <p:cNvPr id="17421" name="TextBox 17420"/>
+          <p:cNvSpPr txBox="1"/>
+          <p:nvPr/>
+        </p:nvSpPr>
+        <p:spPr>
+          <a:xfrm>
+            <a:off x="4572000" y="3931920"/>
+            <a:ext cx="1481328" cy="566928"/>
+          </a:xfrm>
+          <a:prstGeom prst="rect">
+            <a:avLst/>
+          </a:prstGeom>
+          <a:noFill/>
+        </p:spPr>
+        <p:txBody>
+          <a:bodyPr wrap="square" lIns="36576" rIns="36576" tIns="18288" bIns="18288">
+            <a:spAutoFit/>
+          </a:bodyPr>
+          <a:lstStyle/>
+          <a:p>
+            <a:pPr>
+              <a:lnSpc>
+                <a:spcPct val="95000"/>
+              </a:lnSpc>
+              <a:spcBef>
+                <a:spcPts val="0"/>
+              </a:spcBef>
+              <a:spcAft>
+                <a:spcPts val="0"/>
+              </a:spcAft>
+            </a:pPr>
+            <a:r>
+              <a:rPr sz="1350" b="1">
+                <a:solidFill>
+                  <a:srgbClr val="C77700"/>
+                </a:solidFill>
+                <a:latin typeface="Arial"/>
+              </a:rPr>
+              <a:t>₹0</a:t>
+            </a:r>
+          </a:p>
+          <a:p>
+            <a:pPr>
+              <a:lnSpc>
+                <a:spcPct val="95000"/>
+              </a:lnSpc>
+              <a:spcBef>
+                <a:spcPts val="200"/>
+              </a:spcBef>
+              <a:spcAft>
+                <a:spcPts val="0"/>
+              </a:spcAft>
+            </a:pPr>
+            <a:r>
+              <a:rPr sz="900" b="0">
+                <a:solidFill>
+                  <a:srgbClr val="5A626C"/>
+                </a:solidFill>
+                <a:latin typeface="Arial"/>
+              </a:rPr>
+              <a:t>a month to run</a:t>
+            </a:r>
+          </a:p>
+        </p:txBody>
+      </p:sp>
+      <p:sp>
+        <p:nvSpPr>
+          <p:cNvPr id="17422" name="Rounded Rectangle 17421"/>
           <p:cNvSpPr/>
           <p:nvPr/>
         </p:nvSpPr>
         <p:spPr>
           <a:xfrm>
-            <a:off x="411480" y="5001768"/>
-            <a:ext cx="5623560" cy="1188720"/>
+            <a:off x="411480" y="4864608"/>
+            <a:ext cx="5760720" cy="1170432"/>
           </a:xfrm>
           <a:prstGeom prst="roundRect">
             <a:avLst>
@@ -11821,64 +12100,23 @@
           </a:fontRef>
         </p:style>
         <p:txBody>
-          <a:bodyPr rtlCol="0" anchor="ctr" wrap="square" lIns="36576" rIns="36576" tIns="18288" bIns="18288"/>
-          <a:lstStyle/>
-          <a:p>
-            <a:pPr algn="ctr">
-              <a:lnSpc>
-                <a:spcPct val="95000"/>
-              </a:lnSpc>
-              <a:spcBef>
-                <a:spcPts val="0"/>
-              </a:spcBef>
-              <a:spcAft>
-                <a:spcPts val="0"/>
-              </a:spcAft>
-            </a:pPr>
-            <a:r>
-              <a:rPr sz="1450" b="1">
-                <a:solidFill>
-                  <a:srgbClr val="4B3F8C"/>
-                </a:solidFill>
-                <a:latin typeface="Arial"/>
-              </a:rPr>
-              <a:t>Regulatory feasibility</a:t>
-            </a:r>
-          </a:p>
-          <a:p>
-            <a:pPr>
-              <a:lnSpc>
-                <a:spcPct val="95000"/>
-              </a:lnSpc>
-              <a:spcBef>
-                <a:spcPts val="400"/>
-              </a:spcBef>
-              <a:spcAft>
-                <a:spcPts val="0"/>
-              </a:spcAft>
-            </a:pPr>
-            <a:r>
-              <a:rPr sz="1200" b="0">
-                <a:solidFill>
-                  <a:srgbClr val="262B33"/>
-                </a:solidFill>
-                <a:latin typeface="Arial"/>
-              </a:rPr>
-              <a:t>Eurostat publishes guidance on web-scraped prices for HICP and names air fares explicitly. ONS has done it since 2014. The method is precedented in official statistics, not experimental.</a:t>
-            </a:r>
-          </a:p>
-        </p:txBody>
-      </p:sp>
-      <p:sp>
-        <p:nvSpPr>
-          <p:cNvPr id="17417" name="Rectangle 17416"/>
+          <a:bodyPr rtlCol="0" anchor="ctr" wrap="square"/>
+          <a:lstStyle/>
+          <a:p>
+            <a:pPr algn="ctr"/>
+          </a:p>
+        </p:txBody>
+      </p:sp>
+      <p:sp>
+        <p:nvSpPr>
+          <p:cNvPr id="17423" name="Rectangle 17422"/>
           <p:cNvSpPr/>
           <p:nvPr/>
         </p:nvSpPr>
         <p:spPr>
           <a:xfrm>
-            <a:off x="411480" y="5001768"/>
-            <a:ext cx="68580" cy="1188720"/>
+            <a:off x="411480" y="4864608"/>
+            <a:ext cx="68580" cy="1170432"/>
           </a:xfrm>
           <a:prstGeom prst="rect">
             <a:avLst/>
@@ -11915,14 +12153,14 @@
       </p:sp>
       <p:sp>
         <p:nvSpPr>
-          <p:cNvPr id="17418" name="TextBox 17417"/>
+          <p:cNvPr id="17424" name="TextBox 17423"/>
           <p:cNvSpPr txBox="1"/>
           <p:nvPr/>
         </p:nvSpPr>
         <p:spPr>
           <a:xfrm>
-            <a:off x="6400800" y="1133856"/>
-            <a:ext cx="5394960" cy="274320"/>
+            <a:off x="640080" y="4956048"/>
+            <a:ext cx="3840480" cy="987552"/>
           </a:xfrm>
           <a:prstGeom prst="rect">
             <a:avLst/>
@@ -11947,6 +12185,140 @@
               </a:spcAft>
             </a:pPr>
             <a:r>
+              <a:rPr sz="1400" b="1">
+                <a:solidFill>
+                  <a:srgbClr val="4B3F8C"/>
+                </a:solidFill>
+                <a:latin typeface="Arial"/>
+              </a:rPr>
+              <a:t>Regulatory feasibility</a:t>
+            </a:r>
+          </a:p>
+          <a:p>
+            <a:pPr>
+              <a:lnSpc>
+                <a:spcPct val="95000"/>
+              </a:lnSpc>
+              <a:spcBef>
+                <a:spcPts val="400"/>
+              </a:spcBef>
+              <a:spcAft>
+                <a:spcPts val="0"/>
+              </a:spcAft>
+            </a:pPr>
+            <a:r>
+              <a:rPr sz="1150" b="0">
+                <a:solidFill>
+                  <a:srgbClr val="262B33"/>
+                </a:solidFill>
+                <a:latin typeface="Arial"/>
+              </a:rPr>
+              <a:t>Eurostat's HICP guidance names air fares as a scrapeable category and the ONS has published on it since 2014 — precedented, not experimental.</a:t>
+            </a:r>
+          </a:p>
+        </p:txBody>
+      </p:sp>
+      <p:sp>
+        <p:nvSpPr>
+          <p:cNvPr id="17425" name="TextBox 17424"/>
+          <p:cNvSpPr txBox="1"/>
+          <p:nvPr/>
+        </p:nvSpPr>
+        <p:spPr>
+          <a:xfrm>
+            <a:off x="4572000" y="5175504"/>
+            <a:ext cx="1481328" cy="566928"/>
+          </a:xfrm>
+          <a:prstGeom prst="rect">
+            <a:avLst/>
+          </a:prstGeom>
+          <a:noFill/>
+        </p:spPr>
+        <p:txBody>
+          <a:bodyPr wrap="square" lIns="36576" rIns="36576" tIns="18288" bIns="18288">
+            <a:spAutoFit/>
+          </a:bodyPr>
+          <a:lstStyle/>
+          <a:p>
+            <a:pPr>
+              <a:lnSpc>
+                <a:spcPct val="95000"/>
+              </a:lnSpc>
+              <a:spcBef>
+                <a:spcPts val="0"/>
+              </a:spcBef>
+              <a:spcAft>
+                <a:spcPts val="0"/>
+              </a:spcAft>
+            </a:pPr>
+            <a:r>
+              <a:rPr sz="1350" b="1">
+                <a:solidFill>
+                  <a:srgbClr val="4B3F8C"/>
+                </a:solidFill>
+                <a:latin typeface="Arial"/>
+              </a:rPr>
+              <a:t>since 2014</a:t>
+            </a:r>
+          </a:p>
+          <a:p>
+            <a:pPr>
+              <a:lnSpc>
+                <a:spcPct val="95000"/>
+              </a:lnSpc>
+              <a:spcBef>
+                <a:spcPts val="200"/>
+              </a:spcBef>
+              <a:spcAft>
+                <a:spcPts val="0"/>
+              </a:spcAft>
+            </a:pPr>
+            <a:r>
+              <a:rPr sz="900" b="0">
+                <a:solidFill>
+                  <a:srgbClr val="5A626C"/>
+                </a:solidFill>
+                <a:latin typeface="Arial"/>
+              </a:rPr>
+              <a:t>ONS precedent</a:t>
+            </a:r>
+          </a:p>
+        </p:txBody>
+      </p:sp>
+      <p:sp>
+        <p:nvSpPr>
+          <p:cNvPr id="17426" name="TextBox 17425"/>
+          <p:cNvSpPr txBox="1"/>
+          <p:nvPr/>
+        </p:nvSpPr>
+        <p:spPr>
+          <a:xfrm>
+            <a:off x="6400800" y="1133856"/>
+            <a:ext cx="5394960" cy="274320"/>
+          </a:xfrm>
+          <a:prstGeom prst="rect">
+            <a:avLst/>
+          </a:prstGeom>
+          <a:noFill/>
+        </p:spPr>
+        <p:txBody>
+          <a:bodyPr wrap="square" lIns="36576" rIns="36576" tIns="18288" bIns="18288">
+            <a:spAutoFit/>
+          </a:bodyPr>
+          <a:lstStyle/>
+          <a:p>
+            <a:pPr>
+              <a:lnSpc>
+                <a:spcPct val="95000"/>
+              </a:lnSpc>
+              <a:spcBef>
+                <a:spcPts val="0"/>
+              </a:spcBef>
+              <a:spcAft>
+                <a:spcPts val="0"/>
+              </a:spcAft>
+            </a:pPr>
+            <a:r>
               <a:rPr sz="1500" b="1">
                 <a:solidFill>
                   <a:srgbClr val="1F497D"/>
@@ -11960,7 +12332,7 @@
       </p:sp>
       <p:sp>
         <p:nvSpPr>
-          <p:cNvPr id="17419" name="Rectangle 17418"/>
+          <p:cNvPr id="17427" name="Rectangle 17426"/>
           <p:cNvSpPr/>
           <p:nvPr/>
         </p:nvSpPr>
@@ -12004,14 +12376,14 @@
       </p:sp>
       <p:sp>
         <p:nvSpPr>
-          <p:cNvPr id="17420" name="Rounded Rectangle 17419"/>
+          <p:cNvPr id="17428" name="Rounded Rectangle 17427"/>
           <p:cNvSpPr/>
           <p:nvPr/>
         </p:nvSpPr>
         <p:spPr>
           <a:xfrm>
             <a:off x="6400800" y="1554480"/>
-            <a:ext cx="5394960" cy="868680"/>
+            <a:ext cx="5394960" cy="804672"/>
           </a:xfrm>
           <a:prstGeom prst="roundRect">
             <a:avLst>
@@ -12050,14 +12422,14 @@
       </p:sp>
       <p:sp>
         <p:nvSpPr>
-          <p:cNvPr id="17421" name="Rectangle 17420"/>
+          <p:cNvPr id="17429" name="Rectangle 17428"/>
           <p:cNvSpPr/>
           <p:nvPr/>
         </p:nvSpPr>
         <p:spPr>
           <a:xfrm>
             <a:off x="6400800" y="1554480"/>
-            <a:ext cx="50292" cy="868680"/>
+            <a:ext cx="50292" cy="804672"/>
           </a:xfrm>
           <a:prstGeom prst="rect">
             <a:avLst/>
@@ -12094,14 +12466,14 @@
       </p:sp>
       <p:sp>
         <p:nvSpPr>
-          <p:cNvPr id="17422" name="TextBox 17421"/>
+          <p:cNvPr id="17430" name="TextBox 17429"/>
           <p:cNvSpPr txBox="1"/>
           <p:nvPr/>
         </p:nvSpPr>
         <p:spPr>
           <a:xfrm>
-            <a:off x="6583680" y="1655064"/>
-            <a:ext cx="5120640" cy="713232"/>
+            <a:off x="6583680" y="1636776"/>
+            <a:ext cx="5120640" cy="658368"/>
           </a:xfrm>
           <a:prstGeom prst="rect">
             <a:avLst/>
@@ -12126,7 +12498,7 @@
               </a:spcAft>
             </a:pPr>
             <a:r>
-              <a:rPr sz="1400" b="1">
+              <a:rPr sz="1350" b="1">
                 <a:solidFill>
                   <a:srgbClr val="A63A3A"/>
                 </a:solidFill>
@@ -12148,7 +12520,7 @@
               </a:spcAft>
             </a:pPr>
             <a:r>
-              <a:rPr sz="1200" b="0">
+              <a:rPr sz="1150" b="0">
                 <a:solidFill>
                   <a:srgbClr val="262B33"/>
                 </a:solidFill>
@@ -12161,14 +12533,14 @@
       </p:sp>
       <p:sp>
         <p:nvSpPr>
-          <p:cNvPr id="17423" name="Rounded Rectangle 17422"/>
+          <p:cNvPr id="17431" name="Rounded Rectangle 17430"/>
           <p:cNvSpPr/>
           <p:nvPr/>
         </p:nvSpPr>
         <p:spPr>
           <a:xfrm>
-            <a:off x="6400800" y="2496312"/>
-            <a:ext cx="5394960" cy="868680"/>
+            <a:off x="6400800" y="2432304"/>
+            <a:ext cx="5394960" cy="804672"/>
           </a:xfrm>
           <a:prstGeom prst="roundRect">
             <a:avLst>
@@ -12207,14 +12579,14 @@
       </p:sp>
       <p:sp>
         <p:nvSpPr>
-          <p:cNvPr id="17424" name="Rectangle 17423"/>
+          <p:cNvPr id="17432" name="Rectangle 17431"/>
           <p:cNvSpPr/>
           <p:nvPr/>
         </p:nvSpPr>
         <p:spPr>
           <a:xfrm>
-            <a:off x="6400800" y="2496312"/>
-            <a:ext cx="50292" cy="868680"/>
+            <a:off x="6400800" y="2432304"/>
+            <a:ext cx="50292" cy="804672"/>
           </a:xfrm>
           <a:prstGeom prst="rect">
             <a:avLst/>
@@ -12251,14 +12623,14 @@
       </p:sp>
       <p:sp>
         <p:nvSpPr>
-          <p:cNvPr id="17425" name="TextBox 17424"/>
+          <p:cNvPr id="17433" name="TextBox 17432"/>
           <p:cNvSpPr txBox="1"/>
           <p:nvPr/>
         </p:nvSpPr>
         <p:spPr>
           <a:xfrm>
-            <a:off x="6583680" y="2596896"/>
-            <a:ext cx="5120640" cy="713232"/>
+            <a:off x="6583680" y="2514600"/>
+            <a:ext cx="5120640" cy="658368"/>
           </a:xfrm>
           <a:prstGeom prst="rect">
             <a:avLst/>
@@ -12283,7 +12655,7 @@
               </a:spcAft>
             </a:pPr>
             <a:r>
-              <a:rPr sz="1400" b="1">
+              <a:rPr sz="1350" b="1">
                 <a:solidFill>
                   <a:srgbClr val="A63A3A"/>
                 </a:solidFill>
@@ -12305,7 +12677,7 @@
               </a:spcAft>
             </a:pPr>
             <a:r>
-              <a:rPr sz="1200" b="0">
+              <a:rPr sz="1150" b="0">
                 <a:solidFill>
                   <a:srgbClr val="262B33"/>
                 </a:solidFill>
@@ -12318,14 +12690,14 @@
       </p:sp>
       <p:sp>
         <p:nvSpPr>
-          <p:cNvPr id="17426" name="Rounded Rectangle 17425"/>
+          <p:cNvPr id="17434" name="Rounded Rectangle 17433"/>
           <p:cNvSpPr/>
           <p:nvPr/>
         </p:nvSpPr>
         <p:spPr>
           <a:xfrm>
-            <a:off x="6400800" y="3438144"/>
-            <a:ext cx="5394960" cy="868680"/>
+            <a:off x="6400800" y="3310128"/>
+            <a:ext cx="5394960" cy="804672"/>
           </a:xfrm>
           <a:prstGeom prst="roundRect">
             <a:avLst>
@@ -12364,14 +12736,14 @@
       </p:sp>
       <p:sp>
         <p:nvSpPr>
-          <p:cNvPr id="17427" name="Rectangle 17426"/>
+          <p:cNvPr id="17435" name="Rectangle 17434"/>
           <p:cNvSpPr/>
           <p:nvPr/>
         </p:nvSpPr>
         <p:spPr>
           <a:xfrm>
-            <a:off x="6400800" y="3438144"/>
-            <a:ext cx="50292" cy="868680"/>
+            <a:off x="6400800" y="3310128"/>
+            <a:ext cx="50292" cy="804672"/>
           </a:xfrm>
           <a:prstGeom prst="rect">
             <a:avLst/>
@@ -12408,14 +12780,14 @@
       </p:sp>
       <p:sp>
         <p:nvSpPr>
-          <p:cNvPr id="17428" name="TextBox 17427"/>
+          <p:cNvPr id="17436" name="TextBox 17435"/>
           <p:cNvSpPr txBox="1"/>
           <p:nvPr/>
         </p:nvSpPr>
         <p:spPr>
           <a:xfrm>
-            <a:off x="6583680" y="3538727"/>
-            <a:ext cx="5120640" cy="713232"/>
+            <a:off x="6583680" y="3392424"/>
+            <a:ext cx="5120640" cy="658368"/>
           </a:xfrm>
           <a:prstGeom prst="rect">
             <a:avLst/>
@@ -12440,7 +12812,7 @@
               </a:spcAft>
             </a:pPr>
             <a:r>
-              <a:rPr sz="1400" b="1">
+              <a:rPr sz="1350" b="1">
                 <a:solidFill>
                   <a:srgbClr val="A63A3A"/>
                 </a:solidFill>
@@ -12462,7 +12834,7 @@
               </a:spcAft>
             </a:pPr>
             <a:r>
-              <a:rPr sz="1200" b="0">
+              <a:rPr sz="1150" b="0">
                 <a:solidFill>
                   <a:srgbClr val="262B33"/>
                 </a:solidFill>
@@ -12475,14 +12847,14 @@
       </p:sp>
       <p:sp>
         <p:nvSpPr>
-          <p:cNvPr id="17429" name="Rounded Rectangle 17428"/>
+          <p:cNvPr id="17437" name="Rounded Rectangle 17436"/>
           <p:cNvSpPr/>
           <p:nvPr/>
         </p:nvSpPr>
         <p:spPr>
           <a:xfrm>
-            <a:off x="6400800" y="4379976"/>
-            <a:ext cx="5394960" cy="868680"/>
+            <a:off x="6400800" y="4187952"/>
+            <a:ext cx="5394960" cy="804672"/>
           </a:xfrm>
           <a:prstGeom prst="roundRect">
             <a:avLst>
@@ -12521,14 +12893,14 @@
       </p:sp>
       <p:sp>
         <p:nvSpPr>
-          <p:cNvPr id="17430" name="Rectangle 17429"/>
+          <p:cNvPr id="17438" name="Rectangle 17437"/>
           <p:cNvSpPr/>
           <p:nvPr/>
         </p:nvSpPr>
         <p:spPr>
           <a:xfrm>
-            <a:off x="6400800" y="4379976"/>
-            <a:ext cx="50292" cy="868680"/>
+            <a:off x="6400800" y="4187952"/>
+            <a:ext cx="50292" cy="804672"/>
           </a:xfrm>
           <a:prstGeom prst="rect">
             <a:avLst/>
@@ -12565,14 +12937,14 @@
       </p:sp>
       <p:sp>
         <p:nvSpPr>
-          <p:cNvPr id="17431" name="TextBox 17430"/>
+          <p:cNvPr id="17439" name="TextBox 17438"/>
           <p:cNvSpPr txBox="1"/>
           <p:nvPr/>
         </p:nvSpPr>
         <p:spPr>
           <a:xfrm>
-            <a:off x="6583680" y="4480560"/>
-            <a:ext cx="5120640" cy="713232"/>
+            <a:off x="6583680" y="4270248"/>
+            <a:ext cx="5120640" cy="658368"/>
           </a:xfrm>
           <a:prstGeom prst="rect">
             <a:avLst/>
@@ -12597,7 +12969,7 @@
               </a:spcAft>
             </a:pPr>
             <a:r>
-              <a:rPr sz="1400" b="1">
+              <a:rPr sz="1350" b="1">
                 <a:solidFill>
                   <a:srgbClr val="A63A3A"/>
                 </a:solidFill>
@@ -12619,13 +12991,598 @@
               </a:spcAft>
             </a:pPr>
             <a:r>
-              <a:rPr sz="1200" b="0">
+              <a:rPr sz="1150" b="0">
                 <a:solidFill>
                   <a:srgbClr val="262B33"/>
                 </a:solidFill>
                 <a:latin typeface="Arial"/>
               </a:rPr>
               <a:t>Days below 60% basket weight publish as provisional, with the reason.</a:t>
+            </a:r>
+          </a:p>
+        </p:txBody>
+      </p:sp>
+      <p:sp>
+        <p:nvSpPr>
+          <p:cNvPr id="17440" name="TextBox 17439"/>
+          <p:cNvSpPr txBox="1"/>
+          <p:nvPr/>
+        </p:nvSpPr>
+        <p:spPr>
+          <a:xfrm>
+            <a:off x="6400800" y="5102352"/>
+            <a:ext cx="5394960" cy="274320"/>
+          </a:xfrm>
+          <a:prstGeom prst="rect">
+            <a:avLst/>
+          </a:prstGeom>
+          <a:noFill/>
+        </p:spPr>
+        <p:txBody>
+          <a:bodyPr wrap="square" lIns="36576" rIns="36576" tIns="18288" bIns="18288">
+            <a:spAutoFit/>
+          </a:bodyPr>
+          <a:lstStyle/>
+          <a:p>
+            <a:pPr>
+              <a:lnSpc>
+                <a:spcPct val="95000"/>
+              </a:lnSpc>
+              <a:spcBef>
+                <a:spcPts val="0"/>
+              </a:spcBef>
+              <a:spcAft>
+                <a:spcPts val="0"/>
+              </a:spcAft>
+            </a:pPr>
+            <a:r>
+              <a:rPr sz="1500" b="1">
+                <a:solidFill>
+                  <a:srgbClr val="1F497D"/>
+                </a:solidFill>
+                <a:latin typeface="Arial"/>
+              </a:rPr>
+              <a:t>What it costs to run</a:t>
+            </a:r>
+          </a:p>
+        </p:txBody>
+      </p:sp>
+      <p:sp>
+        <p:nvSpPr>
+          <p:cNvPr id="17441" name="Rectangle 17440"/>
+          <p:cNvSpPr/>
+          <p:nvPr/>
+        </p:nvSpPr>
+        <p:spPr>
+          <a:xfrm>
+            <a:off x="6419088" y="5376672"/>
+            <a:ext cx="1371600" cy="25603"/>
+          </a:xfrm>
+          <a:prstGeom prst="rect">
+            <a:avLst/>
+          </a:prstGeom>
+          <a:solidFill>
+            <a:srgbClr val="4F81BD"/>
+          </a:solidFill>
+          <a:ln>
+            <a:noFill/>
+          </a:ln>
+          <a:effectLst/>
+        </p:spPr>
+        <p:style>
+          <a:lnRef idx="1">
+            <a:schemeClr val="accent1"/>
+          </a:lnRef>
+          <a:fillRef idx="3">
+            <a:schemeClr val="accent1"/>
+          </a:fillRef>
+          <a:effectRef idx="2">
+            <a:schemeClr val="accent1"/>
+          </a:effectRef>
+          <a:fontRef idx="minor">
+            <a:schemeClr val="lt1"/>
+          </a:fontRef>
+        </p:style>
+        <p:txBody>
+          <a:bodyPr rtlCol="0" anchor="ctr"/>
+          <a:lstStyle/>
+          <a:p>
+            <a:pPr algn="ctr"/>
+          </a:p>
+        </p:txBody>
+      </p:sp>
+      <p:sp>
+        <p:nvSpPr>
+          <p:cNvPr id="17442" name="Rounded Rectangle 17441"/>
+          <p:cNvSpPr/>
+          <p:nvPr/>
+        </p:nvSpPr>
+        <p:spPr>
+          <a:xfrm>
+            <a:off x="6400800" y="5468112"/>
+            <a:ext cx="5394960" cy="841248"/>
+          </a:xfrm>
+          <a:prstGeom prst="roundRect">
+            <a:avLst>
+              <a:gd name="adj" fmla="val 6000"/>
+            </a:avLst>
+          </a:prstGeom>
+          <a:solidFill>
+            <a:srgbClr val="E4F4EC"/>
+          </a:solidFill>
+          <a:ln>
+            <a:noFill/>
+          </a:ln>
+          <a:effectLst/>
+        </p:spPr>
+        <p:style>
+          <a:lnRef idx="1">
+            <a:schemeClr val="accent1"/>
+          </a:lnRef>
+          <a:fillRef idx="3">
+            <a:schemeClr val="accent1"/>
+          </a:fillRef>
+          <a:effectRef idx="2">
+            <a:schemeClr val="accent1"/>
+          </a:effectRef>
+          <a:fontRef idx="minor">
+            <a:schemeClr val="lt1"/>
+          </a:fontRef>
+        </p:style>
+        <p:txBody>
+          <a:bodyPr rtlCol="0" anchor="ctr" wrap="square"/>
+          <a:lstStyle/>
+          <a:p>
+            <a:pPr algn="ctr"/>
+          </a:p>
+        </p:txBody>
+      </p:sp>
+      <p:sp>
+        <p:nvSpPr>
+          <p:cNvPr id="17443" name="TextBox 17442"/>
+          <p:cNvSpPr txBox="1"/>
+          <p:nvPr/>
+        </p:nvSpPr>
+        <p:spPr>
+          <a:xfrm>
+            <a:off x="6547104" y="5522976"/>
+            <a:ext cx="3291840" cy="155448"/>
+          </a:xfrm>
+          <a:prstGeom prst="rect">
+            <a:avLst/>
+          </a:prstGeom>
+          <a:noFill/>
+        </p:spPr>
+        <p:txBody>
+          <a:bodyPr wrap="square" lIns="36576" rIns="36576" tIns="18288" bIns="18288">
+            <a:spAutoFit/>
+          </a:bodyPr>
+          <a:lstStyle/>
+          <a:p>
+            <a:pPr>
+              <a:lnSpc>
+                <a:spcPct val="95000"/>
+              </a:lnSpc>
+              <a:spcBef>
+                <a:spcPts val="0"/>
+              </a:spcBef>
+              <a:spcAft>
+                <a:spcPts val="0"/>
+              </a:spcAft>
+            </a:pPr>
+            <a:r>
+              <a:rPr sz="1000" b="0">
+                <a:solidFill>
+                  <a:srgbClr val="262B33"/>
+                </a:solidFill>
+                <a:latin typeface="Arial"/>
+              </a:rPr>
+              <a:t>Collection · Playwright</a:t>
+            </a:r>
+          </a:p>
+        </p:txBody>
+      </p:sp>
+      <p:sp>
+        <p:nvSpPr>
+          <p:cNvPr id="17444" name="TextBox 17443"/>
+          <p:cNvSpPr txBox="1"/>
+          <p:nvPr/>
+        </p:nvSpPr>
+        <p:spPr>
+          <a:xfrm>
+            <a:off x="9921240" y="5522976"/>
+            <a:ext cx="1737360" cy="155448"/>
+          </a:xfrm>
+          <a:prstGeom prst="rect">
+            <a:avLst/>
+          </a:prstGeom>
+          <a:noFill/>
+        </p:spPr>
+        <p:txBody>
+          <a:bodyPr wrap="square" lIns="36576" rIns="36576" tIns="18288" bIns="18288">
+            <a:spAutoFit/>
+          </a:bodyPr>
+          <a:lstStyle/>
+          <a:p>
+            <a:pPr>
+              <a:lnSpc>
+                <a:spcPct val="95000"/>
+              </a:lnSpc>
+              <a:spcBef>
+                <a:spcPts val="0"/>
+              </a:spcBef>
+              <a:spcAft>
+                <a:spcPts val="0"/>
+              </a:spcAft>
+            </a:pPr>
+            <a:r>
+              <a:rPr sz="1000" b="0">
+                <a:solidFill>
+                  <a:srgbClr val="5A626C"/>
+                </a:solidFill>
+                <a:latin typeface="Arial"/>
+              </a:rPr>
+              <a:t>₹0 · free tier</a:t>
+            </a:r>
+          </a:p>
+        </p:txBody>
+      </p:sp>
+      <p:sp>
+        <p:nvSpPr>
+          <p:cNvPr id="17445" name="TextBox 17444"/>
+          <p:cNvSpPr txBox="1"/>
+          <p:nvPr/>
+        </p:nvSpPr>
+        <p:spPr>
+          <a:xfrm>
+            <a:off x="6547104" y="5678424"/>
+            <a:ext cx="3291840" cy="155448"/>
+          </a:xfrm>
+          <a:prstGeom prst="rect">
+            <a:avLst/>
+          </a:prstGeom>
+          <a:noFill/>
+        </p:spPr>
+        <p:txBody>
+          <a:bodyPr wrap="square" lIns="36576" rIns="36576" tIns="18288" bIns="18288">
+            <a:spAutoFit/>
+          </a:bodyPr>
+          <a:lstStyle/>
+          <a:p>
+            <a:pPr>
+              <a:lnSpc>
+                <a:spcPct val="95000"/>
+              </a:lnSpc>
+              <a:spcBef>
+                <a:spcPts val="0"/>
+              </a:spcBef>
+              <a:spcAft>
+                <a:spcPts val="0"/>
+              </a:spcAft>
+            </a:pPr>
+            <a:r>
+              <a:rPr sz="1000" b="0">
+                <a:solidFill>
+                  <a:srgbClr val="262B33"/>
+                </a:solidFill>
+                <a:latin typeface="Arial"/>
+              </a:rPr>
+              <a:t>Extraction · NVIDIA NIM LLM</a:t>
+            </a:r>
+          </a:p>
+        </p:txBody>
+      </p:sp>
+      <p:sp>
+        <p:nvSpPr>
+          <p:cNvPr id="17446" name="TextBox 17445"/>
+          <p:cNvSpPr txBox="1"/>
+          <p:nvPr/>
+        </p:nvSpPr>
+        <p:spPr>
+          <a:xfrm>
+            <a:off x="9921240" y="5678424"/>
+            <a:ext cx="1737360" cy="155448"/>
+          </a:xfrm>
+          <a:prstGeom prst="rect">
+            <a:avLst/>
+          </a:prstGeom>
+          <a:noFill/>
+        </p:spPr>
+        <p:txBody>
+          <a:bodyPr wrap="square" lIns="36576" rIns="36576" tIns="18288" bIns="18288">
+            <a:spAutoFit/>
+          </a:bodyPr>
+          <a:lstStyle/>
+          <a:p>
+            <a:pPr>
+              <a:lnSpc>
+                <a:spcPct val="95000"/>
+              </a:lnSpc>
+              <a:spcBef>
+                <a:spcPts val="0"/>
+              </a:spcBef>
+              <a:spcAft>
+                <a:spcPts val="0"/>
+              </a:spcAft>
+            </a:pPr>
+            <a:r>
+              <a:rPr sz="1000" b="0">
+                <a:solidFill>
+                  <a:srgbClr val="5A626C"/>
+                </a:solidFill>
+                <a:latin typeface="Arial"/>
+              </a:rPr>
+              <a:t>₹0 · free tier</a:t>
+            </a:r>
+          </a:p>
+        </p:txBody>
+      </p:sp>
+      <p:sp>
+        <p:nvSpPr>
+          <p:cNvPr id="17447" name="TextBox 17446"/>
+          <p:cNvSpPr txBox="1"/>
+          <p:nvPr/>
+        </p:nvSpPr>
+        <p:spPr>
+          <a:xfrm>
+            <a:off x="6547104" y="5833872"/>
+            <a:ext cx="3291840" cy="155448"/>
+          </a:xfrm>
+          <a:prstGeom prst="rect">
+            <a:avLst/>
+          </a:prstGeom>
+          <a:noFill/>
+        </p:spPr>
+        <p:txBody>
+          <a:bodyPr wrap="square" lIns="36576" rIns="36576" tIns="18288" bIns="18288">
+            <a:spAutoFit/>
+          </a:bodyPr>
+          <a:lstStyle/>
+          <a:p>
+            <a:pPr>
+              <a:lnSpc>
+                <a:spcPct val="95000"/>
+              </a:lnSpc>
+              <a:spcBef>
+                <a:spcPts val="0"/>
+              </a:spcBef>
+              <a:spcAft>
+                <a:spcPts val="0"/>
+              </a:spcAft>
+            </a:pPr>
+            <a:r>
+              <a:rPr sz="1000" b="0">
+                <a:solidFill>
+                  <a:srgbClr val="262B33"/>
+                </a:solidFill>
+                <a:latin typeface="Arial"/>
+              </a:rPr>
+              <a:t>Storage · Supabase Postgres</a:t>
+            </a:r>
+          </a:p>
+        </p:txBody>
+      </p:sp>
+      <p:sp>
+        <p:nvSpPr>
+          <p:cNvPr id="17448" name="TextBox 17447"/>
+          <p:cNvSpPr txBox="1"/>
+          <p:nvPr/>
+        </p:nvSpPr>
+        <p:spPr>
+          <a:xfrm>
+            <a:off x="9921240" y="5833872"/>
+            <a:ext cx="1737360" cy="155448"/>
+          </a:xfrm>
+          <a:prstGeom prst="rect">
+            <a:avLst/>
+          </a:prstGeom>
+          <a:noFill/>
+        </p:spPr>
+        <p:txBody>
+          <a:bodyPr wrap="square" lIns="36576" rIns="36576" tIns="18288" bIns="18288">
+            <a:spAutoFit/>
+          </a:bodyPr>
+          <a:lstStyle/>
+          <a:p>
+            <a:pPr>
+              <a:lnSpc>
+                <a:spcPct val="95000"/>
+              </a:lnSpc>
+              <a:spcBef>
+                <a:spcPts val="0"/>
+              </a:spcBef>
+              <a:spcAft>
+                <a:spcPts val="0"/>
+              </a:spcAft>
+            </a:pPr>
+            <a:r>
+              <a:rPr sz="1000" b="0">
+                <a:solidFill>
+                  <a:srgbClr val="5A626C"/>
+                </a:solidFill>
+                <a:latin typeface="Arial"/>
+              </a:rPr>
+              <a:t>₹0 · free tier</a:t>
+            </a:r>
+          </a:p>
+        </p:txBody>
+      </p:sp>
+      <p:sp>
+        <p:nvSpPr>
+          <p:cNvPr id="17449" name="TextBox 17448"/>
+          <p:cNvSpPr txBox="1"/>
+          <p:nvPr/>
+        </p:nvSpPr>
+        <p:spPr>
+          <a:xfrm>
+            <a:off x="6547104" y="5989320"/>
+            <a:ext cx="3291840" cy="155448"/>
+          </a:xfrm>
+          <a:prstGeom prst="rect">
+            <a:avLst/>
+          </a:prstGeom>
+          <a:noFill/>
+        </p:spPr>
+        <p:txBody>
+          <a:bodyPr wrap="square" lIns="36576" rIns="36576" tIns="18288" bIns="18288">
+            <a:spAutoFit/>
+          </a:bodyPr>
+          <a:lstStyle/>
+          <a:p>
+            <a:pPr>
+              <a:lnSpc>
+                <a:spcPct val="95000"/>
+              </a:lnSpc>
+              <a:spcBef>
+                <a:spcPts val="0"/>
+              </a:spcBef>
+              <a:spcAft>
+                <a:spcPts val="0"/>
+              </a:spcAft>
+            </a:pPr>
+            <a:r>
+              <a:rPr sz="1000" b="0">
+                <a:solidFill>
+                  <a:srgbClr val="262B33"/>
+                </a:solidFill>
+                <a:latin typeface="Arial"/>
+              </a:rPr>
+              <a:t>Publication · Render + Cloudflare</a:t>
+            </a:r>
+          </a:p>
+        </p:txBody>
+      </p:sp>
+      <p:sp>
+        <p:nvSpPr>
+          <p:cNvPr id="17450" name="TextBox 17449"/>
+          <p:cNvSpPr txBox="1"/>
+          <p:nvPr/>
+        </p:nvSpPr>
+        <p:spPr>
+          <a:xfrm>
+            <a:off x="9921240" y="5989320"/>
+            <a:ext cx="1737360" cy="155448"/>
+          </a:xfrm>
+          <a:prstGeom prst="rect">
+            <a:avLst/>
+          </a:prstGeom>
+          <a:noFill/>
+        </p:spPr>
+        <p:txBody>
+          <a:bodyPr wrap="square" lIns="36576" rIns="36576" tIns="18288" bIns="18288">
+            <a:spAutoFit/>
+          </a:bodyPr>
+          <a:lstStyle/>
+          <a:p>
+            <a:pPr>
+              <a:lnSpc>
+                <a:spcPct val="95000"/>
+              </a:lnSpc>
+              <a:spcBef>
+                <a:spcPts val="0"/>
+              </a:spcBef>
+              <a:spcAft>
+                <a:spcPts val="0"/>
+              </a:spcAft>
+            </a:pPr>
+            <a:r>
+              <a:rPr sz="1000" b="0">
+                <a:solidFill>
+                  <a:srgbClr val="5A626C"/>
+                </a:solidFill>
+                <a:latin typeface="Arial"/>
+              </a:rPr>
+              <a:t>₹0 · free tier</a:t>
+            </a:r>
+          </a:p>
+        </p:txBody>
+      </p:sp>
+      <p:sp>
+        <p:nvSpPr>
+          <p:cNvPr id="17451" name="TextBox 17450"/>
+          <p:cNvSpPr txBox="1"/>
+          <p:nvPr/>
+        </p:nvSpPr>
+        <p:spPr>
+          <a:xfrm>
+            <a:off x="6547104" y="6144768"/>
+            <a:ext cx="3291840" cy="155448"/>
+          </a:xfrm>
+          <a:prstGeom prst="rect">
+            <a:avLst/>
+          </a:prstGeom>
+          <a:noFill/>
+        </p:spPr>
+        <p:txBody>
+          <a:bodyPr wrap="square" lIns="36576" rIns="36576" tIns="18288" bIns="18288">
+            <a:spAutoFit/>
+          </a:bodyPr>
+          <a:lstStyle/>
+          <a:p>
+            <a:pPr>
+              <a:lnSpc>
+                <a:spcPct val="95000"/>
+              </a:lnSpc>
+              <a:spcBef>
+                <a:spcPts val="0"/>
+              </a:spcBef>
+              <a:spcAft>
+                <a:spcPts val="0"/>
+              </a:spcAft>
+            </a:pPr>
+            <a:r>
+              <a:rPr sz="1000" b="1">
+                <a:solidFill>
+                  <a:srgbClr val="1B8A5A"/>
+                </a:solidFill>
+                <a:latin typeface="Arial"/>
+              </a:rPr>
+              <a:t>Total · 144 cycles a day</a:t>
+            </a:r>
+          </a:p>
+        </p:txBody>
+      </p:sp>
+      <p:sp>
+        <p:nvSpPr>
+          <p:cNvPr id="17452" name="TextBox 17451"/>
+          <p:cNvSpPr txBox="1"/>
+          <p:nvPr/>
+        </p:nvSpPr>
+        <p:spPr>
+          <a:xfrm>
+            <a:off x="9921240" y="6144768"/>
+            <a:ext cx="1737360" cy="155448"/>
+          </a:xfrm>
+          <a:prstGeom prst="rect">
+            <a:avLst/>
+          </a:prstGeom>
+          <a:noFill/>
+        </p:spPr>
+        <p:txBody>
+          <a:bodyPr wrap="square" lIns="36576" rIns="36576" tIns="18288" bIns="18288">
+            <a:spAutoFit/>
+          </a:bodyPr>
+          <a:lstStyle/>
+          <a:p>
+            <a:pPr>
+              <a:lnSpc>
+                <a:spcPct val="95000"/>
+              </a:lnSpc>
+              <a:spcBef>
+                <a:spcPts val="0"/>
+              </a:spcBef>
+              <a:spcAft>
+                <a:spcPts val="0"/>
+              </a:spcAft>
+            </a:pPr>
+            <a:r>
+              <a:rPr sz="1000" b="1">
+                <a:solidFill>
+                  <a:srgbClr val="1B8A5A"/>
+                </a:solidFill>
+                <a:latin typeface="Arial"/>
+              </a:rPr>
+              <a:t>₹0 a month</a:t>
             </a:r>
           </a:p>
         </p:txBody>
@@ -13195,8 +14152,7 @@
                 </a:solidFill>
                 <a:latin typeface="Arial"/>
               </a:rPr>
-              <a:t>A portal shows a price for one route
-on one departure date</a:t>
+              <a:t>A portal shows a price for one route, one date</a:t>
             </a:r>
           </a:p>
         </p:txBody>
@@ -13349,8 +14305,7 @@
                 </a:solidFill>
                 <a:latin typeface="Arial"/>
               </a:rPr>
-              <a:t>Collected every 10 minutes,
-robots-checked, timestamped</a:t>
+              <a:t>Read every 10 minutes, robots-checked</a:t>
             </a:r>
           </a:p>
         </p:txBody>
@@ -13503,8 +14458,7 @@
                 </a:solidFill>
                 <a:latin typeface="Arial"/>
               </a:rPr>
-              <a:t>Cheapest fare per route × lead time
-— what a traveller could transact at</a:t>
+              <a:t>Cheapest logical fare per route × lead time</a:t>
             </a:r>
           </a:p>
         </p:txBody>
@@ -13657,8 +14611,7 @@
                 </a:solidFill>
                 <a:latin typeface="Arial"/>
               </a:rPr>
-              <a:t>Weighted Jevons across the basket
-→ airfare inflation</a:t>
+              <a:t>Weighted Jevons across the basket</a:t>
             </a:r>
           </a:p>
         </p:txBody>
@@ -13811,8 +14764,7 @@
                 </a:solidFill>
                 <a:latin typeface="Arial"/>
               </a:rPr>
-              <a:t>REST API with method, coverage
-and revision history attached</a:t>
+              <a:t>REST API with method and coverage</a:t>
             </a:r>
           </a:p>
         </p:txBody>
@@ -13965,8 +14917,7 @@
                 </a:solidFill>
                 <a:latin typeface="Arial"/>
               </a:rPr>
-              <a:t>Transport sub-index priced from
-144 daily observations, not 1 visit</a:t>
+              <a:t>Transport sub-index from 144 daily reads</a:t>
             </a:r>
           </a:p>
         </p:txBody>
@@ -14003,7 +14954,7 @@
         </p:nvSpPr>
         <p:spPr>
           <a:xfrm>
-            <a:off x="411480" y="5870448"/>
+            <a:off x="411480" y="5852160"/>
             <a:ext cx="5669280" cy="402336"/>
           </a:xfrm>
           <a:prstGeom prst="rect">
@@ -14058,7 +15009,7 @@
                 </a:solidFill>
                 <a:latin typeface="Arial"/>
               </a:rPr>
-              <a:t>Headline inflation, release status and the method, stated on the page.</a:t>
+              <a:t>Headline inflation, release status and method on one page.</a:t>
             </a:r>
           </a:p>
         </p:txBody>
@@ -14241,7 +15192,7 @@
               </a:spcAft>
             </a:pPr>
             <a:r>
-              <a:rPr sz="1200" b="0">
+              <a:rPr sz="1150" b="0">
                 <a:solidFill>
                   <a:srgbClr val="262B33"/>
                 </a:solidFill>
@@ -14260,7 +15211,7 @@
         </p:nvSpPr>
         <p:spPr>
           <a:xfrm>
-            <a:off x="6400800" y="3986783"/>
+            <a:off x="6400800" y="3913631"/>
             <a:ext cx="1691640" cy="292608"/>
           </a:xfrm>
           <a:prstGeom prst="roundRect">
@@ -14315,7 +15266,7 @@
         </p:nvSpPr>
         <p:spPr>
           <a:xfrm>
-            <a:off x="8275320" y="3968496"/>
+            <a:off x="8275320" y="3895344"/>
             <a:ext cx="3520440" cy="457200"/>
           </a:xfrm>
           <a:prstGeom prst="rect">
@@ -14341,7 +15292,7 @@
               </a:spcAft>
             </a:pPr>
             <a:r>
-              <a:rPr sz="1200" b="0">
+              <a:rPr sz="1150" b="0">
                 <a:solidFill>
                   <a:srgbClr val="262B33"/>
                 </a:solidFill>
@@ -14360,7 +15311,7 @@
         </p:nvSpPr>
         <p:spPr>
           <a:xfrm>
-            <a:off x="6400800" y="4535423"/>
+            <a:off x="6400800" y="4389119"/>
             <a:ext cx="1691640" cy="292608"/>
           </a:xfrm>
           <a:prstGeom prst="roundRect">
@@ -14415,7 +15366,7 @@
         </p:nvSpPr>
         <p:spPr>
           <a:xfrm>
-            <a:off x="8275320" y="4517136"/>
+            <a:off x="8275320" y="4370831"/>
             <a:ext cx="3520440" cy="457200"/>
           </a:xfrm>
           <a:prstGeom prst="rect">
@@ -14441,7 +15392,7 @@
               </a:spcAft>
             </a:pPr>
             <a:r>
-              <a:rPr sz="1200" b="0">
+              <a:rPr sz="1150" b="0">
                 <a:solidFill>
                   <a:srgbClr val="262B33"/>
                 </a:solidFill>
@@ -14460,7 +15411,7 @@
         </p:nvSpPr>
         <p:spPr>
           <a:xfrm>
-            <a:off x="6400800" y="5084063"/>
+            <a:off x="6400800" y="4864607"/>
             <a:ext cx="1691640" cy="292608"/>
           </a:xfrm>
           <a:prstGeom prst="roundRect">
@@ -14515,7 +15466,7 @@
         </p:nvSpPr>
         <p:spPr>
           <a:xfrm>
-            <a:off x="8275320" y="5065775"/>
+            <a:off x="8275320" y="4846319"/>
             <a:ext cx="3520440" cy="457200"/>
           </a:xfrm>
           <a:prstGeom prst="rect">
@@ -14541,7 +15492,7 @@
               </a:spcAft>
             </a:pPr>
             <a:r>
-              <a:rPr sz="1200" b="0">
+              <a:rPr sz="1150" b="0">
                 <a:solidFill>
                   <a:srgbClr val="262B33"/>
                 </a:solidFill>
@@ -14560,8 +15511,8 @@
         </p:nvSpPr>
         <p:spPr>
           <a:xfrm>
-            <a:off x="6400800" y="5504688"/>
-            <a:ext cx="5394960" cy="768096"/>
+            <a:off x="6400800" y="5303520"/>
+            <a:ext cx="1700784" cy="566928"/>
           </a:xfrm>
           <a:prstGeom prst="roundRect">
             <a:avLst>
@@ -14591,6 +15542,345 @@
           </a:fontRef>
         </p:style>
         <p:txBody>
+          <a:bodyPr rtlCol="0" anchor="ctr" wrap="square"/>
+          <a:lstStyle/>
+          <a:p>
+            <a:pPr algn="ctr"/>
+          </a:p>
+        </p:txBody>
+      </p:sp>
+      <p:sp>
+        <p:nvSpPr>
+          <p:cNvPr id="17436" name="TextBox 17435"/>
+          <p:cNvSpPr txBox="1"/>
+          <p:nvPr/>
+        </p:nvSpPr>
+        <p:spPr>
+          <a:xfrm>
+            <a:off x="6492240" y="5340096"/>
+            <a:ext cx="1517904" cy="493776"/>
+          </a:xfrm>
+          <a:prstGeom prst="rect">
+            <a:avLst/>
+          </a:prstGeom>
+          <a:noFill/>
+        </p:spPr>
+        <p:txBody>
+          <a:bodyPr wrap="square" lIns="36576" rIns="36576" tIns="18288" bIns="18288">
+            <a:spAutoFit/>
+          </a:bodyPr>
+          <a:lstStyle/>
+          <a:p>
+            <a:pPr>
+              <a:lnSpc>
+                <a:spcPct val="95000"/>
+              </a:lnSpc>
+              <a:spcBef>
+                <a:spcPts val="0"/>
+              </a:spcBef>
+              <a:spcAft>
+                <a:spcPts val="0"/>
+              </a:spcAft>
+            </a:pPr>
+            <a:r>
+              <a:rPr sz="1500" b="1">
+                <a:solidFill>
+                  <a:srgbClr val="1B8A5A"/>
+                </a:solidFill>
+                <a:latin typeface="Arial"/>
+              </a:rPr>
+              <a:t>144 ×</a:t>
+            </a:r>
+          </a:p>
+          <a:p>
+            <a:pPr>
+              <a:lnSpc>
+                <a:spcPct val="95000"/>
+              </a:lnSpc>
+              <a:spcBef>
+                <a:spcPts val="100"/>
+              </a:spcBef>
+              <a:spcAft>
+                <a:spcPts val="0"/>
+              </a:spcAft>
+            </a:pPr>
+            <a:r>
+              <a:rPr sz="850" b="0">
+                <a:solidFill>
+                  <a:srgbClr val="5A626C"/>
+                </a:solidFill>
+                <a:latin typeface="Arial"/>
+              </a:rPr>
+              <a:t>observations a day, not one a month</a:t>
+            </a:r>
+          </a:p>
+        </p:txBody>
+      </p:sp>
+      <p:sp>
+        <p:nvSpPr>
+          <p:cNvPr id="17437" name="Rounded Rectangle 17436"/>
+          <p:cNvSpPr/>
+          <p:nvPr/>
+        </p:nvSpPr>
+        <p:spPr>
+          <a:xfrm>
+            <a:off x="8247888" y="5303520"/>
+            <a:ext cx="1700784" cy="566928"/>
+          </a:xfrm>
+          <a:prstGeom prst="roundRect">
+            <a:avLst>
+              <a:gd name="adj" fmla="val 6000"/>
+            </a:avLst>
+          </a:prstGeom>
+          <a:solidFill>
+            <a:srgbClr val="ECEAF7"/>
+          </a:solidFill>
+          <a:ln>
+            <a:noFill/>
+          </a:ln>
+          <a:effectLst/>
+        </p:spPr>
+        <p:style>
+          <a:lnRef idx="1">
+            <a:schemeClr val="accent1"/>
+          </a:lnRef>
+          <a:fillRef idx="3">
+            <a:schemeClr val="accent1"/>
+          </a:fillRef>
+          <a:effectRef idx="2">
+            <a:schemeClr val="accent1"/>
+          </a:effectRef>
+          <a:fontRef idx="minor">
+            <a:schemeClr val="lt1"/>
+          </a:fontRef>
+        </p:style>
+        <p:txBody>
+          <a:bodyPr rtlCol="0" anchor="ctr" wrap="square"/>
+          <a:lstStyle/>
+          <a:p>
+            <a:pPr algn="ctr"/>
+          </a:p>
+        </p:txBody>
+      </p:sp>
+      <p:sp>
+        <p:nvSpPr>
+          <p:cNvPr id="17438" name="TextBox 17437"/>
+          <p:cNvSpPr txBox="1"/>
+          <p:nvPr/>
+        </p:nvSpPr>
+        <p:spPr>
+          <a:xfrm>
+            <a:off x="8339327" y="5340096"/>
+            <a:ext cx="1517904" cy="493776"/>
+          </a:xfrm>
+          <a:prstGeom prst="rect">
+            <a:avLst/>
+          </a:prstGeom>
+          <a:noFill/>
+        </p:spPr>
+        <p:txBody>
+          <a:bodyPr wrap="square" lIns="36576" rIns="36576" tIns="18288" bIns="18288">
+            <a:spAutoFit/>
+          </a:bodyPr>
+          <a:lstStyle/>
+          <a:p>
+            <a:pPr>
+              <a:lnSpc>
+                <a:spcPct val="95000"/>
+              </a:lnSpc>
+              <a:spcBef>
+                <a:spcPts val="0"/>
+              </a:spcBef>
+              <a:spcAft>
+                <a:spcPts val="0"/>
+              </a:spcAft>
+            </a:pPr>
+            <a:r>
+              <a:rPr sz="1500" b="1">
+                <a:solidFill>
+                  <a:srgbClr val="4B3F8C"/>
+                </a:solidFill>
+                <a:latin typeface="Arial"/>
+              </a:rPr>
+              <a:t>75</a:t>
+            </a:r>
+          </a:p>
+          <a:p>
+            <a:pPr>
+              <a:lnSpc>
+                <a:spcPct val="95000"/>
+              </a:lnSpc>
+              <a:spcBef>
+                <a:spcPts val="100"/>
+              </a:spcBef>
+              <a:spcAft>
+                <a:spcPts val="0"/>
+              </a:spcAft>
+            </a:pPr>
+            <a:r>
+              <a:rPr sz="850" b="0">
+                <a:solidFill>
+                  <a:srgbClr val="5A626C"/>
+                </a:solidFill>
+                <a:latin typeface="Arial"/>
+              </a:rPr>
+              <a:t>priced cells behind every figure</a:t>
+            </a:r>
+          </a:p>
+        </p:txBody>
+      </p:sp>
+      <p:sp>
+        <p:nvSpPr>
+          <p:cNvPr id="17439" name="Rounded Rectangle 17438"/>
+          <p:cNvSpPr/>
+          <p:nvPr/>
+        </p:nvSpPr>
+        <p:spPr>
+          <a:xfrm>
+            <a:off x="10094976" y="5303520"/>
+            <a:ext cx="1700784" cy="566928"/>
+          </a:xfrm>
+          <a:prstGeom prst="roundRect">
+            <a:avLst>
+              <a:gd name="adj" fmla="val 6000"/>
+            </a:avLst>
+          </a:prstGeom>
+          <a:solidFill>
+            <a:srgbClr val="F4EAF1"/>
+          </a:solidFill>
+          <a:ln>
+            <a:noFill/>
+          </a:ln>
+          <a:effectLst/>
+        </p:spPr>
+        <p:style>
+          <a:lnRef idx="1">
+            <a:schemeClr val="accent1"/>
+          </a:lnRef>
+          <a:fillRef idx="3">
+            <a:schemeClr val="accent1"/>
+          </a:fillRef>
+          <a:effectRef idx="2">
+            <a:schemeClr val="accent1"/>
+          </a:effectRef>
+          <a:fontRef idx="minor">
+            <a:schemeClr val="lt1"/>
+          </a:fontRef>
+        </p:style>
+        <p:txBody>
+          <a:bodyPr rtlCol="0" anchor="ctr" wrap="square"/>
+          <a:lstStyle/>
+          <a:p>
+            <a:pPr algn="ctr"/>
+          </a:p>
+        </p:txBody>
+      </p:sp>
+      <p:sp>
+        <p:nvSpPr>
+          <p:cNvPr id="17440" name="TextBox 17439"/>
+          <p:cNvSpPr txBox="1"/>
+          <p:nvPr/>
+        </p:nvSpPr>
+        <p:spPr>
+          <a:xfrm>
+            <a:off x="10186415" y="5340096"/>
+            <a:ext cx="1517904" cy="493776"/>
+          </a:xfrm>
+          <a:prstGeom prst="rect">
+            <a:avLst/>
+          </a:prstGeom>
+          <a:noFill/>
+        </p:spPr>
+        <p:txBody>
+          <a:bodyPr wrap="square" lIns="36576" rIns="36576" tIns="18288" bIns="18288">
+            <a:spAutoFit/>
+          </a:bodyPr>
+          <a:lstStyle/>
+          <a:p>
+            <a:pPr>
+              <a:lnSpc>
+                <a:spcPct val="95000"/>
+              </a:lnSpc>
+              <a:spcBef>
+                <a:spcPts val="0"/>
+              </a:spcBef>
+              <a:spcAft>
+                <a:spcPts val="0"/>
+              </a:spcAft>
+            </a:pPr>
+            <a:r>
+              <a:rPr sz="1500" b="1">
+                <a:solidFill>
+                  <a:srgbClr val="0E7C86"/>
+                </a:solidFill>
+                <a:latin typeface="Arial"/>
+              </a:rPr>
+              <a:t>T+0</a:t>
+            </a:r>
+          </a:p>
+          <a:p>
+            <a:pPr>
+              <a:lnSpc>
+                <a:spcPct val="95000"/>
+              </a:lnSpc>
+              <a:spcBef>
+                <a:spcPts val="100"/>
+              </a:spcBef>
+              <a:spcAft>
+                <a:spcPts val="0"/>
+              </a:spcAft>
+            </a:pPr>
+            <a:r>
+              <a:rPr sz="850" b="0">
+                <a:solidFill>
+                  <a:srgbClr val="5A626C"/>
+                </a:solidFill>
+                <a:latin typeface="Arial"/>
+              </a:rPr>
+              <a:t>same-day index, not a two-week lag</a:t>
+            </a:r>
+          </a:p>
+        </p:txBody>
+      </p:sp>
+      <p:sp>
+        <p:nvSpPr>
+          <p:cNvPr id="17441" name="Rounded Rectangle 17440"/>
+          <p:cNvSpPr/>
+          <p:nvPr/>
+        </p:nvSpPr>
+        <p:spPr>
+          <a:xfrm>
+            <a:off x="6400800" y="5925312"/>
+            <a:ext cx="5394960" cy="402336"/>
+          </a:xfrm>
+          <a:prstGeom prst="roundRect">
+            <a:avLst>
+              <a:gd name="adj" fmla="val 6000"/>
+            </a:avLst>
+          </a:prstGeom>
+          <a:solidFill>
+            <a:srgbClr val="E4F4EC"/>
+          </a:solidFill>
+          <a:ln>
+            <a:noFill/>
+          </a:ln>
+          <a:effectLst/>
+        </p:spPr>
+        <p:style>
+          <a:lnRef idx="1">
+            <a:schemeClr val="accent1"/>
+          </a:lnRef>
+          <a:fillRef idx="3">
+            <a:schemeClr val="accent1"/>
+          </a:fillRef>
+          <a:effectRef idx="2">
+            <a:schemeClr val="accent1"/>
+          </a:effectRef>
+          <a:fontRef idx="minor">
+            <a:schemeClr val="lt1"/>
+          </a:fontRef>
+        </p:style>
+        <p:txBody>
           <a:bodyPr rtlCol="0" anchor="ctr" wrap="square" lIns="36576" rIns="36576" tIns="18288" bIns="18288"/>
           <a:lstStyle/>
           <a:p>
@@ -14606,35 +15896,13 @@
               </a:spcAft>
             </a:pPr>
             <a:r>
-              <a:rPr sz="1150" b="1">
-                <a:solidFill>
-                  <a:srgbClr val="1B8A5A"/>
+              <a:rPr sz="1100" b="0">
+                <a:solidFill>
+                  <a:srgbClr val="262B33"/>
                 </a:solidFill>
                 <a:latin typeface="Arial"/>
               </a:rPr>
-              <a:t>OUR PROMISE</a:t>
-            </a:r>
-          </a:p>
-          <a:p>
-            <a:pPr>
-              <a:lnSpc>
-                <a:spcPct val="95000"/>
-              </a:lnSpc>
-              <a:spcBef>
-                <a:spcPts val="300"/>
-              </a:spcBef>
-              <a:spcAft>
-                <a:spcPts val="0"/>
-              </a:spcAft>
-            </a:pPr>
-            <a:r>
-              <a:rPr sz="1300" b="0">
-                <a:solidFill>
-                  <a:srgbClr val="262B33"/>
-                </a:solidFill>
-                <a:latin typeface="Arial"/>
-              </a:rPr>
-              <a:t>Replace one manual price visit a month with 144 automated observations a day — at zero marginal cost.</a:t>
+              <a:t>Our promise — replace one manual price visit a month with 144 automated observations a day, at zero marginal cost.</a:t>
             </a:r>
           </a:p>
         </p:txBody>
@@ -16107,8 +17375,8 @@
         </p:blipFill>
         <p:spPr>
           <a:xfrm>
-            <a:off x="411480" y="4809744"/>
-            <a:ext cx="4023360" cy="1333831"/>
+            <a:off x="411480" y="4754880"/>
+            <a:ext cx="4160520" cy="1379303"/>
           </a:xfrm>
           <a:prstGeom prst="rect">
             <a:avLst/>
@@ -16123,8 +17391,8 @@
         </p:nvSpPr>
         <p:spPr>
           <a:xfrm>
-            <a:off x="4663440" y="4864608"/>
-            <a:ext cx="7086600" cy="1371600"/>
+            <a:off x="4800600" y="4791456"/>
+            <a:ext cx="6949440" cy="1188720"/>
           </a:xfrm>
           <a:prstGeom prst="rect">
             <a:avLst/>
@@ -16201,6 +17469,189 @@
                 <a:hlinkClick r:id="rId11"/>
               </a:rPr>
               <a:t>Live API and interactive documentation →</a:t>
+            </a:r>
+          </a:p>
+        </p:txBody>
+      </p:sp>
+      <p:sp>
+        <p:nvSpPr>
+          <p:cNvPr id="17430" name="TextBox 17429"/>
+          <p:cNvSpPr txBox="1"/>
+          <p:nvPr/>
+        </p:nvSpPr>
+        <p:spPr>
+          <a:xfrm>
+            <a:off x="4800600" y="5925312"/>
+            <a:ext cx="731520" cy="219456"/>
+          </a:xfrm>
+          <a:prstGeom prst="rect">
+            <a:avLst/>
+          </a:prstGeom>
+          <a:noFill/>
+        </p:spPr>
+        <p:txBody>
+          <a:bodyPr wrap="square" lIns="36576" rIns="36576" tIns="18288" bIns="18288">
+            <a:spAutoFit/>
+          </a:bodyPr>
+          <a:lstStyle/>
+          <a:p>
+            <a:pPr>
+              <a:lnSpc>
+                <a:spcPct val="95000"/>
+              </a:lnSpc>
+              <a:spcBef>
+                <a:spcPts val="0"/>
+              </a:spcBef>
+              <a:spcAft>
+                <a:spcPts val="0"/>
+              </a:spcAft>
+            </a:pPr>
+            <a:r>
+              <a:rPr sz="950" b="1">
+                <a:solidFill>
+                  <a:srgbClr val="5A626C"/>
+                </a:solidFill>
+                <a:latin typeface="Arial"/>
+              </a:rPr>
+              <a:t>ALSO</a:t>
+            </a:r>
+          </a:p>
+        </p:txBody>
+      </p:sp>
+      <p:sp>
+        <p:nvSpPr>
+          <p:cNvPr id="17431" name="TextBox 17430"/>
+          <p:cNvSpPr txBox="1"/>
+          <p:nvPr/>
+        </p:nvSpPr>
+        <p:spPr>
+          <a:xfrm>
+            <a:off x="5532120" y="5925312"/>
+            <a:ext cx="2057400" cy="219456"/>
+          </a:xfrm>
+          <a:prstGeom prst="rect">
+            <a:avLst/>
+          </a:prstGeom>
+          <a:noFill/>
+        </p:spPr>
+        <p:txBody>
+          <a:bodyPr wrap="square" lIns="36576" rIns="36576">
+            <a:spAutoFit/>
+          </a:bodyPr>
+          <a:lstStyle/>
+          <a:p>
+            <a:pPr>
+              <a:lnSpc>
+                <a:spcPct val="100000"/>
+              </a:lnSpc>
+              <a:spcBef>
+                <a:spcPts val="0"/>
+              </a:spcBef>
+              <a:spcAft>
+                <a:spcPts val="0"/>
+              </a:spcAft>
+            </a:pPr>
+            <a:r>
+              <a:rPr sz="1000" b="1">
+                <a:solidFill>
+                  <a:srgbClr val="4F81BD"/>
+                </a:solidFill>
+                <a:latin typeface="Arial"/>
+                <a:hlinkClick r:id="rId12"/>
+              </a:rPr>
+              <a:t>README and method notes →</a:t>
+            </a:r>
+          </a:p>
+        </p:txBody>
+      </p:sp>
+      <p:sp>
+        <p:nvSpPr>
+          <p:cNvPr id="17432" name="TextBox 17431"/>
+          <p:cNvSpPr txBox="1"/>
+          <p:nvPr/>
+        </p:nvSpPr>
+        <p:spPr>
+          <a:xfrm>
+            <a:off x="7635240" y="5925312"/>
+            <a:ext cx="2057400" cy="219456"/>
+          </a:xfrm>
+          <a:prstGeom prst="rect">
+            <a:avLst/>
+          </a:prstGeom>
+          <a:noFill/>
+        </p:spPr>
+        <p:txBody>
+          <a:bodyPr wrap="square" lIns="36576" rIns="36576">
+            <a:spAutoFit/>
+          </a:bodyPr>
+          <a:lstStyle/>
+          <a:p>
+            <a:pPr>
+              <a:lnSpc>
+                <a:spcPct val="100000"/>
+              </a:lnSpc>
+              <a:spcBef>
+                <a:spcPts val="0"/>
+              </a:spcBef>
+              <a:spcAft>
+                <a:spcPts val="0"/>
+              </a:spcAft>
+            </a:pPr>
+            <a:r>
+              <a:rPr sz="1000" b="1">
+                <a:solidFill>
+                  <a:srgbClr val="4F81BD"/>
+                </a:solidFill>
+                <a:latin typeface="Arial"/>
+                <a:hlinkClick r:id="rId13"/>
+              </a:rPr>
+              <a:t>Statistical release portal →</a:t>
+            </a:r>
+          </a:p>
+        </p:txBody>
+      </p:sp>
+      <p:sp>
+        <p:nvSpPr>
+          <p:cNvPr id="17433" name="TextBox 17432"/>
+          <p:cNvSpPr txBox="1"/>
+          <p:nvPr/>
+        </p:nvSpPr>
+        <p:spPr>
+          <a:xfrm>
+            <a:off x="9738359" y="5925312"/>
+            <a:ext cx="2057400" cy="219456"/>
+          </a:xfrm>
+          <a:prstGeom prst="rect">
+            <a:avLst/>
+          </a:prstGeom>
+          <a:noFill/>
+        </p:spPr>
+        <p:txBody>
+          <a:bodyPr wrap="square" lIns="36576" rIns="36576">
+            <a:spAutoFit/>
+          </a:bodyPr>
+          <a:lstStyle/>
+          <a:p>
+            <a:pPr>
+              <a:lnSpc>
+                <a:spcPct val="100000"/>
+              </a:lnSpc>
+              <a:spcBef>
+                <a:spcPts val="0"/>
+              </a:spcBef>
+              <a:spcAft>
+                <a:spcPts val="0"/>
+              </a:spcAft>
+            </a:pPr>
+            <a:r>
+              <a:rPr sz="1000" b="1">
+                <a:solidFill>
+                  <a:srgbClr val="4F81BD"/>
+                </a:solidFill>
+                <a:latin typeface="Arial"/>
+                <a:hlinkClick r:id="rId14"/>
+              </a:rPr>
+              <a:t>Indian aviation market size →</a:t>
             </a:r>
           </a:p>
         </p:txBody>

</xml_diff>

<commit_message>
Slide 6 links become buttons; restore the template's own title and slide-1 typography
Co-Authored-By: Claude Opus 5 <noreply@anthropic.com>
Claude-Session: https://claude.ai/code/session_0129UjVhHMAVJgfcaxoN1dD5
</commit_message>
<xml_diff>
--- a/SIH26056-Idea-Presentation.pptx
+++ b/SIH26056-Idea-Presentation.pptx
@@ -5583,8 +5583,8 @@
         </p:nvSpPr>
         <p:spPr>
           <a:xfrm>
-            <a:off x="384048" y="1965960"/>
-            <a:ext cx="5806440" cy="4526280"/>
+            <a:off x="329184" y="2075688"/>
+            <a:ext cx="5925312" cy="4700016"/>
           </a:xfrm>
           <a:prstGeom prst="rect">
             <a:avLst/>
@@ -5609,7 +5609,7 @@
               </a:spcAft>
             </a:pPr>
             <a:r>
-              <a:rPr sz="1600" b="1">
+              <a:rPr sz="2000" b="1">
                 <a:solidFill>
                   <a:srgbClr val="262B33"/>
                 </a:solidFill>
@@ -5625,14 +5625,14 @@
                 <a:spcPct val="106000"/>
               </a:lnSpc>
               <a:spcBef>
-                <a:spcPts val="1100"/>
-              </a:spcBef>
-              <a:spcAft>
-                <a:spcPts val="0"/>
-              </a:spcAft>
-            </a:pPr>
-            <a:r>
-              <a:rPr sz="1600" b="1">
+                <a:spcPts val="800"/>
+              </a:spcBef>
+              <a:spcAft>
+                <a:spcPts val="0"/>
+              </a:spcAft>
+            </a:pPr>
+            <a:r>
+              <a:rPr sz="2000" b="1">
                 <a:solidFill>
                   <a:srgbClr val="262B33"/>
                 </a:solidFill>
@@ -5647,14 +5647,14 @@
                 <a:spcPct val="106000"/>
               </a:lnSpc>
               <a:spcBef>
-                <a:spcPts val="1100"/>
-              </a:spcBef>
-              <a:spcAft>
-                <a:spcPts val="0"/>
-              </a:spcAft>
-            </a:pPr>
-            <a:r>
-              <a:rPr sz="1600" b="1">
+                <a:spcPts val="800"/>
+              </a:spcBef>
+              <a:spcAft>
+                <a:spcPts val="0"/>
+              </a:spcAft>
+            </a:pPr>
+            <a:r>
+              <a:rPr sz="2000" b="1">
                 <a:solidFill>
                   <a:srgbClr val="262B33"/>
                 </a:solidFill>
@@ -5669,14 +5669,14 @@
                 <a:spcPct val="106000"/>
               </a:lnSpc>
               <a:spcBef>
-                <a:spcPts val="1100"/>
-              </a:spcBef>
-              <a:spcAft>
-                <a:spcPts val="0"/>
-              </a:spcAft>
-            </a:pPr>
-            <a:r>
-              <a:rPr sz="1600" b="1">
+                <a:spcPts val="800"/>
+              </a:spcBef>
+              <a:spcAft>
+                <a:spcPts val="0"/>
+              </a:spcAft>
+            </a:pPr>
+            <a:r>
+              <a:rPr sz="2000" b="1">
                 <a:solidFill>
                   <a:srgbClr val="262B33"/>
                 </a:solidFill>
@@ -5691,14 +5691,14 @@
                 <a:spcPct val="106000"/>
               </a:lnSpc>
               <a:spcBef>
-                <a:spcPts val="1100"/>
-              </a:spcBef>
-              <a:spcAft>
-                <a:spcPts val="0"/>
-              </a:spcAft>
-            </a:pPr>
-            <a:r>
-              <a:rPr sz="1600" b="1">
+                <a:spcPts val="800"/>
+              </a:spcBef>
+              <a:spcAft>
+                <a:spcPts val="0"/>
+              </a:spcAft>
+            </a:pPr>
+            <a:r>
+              <a:rPr sz="2000" b="1">
                 <a:solidFill>
                   <a:srgbClr val="262B33"/>
                 </a:solidFill>
@@ -5713,14 +5713,14 @@
                 <a:spcPct val="106000"/>
               </a:lnSpc>
               <a:spcBef>
-                <a:spcPts val="1100"/>
-              </a:spcBef>
-              <a:spcAft>
-                <a:spcPts val="0"/>
-              </a:spcAft>
-            </a:pPr>
-            <a:r>
-              <a:rPr sz="1600" b="1">
+                <a:spcPts val="800"/>
+              </a:spcBef>
+              <a:spcAft>
+                <a:spcPts val="0"/>
+              </a:spcAft>
+            </a:pPr>
+            <a:r>
+              <a:rPr sz="2000" b="1">
                 <a:solidFill>
                   <a:srgbClr val="262B33"/>
                 </a:solidFill>
@@ -5866,13 +5866,13 @@
           <a:p>
             <a:pPr eaLnBrk="1" hangingPunct="1" algn="ctr"/>
             <a:r>
-              <a:rPr sz="2800" b="1">
+              <a:rPr sz="3600" b="1">
                 <a:solidFill>
                   <a:srgbClr val="1F497D"/>
                 </a:solidFill>
                 <a:latin typeface="Times New Roman"/>
               </a:rPr>
-              <a:t>PROPOSED SOLUTION</a:t>
+              <a:t>APIx — AIRFARE PRICE INDEX</a:t>
             </a:r>
           </a:p>
         </p:txBody>
@@ -5987,7 +5987,7 @@
           </a:fontRef>
         </p:style>
         <p:txBody>
-          <a:bodyPr rtlCol="0" anchor="ctr"/>
+          <a:bodyPr rtlCol="0" anchor="ctr" wrap="square"/>
           <a:lstStyle/>
           <a:p>
             <a:pPr algn="ctr"/>
@@ -6037,8 +6037,8 @@
         </p:nvSpPr>
         <p:spPr>
           <a:xfrm>
-            <a:off x="411480" y="987552"/>
-            <a:ext cx="7726679" cy="859536"/>
+            <a:off x="411480" y="950976"/>
+            <a:ext cx="7726679" cy="896112"/>
           </a:xfrm>
           <a:prstGeom prst="rect">
             <a:avLst/>
@@ -6063,13 +6063,35 @@
               </a:spcAft>
             </a:pPr>
             <a:r>
-              <a:rPr sz="1500" b="1">
+              <a:rPr sz="1050" b="1">
+                <a:solidFill>
+                  <a:srgbClr val="4F81BD"/>
+                </a:solidFill>
+                <a:latin typeface="Arial"/>
+              </a:rPr>
+              <a:t>PROPOSED SOLUTION</a:t>
+            </a:r>
+          </a:p>
+          <a:p>
+            <a:pPr>
+              <a:lnSpc>
+                <a:spcPct val="95000"/>
+              </a:lnSpc>
+              <a:spcBef>
+                <a:spcPts val="200"/>
+              </a:spcBef>
+              <a:spcAft>
+                <a:spcPts val="0"/>
+              </a:spcAft>
+            </a:pPr>
+            <a:r>
+              <a:rPr sz="1450" b="1">
                 <a:solidFill>
                   <a:srgbClr val="1F497D"/>
                 </a:solidFill>
                 <a:latin typeface="Arial"/>
               </a:rPr>
-              <a:t>APIx  —  a daily airfare inflation index built for the CPI</a:t>
+              <a:t>A daily airfare inflation index for the CPI</a:t>
             </a:r>
           </a:p>
           <a:p>
@@ -8517,7 +8539,7 @@
           <a:p>
             <a:pPr eaLnBrk="1" hangingPunct="1" algn="ctr"/>
             <a:r>
-              <a:rPr sz="2800" b="1">
+              <a:rPr sz="3600" b="1">
                 <a:solidFill>
                   <a:srgbClr val="1F497D"/>
                 </a:solidFill>
@@ -8638,7 +8660,7 @@
           </a:fontRef>
         </p:style>
         <p:txBody>
-          <a:bodyPr rtlCol="0" anchor="ctr"/>
+          <a:bodyPr rtlCol="0" anchor="ctr" wrap="square"/>
           <a:lstStyle/>
           <a:p>
             <a:pPr algn="ctr"/>
@@ -11143,7 +11165,7 @@
           <a:p>
             <a:pPr eaLnBrk="1" hangingPunct="1" algn="ctr"/>
             <a:r>
-              <a:rPr sz="2800" b="1">
+              <a:rPr sz="3600" b="1">
                 <a:solidFill>
                   <a:srgbClr val="1F497D"/>
                 </a:solidFill>
@@ -11347,7 +11369,7 @@
           </a:fontRef>
         </p:style>
         <p:txBody>
-          <a:bodyPr rtlCol="0" anchor="ctr"/>
+          <a:bodyPr rtlCol="0" anchor="ctr" wrap="square"/>
           <a:lstStyle/>
           <a:p>
             <a:pPr algn="ctr"/>
@@ -13713,7 +13735,7 @@
           <a:p>
             <a:pPr eaLnBrk="1" hangingPunct="1" algn="ctr"/>
             <a:r>
-              <a:rPr sz="2800" b="1">
+              <a:rPr sz="3600" b="1">
                 <a:solidFill>
                   <a:srgbClr val="1F497D"/>
                 </a:solidFill>
@@ -13917,7 +13939,7 @@
           </a:fontRef>
         </p:style>
         <p:txBody>
-          <a:bodyPr rtlCol="0" anchor="ctr"/>
+          <a:bodyPr rtlCol="0" anchor="ctr" wrap="square"/>
           <a:lstStyle/>
           <a:p>
             <a:pPr algn="ctr"/>
@@ -16033,7 +16055,7 @@
           <a:p>
             <a:pPr eaLnBrk="1" hangingPunct="1" algn="ctr"/>
             <a:r>
-              <a:rPr sz="2800" b="1">
+              <a:rPr sz="3600" b="1">
                 <a:solidFill>
                   <a:srgbClr val="1F497D"/>
                 </a:solidFill>
@@ -16237,7 +16259,7 @@
           </a:fontRef>
         </p:style>
         <p:txBody>
-          <a:bodyPr rtlCol="0" anchor="ctr"/>
+          <a:bodyPr rtlCol="0" anchor="ctr" wrap="square"/>
           <a:lstStyle/>
           <a:p>
             <a:pPr algn="ctr"/>
@@ -16378,7 +16400,7 @@
         <p:spPr>
           <a:xfrm>
             <a:off x="557784" y="1280160"/>
-            <a:ext cx="3410712" cy="1444752"/>
+            <a:ext cx="3410712" cy="1042416"/>
           </a:xfrm>
           <a:prstGeom prst="rect">
             <a:avLst/>
@@ -16386,14 +16408,14 @@
           <a:noFill/>
         </p:spPr>
         <p:txBody>
-          <a:bodyPr wrap="square" lIns="36576" rIns="36576">
+          <a:bodyPr wrap="square" lIns="36576" rIns="36576" tIns="18288" bIns="18288">
             <a:spAutoFit/>
           </a:bodyPr>
           <a:lstStyle/>
           <a:p>
             <a:pPr>
               <a:lnSpc>
-                <a:spcPct val="100000"/>
+                <a:spcPct val="95000"/>
               </a:lnSpc>
               <a:spcBef>
                 <a:spcPts val="0"/>
@@ -16415,7 +16437,7 @@
           <a:p>
             <a:pPr>
               <a:lnSpc>
-                <a:spcPct val="100000"/>
+                <a:spcPct val="95000"/>
               </a:lnSpc>
               <a:spcBef>
                 <a:spcPts val="400"/>
@@ -16434,34 +16456,68 @@
               <a:t>Eurostat, Practical guidelines on web scraping for the HICP (2020). Names air fares explicitly as a scraped category.</a:t>
             </a:r>
           </a:p>
-          <a:p>
-            <a:pPr>
-              <a:lnSpc>
-                <a:spcPct val="100000"/>
-              </a:lnSpc>
-              <a:spcBef>
-                <a:spcPts val="500"/>
-              </a:spcBef>
-              <a:spcAft>
-                <a:spcPts val="0"/>
-              </a:spcAft>
-            </a:pPr>
-            <a:r>
-              <a:rPr sz="1100" b="1">
-                <a:solidFill>
-                  <a:srgbClr val="4F81BD"/>
+        </p:txBody>
+      </p:sp>
+      <p:sp>
+        <p:nvSpPr>
+          <p:cNvPr id="17413" name="Rounded Rectangle 17412">
+            <a:hlinkClick r:id="rId4"/>
+          </p:cNvPr>
+          <p:cNvSpPr/>
+          <p:nvPr/>
+        </p:nvSpPr>
+        <p:spPr>
+          <a:xfrm>
+            <a:off x="557784" y="2414016"/>
+            <a:ext cx="1783080" cy="274320"/>
+          </a:xfrm>
+          <a:prstGeom prst="roundRect">
+            <a:avLst>
+              <a:gd name="adj" fmla="val 6000"/>
+            </a:avLst>
+          </a:prstGeom>
+          <a:solidFill>
+            <a:srgbClr val="4F81BD"/>
+          </a:solidFill>
+          <a:ln>
+            <a:noFill/>
+          </a:ln>
+          <a:effectLst/>
+        </p:spPr>
+        <p:style>
+          <a:lnRef idx="1">
+            <a:schemeClr val="accent1"/>
+          </a:lnRef>
+          <a:fillRef idx="3">
+            <a:schemeClr val="accent1"/>
+          </a:fillRef>
+          <a:effectRef idx="2">
+            <a:schemeClr val="accent1"/>
+          </a:effectRef>
+          <a:fontRef idx="minor">
+            <a:schemeClr val="lt1"/>
+          </a:fontRef>
+        </p:style>
+        <p:txBody>
+          <a:bodyPr rtlCol="0" anchor="ctr" wrap="none" lIns="54864" rIns="54864" tIns="0" bIns="0"/>
+          <a:lstStyle/>
+          <a:p>
+            <a:pPr algn="ctr"/>
+            <a:r>
+              <a:rPr sz="1000" b="1">
+                <a:solidFill>
+                  <a:srgbClr val="FFFFFF"/>
                 </a:solidFill>
                 <a:latin typeface="Arial"/>
-                <a:hlinkClick r:id="rId4"/>
-              </a:rPr>
-              <a:t>Eurostat HICP guidance →</a:t>
-            </a:r>
-          </a:p>
-        </p:txBody>
-      </p:sp>
-      <p:sp>
-        <p:nvSpPr>
-          <p:cNvPr id="17413" name="Rounded Rectangle 17412"/>
+              </a:rPr>
+              <a:t>Eurostat guidance</a:t>
+            </a:r>
+          </a:p>
+        </p:txBody>
+      </p:sp>
+      <p:sp>
+        <p:nvSpPr>
+          <p:cNvPr id="17414" name="Rounded Rectangle 17413"/>
           <p:cNvSpPr/>
           <p:nvPr/>
         </p:nvSpPr>
@@ -16507,7 +16563,7 @@
       </p:sp>
       <p:sp>
         <p:nvSpPr>
-          <p:cNvPr id="17414" name="Rectangle 17413"/>
+          <p:cNvPr id="17415" name="Rectangle 17414"/>
           <p:cNvSpPr/>
           <p:nvPr/>
         </p:nvSpPr>
@@ -16551,14 +16607,14 @@
       </p:sp>
       <p:sp>
         <p:nvSpPr>
-          <p:cNvPr id="17415" name="TextBox 17414"/>
+          <p:cNvPr id="17416" name="TextBox 17415"/>
           <p:cNvSpPr txBox="1"/>
           <p:nvPr/>
         </p:nvSpPr>
         <p:spPr>
           <a:xfrm>
             <a:off x="4517136" y="1280160"/>
-            <a:ext cx="3410712" cy="1444752"/>
+            <a:ext cx="3410712" cy="1042416"/>
           </a:xfrm>
           <a:prstGeom prst="rect">
             <a:avLst/>
@@ -16566,14 +16622,14 @@
           <a:noFill/>
         </p:spPr>
         <p:txBody>
-          <a:bodyPr wrap="square" lIns="36576" rIns="36576">
+          <a:bodyPr wrap="square" lIns="36576" rIns="36576" tIns="18288" bIns="18288">
             <a:spAutoFit/>
           </a:bodyPr>
           <a:lstStyle/>
           <a:p>
             <a:pPr>
               <a:lnSpc>
-                <a:spcPct val="100000"/>
+                <a:spcPct val="95000"/>
               </a:lnSpc>
               <a:spcBef>
                 <a:spcPts val="0"/>
@@ -16595,7 +16651,7 @@
           <a:p>
             <a:pPr>
               <a:lnSpc>
-                <a:spcPct val="100000"/>
+                <a:spcPct val="95000"/>
               </a:lnSpc>
               <a:spcBef>
                 <a:spcPts val="400"/>
@@ -16614,34 +16670,68 @@
               <a:t>ONS ran a web-scraping programme for consumer prices from 2014, Eurostat-funded from 2015.</a:t>
             </a:r>
           </a:p>
-          <a:p>
-            <a:pPr>
-              <a:lnSpc>
-                <a:spcPct val="100000"/>
-              </a:lnSpc>
-              <a:spcBef>
-                <a:spcPts val="500"/>
-              </a:spcBef>
-              <a:spcAft>
-                <a:spcPts val="0"/>
-              </a:spcAft>
-            </a:pPr>
-            <a:r>
-              <a:rPr sz="1100" b="1">
-                <a:solidFill>
-                  <a:srgbClr val="4F81BD"/>
+        </p:txBody>
+      </p:sp>
+      <p:sp>
+        <p:nvSpPr>
+          <p:cNvPr id="17417" name="Rounded Rectangle 17416">
+            <a:hlinkClick r:id="rId5"/>
+          </p:cNvPr>
+          <p:cNvSpPr/>
+          <p:nvPr/>
+        </p:nvSpPr>
+        <p:spPr>
+          <a:xfrm>
+            <a:off x="4517136" y="2414016"/>
+            <a:ext cx="1783080" cy="274320"/>
+          </a:xfrm>
+          <a:prstGeom prst="roundRect">
+            <a:avLst>
+              <a:gd name="adj" fmla="val 6000"/>
+            </a:avLst>
+          </a:prstGeom>
+          <a:solidFill>
+            <a:srgbClr val="1B8A5A"/>
+          </a:solidFill>
+          <a:ln>
+            <a:noFill/>
+          </a:ln>
+          <a:effectLst/>
+        </p:spPr>
+        <p:style>
+          <a:lnRef idx="1">
+            <a:schemeClr val="accent1"/>
+          </a:lnRef>
+          <a:fillRef idx="3">
+            <a:schemeClr val="accent1"/>
+          </a:fillRef>
+          <a:effectRef idx="2">
+            <a:schemeClr val="accent1"/>
+          </a:effectRef>
+          <a:fontRef idx="minor">
+            <a:schemeClr val="lt1"/>
+          </a:fontRef>
+        </p:style>
+        <p:txBody>
+          <a:bodyPr rtlCol="0" anchor="ctr" wrap="none" lIns="54864" rIns="54864" tIns="0" bIns="0"/>
+          <a:lstStyle/>
+          <a:p>
+            <a:pPr algn="ctr"/>
+            <a:r>
+              <a:rPr sz="1000" b="1">
+                <a:solidFill>
+                  <a:srgbClr val="FFFFFF"/>
                 </a:solidFill>
                 <a:latin typeface="Arial"/>
-                <a:hlinkClick r:id="rId5"/>
-              </a:rPr>
-              <a:t>ONS research indices →</a:t>
-            </a:r>
-          </a:p>
-        </p:txBody>
-      </p:sp>
-      <p:sp>
-        <p:nvSpPr>
-          <p:cNvPr id="17416" name="Rounded Rectangle 17415"/>
+              </a:rPr>
+              <a:t>ONS study</a:t>
+            </a:r>
+          </a:p>
+        </p:txBody>
+      </p:sp>
+      <p:sp>
+        <p:nvSpPr>
+          <p:cNvPr id="17418" name="Rounded Rectangle 17417"/>
           <p:cNvSpPr/>
           <p:nvPr/>
         </p:nvSpPr>
@@ -16687,7 +16777,7 @@
       </p:sp>
       <p:sp>
         <p:nvSpPr>
-          <p:cNvPr id="17417" name="Rectangle 17416"/>
+          <p:cNvPr id="17419" name="Rectangle 17418"/>
           <p:cNvSpPr/>
           <p:nvPr/>
         </p:nvSpPr>
@@ -16731,14 +16821,14 @@
       </p:sp>
       <p:sp>
         <p:nvSpPr>
-          <p:cNvPr id="17418" name="TextBox 17417"/>
+          <p:cNvPr id="17420" name="TextBox 17419"/>
           <p:cNvSpPr txBox="1"/>
           <p:nvPr/>
         </p:nvSpPr>
         <p:spPr>
           <a:xfrm>
             <a:off x="8476488" y="1280160"/>
-            <a:ext cx="3410712" cy="1444752"/>
+            <a:ext cx="3410712" cy="1042416"/>
           </a:xfrm>
           <a:prstGeom prst="rect">
             <a:avLst/>
@@ -16746,14 +16836,14 @@
           <a:noFill/>
         </p:spPr>
         <p:txBody>
-          <a:bodyPr wrap="square" lIns="36576" rIns="36576">
+          <a:bodyPr wrap="square" lIns="36576" rIns="36576" tIns="18288" bIns="18288">
             <a:spAutoFit/>
           </a:bodyPr>
           <a:lstStyle/>
           <a:p>
             <a:pPr>
               <a:lnSpc>
-                <a:spcPct val="100000"/>
+                <a:spcPct val="95000"/>
               </a:lnSpc>
               <a:spcBef>
                 <a:spcPts val="0"/>
@@ -16775,7 +16865,7 @@
           <a:p>
             <a:pPr>
               <a:lnSpc>
-                <a:spcPct val="100000"/>
+                <a:spcPct val="95000"/>
               </a:lnSpc>
               <a:spcBef>
                 <a:spcPts val="400"/>
@@ -16794,34 +16884,68 @@
               <a:t>DGCA city-pair statistics: 164 m domestic passengers, IndiGo 64.2%. Our own 1,000-fare sample returned 68.2% — arrived at independently.</a:t>
             </a:r>
           </a:p>
-          <a:p>
-            <a:pPr>
-              <a:lnSpc>
-                <a:spcPct val="100000"/>
-              </a:lnSpc>
-              <a:spcBef>
-                <a:spcPts val="500"/>
-              </a:spcBef>
-              <a:spcAft>
-                <a:spcPts val="0"/>
-              </a:spcAft>
-            </a:pPr>
-            <a:r>
-              <a:rPr sz="1100" b="1">
-                <a:solidFill>
-                  <a:srgbClr val="4F81BD"/>
+        </p:txBody>
+      </p:sp>
+      <p:sp>
+        <p:nvSpPr>
+          <p:cNvPr id="17421" name="Rounded Rectangle 17420">
+            <a:hlinkClick r:id="rId6"/>
+          </p:cNvPr>
+          <p:cNvSpPr/>
+          <p:nvPr/>
+        </p:nvSpPr>
+        <p:spPr>
+          <a:xfrm>
+            <a:off x="8476488" y="2414016"/>
+            <a:ext cx="1783080" cy="274320"/>
+          </a:xfrm>
+          <a:prstGeom prst="roundRect">
+            <a:avLst>
+              <a:gd name="adj" fmla="val 6000"/>
+            </a:avLst>
+          </a:prstGeom>
+          <a:solidFill>
+            <a:srgbClr val="C77700"/>
+          </a:solidFill>
+          <a:ln>
+            <a:noFill/>
+          </a:ln>
+          <a:effectLst/>
+        </p:spPr>
+        <p:style>
+          <a:lnRef idx="1">
+            <a:schemeClr val="accent1"/>
+          </a:lnRef>
+          <a:fillRef idx="3">
+            <a:schemeClr val="accent1"/>
+          </a:fillRef>
+          <a:effectRef idx="2">
+            <a:schemeClr val="accent1"/>
+          </a:effectRef>
+          <a:fontRef idx="minor">
+            <a:schemeClr val="lt1"/>
+          </a:fontRef>
+        </p:style>
+        <p:txBody>
+          <a:bodyPr rtlCol="0" anchor="ctr" wrap="none" lIns="54864" rIns="54864" tIns="0" bIns="0"/>
+          <a:lstStyle/>
+          <a:p>
+            <a:pPr algn="ctr"/>
+            <a:r>
+              <a:rPr sz="1000" b="1">
+                <a:solidFill>
+                  <a:srgbClr val="FFFFFF"/>
                 </a:solidFill>
                 <a:latin typeface="Arial"/>
-                <a:hlinkClick r:id="rId6"/>
-              </a:rPr>
-              <a:t>DGCA monthly statistics →</a:t>
-            </a:r>
-          </a:p>
-        </p:txBody>
-      </p:sp>
-      <p:sp>
-        <p:nvSpPr>
-          <p:cNvPr id="17419" name="Rounded Rectangle 17418"/>
+              </a:rPr>
+              <a:t>DGCA statistics</a:t>
+            </a:r>
+          </a:p>
+        </p:txBody>
+      </p:sp>
+      <p:sp>
+        <p:nvSpPr>
+          <p:cNvPr id="17422" name="Rounded Rectangle 17421"/>
           <p:cNvSpPr/>
           <p:nvPr/>
         </p:nvSpPr>
@@ -16867,7 +16991,7 @@
       </p:sp>
       <p:sp>
         <p:nvSpPr>
-          <p:cNvPr id="17420" name="Rectangle 17419"/>
+          <p:cNvPr id="17423" name="Rectangle 17422"/>
           <p:cNvSpPr/>
           <p:nvPr/>
         </p:nvSpPr>
@@ -16911,14 +17035,14 @@
       </p:sp>
       <p:sp>
         <p:nvSpPr>
-          <p:cNvPr id="17421" name="TextBox 17420"/>
+          <p:cNvPr id="17424" name="TextBox 17423"/>
           <p:cNvSpPr txBox="1"/>
           <p:nvPr/>
         </p:nvSpPr>
         <p:spPr>
           <a:xfrm>
             <a:off x="557784" y="3145536"/>
-            <a:ext cx="3410712" cy="1444752"/>
+            <a:ext cx="3410712" cy="1042416"/>
           </a:xfrm>
           <a:prstGeom prst="rect">
             <a:avLst/>
@@ -16926,14 +17050,14 @@
           <a:noFill/>
         </p:spPr>
         <p:txBody>
-          <a:bodyPr wrap="square" lIns="36576" rIns="36576">
+          <a:bodyPr wrap="square" lIns="36576" rIns="36576" tIns="18288" bIns="18288">
             <a:spAutoFit/>
           </a:bodyPr>
           <a:lstStyle/>
           <a:p>
             <a:pPr>
               <a:lnSpc>
-                <a:spcPct val="100000"/>
+                <a:spcPct val="95000"/>
               </a:lnSpc>
               <a:spcBef>
                 <a:spcPts val="0"/>
@@ -16955,7 +17079,7 @@
           <a:p>
             <a:pPr>
               <a:lnSpc>
-                <a:spcPct val="100000"/>
+                <a:spcPct val="95000"/>
               </a:lnSpc>
               <a:spcBef>
                 <a:spcPts val="400"/>
@@ -16974,34 +17098,68 @@
               <a:t>RFC 9309, the Robots Exclusion Protocol. We implemented it ourselves after finding Python's standard parser reports disallowed paths as allowed.</a:t>
             </a:r>
           </a:p>
-          <a:p>
-            <a:pPr>
-              <a:lnSpc>
-                <a:spcPct val="100000"/>
-              </a:lnSpc>
-              <a:spcBef>
-                <a:spcPts val="500"/>
-              </a:spcBef>
-              <a:spcAft>
-                <a:spcPts val="0"/>
-              </a:spcAft>
-            </a:pPr>
-            <a:r>
-              <a:rPr sz="1100" b="1">
-                <a:solidFill>
-                  <a:srgbClr val="4F81BD"/>
+        </p:txBody>
+      </p:sp>
+      <p:sp>
+        <p:nvSpPr>
+          <p:cNvPr id="17425" name="Rounded Rectangle 17424">
+            <a:hlinkClick r:id="rId7"/>
+          </p:cNvPr>
+          <p:cNvSpPr/>
+          <p:nvPr/>
+        </p:nvSpPr>
+        <p:spPr>
+          <a:xfrm>
+            <a:off x="557784" y="4279392"/>
+            <a:ext cx="1783080" cy="274320"/>
+          </a:xfrm>
+          <a:prstGeom prst="roundRect">
+            <a:avLst>
+              <a:gd name="adj" fmla="val 6000"/>
+            </a:avLst>
+          </a:prstGeom>
+          <a:solidFill>
+            <a:srgbClr val="4B3F8C"/>
+          </a:solidFill>
+          <a:ln>
+            <a:noFill/>
+          </a:ln>
+          <a:effectLst/>
+        </p:spPr>
+        <p:style>
+          <a:lnRef idx="1">
+            <a:schemeClr val="accent1"/>
+          </a:lnRef>
+          <a:fillRef idx="3">
+            <a:schemeClr val="accent1"/>
+          </a:fillRef>
+          <a:effectRef idx="2">
+            <a:schemeClr val="accent1"/>
+          </a:effectRef>
+          <a:fontRef idx="minor">
+            <a:schemeClr val="lt1"/>
+          </a:fontRef>
+        </p:style>
+        <p:txBody>
+          <a:bodyPr rtlCol="0" anchor="ctr" wrap="none" lIns="54864" rIns="54864" tIns="0" bIns="0"/>
+          <a:lstStyle/>
+          <a:p>
+            <a:pPr algn="ctr"/>
+            <a:r>
+              <a:rPr sz="1000" b="1">
+                <a:solidFill>
+                  <a:srgbClr val="FFFFFF"/>
                 </a:solidFill>
                 <a:latin typeface="Arial"/>
-                <a:hlinkClick r:id="rId7"/>
-              </a:rPr>
-              <a:t>RFC 9309 →</a:t>
-            </a:r>
-          </a:p>
-        </p:txBody>
-      </p:sp>
-      <p:sp>
-        <p:nvSpPr>
-          <p:cNvPr id="17422" name="Rounded Rectangle 17421"/>
+              </a:rPr>
+              <a:t>RFC 9309</a:t>
+            </a:r>
+          </a:p>
+        </p:txBody>
+      </p:sp>
+      <p:sp>
+        <p:nvSpPr>
+          <p:cNvPr id="17426" name="Rounded Rectangle 17425"/>
           <p:cNvSpPr/>
           <p:nvPr/>
         </p:nvSpPr>
@@ -17047,7 +17205,7 @@
       </p:sp>
       <p:sp>
         <p:nvSpPr>
-          <p:cNvPr id="17423" name="Rectangle 17422"/>
+          <p:cNvPr id="17427" name="Rectangle 17426"/>
           <p:cNvSpPr/>
           <p:nvPr/>
         </p:nvSpPr>
@@ -17091,14 +17249,14 @@
       </p:sp>
       <p:sp>
         <p:nvSpPr>
-          <p:cNvPr id="17424" name="TextBox 17423"/>
+          <p:cNvPr id="17428" name="TextBox 17427"/>
           <p:cNvSpPr txBox="1"/>
           <p:nvPr/>
         </p:nvSpPr>
         <p:spPr>
           <a:xfrm>
             <a:off x="4517136" y="3145536"/>
-            <a:ext cx="3410712" cy="1444752"/>
+            <a:ext cx="3410712" cy="1042416"/>
           </a:xfrm>
           <a:prstGeom prst="rect">
             <a:avLst/>
@@ -17106,14 +17264,14 @@
           <a:noFill/>
         </p:spPr>
         <p:txBody>
-          <a:bodyPr wrap="square" lIns="36576" rIns="36576">
+          <a:bodyPr wrap="square" lIns="36576" rIns="36576" tIns="18288" bIns="18288">
             <a:spAutoFit/>
           </a:bodyPr>
           <a:lstStyle/>
           <a:p>
             <a:pPr>
               <a:lnSpc>
-                <a:spcPct val="100000"/>
+                <a:spcPct val="95000"/>
               </a:lnSpc>
               <a:spcBef>
                 <a:spcPts val="0"/>
@@ -17135,7 +17293,7 @@
           <a:p>
             <a:pPr>
               <a:lnSpc>
-                <a:spcPct val="100000"/>
+                <a:spcPct val="95000"/>
               </a:lnSpc>
               <a:spcBef>
                 <a:spcPts val="400"/>
@@ -17154,34 +17312,68 @@
               <a:t>MoSPI CPI (Base 2012=100). Field collectors visit shops and markets monthly — the process this augments.</a:t>
             </a:r>
           </a:p>
-          <a:p>
-            <a:pPr>
-              <a:lnSpc>
-                <a:spcPct val="100000"/>
-              </a:lnSpc>
-              <a:spcBef>
-                <a:spcPts val="500"/>
-              </a:spcBef>
-              <a:spcAft>
-                <a:spcPts val="0"/>
-              </a:spcAft>
-            </a:pPr>
-            <a:r>
-              <a:rPr sz="1100" b="1">
-                <a:solidFill>
-                  <a:srgbClr val="4F81BD"/>
+        </p:txBody>
+      </p:sp>
+      <p:sp>
+        <p:nvSpPr>
+          <p:cNvPr id="17429" name="Rounded Rectangle 17428">
+            <a:hlinkClick r:id="rId8"/>
+          </p:cNvPr>
+          <p:cNvSpPr/>
+          <p:nvPr/>
+        </p:nvSpPr>
+        <p:spPr>
+          <a:xfrm>
+            <a:off x="4517136" y="4279392"/>
+            <a:ext cx="1783080" cy="274320"/>
+          </a:xfrm>
+          <a:prstGeom prst="roundRect">
+            <a:avLst>
+              <a:gd name="adj" fmla="val 6000"/>
+            </a:avLst>
+          </a:prstGeom>
+          <a:solidFill>
+            <a:srgbClr val="0E7C86"/>
+          </a:solidFill>
+          <a:ln>
+            <a:noFill/>
+          </a:ln>
+          <a:effectLst/>
+        </p:spPr>
+        <p:style>
+          <a:lnRef idx="1">
+            <a:schemeClr val="accent1"/>
+          </a:lnRef>
+          <a:fillRef idx="3">
+            <a:schemeClr val="accent1"/>
+          </a:fillRef>
+          <a:effectRef idx="2">
+            <a:schemeClr val="accent1"/>
+          </a:effectRef>
+          <a:fontRef idx="minor">
+            <a:schemeClr val="lt1"/>
+          </a:fontRef>
+        </p:style>
+        <p:txBody>
+          <a:bodyPr rtlCol="0" anchor="ctr" wrap="none" lIns="54864" rIns="54864" tIns="0" bIns="0"/>
+          <a:lstStyle/>
+          <a:p>
+            <a:pPr algn="ctr"/>
+            <a:r>
+              <a:rPr sz="1000" b="1">
+                <a:solidFill>
+                  <a:srgbClr val="FFFFFF"/>
                 </a:solidFill>
                 <a:latin typeface="Arial"/>
-                <a:hlinkClick r:id="rId8"/>
-              </a:rPr>
-              <a:t>MoSPI CPI series →</a:t>
-            </a:r>
-          </a:p>
-        </p:txBody>
-      </p:sp>
-      <p:sp>
-        <p:nvSpPr>
-          <p:cNvPr id="17425" name="Rounded Rectangle 17424"/>
+              </a:rPr>
+              <a:t>MoSPI CPI series</a:t>
+            </a:r>
+          </a:p>
+        </p:txBody>
+      </p:sp>
+      <p:sp>
+        <p:nvSpPr>
+          <p:cNvPr id="17430" name="Rounded Rectangle 17429"/>
           <p:cNvSpPr/>
           <p:nvPr/>
         </p:nvSpPr>
@@ -17227,7 +17419,7 @@
       </p:sp>
       <p:sp>
         <p:nvSpPr>
-          <p:cNvPr id="17426" name="Rectangle 17425"/>
+          <p:cNvPr id="17431" name="Rectangle 17430"/>
           <p:cNvSpPr/>
           <p:nvPr/>
         </p:nvSpPr>
@@ -17271,14 +17463,14 @@
       </p:sp>
       <p:sp>
         <p:nvSpPr>
-          <p:cNvPr id="17427" name="TextBox 17426"/>
+          <p:cNvPr id="17432" name="TextBox 17431"/>
           <p:cNvSpPr txBox="1"/>
           <p:nvPr/>
         </p:nvSpPr>
         <p:spPr>
           <a:xfrm>
             <a:off x="8476488" y="3145536"/>
-            <a:ext cx="3410712" cy="1444752"/>
+            <a:ext cx="3410712" cy="1042416"/>
           </a:xfrm>
           <a:prstGeom prst="rect">
             <a:avLst/>
@@ -17286,14 +17478,14 @@
           <a:noFill/>
         </p:spPr>
         <p:txBody>
-          <a:bodyPr wrap="square" lIns="36576" rIns="36576">
+          <a:bodyPr wrap="square" lIns="36576" rIns="36576" tIns="18288" bIns="18288">
             <a:spAutoFit/>
           </a:bodyPr>
           <a:lstStyle/>
           <a:p>
             <a:pPr>
               <a:lnSpc>
-                <a:spcPct val="100000"/>
+                <a:spcPct val="95000"/>
               </a:lnSpc>
               <a:spcBef>
                 <a:spcPts val="0"/>
@@ -17315,7 +17507,7 @@
           <a:p>
             <a:pPr>
               <a:lnSpc>
-                <a:spcPct val="100000"/>
+                <a:spcPct val="95000"/>
               </a:lnSpc>
               <a:spcBef>
                 <a:spcPts val="400"/>
@@ -17331,37 +17523,72 @@
                 </a:solidFill>
                 <a:latin typeface="Arial"/>
               </a:rPr>
-              <a:t>Collector, index engine, export API and portal. The README documents the method, the exclusion rules and the publication threshold.</a:t>
-            </a:r>
-          </a:p>
-          <a:p>
-            <a:pPr>
-              <a:lnSpc>
-                <a:spcPct val="100000"/>
-              </a:lnSpc>
-              <a:spcBef>
-                <a:spcPts val="500"/>
-              </a:spcBef>
-              <a:spcAft>
-                <a:spcPts val="0"/>
-              </a:spcAft>
-            </a:pPr>
-            <a:r>
-              <a:rPr sz="1100" b="1">
-                <a:solidFill>
-                  <a:srgbClr val="4F81BD"/>
+              <a:t>Collector, index engine, export API and portal. The README documents the method and the publication threshold.
+github.com/BradCage-afk/sih-2026-airfare-index</a:t>
+            </a:r>
+          </a:p>
+        </p:txBody>
+      </p:sp>
+      <p:sp>
+        <p:nvSpPr>
+          <p:cNvPr id="17433" name="Rounded Rectangle 17432">
+            <a:hlinkClick r:id="rId9"/>
+          </p:cNvPr>
+          <p:cNvSpPr/>
+          <p:nvPr/>
+        </p:nvSpPr>
+        <p:spPr>
+          <a:xfrm>
+            <a:off x="8476488" y="4279392"/>
+            <a:ext cx="1783080" cy="274320"/>
+          </a:xfrm>
+          <a:prstGeom prst="roundRect">
+            <a:avLst>
+              <a:gd name="adj" fmla="val 6000"/>
+            </a:avLst>
+          </a:prstGeom>
+          <a:solidFill>
+            <a:srgbClr val="7A3E6B"/>
+          </a:solidFill>
+          <a:ln>
+            <a:noFill/>
+          </a:ln>
+          <a:effectLst/>
+        </p:spPr>
+        <p:style>
+          <a:lnRef idx="1">
+            <a:schemeClr val="accent1"/>
+          </a:lnRef>
+          <a:fillRef idx="3">
+            <a:schemeClr val="accent1"/>
+          </a:fillRef>
+          <a:effectRef idx="2">
+            <a:schemeClr val="accent1"/>
+          </a:effectRef>
+          <a:fontRef idx="minor">
+            <a:schemeClr val="lt1"/>
+          </a:fontRef>
+        </p:style>
+        <p:txBody>
+          <a:bodyPr rtlCol="0" anchor="ctr" wrap="none" lIns="54864" rIns="54864" tIns="0" bIns="0"/>
+          <a:lstStyle/>
+          <a:p>
+            <a:pPr algn="ctr"/>
+            <a:r>
+              <a:rPr sz="1000" b="1">
+                <a:solidFill>
+                  <a:srgbClr val="FFFFFF"/>
                 </a:solidFill>
                 <a:latin typeface="Arial"/>
-                <a:hlinkClick r:id="rId9"/>
-              </a:rPr>
-              <a:t>github.com/BradCage-afk/sih-2026-airfare-index →</a:t>
+              </a:rPr>
+              <a:t>Open the repo</a:t>
             </a:r>
           </a:p>
         </p:txBody>
       </p:sp>
       <p:pic>
         <p:nvPicPr>
-          <p:cNvPr id="17428" name="Picture 17427" descr="chart-survey.png"/>
+          <p:cNvPr id="17434" name="Picture 17433" descr="chart-survey.png"/>
           <p:cNvPicPr>
             <a:picLocks noChangeAspect="1"/>
           </p:cNvPicPr>
@@ -17385,7 +17612,7 @@
       </p:pic>
       <p:sp>
         <p:nvSpPr>
-          <p:cNvPr id="17429" name="TextBox 17428"/>
+          <p:cNvPr id="17435" name="TextBox 17434"/>
           <p:cNvSpPr txBox="1"/>
           <p:nvPr/>
         </p:nvSpPr>
@@ -17454,7 +17681,7 @@
                 <a:spcPct val="100000"/>
               </a:lnSpc>
               <a:spcBef>
-                <a:spcPts val="500"/>
+                <a:spcPts val="600"/>
               </a:spcBef>
               <a:spcAft>
                 <a:spcPts val="0"/>
@@ -17463,195 +17690,239 @@
             <a:r>
               <a:rPr sz="1150" b="1">
                 <a:solidFill>
-                  <a:srgbClr val="4F81BD"/>
+                  <a:srgbClr val="1F497D"/>
                 </a:solidFill>
                 <a:latin typeface="Arial"/>
-                <a:hlinkClick r:id="rId11"/>
-              </a:rPr>
-              <a:t>Live API and interactive documentation →</a:t>
-            </a:r>
-          </a:p>
-        </p:txBody>
-      </p:sp>
-      <p:sp>
-        <p:nvSpPr>
-          <p:cNvPr id="17430" name="TextBox 17429"/>
-          <p:cNvSpPr txBox="1"/>
-          <p:nvPr/>
-        </p:nvSpPr>
-        <p:spPr>
-          <a:xfrm>
-            <a:off x="4800600" y="5925312"/>
-            <a:ext cx="731520" cy="219456"/>
-          </a:xfrm>
-          <a:prstGeom prst="rect">
-            <a:avLst/>
-          </a:prstGeom>
-          <a:noFill/>
-        </p:spPr>
-        <p:txBody>
-          <a:bodyPr wrap="square" lIns="36576" rIns="36576" tIns="18288" bIns="18288">
-            <a:spAutoFit/>
-          </a:bodyPr>
-          <a:lstStyle/>
-          <a:p>
-            <a:pPr>
-              <a:lnSpc>
-                <a:spcPct val="95000"/>
-              </a:lnSpc>
-              <a:spcBef>
-                <a:spcPts val="0"/>
-              </a:spcBef>
-              <a:spcAft>
-                <a:spcPts val="0"/>
-              </a:spcAft>
-            </a:pPr>
-            <a:r>
-              <a:rPr sz="950" b="1">
-                <a:solidFill>
-                  <a:srgbClr val="5A626C"/>
+              </a:rPr>
+              <a:t>Everything in this deck is checkable against a live system:</a:t>
+            </a:r>
+          </a:p>
+        </p:txBody>
+      </p:sp>
+      <p:sp>
+        <p:nvSpPr>
+          <p:cNvPr id="17436" name="Rounded Rectangle 17435">
+            <a:hlinkClick r:id="rId11"/>
+          </p:cNvPr>
+          <p:cNvSpPr/>
+          <p:nvPr/>
+        </p:nvSpPr>
+        <p:spPr>
+          <a:xfrm>
+            <a:off x="4800600" y="5870448"/>
+            <a:ext cx="1627631" cy="310896"/>
+          </a:xfrm>
+          <a:prstGeom prst="roundRect">
+            <a:avLst>
+              <a:gd name="adj" fmla="val 6000"/>
+            </a:avLst>
+          </a:prstGeom>
+          <a:solidFill>
+            <a:srgbClr val="1F497D"/>
+          </a:solidFill>
+          <a:ln>
+            <a:noFill/>
+          </a:ln>
+          <a:effectLst/>
+        </p:spPr>
+        <p:style>
+          <a:lnRef idx="1">
+            <a:schemeClr val="accent1"/>
+          </a:lnRef>
+          <a:fillRef idx="3">
+            <a:schemeClr val="accent1"/>
+          </a:fillRef>
+          <a:effectRef idx="2">
+            <a:schemeClr val="accent1"/>
+          </a:effectRef>
+          <a:fontRef idx="minor">
+            <a:schemeClr val="lt1"/>
+          </a:fontRef>
+        </p:style>
+        <p:txBody>
+          <a:bodyPr rtlCol="0" anchor="ctr" wrap="none" lIns="54864" rIns="54864" tIns="0" bIns="0"/>
+          <a:lstStyle/>
+          <a:p>
+            <a:pPr algn="ctr"/>
+            <a:r>
+              <a:rPr sz="1050" b="1">
+                <a:solidFill>
+                  <a:srgbClr val="FFFFFF"/>
                 </a:solidFill>
                 <a:latin typeface="Arial"/>
               </a:rPr>
-              <a:t>ALSO</a:t>
-            </a:r>
-          </a:p>
-        </p:txBody>
-      </p:sp>
-      <p:sp>
-        <p:nvSpPr>
-          <p:cNvPr id="17431" name="TextBox 17430"/>
-          <p:cNvSpPr txBox="1"/>
-          <p:nvPr/>
-        </p:nvSpPr>
-        <p:spPr>
-          <a:xfrm>
-            <a:off x="5532120" y="5925312"/>
-            <a:ext cx="2057400" cy="219456"/>
-          </a:xfrm>
-          <a:prstGeom prst="rect">
-            <a:avLst/>
-          </a:prstGeom>
-          <a:noFill/>
-        </p:spPr>
-        <p:txBody>
-          <a:bodyPr wrap="square" lIns="36576" rIns="36576">
-            <a:spAutoFit/>
-          </a:bodyPr>
-          <a:lstStyle/>
-          <a:p>
-            <a:pPr>
-              <a:lnSpc>
-                <a:spcPct val="100000"/>
-              </a:lnSpc>
-              <a:spcBef>
-                <a:spcPts val="0"/>
-              </a:spcBef>
-              <a:spcAft>
-                <a:spcPts val="0"/>
-              </a:spcAft>
-            </a:pPr>
-            <a:r>
-              <a:rPr sz="1000" b="1">
-                <a:solidFill>
-                  <a:srgbClr val="4F81BD"/>
+              <a:t>Live API docs</a:t>
+            </a:r>
+          </a:p>
+        </p:txBody>
+      </p:sp>
+      <p:sp>
+        <p:nvSpPr>
+          <p:cNvPr id="17437" name="Rounded Rectangle 17436">
+            <a:hlinkClick r:id="rId12"/>
+          </p:cNvPr>
+          <p:cNvSpPr/>
+          <p:nvPr/>
+        </p:nvSpPr>
+        <p:spPr>
+          <a:xfrm>
+            <a:off x="6574536" y="5870448"/>
+            <a:ext cx="1627631" cy="310896"/>
+          </a:xfrm>
+          <a:prstGeom prst="roundRect">
+            <a:avLst>
+              <a:gd name="adj" fmla="val 6000"/>
+            </a:avLst>
+          </a:prstGeom>
+          <a:solidFill>
+            <a:srgbClr val="1B8A5A"/>
+          </a:solidFill>
+          <a:ln>
+            <a:noFill/>
+          </a:ln>
+          <a:effectLst/>
+        </p:spPr>
+        <p:style>
+          <a:lnRef idx="1">
+            <a:schemeClr val="accent1"/>
+          </a:lnRef>
+          <a:fillRef idx="3">
+            <a:schemeClr val="accent1"/>
+          </a:fillRef>
+          <a:effectRef idx="2">
+            <a:schemeClr val="accent1"/>
+          </a:effectRef>
+          <a:fontRef idx="minor">
+            <a:schemeClr val="lt1"/>
+          </a:fontRef>
+        </p:style>
+        <p:txBody>
+          <a:bodyPr rtlCol="0" anchor="ctr" wrap="none" lIns="54864" rIns="54864" tIns="0" bIns="0"/>
+          <a:lstStyle/>
+          <a:p>
+            <a:pPr algn="ctr"/>
+            <a:r>
+              <a:rPr sz="1050" b="1">
+                <a:solidFill>
+                  <a:srgbClr val="FFFFFF"/>
                 </a:solidFill>
                 <a:latin typeface="Arial"/>
-                <a:hlinkClick r:id="rId12"/>
-              </a:rPr>
-              <a:t>README and method notes →</a:t>
-            </a:r>
-          </a:p>
-        </p:txBody>
-      </p:sp>
-      <p:sp>
-        <p:nvSpPr>
-          <p:cNvPr id="17432" name="TextBox 17431"/>
-          <p:cNvSpPr txBox="1"/>
-          <p:nvPr/>
-        </p:nvSpPr>
-        <p:spPr>
-          <a:xfrm>
-            <a:off x="7635240" y="5925312"/>
-            <a:ext cx="2057400" cy="219456"/>
-          </a:xfrm>
-          <a:prstGeom prst="rect">
-            <a:avLst/>
-          </a:prstGeom>
-          <a:noFill/>
-        </p:spPr>
-        <p:txBody>
-          <a:bodyPr wrap="square" lIns="36576" rIns="36576">
-            <a:spAutoFit/>
-          </a:bodyPr>
-          <a:lstStyle/>
-          <a:p>
-            <a:pPr>
-              <a:lnSpc>
-                <a:spcPct val="100000"/>
-              </a:lnSpc>
-              <a:spcBef>
-                <a:spcPts val="0"/>
-              </a:spcBef>
-              <a:spcAft>
-                <a:spcPts val="0"/>
-              </a:spcAft>
-            </a:pPr>
-            <a:r>
-              <a:rPr sz="1000" b="1">
-                <a:solidFill>
-                  <a:srgbClr val="4F81BD"/>
+              </a:rPr>
+              <a:t>Release portal</a:t>
+            </a:r>
+          </a:p>
+        </p:txBody>
+      </p:sp>
+      <p:sp>
+        <p:nvSpPr>
+          <p:cNvPr id="17438" name="Rounded Rectangle 17437">
+            <a:hlinkClick r:id="rId13"/>
+          </p:cNvPr>
+          <p:cNvSpPr/>
+          <p:nvPr/>
+        </p:nvSpPr>
+        <p:spPr>
+          <a:xfrm>
+            <a:off x="8348471" y="5870448"/>
+            <a:ext cx="1627631" cy="310896"/>
+          </a:xfrm>
+          <a:prstGeom prst="roundRect">
+            <a:avLst>
+              <a:gd name="adj" fmla="val 6000"/>
+            </a:avLst>
+          </a:prstGeom>
+          <a:solidFill>
+            <a:srgbClr val="4B3F8C"/>
+          </a:solidFill>
+          <a:ln>
+            <a:noFill/>
+          </a:ln>
+          <a:effectLst/>
+        </p:spPr>
+        <p:style>
+          <a:lnRef idx="1">
+            <a:schemeClr val="accent1"/>
+          </a:lnRef>
+          <a:fillRef idx="3">
+            <a:schemeClr val="accent1"/>
+          </a:fillRef>
+          <a:effectRef idx="2">
+            <a:schemeClr val="accent1"/>
+          </a:effectRef>
+          <a:fontRef idx="minor">
+            <a:schemeClr val="lt1"/>
+          </a:fontRef>
+        </p:style>
+        <p:txBody>
+          <a:bodyPr rtlCol="0" anchor="ctr" wrap="none" lIns="54864" rIns="54864" tIns="0" bIns="0"/>
+          <a:lstStyle/>
+          <a:p>
+            <a:pPr algn="ctr"/>
+            <a:r>
+              <a:rPr sz="1050" b="1">
+                <a:solidFill>
+                  <a:srgbClr val="FFFFFF"/>
                 </a:solidFill>
                 <a:latin typeface="Arial"/>
-                <a:hlinkClick r:id="rId13"/>
-              </a:rPr>
-              <a:t>Statistical release portal →</a:t>
-            </a:r>
-          </a:p>
-        </p:txBody>
-      </p:sp>
-      <p:sp>
-        <p:nvSpPr>
-          <p:cNvPr id="17433" name="TextBox 17432"/>
-          <p:cNvSpPr txBox="1"/>
-          <p:nvPr/>
-        </p:nvSpPr>
-        <p:spPr>
-          <a:xfrm>
-            <a:off x="9738359" y="5925312"/>
-            <a:ext cx="2057400" cy="219456"/>
-          </a:xfrm>
-          <a:prstGeom prst="rect">
-            <a:avLst/>
-          </a:prstGeom>
-          <a:noFill/>
-        </p:spPr>
-        <p:txBody>
-          <a:bodyPr wrap="square" lIns="36576" rIns="36576">
-            <a:spAutoFit/>
-          </a:bodyPr>
-          <a:lstStyle/>
-          <a:p>
-            <a:pPr>
-              <a:lnSpc>
-                <a:spcPct val="100000"/>
-              </a:lnSpc>
-              <a:spcBef>
-                <a:spcPts val="0"/>
-              </a:spcBef>
-              <a:spcAft>
-                <a:spcPts val="0"/>
-              </a:spcAft>
-            </a:pPr>
-            <a:r>
-              <a:rPr sz="1000" b="1">
-                <a:solidFill>
-                  <a:srgbClr val="4F81BD"/>
+              </a:rPr>
+              <a:t>README + method</a:t>
+            </a:r>
+          </a:p>
+        </p:txBody>
+      </p:sp>
+      <p:sp>
+        <p:nvSpPr>
+          <p:cNvPr id="17439" name="Rounded Rectangle 17438">
+            <a:hlinkClick r:id="rId14"/>
+          </p:cNvPr>
+          <p:cNvSpPr/>
+          <p:nvPr/>
+        </p:nvSpPr>
+        <p:spPr>
+          <a:xfrm>
+            <a:off x="10122408" y="5870448"/>
+            <a:ext cx="1627631" cy="310896"/>
+          </a:xfrm>
+          <a:prstGeom prst="roundRect">
+            <a:avLst>
+              <a:gd name="adj" fmla="val 6000"/>
+            </a:avLst>
+          </a:prstGeom>
+          <a:solidFill>
+            <a:srgbClr val="0E7C86"/>
+          </a:solidFill>
+          <a:ln>
+            <a:noFill/>
+          </a:ln>
+          <a:effectLst/>
+        </p:spPr>
+        <p:style>
+          <a:lnRef idx="1">
+            <a:schemeClr val="accent1"/>
+          </a:lnRef>
+          <a:fillRef idx="3">
+            <a:schemeClr val="accent1"/>
+          </a:fillRef>
+          <a:effectRef idx="2">
+            <a:schemeClr val="accent1"/>
+          </a:effectRef>
+          <a:fontRef idx="minor">
+            <a:schemeClr val="lt1"/>
+          </a:fontRef>
+        </p:style>
+        <p:txBody>
+          <a:bodyPr rtlCol="0" anchor="ctr" wrap="none" lIns="54864" rIns="54864" tIns="0" bIns="0"/>
+          <a:lstStyle/>
+          <a:p>
+            <a:pPr algn="ctr"/>
+            <a:r>
+              <a:rPr sz="1050" b="1">
+                <a:solidFill>
+                  <a:srgbClr val="FFFFFF"/>
                 </a:solidFill>
                 <a:latin typeface="Arial"/>
-                <a:hlinkClick r:id="rId14"/>
-              </a:rPr>
-              <a:t>Indian aviation market size →</a:t>
+              </a:rPr>
+              <a:t>Market data</a:t>
             </a:r>
           </a:p>
         </p:txBody>

</xml_diff>

<commit_message>
Slide 6: replace buttons with underlined text hyperlinks, matching the reference deck
Whole card carries the hyperlink, with a small underlined link at its lower
right and a note that the cards are clickable - the treatment used on the
SIH1645 references slide.

Co-Authored-By: Claude Opus 5 <noreply@anthropic.com>
Claude-Session: https://claude.ai/code/session_0129UjVhHMAVJgfcaxoN1dD5
</commit_message>
<xml_diff>
--- a/SIH26056-Idea-Presentation.pptx
+++ b/SIH26056-Idea-Presentation.pptx
@@ -16303,14 +16303,61 @@
       </p:pic>
       <p:sp>
         <p:nvSpPr>
-          <p:cNvPr id="17410" name="Rounded Rectangle 17409"/>
+          <p:cNvPr id="17410" name="TextBox 17409"/>
+          <p:cNvSpPr txBox="1"/>
+          <p:nvPr/>
+        </p:nvSpPr>
+        <p:spPr>
+          <a:xfrm>
+            <a:off x="411480" y="1060704"/>
+            <a:ext cx="5486400" cy="219456"/>
+          </a:xfrm>
+          <a:prstGeom prst="rect">
+            <a:avLst/>
+          </a:prstGeom>
+          <a:noFill/>
+        </p:spPr>
+        <p:txBody>
+          <a:bodyPr wrap="square" lIns="36576" rIns="36576" tIns="18288" bIns="18288">
+            <a:spAutoFit/>
+          </a:bodyPr>
+          <a:lstStyle/>
+          <a:p>
+            <a:pPr>
+              <a:lnSpc>
+                <a:spcPct val="95000"/>
+              </a:lnSpc>
+              <a:spcBef>
+                <a:spcPts val="0"/>
+              </a:spcBef>
+              <a:spcAft>
+                <a:spcPts val="0"/>
+              </a:spcAft>
+            </a:pPr>
+            <a:r>
+              <a:rPr sz="950" b="1">
+                <a:solidFill>
+                  <a:srgbClr val="5A626C"/>
+                </a:solidFill>
+                <a:latin typeface="Arial"/>
+              </a:rPr>
+              <a:t>EVERY CARD IS CLICKABLE — THE UNDERLINED LINK OPENS THE SOURCE</a:t>
+            </a:r>
+          </a:p>
+        </p:txBody>
+      </p:sp>
+      <p:sp>
+        <p:nvSpPr>
+          <p:cNvPr id="17411" name="Rounded Rectangle 17410">
+            <a:hlinkClick r:id="rId4"/>
+          </p:cNvPr>
           <p:cNvSpPr/>
           <p:nvPr/>
         </p:nvSpPr>
         <p:spPr>
           <a:xfrm>
-            <a:off x="411480" y="1133856"/>
-            <a:ext cx="3703320" cy="1700784"/>
+            <a:off x="411480" y="1335024"/>
+            <a:ext cx="3703320" cy="1627632"/>
           </a:xfrm>
           <a:prstGeom prst="roundRect">
             <a:avLst>
@@ -16349,13 +16396,13 @@
       </p:sp>
       <p:sp>
         <p:nvSpPr>
-          <p:cNvPr id="17411" name="Rectangle 17410"/>
+          <p:cNvPr id="17412" name="Rectangle 17411"/>
           <p:cNvSpPr/>
           <p:nvPr/>
         </p:nvSpPr>
         <p:spPr>
           <a:xfrm>
-            <a:off x="411480" y="1133856"/>
+            <a:off x="411480" y="1335024"/>
             <a:ext cx="3703320" cy="64008"/>
           </a:xfrm>
           <a:prstGeom prst="rect">
@@ -16393,14 +16440,14 @@
       </p:sp>
       <p:sp>
         <p:nvSpPr>
-          <p:cNvPr id="17412" name="TextBox 17411"/>
+          <p:cNvPr id="17413" name="TextBox 17412"/>
           <p:cNvSpPr txBox="1"/>
           <p:nvPr/>
         </p:nvSpPr>
         <p:spPr>
           <a:xfrm>
-            <a:off x="557784" y="1280160"/>
-            <a:ext cx="3410712" cy="1042416"/>
+            <a:off x="557784" y="1463040"/>
+            <a:ext cx="3410712" cy="1207008"/>
           </a:xfrm>
           <a:prstGeom prst="rect">
             <a:avLst/>
@@ -16460,71 +16507,52 @@
       </p:sp>
       <p:sp>
         <p:nvSpPr>
-          <p:cNvPr id="17413" name="Rounded Rectangle 17412">
-            <a:hlinkClick r:id="rId4"/>
+          <p:cNvPr id="17414" name="TextBox 17413"/>
+          <p:cNvSpPr txBox="1"/>
+          <p:nvPr/>
+        </p:nvSpPr>
+        <p:spPr>
+          <a:xfrm>
+            <a:off x="1956816" y="2706624"/>
+            <a:ext cx="2011680" cy="219456"/>
+          </a:xfrm>
+          <a:prstGeom prst="rect">
+            <a:avLst/>
+          </a:prstGeom>
+          <a:noFill/>
+        </p:spPr>
+        <p:txBody>
+          <a:bodyPr wrap="none" lIns="0" rIns="0" tIns="0" bIns="0">
+            <a:spAutoFit/>
+          </a:bodyPr>
+          <a:lstStyle/>
+          <a:p>
+            <a:pPr algn="r"/>
+            <a:r>
+              <a:rPr sz="1050" b="1" u="sng">
+                <a:solidFill>
+                  <a:srgbClr val="4F81BD"/>
+                </a:solidFill>
+                <a:latin typeface="Arial"/>
+                <a:hlinkClick r:id="rId4"/>
+              </a:rPr>
+              <a:t>Eurostat guidance</a:t>
+            </a:r>
+          </a:p>
+        </p:txBody>
+      </p:sp>
+      <p:sp>
+        <p:nvSpPr>
+          <p:cNvPr id="17415" name="Rounded Rectangle 17414">
+            <a:hlinkClick r:id="rId5"/>
           </p:cNvPr>
           <p:cNvSpPr/>
           <p:nvPr/>
         </p:nvSpPr>
         <p:spPr>
           <a:xfrm>
-            <a:off x="557784" y="2414016"/>
-            <a:ext cx="1783080" cy="274320"/>
-          </a:xfrm>
-          <a:prstGeom prst="roundRect">
-            <a:avLst>
-              <a:gd name="adj" fmla="val 6000"/>
-            </a:avLst>
-          </a:prstGeom>
-          <a:solidFill>
-            <a:srgbClr val="4F81BD"/>
-          </a:solidFill>
-          <a:ln>
-            <a:noFill/>
-          </a:ln>
-          <a:effectLst/>
-        </p:spPr>
-        <p:style>
-          <a:lnRef idx="1">
-            <a:schemeClr val="accent1"/>
-          </a:lnRef>
-          <a:fillRef idx="3">
-            <a:schemeClr val="accent1"/>
-          </a:fillRef>
-          <a:effectRef idx="2">
-            <a:schemeClr val="accent1"/>
-          </a:effectRef>
-          <a:fontRef idx="minor">
-            <a:schemeClr val="lt1"/>
-          </a:fontRef>
-        </p:style>
-        <p:txBody>
-          <a:bodyPr rtlCol="0" anchor="ctr" wrap="none" lIns="54864" rIns="54864" tIns="0" bIns="0"/>
-          <a:lstStyle/>
-          <a:p>
-            <a:pPr algn="ctr"/>
-            <a:r>
-              <a:rPr sz="1000" b="1">
-                <a:solidFill>
-                  <a:srgbClr val="FFFFFF"/>
-                </a:solidFill>
-                <a:latin typeface="Arial"/>
-              </a:rPr>
-              <a:t>Eurostat guidance</a:t>
-            </a:r>
-          </a:p>
-        </p:txBody>
-      </p:sp>
-      <p:sp>
-        <p:nvSpPr>
-          <p:cNvPr id="17414" name="Rounded Rectangle 17413"/>
-          <p:cNvSpPr/>
-          <p:nvPr/>
-        </p:nvSpPr>
-        <p:spPr>
-          <a:xfrm>
-            <a:off x="4370832" y="1133856"/>
-            <a:ext cx="3703320" cy="1700784"/>
+            <a:off x="4370832" y="1335024"/>
+            <a:ext cx="3703320" cy="1627632"/>
           </a:xfrm>
           <a:prstGeom prst="roundRect">
             <a:avLst>
@@ -16563,13 +16591,13 @@
       </p:sp>
       <p:sp>
         <p:nvSpPr>
-          <p:cNvPr id="17415" name="Rectangle 17414"/>
+          <p:cNvPr id="17416" name="Rectangle 17415"/>
           <p:cNvSpPr/>
           <p:nvPr/>
         </p:nvSpPr>
         <p:spPr>
           <a:xfrm>
-            <a:off x="4370832" y="1133856"/>
+            <a:off x="4370832" y="1335024"/>
             <a:ext cx="3703320" cy="64008"/>
           </a:xfrm>
           <a:prstGeom prst="rect">
@@ -16607,14 +16635,14 @@
       </p:sp>
       <p:sp>
         <p:nvSpPr>
-          <p:cNvPr id="17416" name="TextBox 17415"/>
+          <p:cNvPr id="17417" name="TextBox 17416"/>
           <p:cNvSpPr txBox="1"/>
           <p:nvPr/>
         </p:nvSpPr>
         <p:spPr>
           <a:xfrm>
-            <a:off x="4517136" y="1280160"/>
-            <a:ext cx="3410712" cy="1042416"/>
+            <a:off x="4517136" y="1463040"/>
+            <a:ext cx="3410712" cy="1207008"/>
           </a:xfrm>
           <a:prstGeom prst="rect">
             <a:avLst/>
@@ -16674,71 +16702,52 @@
       </p:sp>
       <p:sp>
         <p:nvSpPr>
-          <p:cNvPr id="17417" name="Rounded Rectangle 17416">
-            <a:hlinkClick r:id="rId5"/>
+          <p:cNvPr id="17418" name="TextBox 17417"/>
+          <p:cNvSpPr txBox="1"/>
+          <p:nvPr/>
+        </p:nvSpPr>
+        <p:spPr>
+          <a:xfrm>
+            <a:off x="5916168" y="2706624"/>
+            <a:ext cx="2011680" cy="219456"/>
+          </a:xfrm>
+          <a:prstGeom prst="rect">
+            <a:avLst/>
+          </a:prstGeom>
+          <a:noFill/>
+        </p:spPr>
+        <p:txBody>
+          <a:bodyPr wrap="none" lIns="0" rIns="0" tIns="0" bIns="0">
+            <a:spAutoFit/>
+          </a:bodyPr>
+          <a:lstStyle/>
+          <a:p>
+            <a:pPr algn="r"/>
+            <a:r>
+              <a:rPr sz="1050" b="1" u="sng">
+                <a:solidFill>
+                  <a:srgbClr val="1B8A5A"/>
+                </a:solidFill>
+                <a:latin typeface="Arial"/>
+                <a:hlinkClick r:id="rId5"/>
+              </a:rPr>
+              <a:t>ONS study</a:t>
+            </a:r>
+          </a:p>
+        </p:txBody>
+      </p:sp>
+      <p:sp>
+        <p:nvSpPr>
+          <p:cNvPr id="17419" name="Rounded Rectangle 17418">
+            <a:hlinkClick r:id="rId6"/>
           </p:cNvPr>
           <p:cNvSpPr/>
           <p:nvPr/>
         </p:nvSpPr>
         <p:spPr>
           <a:xfrm>
-            <a:off x="4517136" y="2414016"/>
-            <a:ext cx="1783080" cy="274320"/>
-          </a:xfrm>
-          <a:prstGeom prst="roundRect">
-            <a:avLst>
-              <a:gd name="adj" fmla="val 6000"/>
-            </a:avLst>
-          </a:prstGeom>
-          <a:solidFill>
-            <a:srgbClr val="1B8A5A"/>
-          </a:solidFill>
-          <a:ln>
-            <a:noFill/>
-          </a:ln>
-          <a:effectLst/>
-        </p:spPr>
-        <p:style>
-          <a:lnRef idx="1">
-            <a:schemeClr val="accent1"/>
-          </a:lnRef>
-          <a:fillRef idx="3">
-            <a:schemeClr val="accent1"/>
-          </a:fillRef>
-          <a:effectRef idx="2">
-            <a:schemeClr val="accent1"/>
-          </a:effectRef>
-          <a:fontRef idx="minor">
-            <a:schemeClr val="lt1"/>
-          </a:fontRef>
-        </p:style>
-        <p:txBody>
-          <a:bodyPr rtlCol="0" anchor="ctr" wrap="none" lIns="54864" rIns="54864" tIns="0" bIns="0"/>
-          <a:lstStyle/>
-          <a:p>
-            <a:pPr algn="ctr"/>
-            <a:r>
-              <a:rPr sz="1000" b="1">
-                <a:solidFill>
-                  <a:srgbClr val="FFFFFF"/>
-                </a:solidFill>
-                <a:latin typeface="Arial"/>
-              </a:rPr>
-              <a:t>ONS study</a:t>
-            </a:r>
-          </a:p>
-        </p:txBody>
-      </p:sp>
-      <p:sp>
-        <p:nvSpPr>
-          <p:cNvPr id="17418" name="Rounded Rectangle 17417"/>
-          <p:cNvSpPr/>
-          <p:nvPr/>
-        </p:nvSpPr>
-        <p:spPr>
-          <a:xfrm>
-            <a:off x="8330183" y="1133856"/>
-            <a:ext cx="3703320" cy="1700784"/>
+            <a:off x="8330183" y="1335024"/>
+            <a:ext cx="3703320" cy="1627632"/>
           </a:xfrm>
           <a:prstGeom prst="roundRect">
             <a:avLst>
@@ -16777,13 +16786,13 @@
       </p:sp>
       <p:sp>
         <p:nvSpPr>
-          <p:cNvPr id="17419" name="Rectangle 17418"/>
+          <p:cNvPr id="17420" name="Rectangle 17419"/>
           <p:cNvSpPr/>
           <p:nvPr/>
         </p:nvSpPr>
         <p:spPr>
           <a:xfrm>
-            <a:off x="8330183" y="1133856"/>
+            <a:off x="8330183" y="1335024"/>
             <a:ext cx="3703320" cy="64008"/>
           </a:xfrm>
           <a:prstGeom prst="rect">
@@ -16821,14 +16830,14 @@
       </p:sp>
       <p:sp>
         <p:nvSpPr>
-          <p:cNvPr id="17420" name="TextBox 17419"/>
+          <p:cNvPr id="17421" name="TextBox 17420"/>
           <p:cNvSpPr txBox="1"/>
           <p:nvPr/>
         </p:nvSpPr>
         <p:spPr>
           <a:xfrm>
-            <a:off x="8476488" y="1280160"/>
-            <a:ext cx="3410712" cy="1042416"/>
+            <a:off x="8476488" y="1463040"/>
+            <a:ext cx="3410712" cy="1207008"/>
           </a:xfrm>
           <a:prstGeom prst="rect">
             <a:avLst/>
@@ -16888,71 +16897,52 @@
       </p:sp>
       <p:sp>
         <p:nvSpPr>
-          <p:cNvPr id="17421" name="Rounded Rectangle 17420">
-            <a:hlinkClick r:id="rId6"/>
+          <p:cNvPr id="17422" name="TextBox 17421"/>
+          <p:cNvSpPr txBox="1"/>
+          <p:nvPr/>
+        </p:nvSpPr>
+        <p:spPr>
+          <a:xfrm>
+            <a:off x="9875520" y="2706624"/>
+            <a:ext cx="2011680" cy="219456"/>
+          </a:xfrm>
+          <a:prstGeom prst="rect">
+            <a:avLst/>
+          </a:prstGeom>
+          <a:noFill/>
+        </p:spPr>
+        <p:txBody>
+          <a:bodyPr wrap="none" lIns="0" rIns="0" tIns="0" bIns="0">
+            <a:spAutoFit/>
+          </a:bodyPr>
+          <a:lstStyle/>
+          <a:p>
+            <a:pPr algn="r"/>
+            <a:r>
+              <a:rPr sz="1050" b="1" u="sng">
+                <a:solidFill>
+                  <a:srgbClr val="C77700"/>
+                </a:solidFill>
+                <a:latin typeface="Arial"/>
+                <a:hlinkClick r:id="rId6"/>
+              </a:rPr>
+              <a:t>DGCA statistics</a:t>
+            </a:r>
+          </a:p>
+        </p:txBody>
+      </p:sp>
+      <p:sp>
+        <p:nvSpPr>
+          <p:cNvPr id="17423" name="Rounded Rectangle 17422">
+            <a:hlinkClick r:id="rId7"/>
           </p:cNvPr>
           <p:cNvSpPr/>
           <p:nvPr/>
         </p:nvSpPr>
         <p:spPr>
           <a:xfrm>
-            <a:off x="8476488" y="2414016"/>
-            <a:ext cx="1783080" cy="274320"/>
-          </a:xfrm>
-          <a:prstGeom prst="roundRect">
-            <a:avLst>
-              <a:gd name="adj" fmla="val 6000"/>
-            </a:avLst>
-          </a:prstGeom>
-          <a:solidFill>
-            <a:srgbClr val="C77700"/>
-          </a:solidFill>
-          <a:ln>
-            <a:noFill/>
-          </a:ln>
-          <a:effectLst/>
-        </p:spPr>
-        <p:style>
-          <a:lnRef idx="1">
-            <a:schemeClr val="accent1"/>
-          </a:lnRef>
-          <a:fillRef idx="3">
-            <a:schemeClr val="accent1"/>
-          </a:fillRef>
-          <a:effectRef idx="2">
-            <a:schemeClr val="accent1"/>
-          </a:effectRef>
-          <a:fontRef idx="minor">
-            <a:schemeClr val="lt1"/>
-          </a:fontRef>
-        </p:style>
-        <p:txBody>
-          <a:bodyPr rtlCol="0" anchor="ctr" wrap="none" lIns="54864" rIns="54864" tIns="0" bIns="0"/>
-          <a:lstStyle/>
-          <a:p>
-            <a:pPr algn="ctr"/>
-            <a:r>
-              <a:rPr sz="1000" b="1">
-                <a:solidFill>
-                  <a:srgbClr val="FFFFFF"/>
-                </a:solidFill>
-                <a:latin typeface="Arial"/>
-              </a:rPr>
-              <a:t>DGCA statistics</a:t>
-            </a:r>
-          </a:p>
-        </p:txBody>
-      </p:sp>
-      <p:sp>
-        <p:nvSpPr>
-          <p:cNvPr id="17422" name="Rounded Rectangle 17421"/>
-          <p:cNvSpPr/>
-          <p:nvPr/>
-        </p:nvSpPr>
-        <p:spPr>
-          <a:xfrm>
-            <a:off x="411480" y="2999232"/>
-            <a:ext cx="3703320" cy="1700784"/>
+            <a:off x="411480" y="3108960"/>
+            <a:ext cx="3703320" cy="1627632"/>
           </a:xfrm>
           <a:prstGeom prst="roundRect">
             <a:avLst>
@@ -16991,13 +16981,13 @@
       </p:sp>
       <p:sp>
         <p:nvSpPr>
-          <p:cNvPr id="17423" name="Rectangle 17422"/>
+          <p:cNvPr id="17424" name="Rectangle 17423"/>
           <p:cNvSpPr/>
           <p:nvPr/>
         </p:nvSpPr>
         <p:spPr>
           <a:xfrm>
-            <a:off x="411480" y="2999232"/>
+            <a:off x="411480" y="3108960"/>
             <a:ext cx="3703320" cy="64008"/>
           </a:xfrm>
           <a:prstGeom prst="rect">
@@ -17035,14 +17025,14 @@
       </p:sp>
       <p:sp>
         <p:nvSpPr>
-          <p:cNvPr id="17424" name="TextBox 17423"/>
+          <p:cNvPr id="17425" name="TextBox 17424"/>
           <p:cNvSpPr txBox="1"/>
           <p:nvPr/>
         </p:nvSpPr>
         <p:spPr>
           <a:xfrm>
-            <a:off x="557784" y="3145536"/>
-            <a:ext cx="3410712" cy="1042416"/>
+            <a:off x="557784" y="3236976"/>
+            <a:ext cx="3410712" cy="1207008"/>
           </a:xfrm>
           <a:prstGeom prst="rect">
             <a:avLst/>
@@ -17102,71 +17092,52 @@
       </p:sp>
       <p:sp>
         <p:nvSpPr>
-          <p:cNvPr id="17425" name="Rounded Rectangle 17424">
-            <a:hlinkClick r:id="rId7"/>
+          <p:cNvPr id="17426" name="TextBox 17425"/>
+          <p:cNvSpPr txBox="1"/>
+          <p:nvPr/>
+        </p:nvSpPr>
+        <p:spPr>
+          <a:xfrm>
+            <a:off x="1956816" y="4480559"/>
+            <a:ext cx="2011680" cy="219456"/>
+          </a:xfrm>
+          <a:prstGeom prst="rect">
+            <a:avLst/>
+          </a:prstGeom>
+          <a:noFill/>
+        </p:spPr>
+        <p:txBody>
+          <a:bodyPr wrap="none" lIns="0" rIns="0" tIns="0" bIns="0">
+            <a:spAutoFit/>
+          </a:bodyPr>
+          <a:lstStyle/>
+          <a:p>
+            <a:pPr algn="r"/>
+            <a:r>
+              <a:rPr sz="1050" b="1" u="sng">
+                <a:solidFill>
+                  <a:srgbClr val="4B3F8C"/>
+                </a:solidFill>
+                <a:latin typeface="Arial"/>
+                <a:hlinkClick r:id="rId7"/>
+              </a:rPr>
+              <a:t>RFC 9309</a:t>
+            </a:r>
+          </a:p>
+        </p:txBody>
+      </p:sp>
+      <p:sp>
+        <p:nvSpPr>
+          <p:cNvPr id="17427" name="Rounded Rectangle 17426">
+            <a:hlinkClick r:id="rId8"/>
           </p:cNvPr>
           <p:cNvSpPr/>
           <p:nvPr/>
         </p:nvSpPr>
         <p:spPr>
           <a:xfrm>
-            <a:off x="557784" y="4279392"/>
-            <a:ext cx="1783080" cy="274320"/>
-          </a:xfrm>
-          <a:prstGeom prst="roundRect">
-            <a:avLst>
-              <a:gd name="adj" fmla="val 6000"/>
-            </a:avLst>
-          </a:prstGeom>
-          <a:solidFill>
-            <a:srgbClr val="4B3F8C"/>
-          </a:solidFill>
-          <a:ln>
-            <a:noFill/>
-          </a:ln>
-          <a:effectLst/>
-        </p:spPr>
-        <p:style>
-          <a:lnRef idx="1">
-            <a:schemeClr val="accent1"/>
-          </a:lnRef>
-          <a:fillRef idx="3">
-            <a:schemeClr val="accent1"/>
-          </a:fillRef>
-          <a:effectRef idx="2">
-            <a:schemeClr val="accent1"/>
-          </a:effectRef>
-          <a:fontRef idx="minor">
-            <a:schemeClr val="lt1"/>
-          </a:fontRef>
-        </p:style>
-        <p:txBody>
-          <a:bodyPr rtlCol="0" anchor="ctr" wrap="none" lIns="54864" rIns="54864" tIns="0" bIns="0"/>
-          <a:lstStyle/>
-          <a:p>
-            <a:pPr algn="ctr"/>
-            <a:r>
-              <a:rPr sz="1000" b="1">
-                <a:solidFill>
-                  <a:srgbClr val="FFFFFF"/>
-                </a:solidFill>
-                <a:latin typeface="Arial"/>
-              </a:rPr>
-              <a:t>RFC 9309</a:t>
-            </a:r>
-          </a:p>
-        </p:txBody>
-      </p:sp>
-      <p:sp>
-        <p:nvSpPr>
-          <p:cNvPr id="17426" name="Rounded Rectangle 17425"/>
-          <p:cNvSpPr/>
-          <p:nvPr/>
-        </p:nvSpPr>
-        <p:spPr>
-          <a:xfrm>
-            <a:off x="4370832" y="2999232"/>
-            <a:ext cx="3703320" cy="1700784"/>
+            <a:off x="4370832" y="3108960"/>
+            <a:ext cx="3703320" cy="1627632"/>
           </a:xfrm>
           <a:prstGeom prst="roundRect">
             <a:avLst>
@@ -17205,13 +17176,13 @@
       </p:sp>
       <p:sp>
         <p:nvSpPr>
-          <p:cNvPr id="17427" name="Rectangle 17426"/>
+          <p:cNvPr id="17428" name="Rectangle 17427"/>
           <p:cNvSpPr/>
           <p:nvPr/>
         </p:nvSpPr>
         <p:spPr>
           <a:xfrm>
-            <a:off x="4370832" y="2999232"/>
+            <a:off x="4370832" y="3108960"/>
             <a:ext cx="3703320" cy="64008"/>
           </a:xfrm>
           <a:prstGeom prst="rect">
@@ -17249,14 +17220,14 @@
       </p:sp>
       <p:sp>
         <p:nvSpPr>
-          <p:cNvPr id="17428" name="TextBox 17427"/>
+          <p:cNvPr id="17429" name="TextBox 17428"/>
           <p:cNvSpPr txBox="1"/>
           <p:nvPr/>
         </p:nvSpPr>
         <p:spPr>
           <a:xfrm>
-            <a:off x="4517136" y="3145536"/>
-            <a:ext cx="3410712" cy="1042416"/>
+            <a:off x="4517136" y="3236976"/>
+            <a:ext cx="3410712" cy="1207008"/>
           </a:xfrm>
           <a:prstGeom prst="rect">
             <a:avLst/>
@@ -17316,71 +17287,52 @@
       </p:sp>
       <p:sp>
         <p:nvSpPr>
-          <p:cNvPr id="17429" name="Rounded Rectangle 17428">
-            <a:hlinkClick r:id="rId8"/>
+          <p:cNvPr id="17430" name="TextBox 17429"/>
+          <p:cNvSpPr txBox="1"/>
+          <p:nvPr/>
+        </p:nvSpPr>
+        <p:spPr>
+          <a:xfrm>
+            <a:off x="5916168" y="4480559"/>
+            <a:ext cx="2011680" cy="219456"/>
+          </a:xfrm>
+          <a:prstGeom prst="rect">
+            <a:avLst/>
+          </a:prstGeom>
+          <a:noFill/>
+        </p:spPr>
+        <p:txBody>
+          <a:bodyPr wrap="none" lIns="0" rIns="0" tIns="0" bIns="0">
+            <a:spAutoFit/>
+          </a:bodyPr>
+          <a:lstStyle/>
+          <a:p>
+            <a:pPr algn="r"/>
+            <a:r>
+              <a:rPr sz="1050" b="1" u="sng">
+                <a:solidFill>
+                  <a:srgbClr val="0E7C86"/>
+                </a:solidFill>
+                <a:latin typeface="Arial"/>
+                <a:hlinkClick r:id="rId8"/>
+              </a:rPr>
+              <a:t>MoSPI CPI series</a:t>
+            </a:r>
+          </a:p>
+        </p:txBody>
+      </p:sp>
+      <p:sp>
+        <p:nvSpPr>
+          <p:cNvPr id="17431" name="Rounded Rectangle 17430">
+            <a:hlinkClick r:id="rId9"/>
           </p:cNvPr>
           <p:cNvSpPr/>
           <p:nvPr/>
         </p:nvSpPr>
         <p:spPr>
           <a:xfrm>
-            <a:off x="4517136" y="4279392"/>
-            <a:ext cx="1783080" cy="274320"/>
-          </a:xfrm>
-          <a:prstGeom prst="roundRect">
-            <a:avLst>
-              <a:gd name="adj" fmla="val 6000"/>
-            </a:avLst>
-          </a:prstGeom>
-          <a:solidFill>
-            <a:srgbClr val="0E7C86"/>
-          </a:solidFill>
-          <a:ln>
-            <a:noFill/>
-          </a:ln>
-          <a:effectLst/>
-        </p:spPr>
-        <p:style>
-          <a:lnRef idx="1">
-            <a:schemeClr val="accent1"/>
-          </a:lnRef>
-          <a:fillRef idx="3">
-            <a:schemeClr val="accent1"/>
-          </a:fillRef>
-          <a:effectRef idx="2">
-            <a:schemeClr val="accent1"/>
-          </a:effectRef>
-          <a:fontRef idx="minor">
-            <a:schemeClr val="lt1"/>
-          </a:fontRef>
-        </p:style>
-        <p:txBody>
-          <a:bodyPr rtlCol="0" anchor="ctr" wrap="none" lIns="54864" rIns="54864" tIns="0" bIns="0"/>
-          <a:lstStyle/>
-          <a:p>
-            <a:pPr algn="ctr"/>
-            <a:r>
-              <a:rPr sz="1000" b="1">
-                <a:solidFill>
-                  <a:srgbClr val="FFFFFF"/>
-                </a:solidFill>
-                <a:latin typeface="Arial"/>
-              </a:rPr>
-              <a:t>MoSPI CPI series</a:t>
-            </a:r>
-          </a:p>
-        </p:txBody>
-      </p:sp>
-      <p:sp>
-        <p:nvSpPr>
-          <p:cNvPr id="17430" name="Rounded Rectangle 17429"/>
-          <p:cNvSpPr/>
-          <p:nvPr/>
-        </p:nvSpPr>
-        <p:spPr>
-          <a:xfrm>
-            <a:off x="8330183" y="2999232"/>
-            <a:ext cx="3703320" cy="1700784"/>
+            <a:off x="8330183" y="3108960"/>
+            <a:ext cx="3703320" cy="1627632"/>
           </a:xfrm>
           <a:prstGeom prst="roundRect">
             <a:avLst>
@@ -17419,13 +17371,13 @@
       </p:sp>
       <p:sp>
         <p:nvSpPr>
-          <p:cNvPr id="17431" name="Rectangle 17430"/>
+          <p:cNvPr id="17432" name="Rectangle 17431"/>
           <p:cNvSpPr/>
           <p:nvPr/>
         </p:nvSpPr>
         <p:spPr>
           <a:xfrm>
-            <a:off x="8330183" y="2999232"/>
+            <a:off x="8330183" y="3108960"/>
             <a:ext cx="3703320" cy="64008"/>
           </a:xfrm>
           <a:prstGeom prst="rect">
@@ -17463,14 +17415,14 @@
       </p:sp>
       <p:sp>
         <p:nvSpPr>
-          <p:cNvPr id="17432" name="TextBox 17431"/>
+          <p:cNvPr id="17433" name="TextBox 17432"/>
           <p:cNvSpPr txBox="1"/>
           <p:nvPr/>
         </p:nvSpPr>
         <p:spPr>
           <a:xfrm>
-            <a:off x="8476488" y="3145536"/>
-            <a:ext cx="3410712" cy="1042416"/>
+            <a:off x="8476488" y="3236976"/>
+            <a:ext cx="3410712" cy="1207008"/>
           </a:xfrm>
           <a:prstGeom prst="rect">
             <a:avLst/>
@@ -17531,55 +17483,34 @@
       </p:sp>
       <p:sp>
         <p:nvSpPr>
-          <p:cNvPr id="17433" name="Rounded Rectangle 17432">
-            <a:hlinkClick r:id="rId9"/>
-          </p:cNvPr>
-          <p:cNvSpPr/>
-          <p:nvPr/>
-        </p:nvSpPr>
-        <p:spPr>
-          <a:xfrm>
-            <a:off x="8476488" y="4279392"/>
-            <a:ext cx="1783080" cy="274320"/>
-          </a:xfrm>
-          <a:prstGeom prst="roundRect">
-            <a:avLst>
-              <a:gd name="adj" fmla="val 6000"/>
-            </a:avLst>
-          </a:prstGeom>
-          <a:solidFill>
-            <a:srgbClr val="7A3E6B"/>
-          </a:solidFill>
-          <a:ln>
-            <a:noFill/>
-          </a:ln>
-          <a:effectLst/>
-        </p:spPr>
-        <p:style>
-          <a:lnRef idx="1">
-            <a:schemeClr val="accent1"/>
-          </a:lnRef>
-          <a:fillRef idx="3">
-            <a:schemeClr val="accent1"/>
-          </a:fillRef>
-          <a:effectRef idx="2">
-            <a:schemeClr val="accent1"/>
-          </a:effectRef>
-          <a:fontRef idx="minor">
-            <a:schemeClr val="lt1"/>
-          </a:fontRef>
-        </p:style>
-        <p:txBody>
-          <a:bodyPr rtlCol="0" anchor="ctr" wrap="none" lIns="54864" rIns="54864" tIns="0" bIns="0"/>
-          <a:lstStyle/>
-          <a:p>
-            <a:pPr algn="ctr"/>
-            <a:r>
-              <a:rPr sz="1000" b="1">
-                <a:solidFill>
-                  <a:srgbClr val="FFFFFF"/>
+          <p:cNvPr id="17434" name="TextBox 17433"/>
+          <p:cNvSpPr txBox="1"/>
+          <p:nvPr/>
+        </p:nvSpPr>
+        <p:spPr>
+          <a:xfrm>
+            <a:off x="9875520" y="4480559"/>
+            <a:ext cx="2011680" cy="219456"/>
+          </a:xfrm>
+          <a:prstGeom prst="rect">
+            <a:avLst/>
+          </a:prstGeom>
+          <a:noFill/>
+        </p:spPr>
+        <p:txBody>
+          <a:bodyPr wrap="none" lIns="0" rIns="0" tIns="0" bIns="0">
+            <a:spAutoFit/>
+          </a:bodyPr>
+          <a:lstStyle/>
+          <a:p>
+            <a:pPr algn="r"/>
+            <a:r>
+              <a:rPr sz="1050" b="1" u="sng">
+                <a:solidFill>
+                  <a:srgbClr val="7A3E6B"/>
                 </a:solidFill>
                 <a:latin typeface="Arial"/>
+                <a:hlinkClick r:id="rId9"/>
               </a:rPr>
               <a:t>Open the repo</a:t>
             </a:r>
@@ -17588,7 +17519,7 @@
       </p:sp>
       <p:pic>
         <p:nvPicPr>
-          <p:cNvPr id="17434" name="Picture 17433" descr="chart-survey.png"/>
+          <p:cNvPr id="17435" name="Picture 17434" descr="chart-survey.png"/>
           <p:cNvPicPr>
             <a:picLocks noChangeAspect="1"/>
           </p:cNvPicPr>
@@ -17612,7 +17543,7 @@
       </p:pic>
       <p:sp>
         <p:nvSpPr>
-          <p:cNvPr id="17435" name="TextBox 17434"/>
+          <p:cNvPr id="17436" name="TextBox 17435"/>
           <p:cNvSpPr txBox="1"/>
           <p:nvPr/>
         </p:nvSpPr>
@@ -17701,55 +17632,34 @@
       </p:sp>
       <p:sp>
         <p:nvSpPr>
-          <p:cNvPr id="17436" name="Rounded Rectangle 17435">
-            <a:hlinkClick r:id="rId11"/>
-          </p:cNvPr>
-          <p:cNvSpPr/>
-          <p:nvPr/>
-        </p:nvSpPr>
-        <p:spPr>
-          <a:xfrm>
-            <a:off x="4800600" y="5870448"/>
-            <a:ext cx="1627631" cy="310896"/>
-          </a:xfrm>
-          <a:prstGeom prst="roundRect">
-            <a:avLst>
-              <a:gd name="adj" fmla="val 6000"/>
-            </a:avLst>
-          </a:prstGeom>
-          <a:solidFill>
-            <a:srgbClr val="1F497D"/>
-          </a:solidFill>
-          <a:ln>
-            <a:noFill/>
-          </a:ln>
-          <a:effectLst/>
-        </p:spPr>
-        <p:style>
-          <a:lnRef idx="1">
-            <a:schemeClr val="accent1"/>
-          </a:lnRef>
-          <a:fillRef idx="3">
-            <a:schemeClr val="accent1"/>
-          </a:fillRef>
-          <a:effectRef idx="2">
-            <a:schemeClr val="accent1"/>
-          </a:effectRef>
-          <a:fontRef idx="minor">
-            <a:schemeClr val="lt1"/>
-          </a:fontRef>
-        </p:style>
-        <p:txBody>
-          <a:bodyPr rtlCol="0" anchor="ctr" wrap="none" lIns="54864" rIns="54864" tIns="0" bIns="0"/>
-          <a:lstStyle/>
-          <a:p>
-            <a:pPr algn="ctr"/>
-            <a:r>
-              <a:rPr sz="1050" b="1">
-                <a:solidFill>
-                  <a:srgbClr val="FFFFFF"/>
+          <p:cNvPr id="17437" name="TextBox 17436"/>
+          <p:cNvSpPr txBox="1"/>
+          <p:nvPr/>
+        </p:nvSpPr>
+        <p:spPr>
+          <a:xfrm>
+            <a:off x="4800600" y="5907024"/>
+            <a:ext cx="1641348" cy="219456"/>
+          </a:xfrm>
+          <a:prstGeom prst="rect">
+            <a:avLst/>
+          </a:prstGeom>
+          <a:noFill/>
+        </p:spPr>
+        <p:txBody>
+          <a:bodyPr wrap="none" lIns="0" rIns="0" tIns="0" bIns="0">
+            <a:spAutoFit/>
+          </a:bodyPr>
+          <a:lstStyle/>
+          <a:p>
+            <a:pPr algn="l"/>
+            <a:r>
+              <a:rPr sz="1050" b="1" u="sng">
+                <a:solidFill>
+                  <a:srgbClr val="1F497D"/>
                 </a:solidFill>
                 <a:latin typeface="Arial"/>
+                <a:hlinkClick r:id="rId11"/>
               </a:rPr>
               <a:t>Live API docs</a:t>
             </a:r>
@@ -17758,55 +17668,34 @@
       </p:sp>
       <p:sp>
         <p:nvSpPr>
-          <p:cNvPr id="17437" name="Rounded Rectangle 17436">
-            <a:hlinkClick r:id="rId12"/>
-          </p:cNvPr>
-          <p:cNvSpPr/>
-          <p:nvPr/>
-        </p:nvSpPr>
-        <p:spPr>
-          <a:xfrm>
-            <a:off x="6574536" y="5870448"/>
-            <a:ext cx="1627631" cy="310896"/>
-          </a:xfrm>
-          <a:prstGeom prst="roundRect">
-            <a:avLst>
-              <a:gd name="adj" fmla="val 6000"/>
-            </a:avLst>
-          </a:prstGeom>
-          <a:solidFill>
-            <a:srgbClr val="1B8A5A"/>
-          </a:solidFill>
-          <a:ln>
-            <a:noFill/>
-          </a:ln>
-          <a:effectLst/>
-        </p:spPr>
-        <p:style>
-          <a:lnRef idx="1">
-            <a:schemeClr val="accent1"/>
-          </a:lnRef>
-          <a:fillRef idx="3">
-            <a:schemeClr val="accent1"/>
-          </a:fillRef>
-          <a:effectRef idx="2">
-            <a:schemeClr val="accent1"/>
-          </a:effectRef>
-          <a:fontRef idx="minor">
-            <a:schemeClr val="lt1"/>
-          </a:fontRef>
-        </p:style>
-        <p:txBody>
-          <a:bodyPr rtlCol="0" anchor="ctr" wrap="none" lIns="54864" rIns="54864" tIns="0" bIns="0"/>
-          <a:lstStyle/>
-          <a:p>
-            <a:pPr algn="ctr"/>
-            <a:r>
-              <a:rPr sz="1050" b="1">
-                <a:solidFill>
-                  <a:srgbClr val="FFFFFF"/>
+          <p:cNvPr id="17438" name="TextBox 17437"/>
+          <p:cNvSpPr txBox="1"/>
+          <p:nvPr/>
+        </p:nvSpPr>
+        <p:spPr>
+          <a:xfrm>
+            <a:off x="6569964" y="5907024"/>
+            <a:ext cx="1641348" cy="219456"/>
+          </a:xfrm>
+          <a:prstGeom prst="rect">
+            <a:avLst/>
+          </a:prstGeom>
+          <a:noFill/>
+        </p:spPr>
+        <p:txBody>
+          <a:bodyPr wrap="none" lIns="0" rIns="0" tIns="0" bIns="0">
+            <a:spAutoFit/>
+          </a:bodyPr>
+          <a:lstStyle/>
+          <a:p>
+            <a:pPr algn="l"/>
+            <a:r>
+              <a:rPr sz="1050" b="1" u="sng">
+                <a:solidFill>
+                  <a:srgbClr val="1B8A5A"/>
                 </a:solidFill>
                 <a:latin typeface="Arial"/>
+                <a:hlinkClick r:id="rId12"/>
               </a:rPr>
               <a:t>Release portal</a:t>
             </a:r>
@@ -17815,55 +17704,34 @@
       </p:sp>
       <p:sp>
         <p:nvSpPr>
-          <p:cNvPr id="17438" name="Rounded Rectangle 17437">
-            <a:hlinkClick r:id="rId13"/>
-          </p:cNvPr>
-          <p:cNvSpPr/>
-          <p:nvPr/>
-        </p:nvSpPr>
-        <p:spPr>
-          <a:xfrm>
-            <a:off x="8348471" y="5870448"/>
-            <a:ext cx="1627631" cy="310896"/>
-          </a:xfrm>
-          <a:prstGeom prst="roundRect">
-            <a:avLst>
-              <a:gd name="adj" fmla="val 6000"/>
-            </a:avLst>
-          </a:prstGeom>
-          <a:solidFill>
-            <a:srgbClr val="4B3F8C"/>
-          </a:solidFill>
-          <a:ln>
-            <a:noFill/>
-          </a:ln>
-          <a:effectLst/>
-        </p:spPr>
-        <p:style>
-          <a:lnRef idx="1">
-            <a:schemeClr val="accent1"/>
-          </a:lnRef>
-          <a:fillRef idx="3">
-            <a:schemeClr val="accent1"/>
-          </a:fillRef>
-          <a:effectRef idx="2">
-            <a:schemeClr val="accent1"/>
-          </a:effectRef>
-          <a:fontRef idx="minor">
-            <a:schemeClr val="lt1"/>
-          </a:fontRef>
-        </p:style>
-        <p:txBody>
-          <a:bodyPr rtlCol="0" anchor="ctr" wrap="none" lIns="54864" rIns="54864" tIns="0" bIns="0"/>
-          <a:lstStyle/>
-          <a:p>
-            <a:pPr algn="ctr"/>
-            <a:r>
-              <a:rPr sz="1050" b="1">
-                <a:solidFill>
-                  <a:srgbClr val="FFFFFF"/>
+          <p:cNvPr id="17439" name="TextBox 17438"/>
+          <p:cNvSpPr txBox="1"/>
+          <p:nvPr/>
+        </p:nvSpPr>
+        <p:spPr>
+          <a:xfrm>
+            <a:off x="8339328" y="5907024"/>
+            <a:ext cx="1641348" cy="219456"/>
+          </a:xfrm>
+          <a:prstGeom prst="rect">
+            <a:avLst/>
+          </a:prstGeom>
+          <a:noFill/>
+        </p:spPr>
+        <p:txBody>
+          <a:bodyPr wrap="none" lIns="0" rIns="0" tIns="0" bIns="0">
+            <a:spAutoFit/>
+          </a:bodyPr>
+          <a:lstStyle/>
+          <a:p>
+            <a:pPr algn="l"/>
+            <a:r>
+              <a:rPr sz="1050" b="1" u="sng">
+                <a:solidFill>
+                  <a:srgbClr val="4B3F8C"/>
                 </a:solidFill>
                 <a:latin typeface="Arial"/>
+                <a:hlinkClick r:id="rId13"/>
               </a:rPr>
               <a:t>README + method</a:t>
             </a:r>
@@ -17872,57 +17740,36 @@
       </p:sp>
       <p:sp>
         <p:nvSpPr>
-          <p:cNvPr id="17439" name="Rounded Rectangle 17438">
-            <a:hlinkClick r:id="rId14"/>
-          </p:cNvPr>
-          <p:cNvSpPr/>
-          <p:nvPr/>
-        </p:nvSpPr>
-        <p:spPr>
-          <a:xfrm>
-            <a:off x="10122408" y="5870448"/>
-            <a:ext cx="1627631" cy="310896"/>
-          </a:xfrm>
-          <a:prstGeom prst="roundRect">
-            <a:avLst>
-              <a:gd name="adj" fmla="val 6000"/>
-            </a:avLst>
-          </a:prstGeom>
-          <a:solidFill>
-            <a:srgbClr val="0E7C86"/>
-          </a:solidFill>
-          <a:ln>
-            <a:noFill/>
-          </a:ln>
-          <a:effectLst/>
-        </p:spPr>
-        <p:style>
-          <a:lnRef idx="1">
-            <a:schemeClr val="accent1"/>
-          </a:lnRef>
-          <a:fillRef idx="3">
-            <a:schemeClr val="accent1"/>
-          </a:fillRef>
-          <a:effectRef idx="2">
-            <a:schemeClr val="accent1"/>
-          </a:effectRef>
-          <a:fontRef idx="minor">
-            <a:schemeClr val="lt1"/>
-          </a:fontRef>
-        </p:style>
-        <p:txBody>
-          <a:bodyPr rtlCol="0" anchor="ctr" wrap="none" lIns="54864" rIns="54864" tIns="0" bIns="0"/>
-          <a:lstStyle/>
-          <a:p>
-            <a:pPr algn="ctr"/>
-            <a:r>
-              <a:rPr sz="1050" b="1">
-                <a:solidFill>
-                  <a:srgbClr val="FFFFFF"/>
+          <p:cNvPr id="17440" name="TextBox 17439"/>
+          <p:cNvSpPr txBox="1"/>
+          <p:nvPr/>
+        </p:nvSpPr>
+        <p:spPr>
+          <a:xfrm>
+            <a:off x="10108692" y="5907024"/>
+            <a:ext cx="1641348" cy="219456"/>
+          </a:xfrm>
+          <a:prstGeom prst="rect">
+            <a:avLst/>
+          </a:prstGeom>
+          <a:noFill/>
+        </p:spPr>
+        <p:txBody>
+          <a:bodyPr wrap="none" lIns="0" rIns="0" tIns="0" bIns="0">
+            <a:spAutoFit/>
+          </a:bodyPr>
+          <a:lstStyle/>
+          <a:p>
+            <a:pPr algn="l"/>
+            <a:r>
+              <a:rPr sz="1050" b="1" u="sng">
+                <a:solidFill>
+                  <a:srgbClr val="0E7C86"/>
                 </a:solidFill>
                 <a:latin typeface="Arial"/>
-              </a:rPr>
-              <a:t>Market data</a:t>
+                <a:hlinkClick r:id="rId14"/>
+              </a:rPr>
+              <a:t>Aviation market</a:t>
             </a:r>
           </a:p>
         </p:txBody>

</xml_diff>

<commit_message>
Slide 6: nine references incl. the new CPI 2024=100 series; de-cram slide 2
The MoSPI CPI link was dead and the deck cited base 2012=100. MoSPI moved the
CPI to base 2024=100 in February 2026 (COICOP 2018, 358 weighted items). Added
the ILO/IMF CPI Manual, the collection-method FAQ and the aviation market as
sources; every URL checked to resolve.

Co-Authored-By: Claude Opus 5 <noreply@anthropic.com>
Claude-Session: https://claude.ai/code/session_0129UjVhHMAVJgfcaxoN1dD5
</commit_message>
<xml_diff>
--- a/SIH26056-Idea-Presentation.pptx
+++ b/SIH26056-Idea-Presentation.pptx
@@ -6037,8 +6037,8 @@
         </p:nvSpPr>
         <p:spPr>
           <a:xfrm>
-            <a:off x="411480" y="950976"/>
-            <a:ext cx="7726679" cy="896112"/>
+            <a:off x="411480" y="896112"/>
+            <a:ext cx="7726679" cy="969264"/>
           </a:xfrm>
           <a:prstGeom prst="rect">
             <a:avLst/>
@@ -6113,7 +6113,7 @@
                 </a:solidFill>
                 <a:latin typeface="Arial"/>
               </a:rPr>
-              <a:t>MoSPI prices air travel by hand, once a month, for one departure date. APIx reads the same public fare pages every ten minutes, turns them into one weighted index number, and delivers it to MoSPI through an API instead of a form.</a:t>
+              <a:t>MoSPI prices air travel by hand, once a month, for one departure date. APIx reads the same public pages every ten minutes and delivers one weighted index number to MoSPI through an API.</a:t>
             </a:r>
           </a:p>
         </p:txBody>
@@ -6126,7 +6126,7 @@
         </p:nvSpPr>
         <p:spPr>
           <a:xfrm>
-            <a:off x="8275320" y="987552"/>
+            <a:off x="8275320" y="932688"/>
             <a:ext cx="3474720" cy="822960"/>
           </a:xfrm>
           <a:prstGeom prst="roundRect">
@@ -6213,8 +6213,8 @@
         </p:nvSpPr>
         <p:spPr>
           <a:xfrm>
-            <a:off x="411480" y="1920240"/>
-            <a:ext cx="6355080" cy="1737360"/>
+            <a:off x="411480" y="1901952"/>
+            <a:ext cx="6355080" cy="1719072"/>
           </a:xfrm>
           <a:prstGeom prst="roundRect">
             <a:avLst>
@@ -6259,7 +6259,7 @@
         </p:nvSpPr>
         <p:spPr>
           <a:xfrm>
-            <a:off x="548640" y="1975104"/>
+            <a:off x="548640" y="1965960"/>
             <a:ext cx="3840480" cy="237744"/>
           </a:xfrm>
           <a:prstGeom prst="rect">
@@ -6304,7 +6304,7 @@
         </p:nvSpPr>
         <p:spPr>
           <a:xfrm>
-            <a:off x="2148840" y="2231136"/>
+            <a:off x="2148840" y="2240280"/>
             <a:ext cx="1920240" cy="237744"/>
           </a:xfrm>
           <a:prstGeom prst="rect">
@@ -6349,7 +6349,7 @@
         </p:nvSpPr>
         <p:spPr>
           <a:xfrm>
-            <a:off x="4160520" y="2231136"/>
+            <a:off x="4160520" y="2240280"/>
             <a:ext cx="2468880" cy="237744"/>
           </a:xfrm>
           <a:prstGeom prst="rect">
@@ -6394,7 +6394,7 @@
         </p:nvSpPr>
         <p:spPr>
           <a:xfrm>
-            <a:off x="548640" y="2505456"/>
+            <a:off x="548640" y="2532888"/>
             <a:ext cx="1600200" cy="237744"/>
           </a:xfrm>
           <a:prstGeom prst="rect">
@@ -6439,7 +6439,7 @@
         </p:nvSpPr>
         <p:spPr>
           <a:xfrm>
-            <a:off x="2148840" y="2505456"/>
+            <a:off x="2148840" y="2532888"/>
             <a:ext cx="1920240" cy="237744"/>
           </a:xfrm>
           <a:prstGeom prst="rect">
@@ -6484,7 +6484,7 @@
         </p:nvSpPr>
         <p:spPr>
           <a:xfrm>
-            <a:off x="4160520" y="2505456"/>
+            <a:off x="4160520" y="2532888"/>
             <a:ext cx="2468880" cy="237744"/>
           </a:xfrm>
           <a:prstGeom prst="rect">
@@ -6529,7 +6529,7 @@
         </p:nvSpPr>
         <p:spPr>
           <a:xfrm>
-            <a:off x="548640" y="2770632"/>
+            <a:off x="548640" y="2798064"/>
             <a:ext cx="1600200" cy="237744"/>
           </a:xfrm>
           <a:prstGeom prst="rect">
@@ -6574,7 +6574,7 @@
         </p:nvSpPr>
         <p:spPr>
           <a:xfrm>
-            <a:off x="2148840" y="2770632"/>
+            <a:off x="2148840" y="2798064"/>
             <a:ext cx="1920240" cy="237744"/>
           </a:xfrm>
           <a:prstGeom prst="rect">
@@ -6619,7 +6619,7 @@
         </p:nvSpPr>
         <p:spPr>
           <a:xfrm>
-            <a:off x="4160520" y="2770632"/>
+            <a:off x="4160520" y="2798064"/>
             <a:ext cx="2468880" cy="237744"/>
           </a:xfrm>
           <a:prstGeom prst="rect">
@@ -6664,7 +6664,7 @@
         </p:nvSpPr>
         <p:spPr>
           <a:xfrm>
-            <a:off x="548640" y="3035808"/>
+            <a:off x="548640" y="3063240"/>
             <a:ext cx="1600200" cy="237744"/>
           </a:xfrm>
           <a:prstGeom prst="rect">
@@ -6709,7 +6709,7 @@
         </p:nvSpPr>
         <p:spPr>
           <a:xfrm>
-            <a:off x="2148840" y="3035808"/>
+            <a:off x="2148840" y="3063240"/>
             <a:ext cx="1920240" cy="237744"/>
           </a:xfrm>
           <a:prstGeom prst="rect">
@@ -6754,7 +6754,7 @@
         </p:nvSpPr>
         <p:spPr>
           <a:xfrm>
-            <a:off x="4160520" y="3035808"/>
+            <a:off x="4160520" y="3063240"/>
             <a:ext cx="2468880" cy="237744"/>
           </a:xfrm>
           <a:prstGeom prst="rect">
@@ -6799,7 +6799,7 @@
         </p:nvSpPr>
         <p:spPr>
           <a:xfrm>
-            <a:off x="548640" y="3300984"/>
+            <a:off x="548640" y="3328415"/>
             <a:ext cx="1600200" cy="237744"/>
           </a:xfrm>
           <a:prstGeom prst="rect">
@@ -6844,7 +6844,7 @@
         </p:nvSpPr>
         <p:spPr>
           <a:xfrm>
-            <a:off x="2148840" y="3300984"/>
+            <a:off x="2148840" y="3328415"/>
             <a:ext cx="1920240" cy="237744"/>
           </a:xfrm>
           <a:prstGeom prst="rect">
@@ -6889,7 +6889,7 @@
         </p:nvSpPr>
         <p:spPr>
           <a:xfrm>
-            <a:off x="4160520" y="3300984"/>
+            <a:off x="4160520" y="3328415"/>
             <a:ext cx="2468880" cy="237744"/>
           </a:xfrm>
           <a:prstGeom prst="rect">
@@ -6934,8 +6934,8 @@
         </p:nvSpPr>
         <p:spPr>
           <a:xfrm>
-            <a:off x="6903720" y="1920240"/>
-            <a:ext cx="4846320" cy="877824"/>
+            <a:off x="6903720" y="1901952"/>
+            <a:ext cx="4846320" cy="896112"/>
           </a:xfrm>
           <a:prstGeom prst="roundRect">
             <a:avLst>
@@ -6980,7 +6980,7 @@
         </p:nvSpPr>
         <p:spPr>
           <a:xfrm>
-            <a:off x="7040880" y="1956816"/>
+            <a:off x="7040880" y="1947672"/>
             <a:ext cx="4572000" cy="219456"/>
           </a:xfrm>
           <a:prstGeom prst="rect">
@@ -7025,7 +7025,7 @@
         </p:nvSpPr>
         <p:spPr>
           <a:xfrm>
-            <a:off x="7040880" y="2176272"/>
+            <a:off x="7040880" y="2185416"/>
             <a:ext cx="4572000" cy="237744"/>
           </a:xfrm>
           <a:prstGeom prst="rect">
@@ -7070,7 +7070,7 @@
         </p:nvSpPr>
         <p:spPr>
           <a:xfrm>
-            <a:off x="7040880" y="2414016"/>
+            <a:off x="7040880" y="2432304"/>
             <a:ext cx="4572000" cy="329184"/>
           </a:xfrm>
           <a:prstGeom prst="rect">
@@ -7116,7 +7116,7 @@
         <p:spPr>
           <a:xfrm>
             <a:off x="6903720" y="2834640"/>
-            <a:ext cx="4846320" cy="822960"/>
+            <a:ext cx="4846320" cy="786384"/>
           </a:xfrm>
           <a:prstGeom prst="roundRect">
             <a:avLst>
@@ -7161,7 +7161,7 @@
         </p:nvSpPr>
         <p:spPr>
           <a:xfrm>
-            <a:off x="7040880" y="2871216"/>
+            <a:off x="7040880" y="2862072"/>
             <a:ext cx="4572000" cy="219456"/>
           </a:xfrm>
           <a:prstGeom prst="rect">
@@ -7206,7 +7206,7 @@
         </p:nvSpPr>
         <p:spPr>
           <a:xfrm>
-            <a:off x="7040880" y="3072384"/>
+            <a:off x="7040880" y="3044952"/>
             <a:ext cx="777240" cy="146304"/>
           </a:xfrm>
           <a:prstGeom prst="rect">
@@ -7251,7 +7251,7 @@
         </p:nvSpPr>
         <p:spPr>
           <a:xfrm>
-            <a:off x="7818120" y="3072384"/>
+            <a:off x="7818120" y="3044952"/>
             <a:ext cx="3840480" cy="146304"/>
           </a:xfrm>
           <a:prstGeom prst="rect">
@@ -7296,7 +7296,7 @@
         </p:nvSpPr>
         <p:spPr>
           <a:xfrm>
-            <a:off x="7040880" y="3218688"/>
+            <a:off x="7040880" y="3182112"/>
             <a:ext cx="777240" cy="146304"/>
           </a:xfrm>
           <a:prstGeom prst="rect">
@@ -7341,7 +7341,7 @@
         </p:nvSpPr>
         <p:spPr>
           <a:xfrm>
-            <a:off x="7818120" y="3218688"/>
+            <a:off x="7818120" y="3182112"/>
             <a:ext cx="3840480" cy="146304"/>
           </a:xfrm>
           <a:prstGeom prst="rect">
@@ -7386,7 +7386,7 @@
         </p:nvSpPr>
         <p:spPr>
           <a:xfrm>
-            <a:off x="7040880" y="3364991"/>
+            <a:off x="7040880" y="3319272"/>
             <a:ext cx="777240" cy="146304"/>
           </a:xfrm>
           <a:prstGeom prst="rect">
@@ -7431,7 +7431,7 @@
         </p:nvSpPr>
         <p:spPr>
           <a:xfrm>
-            <a:off x="7818120" y="3364991"/>
+            <a:off x="7818120" y="3319272"/>
             <a:ext cx="3840480" cy="146304"/>
           </a:xfrm>
           <a:prstGeom prst="rect">
@@ -7476,7 +7476,7 @@
         </p:nvSpPr>
         <p:spPr>
           <a:xfrm>
-            <a:off x="7040880" y="3511296"/>
+            <a:off x="7040880" y="3456432"/>
             <a:ext cx="777240" cy="146304"/>
           </a:xfrm>
           <a:prstGeom prst="rect">
@@ -7521,7 +7521,7 @@
         </p:nvSpPr>
         <p:spPr>
           <a:xfrm>
-            <a:off x="7818120" y="3511296"/>
+            <a:off x="7818120" y="3456432"/>
             <a:ext cx="3840480" cy="146304"/>
           </a:xfrm>
           <a:prstGeom prst="rect">
@@ -7566,7 +7566,7 @@
         </p:nvSpPr>
         <p:spPr>
           <a:xfrm>
-            <a:off x="411480" y="3730752"/>
+            <a:off x="411480" y="3712463"/>
             <a:ext cx="11338560" cy="274320"/>
           </a:xfrm>
           <a:prstGeom prst="rect">
@@ -7611,7 +7611,7 @@
         </p:nvSpPr>
         <p:spPr>
           <a:xfrm>
-            <a:off x="429768" y="4005072"/>
+            <a:off x="429768" y="3986783"/>
             <a:ext cx="1371600" cy="25603"/>
           </a:xfrm>
           <a:prstGeom prst="rect">
@@ -7655,7 +7655,7 @@
         </p:nvSpPr>
         <p:spPr>
           <a:xfrm>
-            <a:off x="411480" y="4078224"/>
+            <a:off x="411480" y="4059936"/>
             <a:ext cx="3621024" cy="1060704"/>
           </a:xfrm>
           <a:prstGeom prst="roundRect">
@@ -7742,7 +7742,7 @@
         </p:nvSpPr>
         <p:spPr>
           <a:xfrm>
-            <a:off x="411480" y="4078224"/>
+            <a:off x="411480" y="4059936"/>
             <a:ext cx="3621024" cy="64008"/>
           </a:xfrm>
           <a:prstGeom prst="rect">
@@ -7786,7 +7786,7 @@
         </p:nvSpPr>
         <p:spPr>
           <a:xfrm>
-            <a:off x="4270248" y="4078224"/>
+            <a:off x="4270248" y="4059936"/>
             <a:ext cx="3621024" cy="1060704"/>
           </a:xfrm>
           <a:prstGeom prst="roundRect">
@@ -7873,7 +7873,7 @@
         </p:nvSpPr>
         <p:spPr>
           <a:xfrm>
-            <a:off x="4270248" y="4078224"/>
+            <a:off x="4270248" y="4059936"/>
             <a:ext cx="3621024" cy="64008"/>
           </a:xfrm>
           <a:prstGeom prst="rect">
@@ -7917,7 +7917,7 @@
         </p:nvSpPr>
         <p:spPr>
           <a:xfrm>
-            <a:off x="8129015" y="4078224"/>
+            <a:off x="8129015" y="4059936"/>
             <a:ext cx="3621024" cy="1060704"/>
           </a:xfrm>
           <a:prstGeom prst="roundRect">
@@ -8004,7 +8004,7 @@
         </p:nvSpPr>
         <p:spPr>
           <a:xfrm>
-            <a:off x="8129015" y="4078224"/>
+            <a:off x="8129015" y="4059936"/>
             <a:ext cx="3621024" cy="64008"/>
           </a:xfrm>
           <a:prstGeom prst="rect">
@@ -8048,7 +8048,7 @@
         </p:nvSpPr>
         <p:spPr>
           <a:xfrm>
-            <a:off x="411480" y="5248656"/>
+            <a:off x="411480" y="5266944"/>
             <a:ext cx="3621024" cy="1060704"/>
           </a:xfrm>
           <a:prstGeom prst="roundRect">
@@ -8135,7 +8135,7 @@
         </p:nvSpPr>
         <p:spPr>
           <a:xfrm>
-            <a:off x="411480" y="5248656"/>
+            <a:off x="411480" y="5266944"/>
             <a:ext cx="3621024" cy="64008"/>
           </a:xfrm>
           <a:prstGeom prst="rect">
@@ -8179,7 +8179,7 @@
         </p:nvSpPr>
         <p:spPr>
           <a:xfrm>
-            <a:off x="4270248" y="5248656"/>
+            <a:off x="4270248" y="5266944"/>
             <a:ext cx="3621024" cy="1060704"/>
           </a:xfrm>
           <a:prstGeom prst="roundRect">
@@ -8266,7 +8266,7 @@
         </p:nvSpPr>
         <p:spPr>
           <a:xfrm>
-            <a:off x="4270248" y="5248656"/>
+            <a:off x="4270248" y="5266944"/>
             <a:ext cx="3621024" cy="64008"/>
           </a:xfrm>
           <a:prstGeom prst="rect">
@@ -8310,7 +8310,7 @@
         </p:nvSpPr>
         <p:spPr>
           <a:xfrm>
-            <a:off x="8129015" y="5248656"/>
+            <a:off x="8129015" y="5266944"/>
             <a:ext cx="3621024" cy="1060704"/>
           </a:xfrm>
           <a:prstGeom prst="roundRect">
@@ -8397,7 +8397,7 @@
         </p:nvSpPr>
         <p:spPr>
           <a:xfrm>
-            <a:off x="8129015" y="5248656"/>
+            <a:off x="8129015" y="5266944"/>
             <a:ext cx="3621024" cy="64008"/>
           </a:xfrm>
           <a:prstGeom prst="rect">
@@ -16309,8 +16309,8 @@
         </p:nvSpPr>
         <p:spPr>
           <a:xfrm>
-            <a:off x="411480" y="1060704"/>
-            <a:ext cx="5486400" cy="219456"/>
+            <a:off x="411480" y="987552"/>
+            <a:ext cx="6400800" cy="219456"/>
           </a:xfrm>
           <a:prstGeom prst="rect">
             <a:avLst/>
@@ -16356,8 +16356,8 @@
         </p:nvSpPr>
         <p:spPr>
           <a:xfrm>
-            <a:off x="411480" y="1335024"/>
-            <a:ext cx="3703320" cy="1627632"/>
+            <a:off x="411480" y="1243584"/>
+            <a:ext cx="3703320" cy="1298448"/>
           </a:xfrm>
           <a:prstGeom prst="roundRect">
             <a:avLst>
@@ -16402,8 +16402,8 @@
         </p:nvSpPr>
         <p:spPr>
           <a:xfrm>
-            <a:off x="411480" y="1335024"/>
-            <a:ext cx="3703320" cy="64008"/>
+            <a:off x="411480" y="1243584"/>
+            <a:ext cx="3703320" cy="54864"/>
           </a:xfrm>
           <a:prstGeom prst="rect">
             <a:avLst/>
@@ -16446,8 +16446,8 @@
         </p:nvSpPr>
         <p:spPr>
           <a:xfrm>
-            <a:off x="557784" y="1463040"/>
-            <a:ext cx="3410712" cy="1207008"/>
+            <a:off x="557784" y="1353312"/>
+            <a:ext cx="3410712" cy="896112"/>
           </a:xfrm>
           <a:prstGeom prst="rect">
             <a:avLst/>
@@ -16472,7 +16472,7 @@
               </a:spcAft>
             </a:pPr>
             <a:r>
-              <a:rPr sz="1350" b="1">
+              <a:rPr sz="1250" b="1">
                 <a:solidFill>
                   <a:srgbClr val="4F81BD"/>
                 </a:solidFill>
@@ -16494,7 +16494,7 @@
               </a:spcAft>
             </a:pPr>
             <a:r>
-              <a:rPr sz="1150" b="0">
+              <a:rPr sz="1050" b="0">
                 <a:solidFill>
                   <a:srgbClr val="262B33"/>
                 </a:solidFill>
@@ -16513,7 +16513,7 @@
         </p:nvSpPr>
         <p:spPr>
           <a:xfrm>
-            <a:off x="1956816" y="2706624"/>
+            <a:off x="1956816" y="2304288"/>
             <a:ext cx="2011680" cy="219456"/>
           </a:xfrm>
           <a:prstGeom prst="rect">
@@ -16529,7 +16529,7 @@
           <a:p>
             <a:pPr algn="r"/>
             <a:r>
-              <a:rPr sz="1050" b="1" u="sng">
+              <a:rPr sz="1000" b="1" u="sng">
                 <a:solidFill>
                   <a:srgbClr val="4F81BD"/>
                 </a:solidFill>
@@ -16551,8 +16551,8 @@
         </p:nvSpPr>
         <p:spPr>
           <a:xfrm>
-            <a:off x="4370832" y="1335024"/>
-            <a:ext cx="3703320" cy="1627632"/>
+            <a:off x="4370832" y="1243584"/>
+            <a:ext cx="3703320" cy="1298448"/>
           </a:xfrm>
           <a:prstGeom prst="roundRect">
             <a:avLst>
@@ -16597,8 +16597,8 @@
         </p:nvSpPr>
         <p:spPr>
           <a:xfrm>
-            <a:off x="4370832" y="1335024"/>
-            <a:ext cx="3703320" cy="64008"/>
+            <a:off x="4370832" y="1243584"/>
+            <a:ext cx="3703320" cy="54864"/>
           </a:xfrm>
           <a:prstGeom prst="rect">
             <a:avLst/>
@@ -16641,8 +16641,8 @@
         </p:nvSpPr>
         <p:spPr>
           <a:xfrm>
-            <a:off x="4517136" y="1463040"/>
-            <a:ext cx="3410712" cy="1207008"/>
+            <a:off x="4517136" y="1353312"/>
+            <a:ext cx="3410712" cy="896112"/>
           </a:xfrm>
           <a:prstGeom prst="rect">
             <a:avLst/>
@@ -16667,13 +16667,13 @@
               </a:spcAft>
             </a:pPr>
             <a:r>
-              <a:rPr sz="1350" b="1">
+              <a:rPr sz="1250" b="1">
                 <a:solidFill>
                   <a:srgbClr val="1B8A5A"/>
                 </a:solidFill>
                 <a:latin typeface="Arial"/>
               </a:rPr>
-              <a:t>Precedent — already done</a:t>
+              <a:t>The international standard</a:t>
             </a:r>
           </a:p>
           <a:p>
@@ -16689,13 +16689,13 @@
               </a:spcAft>
             </a:pPr>
             <a:r>
-              <a:rPr sz="1150" b="0">
+              <a:rPr sz="1050" b="0">
                 <a:solidFill>
                   <a:srgbClr val="262B33"/>
                 </a:solidFill>
                 <a:latin typeface="Arial"/>
               </a:rPr>
-              <a:t>ONS ran a web-scraping programme for consumer prices from 2014, Eurostat-funded from 2015.</a:t>
+              <a:t>CPI Manual: Concepts and Methods (ILO, IMF, OECD, UN, World Bank, 2020). Sets out elementary aggregates and why Jevons is preferred.</a:t>
             </a:r>
           </a:p>
         </p:txBody>
@@ -16708,7 +16708,7 @@
         </p:nvSpPr>
         <p:spPr>
           <a:xfrm>
-            <a:off x="5916168" y="2706624"/>
+            <a:off x="5916168" y="2304288"/>
             <a:ext cx="2011680" cy="219456"/>
           </a:xfrm>
           <a:prstGeom prst="rect">
@@ -16724,14 +16724,14 @@
           <a:p>
             <a:pPr algn="r"/>
             <a:r>
-              <a:rPr sz="1050" b="1" u="sng">
+              <a:rPr sz="1000" b="1" u="sng">
                 <a:solidFill>
                   <a:srgbClr val="1B8A5A"/>
                 </a:solidFill>
                 <a:latin typeface="Arial"/>
                 <a:hlinkClick r:id="rId5"/>
               </a:rPr>
-              <a:t>ONS study</a:t>
+              <a:t>CPI Manual 2020</a:t>
             </a:r>
           </a:p>
         </p:txBody>
@@ -16746,8 +16746,8 @@
         </p:nvSpPr>
         <p:spPr>
           <a:xfrm>
-            <a:off x="8330183" y="1335024"/>
-            <a:ext cx="3703320" cy="1627632"/>
+            <a:off x="8330183" y="1243584"/>
+            <a:ext cx="3703320" cy="1298448"/>
           </a:xfrm>
           <a:prstGeom prst="roundRect">
             <a:avLst>
@@ -16792,8 +16792,8 @@
         </p:nvSpPr>
         <p:spPr>
           <a:xfrm>
-            <a:off x="8330183" y="1335024"/>
-            <a:ext cx="3703320" cy="64008"/>
+            <a:off x="8330183" y="1243584"/>
+            <a:ext cx="3703320" cy="54864"/>
           </a:xfrm>
           <a:prstGeom prst="rect">
             <a:avLst/>
@@ -16836,8 +16836,8 @@
         </p:nvSpPr>
         <p:spPr>
           <a:xfrm>
-            <a:off x="8476488" y="1463040"/>
-            <a:ext cx="3410712" cy="1207008"/>
+            <a:off x="8476488" y="1353312"/>
+            <a:ext cx="3410712" cy="896112"/>
           </a:xfrm>
           <a:prstGeom prst="rect">
             <a:avLst/>
@@ -16862,13 +16862,13 @@
               </a:spcAft>
             </a:pPr>
             <a:r>
-              <a:rPr sz="1350" b="1">
+              <a:rPr sz="1250" b="1">
                 <a:solidFill>
                   <a:srgbClr val="C77700"/>
                 </a:solidFill>
                 <a:latin typeface="Arial"/>
               </a:rPr>
-              <a:t>The Indian basket</a:t>
+              <a:t>Precedent — already done</a:t>
             </a:r>
           </a:p>
           <a:p>
@@ -16884,13 +16884,13 @@
               </a:spcAft>
             </a:pPr>
             <a:r>
-              <a:rPr sz="1150" b="0">
+              <a:rPr sz="1050" b="0">
                 <a:solidFill>
                   <a:srgbClr val="262B33"/>
                 </a:solidFill>
                 <a:latin typeface="Arial"/>
               </a:rPr>
-              <a:t>DGCA city-pair statistics: 164 m domestic passengers, IndiGo 64.2%. Our own 1,000-fare sample returned 68.2% — arrived at independently.</a:t>
+              <a:t>The ONS ran a web-scraping programme for consumer prices from 2014, Eurostat-funded from 2015. This is not an untried method.</a:t>
             </a:r>
           </a:p>
         </p:txBody>
@@ -16903,7 +16903,7 @@
         </p:nvSpPr>
         <p:spPr>
           <a:xfrm>
-            <a:off x="9875520" y="2706624"/>
+            <a:off x="9875520" y="2304288"/>
             <a:ext cx="2011680" cy="219456"/>
           </a:xfrm>
           <a:prstGeom prst="rect">
@@ -16919,14 +16919,14 @@
           <a:p>
             <a:pPr algn="r"/>
             <a:r>
-              <a:rPr sz="1050" b="1" u="sng">
+              <a:rPr sz="1000" b="1" u="sng">
                 <a:solidFill>
                   <a:srgbClr val="C77700"/>
                 </a:solidFill>
                 <a:latin typeface="Arial"/>
                 <a:hlinkClick r:id="rId6"/>
               </a:rPr>
-              <a:t>DGCA statistics</a:t>
+              <a:t>ONS research indices</a:t>
             </a:r>
           </a:p>
         </p:txBody>
@@ -16941,8 +16941,8 @@
         </p:nvSpPr>
         <p:spPr>
           <a:xfrm>
-            <a:off x="411480" y="3108960"/>
-            <a:ext cx="3703320" cy="1627632"/>
+            <a:off x="411480" y="2670048"/>
+            <a:ext cx="3703320" cy="1298448"/>
           </a:xfrm>
           <a:prstGeom prst="roundRect">
             <a:avLst>
@@ -16987,8 +16987,8 @@
         </p:nvSpPr>
         <p:spPr>
           <a:xfrm>
-            <a:off x="411480" y="3108960"/>
-            <a:ext cx="3703320" cy="64008"/>
+            <a:off x="411480" y="2670048"/>
+            <a:ext cx="3703320" cy="54864"/>
           </a:xfrm>
           <a:prstGeom prst="rect">
             <a:avLst/>
@@ -17031,8 +17031,8 @@
         </p:nvSpPr>
         <p:spPr>
           <a:xfrm>
-            <a:off x="557784" y="3236976"/>
-            <a:ext cx="3410712" cy="1207008"/>
+            <a:off x="557784" y="2779776"/>
+            <a:ext cx="3410712" cy="896112"/>
           </a:xfrm>
           <a:prstGeom prst="rect">
             <a:avLst/>
@@ -17057,13 +17057,13 @@
               </a:spcAft>
             </a:pPr>
             <a:r>
-              <a:rPr sz="1350" b="1">
+              <a:rPr sz="1250" b="1">
                 <a:solidFill>
                   <a:srgbClr val="4B3F8C"/>
                 </a:solidFill>
                 <a:latin typeface="Arial"/>
               </a:rPr>
-              <a:t>Standards we hold to</a:t>
+              <a:t>The series we augment</a:t>
             </a:r>
           </a:p>
           <a:p>
@@ -17079,13 +17079,13 @@
               </a:spcAft>
             </a:pPr>
             <a:r>
-              <a:rPr sz="1150" b="0">
+              <a:rPr sz="1050" b="0">
                 <a:solidFill>
                   <a:srgbClr val="262B33"/>
                 </a:solidFill>
                 <a:latin typeface="Arial"/>
               </a:rPr>
-              <a:t>RFC 9309, the Robots Exclusion Protocol. We implemented it ourselves after finding Python's standard parser reports disallowed paths as allowed.</a:t>
+              <a:t>MoSPI moved the CPI to base 2024=100 in February 2026, aligned to COICOP 2018 — 358 weighted items, 50 of them services. Air travel sits in Transport.</a:t>
             </a:r>
           </a:p>
         </p:txBody>
@@ -17098,7 +17098,7 @@
         </p:nvSpPr>
         <p:spPr>
           <a:xfrm>
-            <a:off x="1956816" y="4480559"/>
+            <a:off x="1956816" y="3730752"/>
             <a:ext cx="2011680" cy="219456"/>
           </a:xfrm>
           <a:prstGeom prst="rect">
@@ -17114,14 +17114,14 @@
           <a:p>
             <a:pPr algn="r"/>
             <a:r>
-              <a:rPr sz="1050" b="1" u="sng">
+              <a:rPr sz="1000" b="1" u="sng">
                 <a:solidFill>
                   <a:srgbClr val="4B3F8C"/>
                 </a:solidFill>
                 <a:latin typeface="Arial"/>
                 <a:hlinkClick r:id="rId7"/>
               </a:rPr>
-              <a:t>RFC 9309</a:t>
+              <a:t>2024=100 release</a:t>
             </a:r>
           </a:p>
         </p:txBody>
@@ -17136,8 +17136,8 @@
         </p:nvSpPr>
         <p:spPr>
           <a:xfrm>
-            <a:off x="4370832" y="3108960"/>
-            <a:ext cx="3703320" cy="1627632"/>
+            <a:off x="4370832" y="2670048"/>
+            <a:ext cx="3703320" cy="1298448"/>
           </a:xfrm>
           <a:prstGeom prst="roundRect">
             <a:avLst>
@@ -17182,8 +17182,8 @@
         </p:nvSpPr>
         <p:spPr>
           <a:xfrm>
-            <a:off x="4370832" y="3108960"/>
-            <a:ext cx="3703320" cy="64008"/>
+            <a:off x="4370832" y="2670048"/>
+            <a:ext cx="3703320" cy="54864"/>
           </a:xfrm>
           <a:prstGeom prst="rect">
             <a:avLst/>
@@ -17226,8 +17226,8 @@
         </p:nvSpPr>
         <p:spPr>
           <a:xfrm>
-            <a:off x="4517136" y="3236976"/>
-            <a:ext cx="3410712" cy="1207008"/>
+            <a:off x="4517136" y="2779776"/>
+            <a:ext cx="3410712" cy="896112"/>
           </a:xfrm>
           <a:prstGeom prst="rect">
             <a:avLst/>
@@ -17252,13 +17252,13 @@
               </a:spcAft>
             </a:pPr>
             <a:r>
-              <a:rPr sz="1350" b="1">
+              <a:rPr sz="1250" b="1">
                 <a:solidFill>
                   <a:srgbClr val="0E7C86"/>
                 </a:solidFill>
                 <a:latin typeface="Arial"/>
               </a:rPr>
-              <a:t>CPI methodology</a:t>
+              <a:t>How fares are priced now</a:t>
             </a:r>
           </a:p>
           <a:p>
@@ -17274,13 +17274,13 @@
               </a:spcAft>
             </a:pPr>
             <a:r>
-              <a:rPr sz="1150" b="0">
+              <a:rPr sz="1050" b="0">
                 <a:solidFill>
                   <a:srgbClr val="262B33"/>
                 </a:solidFill>
                 <a:latin typeface="Arial"/>
               </a:rPr>
-              <a:t>MoSPI CPI (Base 2012=100). Field collectors visit shops and markets monthly — the process this augments.</a:t>
+              <a:t>Field staff price items in sampled villages and urban markets on a weekly roster. Air travel is collected by hand.</a:t>
             </a:r>
           </a:p>
         </p:txBody>
@@ -17293,7 +17293,7 @@
         </p:nvSpPr>
         <p:spPr>
           <a:xfrm>
-            <a:off x="5916168" y="4480559"/>
+            <a:off x="5916168" y="3730752"/>
             <a:ext cx="2011680" cy="219456"/>
           </a:xfrm>
           <a:prstGeom prst="rect">
@@ -17309,14 +17309,14 @@
           <a:p>
             <a:pPr algn="r"/>
             <a:r>
-              <a:rPr sz="1050" b="1" u="sng">
+              <a:rPr sz="1000" b="1" u="sng">
                 <a:solidFill>
                   <a:srgbClr val="0E7C86"/>
                 </a:solidFill>
                 <a:latin typeface="Arial"/>
                 <a:hlinkClick r:id="rId8"/>
               </a:rPr>
-              <a:t>MoSPI CPI series</a:t>
+              <a:t>CPI 2024 series FAQs</a:t>
             </a:r>
           </a:p>
         </p:txBody>
@@ -17331,8 +17331,8 @@
         </p:nvSpPr>
         <p:spPr>
           <a:xfrm>
-            <a:off x="8330183" y="3108960"/>
-            <a:ext cx="3703320" cy="1627632"/>
+            <a:off x="8330183" y="2670048"/>
+            <a:ext cx="3703320" cy="1298448"/>
           </a:xfrm>
           <a:prstGeom prst="roundRect">
             <a:avLst>
@@ -17377,8 +17377,8 @@
         </p:nvSpPr>
         <p:spPr>
           <a:xfrm>
-            <a:off x="8330183" y="3108960"/>
-            <a:ext cx="3703320" cy="64008"/>
+            <a:off x="8330183" y="2670048"/>
+            <a:ext cx="3703320" cy="54864"/>
           </a:xfrm>
           <a:prstGeom prst="rect">
             <a:avLst/>
@@ -17421,8 +17421,8 @@
         </p:nvSpPr>
         <p:spPr>
           <a:xfrm>
-            <a:off x="8476488" y="3236976"/>
-            <a:ext cx="3410712" cy="1207008"/>
+            <a:off x="8476488" y="2779776"/>
+            <a:ext cx="3410712" cy="896112"/>
           </a:xfrm>
           <a:prstGeom prst="rect">
             <a:avLst/>
@@ -17447,13 +17447,13 @@
               </a:spcAft>
             </a:pPr>
             <a:r>
-              <a:rPr sz="1350" b="1">
+              <a:rPr sz="1250" b="1">
                 <a:solidFill>
                   <a:srgbClr val="7A3E6B"/>
                 </a:solidFill>
                 <a:latin typeface="Arial"/>
               </a:rPr>
-              <a:t>Our code and full method</a:t>
+              <a:t>The Indian basket</a:t>
             </a:r>
           </a:p>
           <a:p>
@@ -17469,14 +17469,13 @@
               </a:spcAft>
             </a:pPr>
             <a:r>
-              <a:rPr sz="1150" b="0">
+              <a:rPr sz="1050" b="0">
                 <a:solidFill>
                   <a:srgbClr val="262B33"/>
                 </a:solidFill>
                 <a:latin typeface="Arial"/>
               </a:rPr>
-              <a:t>Collector, index engine, export API and portal. The README documents the method and the publication threshold.
-github.com/BradCage-afk/sih-2026-airfare-index</a:t>
+              <a:t>DGCA city-pair statistics: 164 m domestic passengers, IndiGo 64.2%. Our own 1,000-fare sample returned 68.2% — arrived at independently.</a:t>
             </a:r>
           </a:p>
         </p:txBody>
@@ -17489,7 +17488,7 @@
         </p:nvSpPr>
         <p:spPr>
           <a:xfrm>
-            <a:off x="9875520" y="4480559"/>
+            <a:off x="9875520" y="3730752"/>
             <a:ext cx="2011680" cy="219456"/>
           </a:xfrm>
           <a:prstGeom prst="rect">
@@ -17505,52 +17504,120 @@
           <a:p>
             <a:pPr algn="r"/>
             <a:r>
-              <a:rPr sz="1050" b="1" u="sng">
+              <a:rPr sz="1000" b="1" u="sng">
                 <a:solidFill>
                   <a:srgbClr val="7A3E6B"/>
                 </a:solidFill>
                 <a:latin typeface="Arial"/>
                 <a:hlinkClick r:id="rId9"/>
               </a:rPr>
-              <a:t>Open the repo</a:t>
-            </a:r>
-          </a:p>
-        </p:txBody>
-      </p:sp>
-      <p:pic>
-        <p:nvPicPr>
-          <p:cNvPr id="17435" name="Picture 17434" descr="chart-survey.png"/>
-          <p:cNvPicPr>
-            <a:picLocks noChangeAspect="1"/>
-          </p:cNvPicPr>
-          <p:nvPr/>
-        </p:nvPicPr>
-        <p:blipFill>
-          <a:blip r:embed="rId10"/>
-          <a:stretch>
-            <a:fillRect/>
-          </a:stretch>
-        </p:blipFill>
-        <p:spPr>
-          <a:xfrm>
-            <a:off x="411480" y="4754880"/>
-            <a:ext cx="4160520" cy="1379303"/>
+              <a:t>DGCA statistics</a:t>
+            </a:r>
+          </a:p>
+        </p:txBody>
+      </p:sp>
+      <p:sp>
+        <p:nvSpPr>
+          <p:cNvPr id="17435" name="Rounded Rectangle 17434">
+            <a:hlinkClick r:id="rId10"/>
+          </p:cNvPr>
+          <p:cNvSpPr/>
+          <p:nvPr/>
+        </p:nvSpPr>
+        <p:spPr>
+          <a:xfrm>
+            <a:off x="411480" y="4096512"/>
+            <a:ext cx="3703320" cy="1298448"/>
+          </a:xfrm>
+          <a:prstGeom prst="roundRect">
+            <a:avLst>
+              <a:gd name="adj" fmla="val 6000"/>
+            </a:avLst>
+          </a:prstGeom>
+          <a:solidFill>
+            <a:srgbClr val="E8F0F9"/>
+          </a:solidFill>
+          <a:ln>
+            <a:noFill/>
+          </a:ln>
+          <a:effectLst/>
+        </p:spPr>
+        <p:style>
+          <a:lnRef idx="1">
+            <a:schemeClr val="accent1"/>
+          </a:lnRef>
+          <a:fillRef idx="3">
+            <a:schemeClr val="accent1"/>
+          </a:fillRef>
+          <a:effectRef idx="2">
+            <a:schemeClr val="accent1"/>
+          </a:effectRef>
+          <a:fontRef idx="minor">
+            <a:schemeClr val="lt1"/>
+          </a:fontRef>
+        </p:style>
+        <p:txBody>
+          <a:bodyPr rtlCol="0" anchor="ctr" wrap="square"/>
+          <a:lstStyle/>
+          <a:p>
+            <a:pPr algn="ctr"/>
+          </a:p>
+        </p:txBody>
+      </p:sp>
+      <p:sp>
+        <p:nvSpPr>
+          <p:cNvPr id="17436" name="Rectangle 17435"/>
+          <p:cNvSpPr/>
+          <p:nvPr/>
+        </p:nvSpPr>
+        <p:spPr>
+          <a:xfrm>
+            <a:off x="411480" y="4096512"/>
+            <a:ext cx="3703320" cy="54864"/>
           </a:xfrm>
           <a:prstGeom prst="rect">
             <a:avLst/>
           </a:prstGeom>
-        </p:spPr>
-      </p:pic>
-      <p:sp>
-        <p:nvSpPr>
-          <p:cNvPr id="17436" name="TextBox 17435"/>
+          <a:solidFill>
+            <a:srgbClr val="4F81BD"/>
+          </a:solidFill>
+          <a:ln>
+            <a:noFill/>
+          </a:ln>
+          <a:effectLst/>
+        </p:spPr>
+        <p:style>
+          <a:lnRef idx="1">
+            <a:schemeClr val="accent1"/>
+          </a:lnRef>
+          <a:fillRef idx="3">
+            <a:schemeClr val="accent1"/>
+          </a:fillRef>
+          <a:effectRef idx="2">
+            <a:schemeClr val="accent1"/>
+          </a:effectRef>
+          <a:fontRef idx="minor">
+            <a:schemeClr val="lt1"/>
+          </a:fontRef>
+        </p:style>
+        <p:txBody>
+          <a:bodyPr rtlCol="0" anchor="ctr"/>
+          <a:lstStyle/>
+          <a:p>
+            <a:pPr algn="ctr"/>
+          </a:p>
+        </p:txBody>
+      </p:sp>
+      <p:sp>
+        <p:nvSpPr>
+          <p:cNvPr id="17437" name="TextBox 17436"/>
           <p:cNvSpPr txBox="1"/>
           <p:nvPr/>
         </p:nvSpPr>
         <p:spPr>
           <a:xfrm>
-            <a:off x="4800600" y="4791456"/>
-            <a:ext cx="6949440" cy="1188720"/>
+            <a:off x="557784" y="4206240"/>
+            <a:ext cx="3410712" cy="896112"/>
           </a:xfrm>
           <a:prstGeom prst="rect">
             <a:avLst/>
@@ -17558,36 +17625,36 @@
           <a:noFill/>
         </p:spPr>
         <p:txBody>
-          <a:bodyPr wrap="square" lIns="36576" rIns="36576">
+          <a:bodyPr wrap="square" lIns="36576" rIns="36576" tIns="18288" bIns="18288">
             <a:spAutoFit/>
           </a:bodyPr>
           <a:lstStyle/>
           <a:p>
             <a:pPr>
               <a:lnSpc>
-                <a:spcPct val="100000"/>
-              </a:lnSpc>
-              <a:spcBef>
-                <a:spcPts val="0"/>
-              </a:spcBef>
-              <a:spcAft>
-                <a:spcPts val="0"/>
-              </a:spcAft>
-            </a:pPr>
-            <a:r>
-              <a:rPr sz="1300" b="1">
-                <a:solidFill>
-                  <a:srgbClr val="1F497D"/>
+                <a:spcPct val="95000"/>
+              </a:lnSpc>
+              <a:spcBef>
+                <a:spcPts val="0"/>
+              </a:spcBef>
+              <a:spcAft>
+                <a:spcPts val="0"/>
+              </a:spcAft>
+            </a:pPr>
+            <a:r>
+              <a:rPr sz="1250" b="1">
+                <a:solidFill>
+                  <a:srgbClr val="4F81BD"/>
                 </a:solidFill>
                 <a:latin typeface="Arial"/>
               </a:rPr>
-              <a:t>Everything above is reproducible.</a:t>
+              <a:t>Standards we hold to</a:t>
             </a:r>
           </a:p>
           <a:p>
             <a:pPr>
               <a:lnSpc>
-                <a:spcPct val="100000"/>
+                <a:spcPct val="95000"/>
               </a:lnSpc>
               <a:spcBef>
                 <a:spcPts val="400"/>
@@ -17597,49 +17664,27 @@
               </a:spcAft>
             </a:pPr>
             <a:r>
-              <a:rPr sz="1150" b="0">
+              <a:rPr sz="1050" b="0">
                 <a:solidFill>
                   <a:srgbClr val="262B33"/>
                 </a:solidFill>
                 <a:latin typeface="Arial"/>
               </a:rPr>
-              <a:t>The index, every chart in this deck and every figure on the portal are regenerated from the database by scripts in the repository. Nothing is transcribed by hand, so no number here can drift from what the system holds.</a:t>
-            </a:r>
-          </a:p>
-          <a:p>
-            <a:pPr>
-              <a:lnSpc>
-                <a:spcPct val="100000"/>
-              </a:lnSpc>
-              <a:spcBef>
-                <a:spcPts val="600"/>
-              </a:spcBef>
-              <a:spcAft>
-                <a:spcPts val="0"/>
-              </a:spcAft>
-            </a:pPr>
-            <a:r>
-              <a:rPr sz="1150" b="1">
-                <a:solidFill>
-                  <a:srgbClr val="1F497D"/>
-                </a:solidFill>
-                <a:latin typeface="Arial"/>
-              </a:rPr>
-              <a:t>Everything in this deck is checkable against a live system:</a:t>
-            </a:r>
-          </a:p>
-        </p:txBody>
-      </p:sp>
-      <p:sp>
-        <p:nvSpPr>
-          <p:cNvPr id="17437" name="TextBox 17436"/>
+              <a:t>RFC 9309, the Robots Exclusion Protocol. We implemented it ourselves after finding Python's standard parser reports disallowed paths as allowed.</a:t>
+            </a:r>
+          </a:p>
+        </p:txBody>
+      </p:sp>
+      <p:sp>
+        <p:nvSpPr>
+          <p:cNvPr id="17438" name="TextBox 17437"/>
           <p:cNvSpPr txBox="1"/>
           <p:nvPr/>
         </p:nvSpPr>
         <p:spPr>
           <a:xfrm>
-            <a:off x="4800600" y="5907024"/>
-            <a:ext cx="1641348" cy="219456"/>
+            <a:off x="1956816" y="5157216"/>
+            <a:ext cx="2011680" cy="219456"/>
           </a:xfrm>
           <a:prstGeom prst="rect">
             <a:avLst/>
@@ -17652,30 +17697,189 @@
           </a:bodyPr>
           <a:lstStyle/>
           <a:p>
-            <a:pPr algn="l"/>
-            <a:r>
-              <a:rPr sz="1050" b="1" u="sng">
-                <a:solidFill>
-                  <a:srgbClr val="1F497D"/>
+            <a:pPr algn="r"/>
+            <a:r>
+              <a:rPr sz="1000" b="1" u="sng">
+                <a:solidFill>
+                  <a:srgbClr val="4F81BD"/>
                 </a:solidFill>
                 <a:latin typeface="Arial"/>
-                <a:hlinkClick r:id="rId11"/>
-              </a:rPr>
-              <a:t>Live API docs</a:t>
-            </a:r>
-          </a:p>
-        </p:txBody>
-      </p:sp>
-      <p:sp>
-        <p:nvSpPr>
-          <p:cNvPr id="17438" name="TextBox 17437"/>
+                <a:hlinkClick r:id="rId10"/>
+              </a:rPr>
+              <a:t>RFC 9309</a:t>
+            </a:r>
+          </a:p>
+        </p:txBody>
+      </p:sp>
+      <p:sp>
+        <p:nvSpPr>
+          <p:cNvPr id="17439" name="Rounded Rectangle 17438">
+            <a:hlinkClick r:id="rId11"/>
+          </p:cNvPr>
+          <p:cNvSpPr/>
+          <p:nvPr/>
+        </p:nvSpPr>
+        <p:spPr>
+          <a:xfrm>
+            <a:off x="4370832" y="4096512"/>
+            <a:ext cx="3703320" cy="1298448"/>
+          </a:xfrm>
+          <a:prstGeom prst="roundRect">
+            <a:avLst>
+              <a:gd name="adj" fmla="val 6000"/>
+            </a:avLst>
+          </a:prstGeom>
+          <a:solidFill>
+            <a:srgbClr val="E4F4EC"/>
+          </a:solidFill>
+          <a:ln>
+            <a:noFill/>
+          </a:ln>
+          <a:effectLst/>
+        </p:spPr>
+        <p:style>
+          <a:lnRef idx="1">
+            <a:schemeClr val="accent1"/>
+          </a:lnRef>
+          <a:fillRef idx="3">
+            <a:schemeClr val="accent1"/>
+          </a:fillRef>
+          <a:effectRef idx="2">
+            <a:schemeClr val="accent1"/>
+          </a:effectRef>
+          <a:fontRef idx="minor">
+            <a:schemeClr val="lt1"/>
+          </a:fontRef>
+        </p:style>
+        <p:txBody>
+          <a:bodyPr rtlCol="0" anchor="ctr" wrap="square"/>
+          <a:lstStyle/>
+          <a:p>
+            <a:pPr algn="ctr"/>
+          </a:p>
+        </p:txBody>
+      </p:sp>
+      <p:sp>
+        <p:nvSpPr>
+          <p:cNvPr id="17440" name="Rectangle 17439"/>
+          <p:cNvSpPr/>
+          <p:nvPr/>
+        </p:nvSpPr>
+        <p:spPr>
+          <a:xfrm>
+            <a:off x="4370832" y="4096512"/>
+            <a:ext cx="3703320" cy="54864"/>
+          </a:xfrm>
+          <a:prstGeom prst="rect">
+            <a:avLst/>
+          </a:prstGeom>
+          <a:solidFill>
+            <a:srgbClr val="1B8A5A"/>
+          </a:solidFill>
+          <a:ln>
+            <a:noFill/>
+          </a:ln>
+          <a:effectLst/>
+        </p:spPr>
+        <p:style>
+          <a:lnRef idx="1">
+            <a:schemeClr val="accent1"/>
+          </a:lnRef>
+          <a:fillRef idx="3">
+            <a:schemeClr val="accent1"/>
+          </a:fillRef>
+          <a:effectRef idx="2">
+            <a:schemeClr val="accent1"/>
+          </a:effectRef>
+          <a:fontRef idx="minor">
+            <a:schemeClr val="lt1"/>
+          </a:fontRef>
+        </p:style>
+        <p:txBody>
+          <a:bodyPr rtlCol="0" anchor="ctr"/>
+          <a:lstStyle/>
+          <a:p>
+            <a:pPr algn="ctr"/>
+          </a:p>
+        </p:txBody>
+      </p:sp>
+      <p:sp>
+        <p:nvSpPr>
+          <p:cNvPr id="17441" name="TextBox 17440"/>
           <p:cNvSpPr txBox="1"/>
           <p:nvPr/>
         </p:nvSpPr>
         <p:spPr>
           <a:xfrm>
-            <a:off x="6569964" y="5907024"/>
-            <a:ext cx="1641348" cy="219456"/>
+            <a:off x="4517136" y="4206240"/>
+            <a:ext cx="3410712" cy="896112"/>
+          </a:xfrm>
+          <a:prstGeom prst="rect">
+            <a:avLst/>
+          </a:prstGeom>
+          <a:noFill/>
+        </p:spPr>
+        <p:txBody>
+          <a:bodyPr wrap="square" lIns="36576" rIns="36576" tIns="18288" bIns="18288">
+            <a:spAutoFit/>
+          </a:bodyPr>
+          <a:lstStyle/>
+          <a:p>
+            <a:pPr>
+              <a:lnSpc>
+                <a:spcPct val="95000"/>
+              </a:lnSpc>
+              <a:spcBef>
+                <a:spcPts val="0"/>
+              </a:spcBef>
+              <a:spcAft>
+                <a:spcPts val="0"/>
+              </a:spcAft>
+            </a:pPr>
+            <a:r>
+              <a:rPr sz="1250" b="1">
+                <a:solidFill>
+                  <a:srgbClr val="1B8A5A"/>
+                </a:solidFill>
+                <a:latin typeface="Arial"/>
+              </a:rPr>
+              <a:t>The market we measure</a:t>
+            </a:r>
+          </a:p>
+          <a:p>
+            <a:pPr>
+              <a:lnSpc>
+                <a:spcPct val="95000"/>
+              </a:lnSpc>
+              <a:spcBef>
+                <a:spcPts val="400"/>
+              </a:spcBef>
+              <a:spcAft>
+                <a:spcPts val="0"/>
+              </a:spcAft>
+            </a:pPr>
+            <a:r>
+              <a:rPr sz="1050" b="0">
+                <a:solidFill>
+                  <a:srgbClr val="262B33"/>
+                </a:solidFill>
+                <a:latin typeface="Arial"/>
+              </a:rPr>
+              <a:t>India is the world's fifth-largest aviation market, worth USD 18.1 bn in 2026 and growing 11.7% a year. Fares move daily; the CPI reads them monthly.</a:t>
+            </a:r>
+          </a:p>
+        </p:txBody>
+      </p:sp>
+      <p:sp>
+        <p:nvSpPr>
+          <p:cNvPr id="17442" name="TextBox 17441"/>
+          <p:cNvSpPr txBox="1"/>
+          <p:nvPr/>
+        </p:nvSpPr>
+        <p:spPr>
+          <a:xfrm>
+            <a:off x="5916168" y="5157216"/>
+            <a:ext cx="2011680" cy="219456"/>
           </a:xfrm>
           <a:prstGeom prst="rect">
             <a:avLst/>
@@ -17688,30 +17892,189 @@
           </a:bodyPr>
           <a:lstStyle/>
           <a:p>
-            <a:pPr algn="l"/>
-            <a:r>
-              <a:rPr sz="1050" b="1" u="sng">
+            <a:pPr algn="r"/>
+            <a:r>
+              <a:rPr sz="1000" b="1" u="sng">
                 <a:solidFill>
                   <a:srgbClr val="1B8A5A"/>
                 </a:solidFill>
                 <a:latin typeface="Arial"/>
-                <a:hlinkClick r:id="rId12"/>
-              </a:rPr>
-              <a:t>Release portal</a:t>
-            </a:r>
-          </a:p>
-        </p:txBody>
-      </p:sp>
-      <p:sp>
-        <p:nvSpPr>
-          <p:cNvPr id="17439" name="TextBox 17438"/>
+                <a:hlinkClick r:id="rId11"/>
+              </a:rPr>
+              <a:t>Aviation market</a:t>
+            </a:r>
+          </a:p>
+        </p:txBody>
+      </p:sp>
+      <p:sp>
+        <p:nvSpPr>
+          <p:cNvPr id="17443" name="Rounded Rectangle 17442">
+            <a:hlinkClick r:id="rId12"/>
+          </p:cNvPr>
+          <p:cNvSpPr/>
+          <p:nvPr/>
+        </p:nvSpPr>
+        <p:spPr>
+          <a:xfrm>
+            <a:off x="8330183" y="4096512"/>
+            <a:ext cx="3703320" cy="1298448"/>
+          </a:xfrm>
+          <a:prstGeom prst="roundRect">
+            <a:avLst>
+              <a:gd name="adj" fmla="val 6000"/>
+            </a:avLst>
+          </a:prstGeom>
+          <a:solidFill>
+            <a:srgbClr val="FBF0DD"/>
+          </a:solidFill>
+          <a:ln>
+            <a:noFill/>
+          </a:ln>
+          <a:effectLst/>
+        </p:spPr>
+        <p:style>
+          <a:lnRef idx="1">
+            <a:schemeClr val="accent1"/>
+          </a:lnRef>
+          <a:fillRef idx="3">
+            <a:schemeClr val="accent1"/>
+          </a:fillRef>
+          <a:effectRef idx="2">
+            <a:schemeClr val="accent1"/>
+          </a:effectRef>
+          <a:fontRef idx="minor">
+            <a:schemeClr val="lt1"/>
+          </a:fontRef>
+        </p:style>
+        <p:txBody>
+          <a:bodyPr rtlCol="0" anchor="ctr" wrap="square"/>
+          <a:lstStyle/>
+          <a:p>
+            <a:pPr algn="ctr"/>
+          </a:p>
+        </p:txBody>
+      </p:sp>
+      <p:sp>
+        <p:nvSpPr>
+          <p:cNvPr id="17444" name="Rectangle 17443"/>
+          <p:cNvSpPr/>
+          <p:nvPr/>
+        </p:nvSpPr>
+        <p:spPr>
+          <a:xfrm>
+            <a:off x="8330183" y="4096512"/>
+            <a:ext cx="3703320" cy="54864"/>
+          </a:xfrm>
+          <a:prstGeom prst="rect">
+            <a:avLst/>
+          </a:prstGeom>
+          <a:solidFill>
+            <a:srgbClr val="C77700"/>
+          </a:solidFill>
+          <a:ln>
+            <a:noFill/>
+          </a:ln>
+          <a:effectLst/>
+        </p:spPr>
+        <p:style>
+          <a:lnRef idx="1">
+            <a:schemeClr val="accent1"/>
+          </a:lnRef>
+          <a:fillRef idx="3">
+            <a:schemeClr val="accent1"/>
+          </a:fillRef>
+          <a:effectRef idx="2">
+            <a:schemeClr val="accent1"/>
+          </a:effectRef>
+          <a:fontRef idx="minor">
+            <a:schemeClr val="lt1"/>
+          </a:fontRef>
+        </p:style>
+        <p:txBody>
+          <a:bodyPr rtlCol="0" anchor="ctr"/>
+          <a:lstStyle/>
+          <a:p>
+            <a:pPr algn="ctr"/>
+          </a:p>
+        </p:txBody>
+      </p:sp>
+      <p:sp>
+        <p:nvSpPr>
+          <p:cNvPr id="17445" name="TextBox 17444"/>
           <p:cNvSpPr txBox="1"/>
           <p:nvPr/>
         </p:nvSpPr>
         <p:spPr>
           <a:xfrm>
-            <a:off x="8339328" y="5907024"/>
-            <a:ext cx="1641348" cy="219456"/>
+            <a:off x="8476488" y="4206240"/>
+            <a:ext cx="3410712" cy="896112"/>
+          </a:xfrm>
+          <a:prstGeom prst="rect">
+            <a:avLst/>
+          </a:prstGeom>
+          <a:noFill/>
+        </p:spPr>
+        <p:txBody>
+          <a:bodyPr wrap="square" lIns="36576" rIns="36576" tIns="18288" bIns="18288">
+            <a:spAutoFit/>
+          </a:bodyPr>
+          <a:lstStyle/>
+          <a:p>
+            <a:pPr>
+              <a:lnSpc>
+                <a:spcPct val="95000"/>
+              </a:lnSpc>
+              <a:spcBef>
+                <a:spcPts val="0"/>
+              </a:spcBef>
+              <a:spcAft>
+                <a:spcPts val="0"/>
+              </a:spcAft>
+            </a:pPr>
+            <a:r>
+              <a:rPr sz="1250" b="1">
+                <a:solidFill>
+                  <a:srgbClr val="C77700"/>
+                </a:solidFill>
+                <a:latin typeface="Arial"/>
+              </a:rPr>
+              <a:t>Our code and full method</a:t>
+            </a:r>
+          </a:p>
+          <a:p>
+            <a:pPr>
+              <a:lnSpc>
+                <a:spcPct val="95000"/>
+              </a:lnSpc>
+              <a:spcBef>
+                <a:spcPts val="400"/>
+              </a:spcBef>
+              <a:spcAft>
+                <a:spcPts val="0"/>
+              </a:spcAft>
+            </a:pPr>
+            <a:r>
+              <a:rPr sz="1050" b="0">
+                <a:solidFill>
+                  <a:srgbClr val="262B33"/>
+                </a:solidFill>
+                <a:latin typeface="Arial"/>
+              </a:rPr>
+              <a:t>Collector, index engine, export API and portal. The README documents the method, the exclusion rules and the publication threshold.</a:t>
+            </a:r>
+          </a:p>
+        </p:txBody>
+      </p:sp>
+      <p:sp>
+        <p:nvSpPr>
+          <p:cNvPr id="17446" name="TextBox 17445"/>
+          <p:cNvSpPr txBox="1"/>
+          <p:nvPr/>
+        </p:nvSpPr>
+        <p:spPr>
+          <a:xfrm>
+            <a:off x="9875520" y="5157216"/>
+            <a:ext cx="2011680" cy="219456"/>
           </a:xfrm>
           <a:prstGeom prst="rect">
             <a:avLst/>
@@ -17724,30 +18087,166 @@
           </a:bodyPr>
           <a:lstStyle/>
           <a:p>
-            <a:pPr algn="l"/>
-            <a:r>
-              <a:rPr sz="1050" b="1" u="sng">
-                <a:solidFill>
-                  <a:srgbClr val="4B3F8C"/>
+            <a:pPr algn="r"/>
+            <a:r>
+              <a:rPr sz="1000" b="1" u="sng">
+                <a:solidFill>
+                  <a:srgbClr val="C77700"/>
                 </a:solidFill>
                 <a:latin typeface="Arial"/>
-                <a:hlinkClick r:id="rId13"/>
-              </a:rPr>
-              <a:t>README + method</a:t>
-            </a:r>
-          </a:p>
-        </p:txBody>
-      </p:sp>
-      <p:sp>
-        <p:nvSpPr>
-          <p:cNvPr id="17440" name="TextBox 17439"/>
+                <a:hlinkClick r:id="rId12"/>
+              </a:rPr>
+              <a:t>Open the repository</a:t>
+            </a:r>
+          </a:p>
+        </p:txBody>
+      </p:sp>
+      <p:sp>
+        <p:nvSpPr>
+          <p:cNvPr id="17447" name="Rounded Rectangle 17446"/>
+          <p:cNvSpPr/>
+          <p:nvPr/>
+        </p:nvSpPr>
+        <p:spPr>
+          <a:xfrm>
+            <a:off x="411480" y="5504688"/>
+            <a:ext cx="11338560" cy="731520"/>
+          </a:xfrm>
+          <a:prstGeom prst="roundRect">
+            <a:avLst>
+              <a:gd name="adj" fmla="val 6000"/>
+            </a:avLst>
+          </a:prstGeom>
+          <a:solidFill>
+            <a:srgbClr val="E4F4EC"/>
+          </a:solidFill>
+          <a:ln>
+            <a:noFill/>
+          </a:ln>
+          <a:effectLst/>
+        </p:spPr>
+        <p:style>
+          <a:lnRef idx="1">
+            <a:schemeClr val="accent1"/>
+          </a:lnRef>
+          <a:fillRef idx="3">
+            <a:schemeClr val="accent1"/>
+          </a:fillRef>
+          <a:effectRef idx="2">
+            <a:schemeClr val="accent1"/>
+          </a:effectRef>
+          <a:fontRef idx="minor">
+            <a:schemeClr val="lt1"/>
+          </a:fontRef>
+        </p:style>
+        <p:txBody>
+          <a:bodyPr rtlCol="0" anchor="ctr" wrap="square"/>
+          <a:lstStyle/>
+          <a:p>
+            <a:pPr algn="ctr"/>
+          </a:p>
+        </p:txBody>
+      </p:sp>
+      <p:sp>
+        <p:nvSpPr>
+          <p:cNvPr id="17448" name="TextBox 17447"/>
           <p:cNvSpPr txBox="1"/>
           <p:nvPr/>
         </p:nvSpPr>
         <p:spPr>
           <a:xfrm>
-            <a:off x="10108692" y="5907024"/>
-            <a:ext cx="1641348" cy="219456"/>
+            <a:off x="566928" y="5559552"/>
+            <a:ext cx="11064240" cy="219456"/>
+          </a:xfrm>
+          <a:prstGeom prst="rect">
+            <a:avLst/>
+          </a:prstGeom>
+          <a:noFill/>
+        </p:spPr>
+        <p:txBody>
+          <a:bodyPr wrap="square" lIns="36576" rIns="36576" tIns="18288" bIns="18288">
+            <a:spAutoFit/>
+          </a:bodyPr>
+          <a:lstStyle/>
+          <a:p>
+            <a:pPr>
+              <a:lnSpc>
+                <a:spcPct val="95000"/>
+              </a:lnSpc>
+              <a:spcBef>
+                <a:spcPts val="0"/>
+              </a:spcBef>
+              <a:spcAft>
+                <a:spcPts val="0"/>
+              </a:spcAft>
+            </a:pPr>
+            <a:r>
+              <a:rPr sz="1100" b="0">
+                <a:solidFill>
+                  <a:srgbClr val="262B33"/>
+                </a:solidFill>
+                <a:latin typeface="Arial"/>
+              </a:rPr>
+              <a:t>Everything above is reproducible — every figure in this deck and on the portal regenerates from the database by scripts in the repository, none typed by hand.</a:t>
+            </a:r>
+          </a:p>
+        </p:txBody>
+      </p:sp>
+      <p:sp>
+        <p:nvSpPr>
+          <p:cNvPr id="17449" name="TextBox 17448"/>
+          <p:cNvSpPr txBox="1"/>
+          <p:nvPr/>
+        </p:nvSpPr>
+        <p:spPr>
+          <a:xfrm>
+            <a:off x="566928" y="5870448"/>
+            <a:ext cx="1188720" cy="219456"/>
+          </a:xfrm>
+          <a:prstGeom prst="rect">
+            <a:avLst/>
+          </a:prstGeom>
+          <a:noFill/>
+        </p:spPr>
+        <p:txBody>
+          <a:bodyPr wrap="square" lIns="36576" rIns="36576" tIns="18288" bIns="18288">
+            <a:spAutoFit/>
+          </a:bodyPr>
+          <a:lstStyle/>
+          <a:p>
+            <a:pPr>
+              <a:lnSpc>
+                <a:spcPct val="95000"/>
+              </a:lnSpc>
+              <a:spcBef>
+                <a:spcPts val="0"/>
+              </a:spcBef>
+              <a:spcAft>
+                <a:spcPts val="0"/>
+              </a:spcAft>
+            </a:pPr>
+            <a:r>
+              <a:rPr sz="950" b="1">
+                <a:solidFill>
+                  <a:srgbClr val="5A626C"/>
+                </a:solidFill>
+                <a:latin typeface="Arial"/>
+              </a:rPr>
+              <a:t>LIVE SYSTEM</a:t>
+            </a:r>
+          </a:p>
+        </p:txBody>
+      </p:sp>
+      <p:sp>
+        <p:nvSpPr>
+          <p:cNvPr id="17450" name="TextBox 17449"/>
+          <p:cNvSpPr txBox="1"/>
+          <p:nvPr/>
+        </p:nvSpPr>
+        <p:spPr>
+          <a:xfrm>
+            <a:off x="1783080" y="5870448"/>
+            <a:ext cx="2286000" cy="219456"/>
           </a:xfrm>
           <a:prstGeom prst="rect">
             <a:avLst/>
@@ -17764,10 +18263,118 @@
             <a:r>
               <a:rPr sz="1050" b="1" u="sng">
                 <a:solidFill>
-                  <a:srgbClr val="0E7C86"/>
+                  <a:srgbClr val="1F497D"/>
+                </a:solidFill>
+                <a:latin typeface="Arial"/>
+                <a:hlinkClick r:id="rId13"/>
+              </a:rPr>
+              <a:t>Live API docs</a:t>
+            </a:r>
+          </a:p>
+        </p:txBody>
+      </p:sp>
+      <p:sp>
+        <p:nvSpPr>
+          <p:cNvPr id="17451" name="TextBox 17450"/>
+          <p:cNvSpPr txBox="1"/>
+          <p:nvPr/>
+        </p:nvSpPr>
+        <p:spPr>
+          <a:xfrm>
+            <a:off x="4160520" y="5870448"/>
+            <a:ext cx="2286000" cy="219456"/>
+          </a:xfrm>
+          <a:prstGeom prst="rect">
+            <a:avLst/>
+          </a:prstGeom>
+          <a:noFill/>
+        </p:spPr>
+        <p:txBody>
+          <a:bodyPr wrap="none" lIns="0" rIns="0" tIns="0" bIns="0">
+            <a:spAutoFit/>
+          </a:bodyPr>
+          <a:lstStyle/>
+          <a:p>
+            <a:pPr algn="l"/>
+            <a:r>
+              <a:rPr sz="1050" b="1" u="sng">
+                <a:solidFill>
+                  <a:srgbClr val="1B8A5A"/>
                 </a:solidFill>
                 <a:latin typeface="Arial"/>
                 <a:hlinkClick r:id="rId14"/>
+              </a:rPr>
+              <a:t>Release portal</a:t>
+            </a:r>
+          </a:p>
+        </p:txBody>
+      </p:sp>
+      <p:sp>
+        <p:nvSpPr>
+          <p:cNvPr id="17452" name="TextBox 17451"/>
+          <p:cNvSpPr txBox="1"/>
+          <p:nvPr/>
+        </p:nvSpPr>
+        <p:spPr>
+          <a:xfrm>
+            <a:off x="6537960" y="5870448"/>
+            <a:ext cx="2286000" cy="219456"/>
+          </a:xfrm>
+          <a:prstGeom prst="rect">
+            <a:avLst/>
+          </a:prstGeom>
+          <a:noFill/>
+        </p:spPr>
+        <p:txBody>
+          <a:bodyPr wrap="none" lIns="0" rIns="0" tIns="0" bIns="0">
+            <a:spAutoFit/>
+          </a:bodyPr>
+          <a:lstStyle/>
+          <a:p>
+            <a:pPr algn="l"/>
+            <a:r>
+              <a:rPr sz="1050" b="1" u="sng">
+                <a:solidFill>
+                  <a:srgbClr val="4B3F8C"/>
+                </a:solidFill>
+                <a:latin typeface="Arial"/>
+                <a:hlinkClick r:id="rId15"/>
+              </a:rPr>
+              <a:t>README + method</a:t>
+            </a:r>
+          </a:p>
+        </p:txBody>
+      </p:sp>
+      <p:sp>
+        <p:nvSpPr>
+          <p:cNvPr id="17453" name="TextBox 17452"/>
+          <p:cNvSpPr txBox="1"/>
+          <p:nvPr/>
+        </p:nvSpPr>
+        <p:spPr>
+          <a:xfrm>
+            <a:off x="8915400" y="5870448"/>
+            <a:ext cx="2286000" cy="219456"/>
+          </a:xfrm>
+          <a:prstGeom prst="rect">
+            <a:avLst/>
+          </a:prstGeom>
+          <a:noFill/>
+        </p:spPr>
+        <p:txBody>
+          <a:bodyPr wrap="none" lIns="0" rIns="0" tIns="0" bIns="0">
+            <a:spAutoFit/>
+          </a:bodyPr>
+          <a:lstStyle/>
+          <a:p>
+            <a:pPr algn="l"/>
+            <a:r>
+              <a:rPr sz="1050" b="1" u="sng">
+                <a:solidFill>
+                  <a:srgbClr val="0E7C86"/>
+                </a:solidFill>
+                <a:latin typeface="Arial"/>
+                <a:hlinkClick r:id="rId11"/>
               </a:rPr>
               <a:t>Aviation market</a:t>
             </a:r>

</xml_diff>

<commit_message>
Deck: read the fare count from the database, tighten stack strip and cost table
The headline said 36,000+ fares while the database held 51,958. It now reads
the live count at build time with a stated fallback, so slide 6's claim that
nothing is typed by hand holds for that figure too.

Co-Authored-By: Claude Opus 5 <noreply@anthropic.com>
Claude-Session: https://claude.ai/code/session_0129UjVhHMAVJgfcaxoN1dD5
</commit_message>
<xml_diff>
--- a/SIH26056-Idea-Presentation.pptx
+++ b/SIH26056-Idea-Presentation.pptx
@@ -6200,7 +6200,7 @@
                 </a:solidFill>
                 <a:latin typeface="Arial"/>
               </a:rPr>
-              <a:t>36,000+ fares collected · 15 city pairs × 5 lead times · every 10 minutes · ₹0 a month to run</a:t>
+              <a:t>51,000+ fares collected · 15 city pairs × 5 lead times · every 10 minutes · ₹0 a month to run</a:t>
             </a:r>
           </a:p>
         </p:txBody>
@@ -13121,8 +13121,8 @@
         </p:nvSpPr>
         <p:spPr>
           <a:xfrm>
-            <a:off x="6400800" y="5468112"/>
-            <a:ext cx="5394960" cy="841248"/>
+            <a:off x="6400800" y="5449824"/>
+            <a:ext cx="5394960" cy="877824"/>
           </a:xfrm>
           <a:prstGeom prst="roundRect">
             <a:avLst>
@@ -13167,7 +13167,7 @@
         </p:nvSpPr>
         <p:spPr>
           <a:xfrm>
-            <a:off x="6547104" y="5522976"/>
+            <a:off x="6547104" y="5504688"/>
             <a:ext cx="3291840" cy="155448"/>
           </a:xfrm>
           <a:prstGeom prst="rect">
@@ -13212,7 +13212,7 @@
         </p:nvSpPr>
         <p:spPr>
           <a:xfrm>
-            <a:off x="9921240" y="5522976"/>
+            <a:off x="9921240" y="5504688"/>
             <a:ext cx="1737360" cy="155448"/>
           </a:xfrm>
           <a:prstGeom prst="rect">
@@ -13257,7 +13257,7 @@
         </p:nvSpPr>
         <p:spPr>
           <a:xfrm>
-            <a:off x="6547104" y="5678424"/>
+            <a:off x="6547104" y="5660136"/>
             <a:ext cx="3291840" cy="155448"/>
           </a:xfrm>
           <a:prstGeom prst="rect">
@@ -13302,7 +13302,7 @@
         </p:nvSpPr>
         <p:spPr>
           <a:xfrm>
-            <a:off x="9921240" y="5678424"/>
+            <a:off x="9921240" y="5660136"/>
             <a:ext cx="1737360" cy="155448"/>
           </a:xfrm>
           <a:prstGeom prst="rect">
@@ -13347,7 +13347,7 @@
         </p:nvSpPr>
         <p:spPr>
           <a:xfrm>
-            <a:off x="6547104" y="5833872"/>
+            <a:off x="6547104" y="5815583"/>
             <a:ext cx="3291840" cy="155448"/>
           </a:xfrm>
           <a:prstGeom prst="rect">
@@ -13392,7 +13392,7 @@
         </p:nvSpPr>
         <p:spPr>
           <a:xfrm>
-            <a:off x="9921240" y="5833872"/>
+            <a:off x="9921240" y="5815583"/>
             <a:ext cx="1737360" cy="155448"/>
           </a:xfrm>
           <a:prstGeom prst="rect">
@@ -13437,7 +13437,7 @@
         </p:nvSpPr>
         <p:spPr>
           <a:xfrm>
-            <a:off x="6547104" y="5989320"/>
+            <a:off x="6547104" y="5971031"/>
             <a:ext cx="3291840" cy="155448"/>
           </a:xfrm>
           <a:prstGeom prst="rect">
@@ -13482,7 +13482,7 @@
         </p:nvSpPr>
         <p:spPr>
           <a:xfrm>
-            <a:off x="9921240" y="5989320"/>
+            <a:off x="9921240" y="5971031"/>
             <a:ext cx="1737360" cy="155448"/>
           </a:xfrm>
           <a:prstGeom prst="rect">
@@ -13527,7 +13527,7 @@
         </p:nvSpPr>
         <p:spPr>
           <a:xfrm>
-            <a:off x="6547104" y="6144768"/>
+            <a:off x="6547104" y="6126479"/>
             <a:ext cx="3291840" cy="155448"/>
           </a:xfrm>
           <a:prstGeom prst="rect">
@@ -13572,7 +13572,7 @@
         </p:nvSpPr>
         <p:spPr>
           <a:xfrm>
-            <a:off x="9921240" y="6144768"/>
+            <a:off x="9921240" y="6126479"/>
             <a:ext cx="1737360" cy="155448"/>
           </a:xfrm>
           <a:prstGeom prst="rect">

</xml_diff>

<commit_message>
Revert slide 6 to six references; cut slide 2 to four uniqueness cards
Both slides were over-packed. Slide 6 goes back to the six-card layout with the
survey chart; slide 2 drops from six uniqueness cards to four in a single row,
which frees the whole middle band. The corrected CPI 2024=100 source and its
working link are kept - the old cpi.mospi.gov.in URL does not resolve.

Co-Authored-By: Claude Opus 5 <noreply@anthropic.com>
Claude-Session: https://claude.ai/code/session_0129UjVhHMAVJgfcaxoN1dD5
</commit_message>
<xml_diff>
--- a/SIH26056-Idea-Presentation.pptx
+++ b/SIH26056-Idea-Presentation.pptx
@@ -6037,8 +6037,8 @@
         </p:nvSpPr>
         <p:spPr>
           <a:xfrm>
-            <a:off x="411480" y="896112"/>
-            <a:ext cx="7726679" cy="969264"/>
+            <a:off x="411480" y="914400"/>
+            <a:ext cx="7726679" cy="914400"/>
           </a:xfrm>
           <a:prstGeom prst="rect">
             <a:avLst/>
@@ -6113,7 +6113,7 @@
                 </a:solidFill>
                 <a:latin typeface="Arial"/>
               </a:rPr>
-              <a:t>MoSPI prices air travel by hand, once a month, for one departure date. APIx reads the same public pages every ten minutes and delivers one weighted index number to MoSPI through an API.</a:t>
+              <a:t>MoSPI prices air travel by hand, once a month, for one departure date. APIx reads the same public pages every ten minutes and delivers one weighted index number through an API.</a:t>
             </a:r>
           </a:p>
         </p:txBody>
@@ -6200,7 +6200,7 @@
                 </a:solidFill>
                 <a:latin typeface="Arial"/>
               </a:rPr>
-              <a:t>51,000+ fares collected · 15 city pairs × 5 lead times · every 10 minutes · ₹0 a month to run</a:t>
+              <a:t>52,000+ fares collected · 15 city pairs × 5 lead times · every 10 minutes · ₹0 a month to run</a:t>
             </a:r>
           </a:p>
         </p:txBody>
@@ -6213,8 +6213,8 @@
         </p:nvSpPr>
         <p:spPr>
           <a:xfrm>
-            <a:off x="411480" y="1901952"/>
-            <a:ext cx="6355080" cy="1719072"/>
+            <a:off x="411480" y="1975104"/>
+            <a:ext cx="6355080" cy="1792224"/>
           </a:xfrm>
           <a:prstGeom prst="roundRect">
             <a:avLst>
@@ -6259,7 +6259,7 @@
         </p:nvSpPr>
         <p:spPr>
           <a:xfrm>
-            <a:off x="548640" y="1965960"/>
+            <a:off x="548640" y="2039112"/>
             <a:ext cx="3840480" cy="237744"/>
           </a:xfrm>
           <a:prstGeom prst="rect">
@@ -6304,7 +6304,7 @@
         </p:nvSpPr>
         <p:spPr>
           <a:xfrm>
-            <a:off x="2148840" y="2240280"/>
+            <a:off x="2148840" y="2331720"/>
             <a:ext cx="1920240" cy="237744"/>
           </a:xfrm>
           <a:prstGeom prst="rect">
@@ -6349,7 +6349,7 @@
         </p:nvSpPr>
         <p:spPr>
           <a:xfrm>
-            <a:off x="4160520" y="2240280"/>
+            <a:off x="4160520" y="2331720"/>
             <a:ext cx="2468880" cy="237744"/>
           </a:xfrm>
           <a:prstGeom prst="rect">
@@ -6394,7 +6394,7 @@
         </p:nvSpPr>
         <p:spPr>
           <a:xfrm>
-            <a:off x="548640" y="2532888"/>
+            <a:off x="548640" y="2633472"/>
             <a:ext cx="1600200" cy="237744"/>
           </a:xfrm>
           <a:prstGeom prst="rect">
@@ -6439,7 +6439,7 @@
         </p:nvSpPr>
         <p:spPr>
           <a:xfrm>
-            <a:off x="2148840" y="2532888"/>
+            <a:off x="2148840" y="2633472"/>
             <a:ext cx="1920240" cy="237744"/>
           </a:xfrm>
           <a:prstGeom prst="rect">
@@ -6484,7 +6484,7 @@
         </p:nvSpPr>
         <p:spPr>
           <a:xfrm>
-            <a:off x="4160520" y="2532888"/>
+            <a:off x="4160520" y="2633472"/>
             <a:ext cx="2468880" cy="237744"/>
           </a:xfrm>
           <a:prstGeom prst="rect">
@@ -6529,7 +6529,7 @@
         </p:nvSpPr>
         <p:spPr>
           <a:xfrm>
-            <a:off x="548640" y="2798064"/>
+            <a:off x="548640" y="2916936"/>
             <a:ext cx="1600200" cy="237744"/>
           </a:xfrm>
           <a:prstGeom prst="rect">
@@ -6574,7 +6574,7 @@
         </p:nvSpPr>
         <p:spPr>
           <a:xfrm>
-            <a:off x="2148840" y="2798064"/>
+            <a:off x="2148840" y="2916936"/>
             <a:ext cx="1920240" cy="237744"/>
           </a:xfrm>
           <a:prstGeom prst="rect">
@@ -6619,7 +6619,7 @@
         </p:nvSpPr>
         <p:spPr>
           <a:xfrm>
-            <a:off x="4160520" y="2798064"/>
+            <a:off x="4160520" y="2916936"/>
             <a:ext cx="2468880" cy="237744"/>
           </a:xfrm>
           <a:prstGeom prst="rect">
@@ -6664,7 +6664,7 @@
         </p:nvSpPr>
         <p:spPr>
           <a:xfrm>
-            <a:off x="548640" y="3063240"/>
+            <a:off x="548640" y="3200400"/>
             <a:ext cx="1600200" cy="237744"/>
           </a:xfrm>
           <a:prstGeom prst="rect">
@@ -6709,7 +6709,7 @@
         </p:nvSpPr>
         <p:spPr>
           <a:xfrm>
-            <a:off x="2148840" y="3063240"/>
+            <a:off x="2148840" y="3200400"/>
             <a:ext cx="1920240" cy="237744"/>
           </a:xfrm>
           <a:prstGeom prst="rect">
@@ -6754,7 +6754,7 @@
         </p:nvSpPr>
         <p:spPr>
           <a:xfrm>
-            <a:off x="4160520" y="3063240"/>
+            <a:off x="4160520" y="3200400"/>
             <a:ext cx="2468880" cy="237744"/>
           </a:xfrm>
           <a:prstGeom prst="rect">
@@ -6799,7 +6799,7 @@
         </p:nvSpPr>
         <p:spPr>
           <a:xfrm>
-            <a:off x="548640" y="3328415"/>
+            <a:off x="548640" y="3483863"/>
             <a:ext cx="1600200" cy="237744"/>
           </a:xfrm>
           <a:prstGeom prst="rect">
@@ -6844,7 +6844,7 @@
         </p:nvSpPr>
         <p:spPr>
           <a:xfrm>
-            <a:off x="2148840" y="3328415"/>
+            <a:off x="2148840" y="3483863"/>
             <a:ext cx="1920240" cy="237744"/>
           </a:xfrm>
           <a:prstGeom prst="rect">
@@ -6889,7 +6889,7 @@
         </p:nvSpPr>
         <p:spPr>
           <a:xfrm>
-            <a:off x="4160520" y="3328415"/>
+            <a:off x="4160520" y="3483863"/>
             <a:ext cx="2468880" cy="237744"/>
           </a:xfrm>
           <a:prstGeom prst="rect">
@@ -6934,8 +6934,8 @@
         </p:nvSpPr>
         <p:spPr>
           <a:xfrm>
-            <a:off x="6903720" y="1901952"/>
-            <a:ext cx="4846320" cy="896112"/>
+            <a:off x="6903720" y="1975104"/>
+            <a:ext cx="4846320" cy="877824"/>
           </a:xfrm>
           <a:prstGeom prst="roundRect">
             <a:avLst>
@@ -6980,7 +6980,7 @@
         </p:nvSpPr>
         <p:spPr>
           <a:xfrm>
-            <a:off x="7040880" y="1947672"/>
+            <a:off x="7040880" y="2020824"/>
             <a:ext cx="4572000" cy="219456"/>
           </a:xfrm>
           <a:prstGeom prst="rect">
@@ -7025,7 +7025,7 @@
         </p:nvSpPr>
         <p:spPr>
           <a:xfrm>
-            <a:off x="7040880" y="2185416"/>
+            <a:off x="7040880" y="2249424"/>
             <a:ext cx="4572000" cy="237744"/>
           </a:xfrm>
           <a:prstGeom prst="rect">
@@ -7070,8 +7070,8 @@
         </p:nvSpPr>
         <p:spPr>
           <a:xfrm>
-            <a:off x="7040880" y="2432304"/>
-            <a:ext cx="4572000" cy="329184"/>
+            <a:off x="7040880" y="2496312"/>
+            <a:ext cx="4572000" cy="310896"/>
           </a:xfrm>
           <a:prstGeom prst="rect">
             <a:avLst/>
@@ -7115,8 +7115,8 @@
         </p:nvSpPr>
         <p:spPr>
           <a:xfrm>
-            <a:off x="6903720" y="2834640"/>
-            <a:ext cx="4846320" cy="786384"/>
+            <a:off x="6903720" y="2926080"/>
+            <a:ext cx="4846320" cy="841248"/>
           </a:xfrm>
           <a:prstGeom prst="roundRect">
             <a:avLst>
@@ -7161,7 +7161,7 @@
         </p:nvSpPr>
         <p:spPr>
           <a:xfrm>
-            <a:off x="7040880" y="2862072"/>
+            <a:off x="7040880" y="2971800"/>
             <a:ext cx="4572000" cy="219456"/>
           </a:xfrm>
           <a:prstGeom prst="rect">
@@ -7206,7 +7206,7 @@
         </p:nvSpPr>
         <p:spPr>
           <a:xfrm>
-            <a:off x="7040880" y="3044952"/>
+            <a:off x="7040880" y="3200400"/>
             <a:ext cx="777240" cy="146304"/>
           </a:xfrm>
           <a:prstGeom prst="rect">
@@ -7251,7 +7251,7 @@
         </p:nvSpPr>
         <p:spPr>
           <a:xfrm>
-            <a:off x="7818120" y="3044952"/>
+            <a:off x="7818120" y="3200400"/>
             <a:ext cx="3840480" cy="146304"/>
           </a:xfrm>
           <a:prstGeom prst="rect">
@@ -7296,7 +7296,7 @@
         </p:nvSpPr>
         <p:spPr>
           <a:xfrm>
-            <a:off x="7040880" y="3182112"/>
+            <a:off x="7040880" y="3342132"/>
             <a:ext cx="777240" cy="146304"/>
           </a:xfrm>
           <a:prstGeom prst="rect">
@@ -7341,7 +7341,7 @@
         </p:nvSpPr>
         <p:spPr>
           <a:xfrm>
-            <a:off x="7818120" y="3182112"/>
+            <a:off x="7818120" y="3342132"/>
             <a:ext cx="3840480" cy="146304"/>
           </a:xfrm>
           <a:prstGeom prst="rect">
@@ -7386,7 +7386,7 @@
         </p:nvSpPr>
         <p:spPr>
           <a:xfrm>
-            <a:off x="7040880" y="3319272"/>
+            <a:off x="7040880" y="3483864"/>
             <a:ext cx="777240" cy="146304"/>
           </a:xfrm>
           <a:prstGeom prst="rect">
@@ -7431,7 +7431,7 @@
         </p:nvSpPr>
         <p:spPr>
           <a:xfrm>
-            <a:off x="7818120" y="3319272"/>
+            <a:off x="7818120" y="3483864"/>
             <a:ext cx="3840480" cy="146304"/>
           </a:xfrm>
           <a:prstGeom prst="rect">
@@ -7476,7 +7476,7 @@
         </p:nvSpPr>
         <p:spPr>
           <a:xfrm>
-            <a:off x="7040880" y="3456432"/>
+            <a:off x="7040880" y="3625596"/>
             <a:ext cx="777240" cy="146304"/>
           </a:xfrm>
           <a:prstGeom prst="rect">
@@ -7521,7 +7521,7 @@
         </p:nvSpPr>
         <p:spPr>
           <a:xfrm>
-            <a:off x="7818120" y="3456432"/>
+            <a:off x="7818120" y="3625596"/>
             <a:ext cx="3840480" cy="146304"/>
           </a:xfrm>
           <a:prstGeom prst="rect">
@@ -7566,7 +7566,7 @@
         </p:nvSpPr>
         <p:spPr>
           <a:xfrm>
-            <a:off x="411480" y="3712463"/>
+            <a:off x="411480" y="3968496"/>
             <a:ext cx="11338560" cy="274320"/>
           </a:xfrm>
           <a:prstGeom prst="rect">
@@ -7611,7 +7611,7 @@
         </p:nvSpPr>
         <p:spPr>
           <a:xfrm>
-            <a:off x="429768" y="3986783"/>
+            <a:off x="429768" y="4242816"/>
             <a:ext cx="1371600" cy="25603"/>
           </a:xfrm>
           <a:prstGeom prst="rect">
@@ -7655,8 +7655,8 @@
         </p:nvSpPr>
         <p:spPr>
           <a:xfrm>
-            <a:off x="411480" y="4059936"/>
-            <a:ext cx="3621024" cy="1060704"/>
+            <a:off x="411480" y="4315968"/>
+            <a:ext cx="2656332" cy="1627632"/>
           </a:xfrm>
           <a:prstGeom prst="roundRect">
             <a:avLst>
@@ -7686,7 +7686,7 @@
           </a:fontRef>
         </p:style>
         <p:txBody>
-          <a:bodyPr rtlCol="0" anchor="ctr" wrap="square" lIns="36576" rIns="36576" tIns="109728" bIns="18288"/>
+          <a:bodyPr rtlCol="0" anchor="ctr" wrap="square" lIns="36576" rIns="36576" tIns="128016" bIns="18288"/>
           <a:lstStyle/>
           <a:p>
             <a:pPr algn="ctr">
@@ -7701,7 +7701,7 @@
               </a:spcAft>
             </a:pPr>
             <a:r>
-              <a:rPr sz="1250" b="1">
+              <a:rPr sz="1200" b="1">
                 <a:solidFill>
                   <a:srgbClr val="4F81BD"/>
                 </a:solidFill>
@@ -7723,13 +7723,13 @@
               </a:spcAft>
             </a:pPr>
             <a:r>
-              <a:rPr sz="1100" b="0">
+              <a:rPr sz="1050" b="0">
                 <a:solidFill>
                   <a:srgbClr val="262B33"/>
                 </a:solidFill>
                 <a:latin typeface="Arial"/>
               </a:rPr>
-              <a:t>Weighted Jevons on minimum logical fares — the elementary-aggregate method Eurostat and ONS use for their own price indices.</a:t>
+              <a:t>Weighted Jevons on minimum logical fares — the elementary-aggregate method Eurostat and the ONS use for their own price indices.</a:t>
             </a:r>
           </a:p>
         </p:txBody>
@@ -7742,8 +7742,8 @@
         </p:nvSpPr>
         <p:spPr>
           <a:xfrm>
-            <a:off x="411480" y="4059936"/>
-            <a:ext cx="3621024" cy="64008"/>
+            <a:off x="411480" y="4315968"/>
+            <a:ext cx="2656332" cy="64008"/>
           </a:xfrm>
           <a:prstGeom prst="rect">
             <a:avLst/>
@@ -7786,8 +7786,8 @@
         </p:nvSpPr>
         <p:spPr>
           <a:xfrm>
-            <a:off x="4270248" y="4059936"/>
-            <a:ext cx="3621024" cy="1060704"/>
+            <a:off x="3305556" y="4315968"/>
+            <a:ext cx="2656332" cy="1627632"/>
           </a:xfrm>
           <a:prstGeom prst="roundRect">
             <a:avLst>
@@ -7817,7 +7817,7 @@
           </a:fontRef>
         </p:style>
         <p:txBody>
-          <a:bodyPr rtlCol="0" anchor="ctr" wrap="square" lIns="36576" rIns="36576" tIns="109728" bIns="18288"/>
+          <a:bodyPr rtlCol="0" anchor="ctr" wrap="square" lIns="36576" rIns="36576" tIns="128016" bIns="18288"/>
           <a:lstStyle/>
           <a:p>
             <a:pPr algn="ctr">
@@ -7832,7 +7832,7 @@
               </a:spcAft>
             </a:pPr>
             <a:r>
-              <a:rPr sz="1250" b="1">
+              <a:rPr sz="1200" b="1">
                 <a:solidFill>
                   <a:srgbClr val="1B8A5A"/>
                 </a:solidFill>
@@ -7854,7 +7854,7 @@
               </a:spcAft>
             </a:pPr>
             <a:r>
-              <a:rPr sz="1100" b="0">
+              <a:rPr sz="1050" b="0">
                 <a:solidFill>
                   <a:srgbClr val="262B33"/>
                 </a:solidFill>
@@ -7873,8 +7873,8 @@
         </p:nvSpPr>
         <p:spPr>
           <a:xfrm>
-            <a:off x="4270248" y="4059936"/>
-            <a:ext cx="3621024" cy="64008"/>
+            <a:off x="3305556" y="4315968"/>
+            <a:ext cx="2656332" cy="64008"/>
           </a:xfrm>
           <a:prstGeom prst="rect">
             <a:avLst/>
@@ -7917,8 +7917,8 @@
         </p:nvSpPr>
         <p:spPr>
           <a:xfrm>
-            <a:off x="8129015" y="4059936"/>
-            <a:ext cx="3621024" cy="1060704"/>
+            <a:off x="6199632" y="4315968"/>
+            <a:ext cx="2656332" cy="1627632"/>
           </a:xfrm>
           <a:prstGeom prst="roundRect">
             <a:avLst>
@@ -7948,7 +7948,7 @@
           </a:fontRef>
         </p:style>
         <p:txBody>
-          <a:bodyPr rtlCol="0" anchor="ctr" wrap="square" lIns="36576" rIns="36576" tIns="109728" bIns="18288"/>
+          <a:bodyPr rtlCol="0" anchor="ctr" wrap="square" lIns="36576" rIns="36576" tIns="128016" bIns="18288"/>
           <a:lstStyle/>
           <a:p>
             <a:pPr algn="ctr">
@@ -7963,13 +7963,13 @@
               </a:spcAft>
             </a:pPr>
             <a:r>
-              <a:rPr sz="1250" b="1">
+              <a:rPr sz="1200" b="1">
                 <a:solidFill>
                   <a:srgbClr val="C77700"/>
                 </a:solidFill>
                 <a:latin typeface="Arial"/>
               </a:rPr>
-              <a:t>It knows when not to publish</a:t>
+              <a:t>Admits thin coverage</a:t>
             </a:r>
           </a:p>
           <a:p>
@@ -7985,13 +7985,13 @@
               </a:spcAft>
             </a:pPr>
             <a:r>
-              <a:rPr sz="1100" b="0">
+              <a:rPr sz="1050" b="0">
                 <a:solidFill>
                   <a:srgbClr val="262B33"/>
                 </a:solidFill>
                 <a:latin typeface="Arial"/>
               </a:rPr>
-              <a:t>Below 60% basket coverage the figure ships marked provisional, with the reason attached. An index that admits thin coverage beats one that never does.</a:t>
+              <a:t>Below 60% basket coverage the figure ships marked provisional, with the reason. An index that admits thin coverage beats one that never does.</a:t>
             </a:r>
           </a:p>
         </p:txBody>
@@ -8004,8 +8004,8 @@
         </p:nvSpPr>
         <p:spPr>
           <a:xfrm>
-            <a:off x="8129015" y="4059936"/>
-            <a:ext cx="3621024" cy="64008"/>
+            <a:off x="6199632" y="4315968"/>
+            <a:ext cx="2656332" cy="64008"/>
           </a:xfrm>
           <a:prstGeom prst="rect">
             <a:avLst/>
@@ -8048,8 +8048,8 @@
         </p:nvSpPr>
         <p:spPr>
           <a:xfrm>
-            <a:off x="411480" y="5266944"/>
-            <a:ext cx="3621024" cy="1060704"/>
+            <a:off x="9093708" y="4315968"/>
+            <a:ext cx="2656332" cy="1627632"/>
           </a:xfrm>
           <a:prstGeom prst="roundRect">
             <a:avLst>
@@ -8079,7 +8079,7 @@
           </a:fontRef>
         </p:style>
         <p:txBody>
-          <a:bodyPr rtlCol="0" anchor="ctr" wrap="square" lIns="36576" rIns="36576" tIns="109728" bIns="18288"/>
+          <a:bodyPr rtlCol="0" anchor="ctr" wrap="square" lIns="36576" rIns="36576" tIns="128016" bIns="18288"/>
           <a:lstStyle/>
           <a:p>
             <a:pPr algn="ctr">
@@ -8094,13 +8094,13 @@
               </a:spcAft>
             </a:pPr>
             <a:r>
-              <a:rPr sz="1250" b="1">
+              <a:rPr sz="1200" b="1">
                 <a:solidFill>
                   <a:srgbClr val="4B3F8C"/>
                 </a:solidFill>
                 <a:latin typeface="Arial"/>
               </a:rPr>
-              <a:t>Machine-readable for MoSPI</a:t>
+              <a:t>Machine-readable</a:t>
             </a:r>
           </a:p>
           <a:p>
@@ -8116,7 +8116,7 @@
               </a:spcAft>
             </a:pPr>
             <a:r>
-              <a:rPr sz="1100" b="0">
+              <a:rPr sz="1050" b="0">
                 <a:solidFill>
                   <a:srgbClr val="262B33"/>
                 </a:solidFill>
@@ -8135,276 +8135,14 @@
         </p:nvSpPr>
         <p:spPr>
           <a:xfrm>
-            <a:off x="411480" y="5266944"/>
-            <a:ext cx="3621024" cy="64008"/>
+            <a:off x="9093708" y="4315968"/>
+            <a:ext cx="2656332" cy="64008"/>
           </a:xfrm>
           <a:prstGeom prst="rect">
             <a:avLst/>
           </a:prstGeom>
           <a:solidFill>
             <a:srgbClr val="4B3F8C"/>
-          </a:solidFill>
-          <a:ln>
-            <a:noFill/>
-          </a:ln>
-          <a:effectLst/>
-        </p:spPr>
-        <p:style>
-          <a:lnRef idx="1">
-            <a:schemeClr val="accent1"/>
-          </a:lnRef>
-          <a:fillRef idx="3">
-            <a:schemeClr val="accent1"/>
-          </a:fillRef>
-          <a:effectRef idx="2">
-            <a:schemeClr val="accent1"/>
-          </a:effectRef>
-          <a:fontRef idx="minor">
-            <a:schemeClr val="lt1"/>
-          </a:fontRef>
-        </p:style>
-        <p:txBody>
-          <a:bodyPr rtlCol="0" anchor="ctr"/>
-          <a:lstStyle/>
-          <a:p>
-            <a:pPr algn="ctr"/>
-          </a:p>
-        </p:txBody>
-      </p:sp>
-      <p:sp>
-        <p:nvSpPr>
-          <p:cNvPr id="15404" name="Rounded Rectangle 15403"/>
-          <p:cNvSpPr/>
-          <p:nvPr/>
-        </p:nvSpPr>
-        <p:spPr>
-          <a:xfrm>
-            <a:off x="4270248" y="5266944"/>
-            <a:ext cx="3621024" cy="1060704"/>
-          </a:xfrm>
-          <a:prstGeom prst="roundRect">
-            <a:avLst>
-              <a:gd name="adj" fmla="val 6000"/>
-            </a:avLst>
-          </a:prstGeom>
-          <a:solidFill>
-            <a:srgbClr val="E2F2F3"/>
-          </a:solidFill>
-          <a:ln>
-            <a:noFill/>
-          </a:ln>
-          <a:effectLst/>
-        </p:spPr>
-        <p:style>
-          <a:lnRef idx="1">
-            <a:schemeClr val="accent1"/>
-          </a:lnRef>
-          <a:fillRef idx="3">
-            <a:schemeClr val="accent1"/>
-          </a:fillRef>
-          <a:effectRef idx="2">
-            <a:schemeClr val="accent1"/>
-          </a:effectRef>
-          <a:fontRef idx="minor">
-            <a:schemeClr val="lt1"/>
-          </a:fontRef>
-        </p:style>
-        <p:txBody>
-          <a:bodyPr rtlCol="0" anchor="ctr" wrap="square" lIns="36576" rIns="36576" tIns="109728" bIns="18288"/>
-          <a:lstStyle/>
-          <a:p>
-            <a:pPr algn="ctr">
-              <a:lnSpc>
-                <a:spcPct val="95000"/>
-              </a:lnSpc>
-              <a:spcBef>
-                <a:spcPts val="0"/>
-              </a:spcBef>
-              <a:spcAft>
-                <a:spcPts val="0"/>
-              </a:spcAft>
-            </a:pPr>
-            <a:r>
-              <a:rPr sz="1250" b="1">
-                <a:solidFill>
-                  <a:srgbClr val="0E7C86"/>
-                </a:solidFill>
-                <a:latin typeface="Arial"/>
-              </a:rPr>
-              <a:t>Compliance by construction</a:t>
-            </a:r>
-          </a:p>
-          <a:p>
-            <a:pPr>
-              <a:lnSpc>
-                <a:spcPct val="95000"/>
-              </a:lnSpc>
-              <a:spcBef>
-                <a:spcPts val="500"/>
-              </a:spcBef>
-              <a:spcAft>
-                <a:spcPts val="0"/>
-              </a:spcAft>
-            </a:pPr>
-            <a:r>
-              <a:rPr sz="1100" b="0">
-                <a:solidFill>
-                  <a:srgbClr val="262B33"/>
-                </a:solidFill>
-                <a:latin typeface="Arial"/>
-              </a:rPr>
-              <a:t>robots.txt is re-checked to RFC 9309 before every request. We wrote the parser ourselves because Python's standard one gets it wrong.</a:t>
-            </a:r>
-          </a:p>
-        </p:txBody>
-      </p:sp>
-      <p:sp>
-        <p:nvSpPr>
-          <p:cNvPr id="15405" name="Rectangle 15404"/>
-          <p:cNvSpPr/>
-          <p:nvPr/>
-        </p:nvSpPr>
-        <p:spPr>
-          <a:xfrm>
-            <a:off x="4270248" y="5266944"/>
-            <a:ext cx="3621024" cy="64008"/>
-          </a:xfrm>
-          <a:prstGeom prst="rect">
-            <a:avLst/>
-          </a:prstGeom>
-          <a:solidFill>
-            <a:srgbClr val="0E7C86"/>
-          </a:solidFill>
-          <a:ln>
-            <a:noFill/>
-          </a:ln>
-          <a:effectLst/>
-        </p:spPr>
-        <p:style>
-          <a:lnRef idx="1">
-            <a:schemeClr val="accent1"/>
-          </a:lnRef>
-          <a:fillRef idx="3">
-            <a:schemeClr val="accent1"/>
-          </a:fillRef>
-          <a:effectRef idx="2">
-            <a:schemeClr val="accent1"/>
-          </a:effectRef>
-          <a:fontRef idx="minor">
-            <a:schemeClr val="lt1"/>
-          </a:fontRef>
-        </p:style>
-        <p:txBody>
-          <a:bodyPr rtlCol="0" anchor="ctr"/>
-          <a:lstStyle/>
-          <a:p>
-            <a:pPr algn="ctr"/>
-          </a:p>
-        </p:txBody>
-      </p:sp>
-      <p:sp>
-        <p:nvSpPr>
-          <p:cNvPr id="15406" name="Rounded Rectangle 15405"/>
-          <p:cNvSpPr/>
-          <p:nvPr/>
-        </p:nvSpPr>
-        <p:spPr>
-          <a:xfrm>
-            <a:off x="8129015" y="5266944"/>
-            <a:ext cx="3621024" cy="1060704"/>
-          </a:xfrm>
-          <a:prstGeom prst="roundRect">
-            <a:avLst>
-              <a:gd name="adj" fmla="val 6000"/>
-            </a:avLst>
-          </a:prstGeom>
-          <a:solidFill>
-            <a:srgbClr val="F4EAF1"/>
-          </a:solidFill>
-          <a:ln>
-            <a:noFill/>
-          </a:ln>
-          <a:effectLst/>
-        </p:spPr>
-        <p:style>
-          <a:lnRef idx="1">
-            <a:schemeClr val="accent1"/>
-          </a:lnRef>
-          <a:fillRef idx="3">
-            <a:schemeClr val="accent1"/>
-          </a:fillRef>
-          <a:effectRef idx="2">
-            <a:schemeClr val="accent1"/>
-          </a:effectRef>
-          <a:fontRef idx="minor">
-            <a:schemeClr val="lt1"/>
-          </a:fontRef>
-        </p:style>
-        <p:txBody>
-          <a:bodyPr rtlCol="0" anchor="ctr" wrap="square" lIns="36576" rIns="36576" tIns="109728" bIns="18288"/>
-          <a:lstStyle/>
-          <a:p>
-            <a:pPr algn="ctr">
-              <a:lnSpc>
-                <a:spcPct val="95000"/>
-              </a:lnSpc>
-              <a:spcBef>
-                <a:spcPts val="0"/>
-              </a:spcBef>
-              <a:spcAft>
-                <a:spcPts val="0"/>
-              </a:spcAft>
-            </a:pPr>
-            <a:r>
-              <a:rPr sz="1250" b="1">
-                <a:solidFill>
-                  <a:srgbClr val="7A3E6B"/>
-                </a:solidFill>
-                <a:latin typeface="Arial"/>
-              </a:rPr>
-              <a:t>It never estimates</a:t>
-            </a:r>
-          </a:p>
-          <a:p>
-            <a:pPr>
-              <a:lnSpc>
-                <a:spcPct val="95000"/>
-              </a:lnSpc>
-              <a:spcBef>
-                <a:spcPts val="500"/>
-              </a:spcBef>
-              <a:spcAft>
-                <a:spcPts val="0"/>
-              </a:spcAft>
-            </a:pPr>
-            <a:r>
-              <a:rPr sz="1100" b="0">
-                <a:solidFill>
-                  <a:srgbClr val="262B33"/>
-                </a:solidFill>
-                <a:latin typeface="Arial"/>
-              </a:rPr>
-              <a:t>Fields a portal does not publish stay NULL. Cells with too few observations are excluded, not filled in — the system says when it does not know.</a:t>
-            </a:r>
-          </a:p>
-        </p:txBody>
-      </p:sp>
-      <p:sp>
-        <p:nvSpPr>
-          <p:cNvPr id="15407" name="Rectangle 15406"/>
-          <p:cNvSpPr/>
-          <p:nvPr/>
-        </p:nvSpPr>
-        <p:spPr>
-          <a:xfrm>
-            <a:off x="8129015" y="5266944"/>
-            <a:ext cx="3621024" cy="64008"/>
-          </a:xfrm>
-          <a:prstGeom prst="rect">
-            <a:avLst/>
-          </a:prstGeom>
-          <a:solidFill>
-            <a:srgbClr val="7A3E6B"/>
           </a:solidFill>
           <a:ln>
             <a:noFill/>
@@ -16309,8 +16047,8 @@
         </p:nvSpPr>
         <p:spPr>
           <a:xfrm>
-            <a:off x="411480" y="987552"/>
-            <a:ext cx="6400800" cy="219456"/>
+            <a:off x="411480" y="1060704"/>
+            <a:ext cx="5486400" cy="219456"/>
           </a:xfrm>
           <a:prstGeom prst="rect">
             <a:avLst/>
@@ -16356,8 +16094,8 @@
         </p:nvSpPr>
         <p:spPr>
           <a:xfrm>
-            <a:off x="411480" y="1243584"/>
-            <a:ext cx="3703320" cy="1298448"/>
+            <a:off x="411480" y="1335024"/>
+            <a:ext cx="3703320" cy="1627632"/>
           </a:xfrm>
           <a:prstGeom prst="roundRect">
             <a:avLst>
@@ -16402,8 +16140,8 @@
         </p:nvSpPr>
         <p:spPr>
           <a:xfrm>
-            <a:off x="411480" y="1243584"/>
-            <a:ext cx="3703320" cy="54864"/>
+            <a:off x="411480" y="1335024"/>
+            <a:ext cx="3703320" cy="64008"/>
           </a:xfrm>
           <a:prstGeom prst="rect">
             <a:avLst/>
@@ -16446,8 +16184,8 @@
         </p:nvSpPr>
         <p:spPr>
           <a:xfrm>
-            <a:off x="557784" y="1353312"/>
-            <a:ext cx="3410712" cy="896112"/>
+            <a:off x="557784" y="1463040"/>
+            <a:ext cx="3410712" cy="1207008"/>
           </a:xfrm>
           <a:prstGeom prst="rect">
             <a:avLst/>
@@ -16472,7 +16210,7 @@
               </a:spcAft>
             </a:pPr>
             <a:r>
-              <a:rPr sz="1250" b="1">
+              <a:rPr sz="1350" b="1">
                 <a:solidFill>
                   <a:srgbClr val="4F81BD"/>
                 </a:solidFill>
@@ -16494,7 +16232,7 @@
               </a:spcAft>
             </a:pPr>
             <a:r>
-              <a:rPr sz="1050" b="0">
+              <a:rPr sz="1150" b="0">
                 <a:solidFill>
                   <a:srgbClr val="262B33"/>
                 </a:solidFill>
@@ -16513,7 +16251,7 @@
         </p:nvSpPr>
         <p:spPr>
           <a:xfrm>
-            <a:off x="1956816" y="2304288"/>
+            <a:off x="1956816" y="2706624"/>
             <a:ext cx="2011680" cy="219456"/>
           </a:xfrm>
           <a:prstGeom prst="rect">
@@ -16529,7 +16267,7 @@
           <a:p>
             <a:pPr algn="r"/>
             <a:r>
-              <a:rPr sz="1000" b="1" u="sng">
+              <a:rPr sz="1050" b="1" u="sng">
                 <a:solidFill>
                   <a:srgbClr val="4F81BD"/>
                 </a:solidFill>
@@ -16551,8 +16289,8 @@
         </p:nvSpPr>
         <p:spPr>
           <a:xfrm>
-            <a:off x="4370832" y="1243584"/>
-            <a:ext cx="3703320" cy="1298448"/>
+            <a:off x="4370832" y="1335024"/>
+            <a:ext cx="3703320" cy="1627632"/>
           </a:xfrm>
           <a:prstGeom prst="roundRect">
             <a:avLst>
@@ -16597,8 +16335,8 @@
         </p:nvSpPr>
         <p:spPr>
           <a:xfrm>
-            <a:off x="4370832" y="1243584"/>
-            <a:ext cx="3703320" cy="54864"/>
+            <a:off x="4370832" y="1335024"/>
+            <a:ext cx="3703320" cy="64008"/>
           </a:xfrm>
           <a:prstGeom prst="rect">
             <a:avLst/>
@@ -16641,8 +16379,8 @@
         </p:nvSpPr>
         <p:spPr>
           <a:xfrm>
-            <a:off x="4517136" y="1353312"/>
-            <a:ext cx="3410712" cy="896112"/>
+            <a:off x="4517136" y="1463040"/>
+            <a:ext cx="3410712" cy="1207008"/>
           </a:xfrm>
           <a:prstGeom prst="rect">
             <a:avLst/>
@@ -16667,13 +16405,13 @@
               </a:spcAft>
             </a:pPr>
             <a:r>
-              <a:rPr sz="1250" b="1">
+              <a:rPr sz="1350" b="1">
                 <a:solidFill>
                   <a:srgbClr val="1B8A5A"/>
                 </a:solidFill>
                 <a:latin typeface="Arial"/>
               </a:rPr>
-              <a:t>The international standard</a:t>
+              <a:t>Precedent — already done</a:t>
             </a:r>
           </a:p>
           <a:p>
@@ -16689,13 +16427,13 @@
               </a:spcAft>
             </a:pPr>
             <a:r>
-              <a:rPr sz="1050" b="0">
+              <a:rPr sz="1150" b="0">
                 <a:solidFill>
                   <a:srgbClr val="262B33"/>
                 </a:solidFill>
                 <a:latin typeface="Arial"/>
               </a:rPr>
-              <a:t>CPI Manual: Concepts and Methods (ILO, IMF, OECD, UN, World Bank, 2020). Sets out elementary aggregates and why Jevons is preferred.</a:t>
+              <a:t>ONS ran a web-scraping programme for consumer prices from 2014, Eurostat-funded from 2015.</a:t>
             </a:r>
           </a:p>
         </p:txBody>
@@ -16708,7 +16446,7 @@
         </p:nvSpPr>
         <p:spPr>
           <a:xfrm>
-            <a:off x="5916168" y="2304288"/>
+            <a:off x="5916168" y="2706624"/>
             <a:ext cx="2011680" cy="219456"/>
           </a:xfrm>
           <a:prstGeom prst="rect">
@@ -16724,14 +16462,14 @@
           <a:p>
             <a:pPr algn="r"/>
             <a:r>
-              <a:rPr sz="1000" b="1" u="sng">
+              <a:rPr sz="1050" b="1" u="sng">
                 <a:solidFill>
                   <a:srgbClr val="1B8A5A"/>
                 </a:solidFill>
                 <a:latin typeface="Arial"/>
                 <a:hlinkClick r:id="rId5"/>
               </a:rPr>
-              <a:t>CPI Manual 2020</a:t>
+              <a:t>ONS study</a:t>
             </a:r>
           </a:p>
         </p:txBody>
@@ -16746,8 +16484,8 @@
         </p:nvSpPr>
         <p:spPr>
           <a:xfrm>
-            <a:off x="8330183" y="1243584"/>
-            <a:ext cx="3703320" cy="1298448"/>
+            <a:off x="8330183" y="1335024"/>
+            <a:ext cx="3703320" cy="1627632"/>
           </a:xfrm>
           <a:prstGeom prst="roundRect">
             <a:avLst>
@@ -16792,8 +16530,8 @@
         </p:nvSpPr>
         <p:spPr>
           <a:xfrm>
-            <a:off x="8330183" y="1243584"/>
-            <a:ext cx="3703320" cy="54864"/>
+            <a:off x="8330183" y="1335024"/>
+            <a:ext cx="3703320" cy="64008"/>
           </a:xfrm>
           <a:prstGeom prst="rect">
             <a:avLst/>
@@ -16836,8 +16574,8 @@
         </p:nvSpPr>
         <p:spPr>
           <a:xfrm>
-            <a:off x="8476488" y="1353312"/>
-            <a:ext cx="3410712" cy="896112"/>
+            <a:off x="8476488" y="1463040"/>
+            <a:ext cx="3410712" cy="1207008"/>
           </a:xfrm>
           <a:prstGeom prst="rect">
             <a:avLst/>
@@ -16862,13 +16600,13 @@
               </a:spcAft>
             </a:pPr>
             <a:r>
-              <a:rPr sz="1250" b="1">
+              <a:rPr sz="1350" b="1">
                 <a:solidFill>
                   <a:srgbClr val="C77700"/>
                 </a:solidFill>
                 <a:latin typeface="Arial"/>
               </a:rPr>
-              <a:t>Precedent — already done</a:t>
+              <a:t>The Indian basket</a:t>
             </a:r>
           </a:p>
           <a:p>
@@ -16884,13 +16622,13 @@
               </a:spcAft>
             </a:pPr>
             <a:r>
-              <a:rPr sz="1050" b="0">
+              <a:rPr sz="1150" b="0">
                 <a:solidFill>
                   <a:srgbClr val="262B33"/>
                 </a:solidFill>
                 <a:latin typeface="Arial"/>
               </a:rPr>
-              <a:t>The ONS ran a web-scraping programme for consumer prices from 2014, Eurostat-funded from 2015. This is not an untried method.</a:t>
+              <a:t>DGCA city-pair statistics: 164 m domestic passengers, IndiGo 64.2%. Our own 1,000-fare sample returned 68.2% — arrived at independently.</a:t>
             </a:r>
           </a:p>
         </p:txBody>
@@ -16903,7 +16641,7 @@
         </p:nvSpPr>
         <p:spPr>
           <a:xfrm>
-            <a:off x="9875520" y="2304288"/>
+            <a:off x="9875520" y="2706624"/>
             <a:ext cx="2011680" cy="219456"/>
           </a:xfrm>
           <a:prstGeom prst="rect">
@@ -16919,14 +16657,14 @@
           <a:p>
             <a:pPr algn="r"/>
             <a:r>
-              <a:rPr sz="1000" b="1" u="sng">
+              <a:rPr sz="1050" b="1" u="sng">
                 <a:solidFill>
                   <a:srgbClr val="C77700"/>
                 </a:solidFill>
                 <a:latin typeface="Arial"/>
                 <a:hlinkClick r:id="rId6"/>
               </a:rPr>
-              <a:t>ONS research indices</a:t>
+              <a:t>DGCA statistics</a:t>
             </a:r>
           </a:p>
         </p:txBody>
@@ -16941,8 +16679,8 @@
         </p:nvSpPr>
         <p:spPr>
           <a:xfrm>
-            <a:off x="411480" y="2670048"/>
-            <a:ext cx="3703320" cy="1298448"/>
+            <a:off x="411480" y="3108960"/>
+            <a:ext cx="3703320" cy="1627632"/>
           </a:xfrm>
           <a:prstGeom prst="roundRect">
             <a:avLst>
@@ -16987,8 +16725,8 @@
         </p:nvSpPr>
         <p:spPr>
           <a:xfrm>
-            <a:off x="411480" y="2670048"/>
-            <a:ext cx="3703320" cy="54864"/>
+            <a:off x="411480" y="3108960"/>
+            <a:ext cx="3703320" cy="64008"/>
           </a:xfrm>
           <a:prstGeom prst="rect">
             <a:avLst/>
@@ -17031,8 +16769,8 @@
         </p:nvSpPr>
         <p:spPr>
           <a:xfrm>
-            <a:off x="557784" y="2779776"/>
-            <a:ext cx="3410712" cy="896112"/>
+            <a:off x="557784" y="3236976"/>
+            <a:ext cx="3410712" cy="1207008"/>
           </a:xfrm>
           <a:prstGeom prst="rect">
             <a:avLst/>
@@ -17057,13 +16795,13 @@
               </a:spcAft>
             </a:pPr>
             <a:r>
-              <a:rPr sz="1250" b="1">
+              <a:rPr sz="1350" b="1">
                 <a:solidFill>
                   <a:srgbClr val="4B3F8C"/>
                 </a:solidFill>
                 <a:latin typeface="Arial"/>
               </a:rPr>
-              <a:t>The series we augment</a:t>
+              <a:t>Standards we hold to</a:t>
             </a:r>
           </a:p>
           <a:p>
@@ -17079,13 +16817,13 @@
               </a:spcAft>
             </a:pPr>
             <a:r>
-              <a:rPr sz="1050" b="0">
+              <a:rPr sz="1150" b="0">
                 <a:solidFill>
                   <a:srgbClr val="262B33"/>
                 </a:solidFill>
                 <a:latin typeface="Arial"/>
               </a:rPr>
-              <a:t>MoSPI moved the CPI to base 2024=100 in February 2026, aligned to COICOP 2018 — 358 weighted items, 50 of them services. Air travel sits in Transport.</a:t>
+              <a:t>RFC 9309, the Robots Exclusion Protocol. We implemented it ourselves after finding Python's standard parser reports disallowed paths as allowed.</a:t>
             </a:r>
           </a:p>
         </p:txBody>
@@ -17098,7 +16836,7 @@
         </p:nvSpPr>
         <p:spPr>
           <a:xfrm>
-            <a:off x="1956816" y="3730752"/>
+            <a:off x="1956816" y="4480559"/>
             <a:ext cx="2011680" cy="219456"/>
           </a:xfrm>
           <a:prstGeom prst="rect">
@@ -17114,14 +16852,14 @@
           <a:p>
             <a:pPr algn="r"/>
             <a:r>
-              <a:rPr sz="1000" b="1" u="sng">
+              <a:rPr sz="1050" b="1" u="sng">
                 <a:solidFill>
                   <a:srgbClr val="4B3F8C"/>
                 </a:solidFill>
                 <a:latin typeface="Arial"/>
                 <a:hlinkClick r:id="rId7"/>
               </a:rPr>
-              <a:t>2024=100 release</a:t>
+              <a:t>RFC 9309</a:t>
             </a:r>
           </a:p>
         </p:txBody>
@@ -17136,8 +16874,8 @@
         </p:nvSpPr>
         <p:spPr>
           <a:xfrm>
-            <a:off x="4370832" y="2670048"/>
-            <a:ext cx="3703320" cy="1298448"/>
+            <a:off x="4370832" y="3108960"/>
+            <a:ext cx="3703320" cy="1627632"/>
           </a:xfrm>
           <a:prstGeom prst="roundRect">
             <a:avLst>
@@ -17182,8 +16920,8 @@
         </p:nvSpPr>
         <p:spPr>
           <a:xfrm>
-            <a:off x="4370832" y="2670048"/>
-            <a:ext cx="3703320" cy="54864"/>
+            <a:off x="4370832" y="3108960"/>
+            <a:ext cx="3703320" cy="64008"/>
           </a:xfrm>
           <a:prstGeom prst="rect">
             <a:avLst/>
@@ -17226,8 +16964,8 @@
         </p:nvSpPr>
         <p:spPr>
           <a:xfrm>
-            <a:off x="4517136" y="2779776"/>
-            <a:ext cx="3410712" cy="896112"/>
+            <a:off x="4517136" y="3236976"/>
+            <a:ext cx="3410712" cy="1207008"/>
           </a:xfrm>
           <a:prstGeom prst="rect">
             <a:avLst/>
@@ -17252,13 +16990,13 @@
               </a:spcAft>
             </a:pPr>
             <a:r>
-              <a:rPr sz="1250" b="1">
+              <a:rPr sz="1350" b="1">
                 <a:solidFill>
                   <a:srgbClr val="0E7C86"/>
                 </a:solidFill>
                 <a:latin typeface="Arial"/>
               </a:rPr>
-              <a:t>How fares are priced now</a:t>
+              <a:t>CPI methodology</a:t>
             </a:r>
           </a:p>
           <a:p>
@@ -17274,13 +17012,13 @@
               </a:spcAft>
             </a:pPr>
             <a:r>
-              <a:rPr sz="1050" b="0">
+              <a:rPr sz="1150" b="0">
                 <a:solidFill>
                   <a:srgbClr val="262B33"/>
                 </a:solidFill>
                 <a:latin typeface="Arial"/>
               </a:rPr>
-              <a:t>Field staff price items in sampled villages and urban markets on a weekly roster. Air travel is collected by hand.</a:t>
+              <a:t>MoSPI moved the CPI to base 2024=100 in February 2026, aligned to COICOP 2018. Air fares are still priced by hand — the process this augments.</a:t>
             </a:r>
           </a:p>
         </p:txBody>
@@ -17293,7 +17031,7 @@
         </p:nvSpPr>
         <p:spPr>
           <a:xfrm>
-            <a:off x="5916168" y="3730752"/>
+            <a:off x="5916168" y="4480559"/>
             <a:ext cx="2011680" cy="219456"/>
           </a:xfrm>
           <a:prstGeom prst="rect">
@@ -17309,14 +17047,14 @@
           <a:p>
             <a:pPr algn="r"/>
             <a:r>
-              <a:rPr sz="1000" b="1" u="sng">
+              <a:rPr sz="1050" b="1" u="sng">
                 <a:solidFill>
                   <a:srgbClr val="0E7C86"/>
                 </a:solidFill>
                 <a:latin typeface="Arial"/>
                 <a:hlinkClick r:id="rId8"/>
               </a:rPr>
-              <a:t>CPI 2024 series FAQs</a:t>
+              <a:t>The 2024=100 series</a:t>
             </a:r>
           </a:p>
         </p:txBody>
@@ -17331,8 +17069,8 @@
         </p:nvSpPr>
         <p:spPr>
           <a:xfrm>
-            <a:off x="8330183" y="2670048"/>
-            <a:ext cx="3703320" cy="1298448"/>
+            <a:off x="8330183" y="3108960"/>
+            <a:ext cx="3703320" cy="1627632"/>
           </a:xfrm>
           <a:prstGeom prst="roundRect">
             <a:avLst>
@@ -17377,8 +17115,8 @@
         </p:nvSpPr>
         <p:spPr>
           <a:xfrm>
-            <a:off x="8330183" y="2670048"/>
-            <a:ext cx="3703320" cy="54864"/>
+            <a:off x="8330183" y="3108960"/>
+            <a:ext cx="3703320" cy="64008"/>
           </a:xfrm>
           <a:prstGeom prst="rect">
             <a:avLst/>
@@ -17421,8 +17159,8 @@
         </p:nvSpPr>
         <p:spPr>
           <a:xfrm>
-            <a:off x="8476488" y="2779776"/>
-            <a:ext cx="3410712" cy="896112"/>
+            <a:off x="8476488" y="3236976"/>
+            <a:ext cx="3410712" cy="1207008"/>
           </a:xfrm>
           <a:prstGeom prst="rect">
             <a:avLst/>
@@ -17447,13 +17185,13 @@
               </a:spcAft>
             </a:pPr>
             <a:r>
-              <a:rPr sz="1250" b="1">
+              <a:rPr sz="1350" b="1">
                 <a:solidFill>
                   <a:srgbClr val="7A3E6B"/>
                 </a:solidFill>
                 <a:latin typeface="Arial"/>
               </a:rPr>
-              <a:t>The Indian basket</a:t>
+              <a:t>Our code and full method</a:t>
             </a:r>
           </a:p>
           <a:p>
@@ -17469,13 +17207,14 @@
               </a:spcAft>
             </a:pPr>
             <a:r>
-              <a:rPr sz="1050" b="0">
+              <a:rPr sz="1150" b="0">
                 <a:solidFill>
                   <a:srgbClr val="262B33"/>
                 </a:solidFill>
                 <a:latin typeface="Arial"/>
               </a:rPr>
-              <a:t>DGCA city-pair statistics: 164 m domestic passengers, IndiGo 64.2%. Our own 1,000-fare sample returned 68.2% — arrived at independently.</a:t>
+              <a:t>Collector, index engine, export API and portal. The README documents the method and the publication threshold.
+github.com/BradCage-afk/sih-2026-airfare-index</a:t>
             </a:r>
           </a:p>
         </p:txBody>
@@ -17488,7 +17227,7 @@
         </p:nvSpPr>
         <p:spPr>
           <a:xfrm>
-            <a:off x="9875520" y="3730752"/>
+            <a:off x="9875520" y="4480559"/>
             <a:ext cx="2011680" cy="219456"/>
           </a:xfrm>
           <a:prstGeom prst="rect">
@@ -17504,107 +17243,128 @@
           <a:p>
             <a:pPr algn="r"/>
             <a:r>
-              <a:rPr sz="1000" b="1" u="sng">
+              <a:rPr sz="1050" b="1" u="sng">
                 <a:solidFill>
                   <a:srgbClr val="7A3E6B"/>
                 </a:solidFill>
                 <a:latin typeface="Arial"/>
                 <a:hlinkClick r:id="rId9"/>
               </a:rPr>
-              <a:t>DGCA statistics</a:t>
-            </a:r>
-          </a:p>
-        </p:txBody>
-      </p:sp>
-      <p:sp>
-        <p:nvSpPr>
-          <p:cNvPr id="17435" name="Rounded Rectangle 17434">
-            <a:hlinkClick r:id="rId10"/>
-          </p:cNvPr>
-          <p:cNvSpPr/>
-          <p:nvPr/>
-        </p:nvSpPr>
-        <p:spPr>
-          <a:xfrm>
-            <a:off x="411480" y="4096512"/>
-            <a:ext cx="3703320" cy="1298448"/>
-          </a:xfrm>
-          <a:prstGeom prst="roundRect">
-            <a:avLst>
-              <a:gd name="adj" fmla="val 6000"/>
-            </a:avLst>
-          </a:prstGeom>
-          <a:solidFill>
-            <a:srgbClr val="E8F0F9"/>
-          </a:solidFill>
-          <a:ln>
-            <a:noFill/>
-          </a:ln>
-          <a:effectLst/>
-        </p:spPr>
-        <p:style>
-          <a:lnRef idx="1">
-            <a:schemeClr val="accent1"/>
-          </a:lnRef>
-          <a:fillRef idx="3">
-            <a:schemeClr val="accent1"/>
-          </a:fillRef>
-          <a:effectRef idx="2">
-            <a:schemeClr val="accent1"/>
-          </a:effectRef>
-          <a:fontRef idx="minor">
-            <a:schemeClr val="lt1"/>
-          </a:fontRef>
-        </p:style>
-        <p:txBody>
-          <a:bodyPr rtlCol="0" anchor="ctr" wrap="square"/>
-          <a:lstStyle/>
-          <a:p>
-            <a:pPr algn="ctr"/>
-          </a:p>
-        </p:txBody>
-      </p:sp>
-      <p:sp>
-        <p:nvSpPr>
-          <p:cNvPr id="17436" name="Rectangle 17435"/>
-          <p:cNvSpPr/>
-          <p:nvPr/>
-        </p:nvSpPr>
-        <p:spPr>
-          <a:xfrm>
-            <a:off x="411480" y="4096512"/>
-            <a:ext cx="3703320" cy="54864"/>
+              <a:t>Open the repo</a:t>
+            </a:r>
+          </a:p>
+        </p:txBody>
+      </p:sp>
+      <p:pic>
+        <p:nvPicPr>
+          <p:cNvPr id="17435" name="Picture 17434" descr="chart-survey.png"/>
+          <p:cNvPicPr>
+            <a:picLocks noChangeAspect="1"/>
+          </p:cNvPicPr>
+          <p:nvPr/>
+        </p:nvPicPr>
+        <p:blipFill>
+          <a:blip r:embed="rId10"/>
+          <a:stretch>
+            <a:fillRect/>
+          </a:stretch>
+        </p:blipFill>
+        <p:spPr>
+          <a:xfrm>
+            <a:off x="411480" y="4754880"/>
+            <a:ext cx="4160520" cy="1379303"/>
           </a:xfrm>
           <a:prstGeom prst="rect">
             <a:avLst/>
           </a:prstGeom>
-          <a:solidFill>
-            <a:srgbClr val="4F81BD"/>
-          </a:solidFill>
-          <a:ln>
-            <a:noFill/>
-          </a:ln>
-          <a:effectLst/>
-        </p:spPr>
-        <p:style>
-          <a:lnRef idx="1">
-            <a:schemeClr val="accent1"/>
-          </a:lnRef>
-          <a:fillRef idx="3">
-            <a:schemeClr val="accent1"/>
-          </a:fillRef>
-          <a:effectRef idx="2">
-            <a:schemeClr val="accent1"/>
-          </a:effectRef>
-          <a:fontRef idx="minor">
-            <a:schemeClr val="lt1"/>
-          </a:fontRef>
-        </p:style>
-        <p:txBody>
-          <a:bodyPr rtlCol="0" anchor="ctr"/>
-          <a:lstStyle/>
-          <a:p>
-            <a:pPr algn="ctr"/>
+        </p:spPr>
+      </p:pic>
+      <p:sp>
+        <p:nvSpPr>
+          <p:cNvPr id="17436" name="TextBox 17435"/>
+          <p:cNvSpPr txBox="1"/>
+          <p:nvPr/>
+        </p:nvSpPr>
+        <p:spPr>
+          <a:xfrm>
+            <a:off x="4800600" y="4791456"/>
+            <a:ext cx="6949440" cy="1188720"/>
+          </a:xfrm>
+          <a:prstGeom prst="rect">
+            <a:avLst/>
+          </a:prstGeom>
+          <a:noFill/>
+        </p:spPr>
+        <p:txBody>
+          <a:bodyPr wrap="square" lIns="36576" rIns="36576">
+            <a:spAutoFit/>
+          </a:bodyPr>
+          <a:lstStyle/>
+          <a:p>
+            <a:pPr>
+              <a:lnSpc>
+                <a:spcPct val="100000"/>
+              </a:lnSpc>
+              <a:spcBef>
+                <a:spcPts val="0"/>
+              </a:spcBef>
+              <a:spcAft>
+                <a:spcPts val="0"/>
+              </a:spcAft>
+            </a:pPr>
+            <a:r>
+              <a:rPr sz="1300" b="1">
+                <a:solidFill>
+                  <a:srgbClr val="1F497D"/>
+                </a:solidFill>
+                <a:latin typeface="Arial"/>
+              </a:rPr>
+              <a:t>Everything above is reproducible.</a:t>
+            </a:r>
+          </a:p>
+          <a:p>
+            <a:pPr>
+              <a:lnSpc>
+                <a:spcPct val="100000"/>
+              </a:lnSpc>
+              <a:spcBef>
+                <a:spcPts val="400"/>
+              </a:spcBef>
+              <a:spcAft>
+                <a:spcPts val="0"/>
+              </a:spcAft>
+            </a:pPr>
+            <a:r>
+              <a:rPr sz="1150" b="0">
+                <a:solidFill>
+                  <a:srgbClr val="262B33"/>
+                </a:solidFill>
+                <a:latin typeface="Arial"/>
+              </a:rPr>
+              <a:t>The index, every chart in this deck and every figure on the portal are regenerated from the database by scripts in the repository. Nothing is transcribed by hand, so no number here can drift from what the system holds.</a:t>
+            </a:r>
+          </a:p>
+          <a:p>
+            <a:pPr>
+              <a:lnSpc>
+                <a:spcPct val="100000"/>
+              </a:lnSpc>
+              <a:spcBef>
+                <a:spcPts val="600"/>
+              </a:spcBef>
+              <a:spcAft>
+                <a:spcPts val="0"/>
+              </a:spcAft>
+            </a:pPr>
+            <a:r>
+              <a:rPr sz="1150" b="1">
+                <a:solidFill>
+                  <a:srgbClr val="1F497D"/>
+                </a:solidFill>
+                <a:latin typeface="Arial"/>
+              </a:rPr>
+              <a:t>Everything in this deck is checkable against a live system:</a:t>
+            </a:r>
           </a:p>
         </p:txBody>
       </p:sp>
@@ -17616,75 +17376,8 @@
         </p:nvSpPr>
         <p:spPr>
           <a:xfrm>
-            <a:off x="557784" y="4206240"/>
-            <a:ext cx="3410712" cy="896112"/>
-          </a:xfrm>
-          <a:prstGeom prst="rect">
-            <a:avLst/>
-          </a:prstGeom>
-          <a:noFill/>
-        </p:spPr>
-        <p:txBody>
-          <a:bodyPr wrap="square" lIns="36576" rIns="36576" tIns="18288" bIns="18288">
-            <a:spAutoFit/>
-          </a:bodyPr>
-          <a:lstStyle/>
-          <a:p>
-            <a:pPr>
-              <a:lnSpc>
-                <a:spcPct val="95000"/>
-              </a:lnSpc>
-              <a:spcBef>
-                <a:spcPts val="0"/>
-              </a:spcBef>
-              <a:spcAft>
-                <a:spcPts val="0"/>
-              </a:spcAft>
-            </a:pPr>
-            <a:r>
-              <a:rPr sz="1250" b="1">
-                <a:solidFill>
-                  <a:srgbClr val="4F81BD"/>
-                </a:solidFill>
-                <a:latin typeface="Arial"/>
-              </a:rPr>
-              <a:t>Standards we hold to</a:t>
-            </a:r>
-          </a:p>
-          <a:p>
-            <a:pPr>
-              <a:lnSpc>
-                <a:spcPct val="95000"/>
-              </a:lnSpc>
-              <a:spcBef>
-                <a:spcPts val="400"/>
-              </a:spcBef>
-              <a:spcAft>
-                <a:spcPts val="0"/>
-              </a:spcAft>
-            </a:pPr>
-            <a:r>
-              <a:rPr sz="1050" b="0">
-                <a:solidFill>
-                  <a:srgbClr val="262B33"/>
-                </a:solidFill>
-                <a:latin typeface="Arial"/>
-              </a:rPr>
-              <a:t>RFC 9309, the Robots Exclusion Protocol. We implemented it ourselves after finding Python's standard parser reports disallowed paths as allowed.</a:t>
-            </a:r>
-          </a:p>
-        </p:txBody>
-      </p:sp>
-      <p:sp>
-        <p:nvSpPr>
-          <p:cNvPr id="17438" name="TextBox 17437"/>
-          <p:cNvSpPr txBox="1"/>
-          <p:nvPr/>
-        </p:nvSpPr>
-        <p:spPr>
-          <a:xfrm>
-            <a:off x="1956816" y="5157216"/>
-            <a:ext cx="2011680" cy="219456"/>
+            <a:off x="4800600" y="5907024"/>
+            <a:ext cx="1641348" cy="219456"/>
           </a:xfrm>
           <a:prstGeom prst="rect">
             <a:avLst/>
@@ -17697,189 +17390,30 @@
           </a:bodyPr>
           <a:lstStyle/>
           <a:p>
-            <a:pPr algn="r"/>
-            <a:r>
-              <a:rPr sz="1000" b="1" u="sng">
-                <a:solidFill>
-                  <a:srgbClr val="4F81BD"/>
+            <a:pPr algn="l"/>
+            <a:r>
+              <a:rPr sz="1050" b="1" u="sng">
+                <a:solidFill>
+                  <a:srgbClr val="1F497D"/>
                 </a:solidFill>
                 <a:latin typeface="Arial"/>
-                <a:hlinkClick r:id="rId10"/>
-              </a:rPr>
-              <a:t>RFC 9309</a:t>
-            </a:r>
-          </a:p>
-        </p:txBody>
-      </p:sp>
-      <p:sp>
-        <p:nvSpPr>
-          <p:cNvPr id="17439" name="Rounded Rectangle 17438">
-            <a:hlinkClick r:id="rId11"/>
-          </p:cNvPr>
-          <p:cNvSpPr/>
-          <p:nvPr/>
-        </p:nvSpPr>
-        <p:spPr>
-          <a:xfrm>
-            <a:off x="4370832" y="4096512"/>
-            <a:ext cx="3703320" cy="1298448"/>
-          </a:xfrm>
-          <a:prstGeom prst="roundRect">
-            <a:avLst>
-              <a:gd name="adj" fmla="val 6000"/>
-            </a:avLst>
-          </a:prstGeom>
-          <a:solidFill>
-            <a:srgbClr val="E4F4EC"/>
-          </a:solidFill>
-          <a:ln>
-            <a:noFill/>
-          </a:ln>
-          <a:effectLst/>
-        </p:spPr>
-        <p:style>
-          <a:lnRef idx="1">
-            <a:schemeClr val="accent1"/>
-          </a:lnRef>
-          <a:fillRef idx="3">
-            <a:schemeClr val="accent1"/>
-          </a:fillRef>
-          <a:effectRef idx="2">
-            <a:schemeClr val="accent1"/>
-          </a:effectRef>
-          <a:fontRef idx="minor">
-            <a:schemeClr val="lt1"/>
-          </a:fontRef>
-        </p:style>
-        <p:txBody>
-          <a:bodyPr rtlCol="0" anchor="ctr" wrap="square"/>
-          <a:lstStyle/>
-          <a:p>
-            <a:pPr algn="ctr"/>
-          </a:p>
-        </p:txBody>
-      </p:sp>
-      <p:sp>
-        <p:nvSpPr>
-          <p:cNvPr id="17440" name="Rectangle 17439"/>
-          <p:cNvSpPr/>
-          <p:nvPr/>
-        </p:nvSpPr>
-        <p:spPr>
-          <a:xfrm>
-            <a:off x="4370832" y="4096512"/>
-            <a:ext cx="3703320" cy="54864"/>
-          </a:xfrm>
-          <a:prstGeom prst="rect">
-            <a:avLst/>
-          </a:prstGeom>
-          <a:solidFill>
-            <a:srgbClr val="1B8A5A"/>
-          </a:solidFill>
-          <a:ln>
-            <a:noFill/>
-          </a:ln>
-          <a:effectLst/>
-        </p:spPr>
-        <p:style>
-          <a:lnRef idx="1">
-            <a:schemeClr val="accent1"/>
-          </a:lnRef>
-          <a:fillRef idx="3">
-            <a:schemeClr val="accent1"/>
-          </a:fillRef>
-          <a:effectRef idx="2">
-            <a:schemeClr val="accent1"/>
-          </a:effectRef>
-          <a:fontRef idx="minor">
-            <a:schemeClr val="lt1"/>
-          </a:fontRef>
-        </p:style>
-        <p:txBody>
-          <a:bodyPr rtlCol="0" anchor="ctr"/>
-          <a:lstStyle/>
-          <a:p>
-            <a:pPr algn="ctr"/>
-          </a:p>
-        </p:txBody>
-      </p:sp>
-      <p:sp>
-        <p:nvSpPr>
-          <p:cNvPr id="17441" name="TextBox 17440"/>
+                <a:hlinkClick r:id="rId11"/>
+              </a:rPr>
+              <a:t>Live API docs</a:t>
+            </a:r>
+          </a:p>
+        </p:txBody>
+      </p:sp>
+      <p:sp>
+        <p:nvSpPr>
+          <p:cNvPr id="17438" name="TextBox 17437"/>
           <p:cNvSpPr txBox="1"/>
           <p:nvPr/>
         </p:nvSpPr>
         <p:spPr>
           <a:xfrm>
-            <a:off x="4517136" y="4206240"/>
-            <a:ext cx="3410712" cy="896112"/>
-          </a:xfrm>
-          <a:prstGeom prst="rect">
-            <a:avLst/>
-          </a:prstGeom>
-          <a:noFill/>
-        </p:spPr>
-        <p:txBody>
-          <a:bodyPr wrap="square" lIns="36576" rIns="36576" tIns="18288" bIns="18288">
-            <a:spAutoFit/>
-          </a:bodyPr>
-          <a:lstStyle/>
-          <a:p>
-            <a:pPr>
-              <a:lnSpc>
-                <a:spcPct val="95000"/>
-              </a:lnSpc>
-              <a:spcBef>
-                <a:spcPts val="0"/>
-              </a:spcBef>
-              <a:spcAft>
-                <a:spcPts val="0"/>
-              </a:spcAft>
-            </a:pPr>
-            <a:r>
-              <a:rPr sz="1250" b="1">
-                <a:solidFill>
-                  <a:srgbClr val="1B8A5A"/>
-                </a:solidFill>
-                <a:latin typeface="Arial"/>
-              </a:rPr>
-              <a:t>The market we measure</a:t>
-            </a:r>
-          </a:p>
-          <a:p>
-            <a:pPr>
-              <a:lnSpc>
-                <a:spcPct val="95000"/>
-              </a:lnSpc>
-              <a:spcBef>
-                <a:spcPts val="400"/>
-              </a:spcBef>
-              <a:spcAft>
-                <a:spcPts val="0"/>
-              </a:spcAft>
-            </a:pPr>
-            <a:r>
-              <a:rPr sz="1050" b="0">
-                <a:solidFill>
-                  <a:srgbClr val="262B33"/>
-                </a:solidFill>
-                <a:latin typeface="Arial"/>
-              </a:rPr>
-              <a:t>India is the world's fifth-largest aviation market, worth USD 18.1 bn in 2026 and growing 11.7% a year. Fares move daily; the CPI reads them monthly.</a:t>
-            </a:r>
-          </a:p>
-        </p:txBody>
-      </p:sp>
-      <p:sp>
-        <p:nvSpPr>
-          <p:cNvPr id="17442" name="TextBox 17441"/>
-          <p:cNvSpPr txBox="1"/>
-          <p:nvPr/>
-        </p:nvSpPr>
-        <p:spPr>
-          <a:xfrm>
-            <a:off x="5916168" y="5157216"/>
-            <a:ext cx="2011680" cy="219456"/>
+            <a:off x="6569964" y="5907024"/>
+            <a:ext cx="1641348" cy="219456"/>
           </a:xfrm>
           <a:prstGeom prst="rect">
             <a:avLst/>
@@ -17892,189 +17426,30 @@
           </a:bodyPr>
           <a:lstStyle/>
           <a:p>
-            <a:pPr algn="r"/>
-            <a:r>
-              <a:rPr sz="1000" b="1" u="sng">
+            <a:pPr algn="l"/>
+            <a:r>
+              <a:rPr sz="1050" b="1" u="sng">
                 <a:solidFill>
                   <a:srgbClr val="1B8A5A"/>
                 </a:solidFill>
                 <a:latin typeface="Arial"/>
-                <a:hlinkClick r:id="rId11"/>
-              </a:rPr>
-              <a:t>Aviation market</a:t>
-            </a:r>
-          </a:p>
-        </p:txBody>
-      </p:sp>
-      <p:sp>
-        <p:nvSpPr>
-          <p:cNvPr id="17443" name="Rounded Rectangle 17442">
-            <a:hlinkClick r:id="rId12"/>
-          </p:cNvPr>
-          <p:cNvSpPr/>
-          <p:nvPr/>
-        </p:nvSpPr>
-        <p:spPr>
-          <a:xfrm>
-            <a:off x="8330183" y="4096512"/>
-            <a:ext cx="3703320" cy="1298448"/>
-          </a:xfrm>
-          <a:prstGeom prst="roundRect">
-            <a:avLst>
-              <a:gd name="adj" fmla="val 6000"/>
-            </a:avLst>
-          </a:prstGeom>
-          <a:solidFill>
-            <a:srgbClr val="FBF0DD"/>
-          </a:solidFill>
-          <a:ln>
-            <a:noFill/>
-          </a:ln>
-          <a:effectLst/>
-        </p:spPr>
-        <p:style>
-          <a:lnRef idx="1">
-            <a:schemeClr val="accent1"/>
-          </a:lnRef>
-          <a:fillRef idx="3">
-            <a:schemeClr val="accent1"/>
-          </a:fillRef>
-          <a:effectRef idx="2">
-            <a:schemeClr val="accent1"/>
-          </a:effectRef>
-          <a:fontRef idx="minor">
-            <a:schemeClr val="lt1"/>
-          </a:fontRef>
-        </p:style>
-        <p:txBody>
-          <a:bodyPr rtlCol="0" anchor="ctr" wrap="square"/>
-          <a:lstStyle/>
-          <a:p>
-            <a:pPr algn="ctr"/>
-          </a:p>
-        </p:txBody>
-      </p:sp>
-      <p:sp>
-        <p:nvSpPr>
-          <p:cNvPr id="17444" name="Rectangle 17443"/>
-          <p:cNvSpPr/>
-          <p:nvPr/>
-        </p:nvSpPr>
-        <p:spPr>
-          <a:xfrm>
-            <a:off x="8330183" y="4096512"/>
-            <a:ext cx="3703320" cy="54864"/>
-          </a:xfrm>
-          <a:prstGeom prst="rect">
-            <a:avLst/>
-          </a:prstGeom>
-          <a:solidFill>
-            <a:srgbClr val="C77700"/>
-          </a:solidFill>
-          <a:ln>
-            <a:noFill/>
-          </a:ln>
-          <a:effectLst/>
-        </p:spPr>
-        <p:style>
-          <a:lnRef idx="1">
-            <a:schemeClr val="accent1"/>
-          </a:lnRef>
-          <a:fillRef idx="3">
-            <a:schemeClr val="accent1"/>
-          </a:fillRef>
-          <a:effectRef idx="2">
-            <a:schemeClr val="accent1"/>
-          </a:effectRef>
-          <a:fontRef idx="minor">
-            <a:schemeClr val="lt1"/>
-          </a:fontRef>
-        </p:style>
-        <p:txBody>
-          <a:bodyPr rtlCol="0" anchor="ctr"/>
-          <a:lstStyle/>
-          <a:p>
-            <a:pPr algn="ctr"/>
-          </a:p>
-        </p:txBody>
-      </p:sp>
-      <p:sp>
-        <p:nvSpPr>
-          <p:cNvPr id="17445" name="TextBox 17444"/>
+                <a:hlinkClick r:id="rId12"/>
+              </a:rPr>
+              <a:t>Release portal</a:t>
+            </a:r>
+          </a:p>
+        </p:txBody>
+      </p:sp>
+      <p:sp>
+        <p:nvSpPr>
+          <p:cNvPr id="17439" name="TextBox 17438"/>
           <p:cNvSpPr txBox="1"/>
           <p:nvPr/>
         </p:nvSpPr>
         <p:spPr>
           <a:xfrm>
-            <a:off x="8476488" y="4206240"/>
-            <a:ext cx="3410712" cy="896112"/>
-          </a:xfrm>
-          <a:prstGeom prst="rect">
-            <a:avLst/>
-          </a:prstGeom>
-          <a:noFill/>
-        </p:spPr>
-        <p:txBody>
-          <a:bodyPr wrap="square" lIns="36576" rIns="36576" tIns="18288" bIns="18288">
-            <a:spAutoFit/>
-          </a:bodyPr>
-          <a:lstStyle/>
-          <a:p>
-            <a:pPr>
-              <a:lnSpc>
-                <a:spcPct val="95000"/>
-              </a:lnSpc>
-              <a:spcBef>
-                <a:spcPts val="0"/>
-              </a:spcBef>
-              <a:spcAft>
-                <a:spcPts val="0"/>
-              </a:spcAft>
-            </a:pPr>
-            <a:r>
-              <a:rPr sz="1250" b="1">
-                <a:solidFill>
-                  <a:srgbClr val="C77700"/>
-                </a:solidFill>
-                <a:latin typeface="Arial"/>
-              </a:rPr>
-              <a:t>Our code and full method</a:t>
-            </a:r>
-          </a:p>
-          <a:p>
-            <a:pPr>
-              <a:lnSpc>
-                <a:spcPct val="95000"/>
-              </a:lnSpc>
-              <a:spcBef>
-                <a:spcPts val="400"/>
-              </a:spcBef>
-              <a:spcAft>
-                <a:spcPts val="0"/>
-              </a:spcAft>
-            </a:pPr>
-            <a:r>
-              <a:rPr sz="1050" b="0">
-                <a:solidFill>
-                  <a:srgbClr val="262B33"/>
-                </a:solidFill>
-                <a:latin typeface="Arial"/>
-              </a:rPr>
-              <a:t>Collector, index engine, export API and portal. The README documents the method, the exclusion rules and the publication threshold.</a:t>
-            </a:r>
-          </a:p>
-        </p:txBody>
-      </p:sp>
-      <p:sp>
-        <p:nvSpPr>
-          <p:cNvPr id="17446" name="TextBox 17445"/>
-          <p:cNvSpPr txBox="1"/>
-          <p:nvPr/>
-        </p:nvSpPr>
-        <p:spPr>
-          <a:xfrm>
-            <a:off x="9875520" y="5157216"/>
-            <a:ext cx="2011680" cy="219456"/>
+            <a:off x="8339328" y="5907024"/>
+            <a:ext cx="1641348" cy="219456"/>
           </a:xfrm>
           <a:prstGeom prst="rect">
             <a:avLst/>
@@ -18087,166 +17462,30 @@
           </a:bodyPr>
           <a:lstStyle/>
           <a:p>
-            <a:pPr algn="r"/>
-            <a:r>
-              <a:rPr sz="1000" b="1" u="sng">
-                <a:solidFill>
-                  <a:srgbClr val="C77700"/>
+            <a:pPr algn="l"/>
+            <a:r>
+              <a:rPr sz="1050" b="1" u="sng">
+                <a:solidFill>
+                  <a:srgbClr val="4B3F8C"/>
                 </a:solidFill>
                 <a:latin typeface="Arial"/>
-                <a:hlinkClick r:id="rId12"/>
-              </a:rPr>
-              <a:t>Open the repository</a:t>
-            </a:r>
-          </a:p>
-        </p:txBody>
-      </p:sp>
-      <p:sp>
-        <p:nvSpPr>
-          <p:cNvPr id="17447" name="Rounded Rectangle 17446"/>
-          <p:cNvSpPr/>
-          <p:nvPr/>
-        </p:nvSpPr>
-        <p:spPr>
-          <a:xfrm>
-            <a:off x="411480" y="5504688"/>
-            <a:ext cx="11338560" cy="731520"/>
-          </a:xfrm>
-          <a:prstGeom prst="roundRect">
-            <a:avLst>
-              <a:gd name="adj" fmla="val 6000"/>
-            </a:avLst>
-          </a:prstGeom>
-          <a:solidFill>
-            <a:srgbClr val="E4F4EC"/>
-          </a:solidFill>
-          <a:ln>
-            <a:noFill/>
-          </a:ln>
-          <a:effectLst/>
-        </p:spPr>
-        <p:style>
-          <a:lnRef idx="1">
-            <a:schemeClr val="accent1"/>
-          </a:lnRef>
-          <a:fillRef idx="3">
-            <a:schemeClr val="accent1"/>
-          </a:fillRef>
-          <a:effectRef idx="2">
-            <a:schemeClr val="accent1"/>
-          </a:effectRef>
-          <a:fontRef idx="minor">
-            <a:schemeClr val="lt1"/>
-          </a:fontRef>
-        </p:style>
-        <p:txBody>
-          <a:bodyPr rtlCol="0" anchor="ctr" wrap="square"/>
-          <a:lstStyle/>
-          <a:p>
-            <a:pPr algn="ctr"/>
-          </a:p>
-        </p:txBody>
-      </p:sp>
-      <p:sp>
-        <p:nvSpPr>
-          <p:cNvPr id="17448" name="TextBox 17447"/>
+                <a:hlinkClick r:id="rId13"/>
+              </a:rPr>
+              <a:t>README + method</a:t>
+            </a:r>
+          </a:p>
+        </p:txBody>
+      </p:sp>
+      <p:sp>
+        <p:nvSpPr>
+          <p:cNvPr id="17440" name="TextBox 17439"/>
           <p:cNvSpPr txBox="1"/>
           <p:nvPr/>
         </p:nvSpPr>
         <p:spPr>
           <a:xfrm>
-            <a:off x="566928" y="5559552"/>
-            <a:ext cx="11064240" cy="219456"/>
-          </a:xfrm>
-          <a:prstGeom prst="rect">
-            <a:avLst/>
-          </a:prstGeom>
-          <a:noFill/>
-        </p:spPr>
-        <p:txBody>
-          <a:bodyPr wrap="square" lIns="36576" rIns="36576" tIns="18288" bIns="18288">
-            <a:spAutoFit/>
-          </a:bodyPr>
-          <a:lstStyle/>
-          <a:p>
-            <a:pPr>
-              <a:lnSpc>
-                <a:spcPct val="95000"/>
-              </a:lnSpc>
-              <a:spcBef>
-                <a:spcPts val="0"/>
-              </a:spcBef>
-              <a:spcAft>
-                <a:spcPts val="0"/>
-              </a:spcAft>
-            </a:pPr>
-            <a:r>
-              <a:rPr sz="1100" b="0">
-                <a:solidFill>
-                  <a:srgbClr val="262B33"/>
-                </a:solidFill>
-                <a:latin typeface="Arial"/>
-              </a:rPr>
-              <a:t>Everything above is reproducible — every figure in this deck and on the portal regenerates from the database by scripts in the repository, none typed by hand.</a:t>
-            </a:r>
-          </a:p>
-        </p:txBody>
-      </p:sp>
-      <p:sp>
-        <p:nvSpPr>
-          <p:cNvPr id="17449" name="TextBox 17448"/>
-          <p:cNvSpPr txBox="1"/>
-          <p:nvPr/>
-        </p:nvSpPr>
-        <p:spPr>
-          <a:xfrm>
-            <a:off x="566928" y="5870448"/>
-            <a:ext cx="1188720" cy="219456"/>
-          </a:xfrm>
-          <a:prstGeom prst="rect">
-            <a:avLst/>
-          </a:prstGeom>
-          <a:noFill/>
-        </p:spPr>
-        <p:txBody>
-          <a:bodyPr wrap="square" lIns="36576" rIns="36576" tIns="18288" bIns="18288">
-            <a:spAutoFit/>
-          </a:bodyPr>
-          <a:lstStyle/>
-          <a:p>
-            <a:pPr>
-              <a:lnSpc>
-                <a:spcPct val="95000"/>
-              </a:lnSpc>
-              <a:spcBef>
-                <a:spcPts val="0"/>
-              </a:spcBef>
-              <a:spcAft>
-                <a:spcPts val="0"/>
-              </a:spcAft>
-            </a:pPr>
-            <a:r>
-              <a:rPr sz="950" b="1">
-                <a:solidFill>
-                  <a:srgbClr val="5A626C"/>
-                </a:solidFill>
-                <a:latin typeface="Arial"/>
-              </a:rPr>
-              <a:t>LIVE SYSTEM</a:t>
-            </a:r>
-          </a:p>
-        </p:txBody>
-      </p:sp>
-      <p:sp>
-        <p:nvSpPr>
-          <p:cNvPr id="17450" name="TextBox 17449"/>
-          <p:cNvSpPr txBox="1"/>
-          <p:nvPr/>
-        </p:nvSpPr>
-        <p:spPr>
-          <a:xfrm>
-            <a:off x="1783080" y="5870448"/>
-            <a:ext cx="2286000" cy="219456"/>
+            <a:off x="10108692" y="5907024"/>
+            <a:ext cx="1641348" cy="219456"/>
           </a:xfrm>
           <a:prstGeom prst="rect">
             <a:avLst/>
@@ -18263,118 +17502,10 @@
             <a:r>
               <a:rPr sz="1050" b="1" u="sng">
                 <a:solidFill>
-                  <a:srgbClr val="1F497D"/>
-                </a:solidFill>
-                <a:latin typeface="Arial"/>
-                <a:hlinkClick r:id="rId13"/>
-              </a:rPr>
-              <a:t>Live API docs</a:t>
-            </a:r>
-          </a:p>
-        </p:txBody>
-      </p:sp>
-      <p:sp>
-        <p:nvSpPr>
-          <p:cNvPr id="17451" name="TextBox 17450"/>
-          <p:cNvSpPr txBox="1"/>
-          <p:nvPr/>
-        </p:nvSpPr>
-        <p:spPr>
-          <a:xfrm>
-            <a:off x="4160520" y="5870448"/>
-            <a:ext cx="2286000" cy="219456"/>
-          </a:xfrm>
-          <a:prstGeom prst="rect">
-            <a:avLst/>
-          </a:prstGeom>
-          <a:noFill/>
-        </p:spPr>
-        <p:txBody>
-          <a:bodyPr wrap="none" lIns="0" rIns="0" tIns="0" bIns="0">
-            <a:spAutoFit/>
-          </a:bodyPr>
-          <a:lstStyle/>
-          <a:p>
-            <a:pPr algn="l"/>
-            <a:r>
-              <a:rPr sz="1050" b="1" u="sng">
-                <a:solidFill>
-                  <a:srgbClr val="1B8A5A"/>
+                  <a:srgbClr val="0E7C86"/>
                 </a:solidFill>
                 <a:latin typeface="Arial"/>
                 <a:hlinkClick r:id="rId14"/>
-              </a:rPr>
-              <a:t>Release portal</a:t>
-            </a:r>
-          </a:p>
-        </p:txBody>
-      </p:sp>
-      <p:sp>
-        <p:nvSpPr>
-          <p:cNvPr id="17452" name="TextBox 17451"/>
-          <p:cNvSpPr txBox="1"/>
-          <p:nvPr/>
-        </p:nvSpPr>
-        <p:spPr>
-          <a:xfrm>
-            <a:off x="6537960" y="5870448"/>
-            <a:ext cx="2286000" cy="219456"/>
-          </a:xfrm>
-          <a:prstGeom prst="rect">
-            <a:avLst/>
-          </a:prstGeom>
-          <a:noFill/>
-        </p:spPr>
-        <p:txBody>
-          <a:bodyPr wrap="none" lIns="0" rIns="0" tIns="0" bIns="0">
-            <a:spAutoFit/>
-          </a:bodyPr>
-          <a:lstStyle/>
-          <a:p>
-            <a:pPr algn="l"/>
-            <a:r>
-              <a:rPr sz="1050" b="1" u="sng">
-                <a:solidFill>
-                  <a:srgbClr val="4B3F8C"/>
-                </a:solidFill>
-                <a:latin typeface="Arial"/>
-                <a:hlinkClick r:id="rId15"/>
-              </a:rPr>
-              <a:t>README + method</a:t>
-            </a:r>
-          </a:p>
-        </p:txBody>
-      </p:sp>
-      <p:sp>
-        <p:nvSpPr>
-          <p:cNvPr id="17453" name="TextBox 17452"/>
-          <p:cNvSpPr txBox="1"/>
-          <p:nvPr/>
-        </p:nvSpPr>
-        <p:spPr>
-          <a:xfrm>
-            <a:off x="8915400" y="5870448"/>
-            <a:ext cx="2286000" cy="219456"/>
-          </a:xfrm>
-          <a:prstGeom prst="rect">
-            <a:avLst/>
-          </a:prstGeom>
-          <a:noFill/>
-        </p:spPr>
-        <p:txBody>
-          <a:bodyPr wrap="none" lIns="0" rIns="0" tIns="0" bIns="0">
-            <a:spAutoFit/>
-          </a:bodyPr>
-          <a:lstStyle/>
-          <a:p>
-            <a:pPr algn="l"/>
-            <a:r>
-              <a:rPr sz="1050" b="1" u="sng">
-                <a:solidFill>
-                  <a:srgbClr val="0E7C86"/>
-                </a:solidFill>
-                <a:latin typeface="Arial"/>
-                <a:hlinkClick r:id="rId11"/>
               </a:rPr>
               <a:t>Aviation market</a:t>
             </a:r>

</xml_diff>

<commit_message>
Slide 3: reframe the NULL row around the price basis a CPI needs
base_fare is NULL in all 53,257 rows, which is true but reads as a gap. A CPI
prices the total a household pays, so the absence is not a limitation - the
row now says the breakdown is stored NULL rather than derived, and why that is
the right basis.

Co-Authored-By: Claude Opus 5 <noreply@anthropic.com>
Claude-Session: https://claude.ai/code/session_0129UjVhHMAVJgfcaxoN1dD5
</commit_message>
<xml_diff>
--- a/SIH26056-Idea-Presentation.pptx
+++ b/SIH26056-Idea-Presentation.pptx
@@ -10516,7 +10516,7 @@
                 </a:solidFill>
                 <a:latin typeface="Arial"/>
               </a:rPr>
-              <a:t>base fare not shown</a:t>
+              <a:t>no tax or fee breakdown</a:t>
             </a:r>
           </a:p>
         </p:txBody>
@@ -10561,7 +10561,7 @@
                 </a:solidFill>
                 <a:latin typeface="Arial"/>
               </a:rPr>
-              <a:t>base_fare = NULL</a:t>
+              <a:t>stored NULL, never derived</a:t>
             </a:r>
           </a:p>
         </p:txBody>
@@ -10606,7 +10606,7 @@
                 </a:solidFill>
                 <a:latin typeface="Arial"/>
               </a:rPr>
-              <a:t>we never estimate what a page omits</a:t>
+              <a:t>a CPI prices the total a household pays</a:t>
             </a:r>
           </a:p>
         </p:txBody>

</xml_diff>